<commit_message>
Unify submission materials around Candy Forge
</commit_message>
<xml_diff>
--- a/Submission/project_deck.pptx
+++ b/Submission/project_deck.pptx
@@ -2,19 +2,20 @@
 <file path=ppt/presentation.xml><?xml version="1.0" encoding="utf-8"?>
 <p:presentation xmlns:p="http://schemas.openxmlformats.org/presentationml/2006/main">
   <p:sldMasterIdLst>
-    <p:sldMasterId xmlns:r="http://schemas.openxmlformats.org/officeDocument/2006/relationships" id="2147483648" r:id="Rff3db4b21c974953"/>
+    <p:sldMasterId xmlns:r="http://schemas.openxmlformats.org/officeDocument/2006/relationships" id="2147483648" r:id="R7d9038a072354d03"/>
   </p:sldMasterIdLst>
   <p:notesMasterIdLst>
-    <p:notesMasterId xmlns:r="http://schemas.openxmlformats.org/officeDocument/2006/relationships" r:id="Rc79389f5dd88416f"/>
+    <p:notesMasterId xmlns:r="http://schemas.openxmlformats.org/officeDocument/2006/relationships" r:id="Rf5a4c4a73aa34455"/>
   </p:notesMasterIdLst>
   <p:sldIdLst>
-    <p:sldId xmlns:r="http://schemas.openxmlformats.org/officeDocument/2006/relationships" id="256" r:id="R21e426837a784677"/>
-    <p:sldId xmlns:r="http://schemas.openxmlformats.org/officeDocument/2006/relationships" id="257" r:id="Rd94e27d41fa549f0"/>
-    <p:sldId xmlns:r="http://schemas.openxmlformats.org/officeDocument/2006/relationships" id="258" r:id="R91e6cc25b0674fc9"/>
-    <p:sldId xmlns:r="http://schemas.openxmlformats.org/officeDocument/2006/relationships" id="259" r:id="R173bbe58da0d4766"/>
-    <p:sldId xmlns:r="http://schemas.openxmlformats.org/officeDocument/2006/relationships" id="260" r:id="Ra090a7635049444e"/>
-    <p:sldId xmlns:r="http://schemas.openxmlformats.org/officeDocument/2006/relationships" id="261" r:id="R9eac080b3ede496a"/>
-    <p:sldId xmlns:r="http://schemas.openxmlformats.org/officeDocument/2006/relationships" id="262" r:id="Ra337b77ede9645f5"/>
+    <p:sldId xmlns:r="http://schemas.openxmlformats.org/officeDocument/2006/relationships" id="256" r:id="R104c2c5b92ed4ba5"/>
+    <p:sldId xmlns:r="http://schemas.openxmlformats.org/officeDocument/2006/relationships" id="257" r:id="R23cc204d3eb84e8e"/>
+    <p:sldId xmlns:r="http://schemas.openxmlformats.org/officeDocument/2006/relationships" id="258" r:id="Re63e292f50694892"/>
+    <p:sldId xmlns:r="http://schemas.openxmlformats.org/officeDocument/2006/relationships" id="259" r:id="Rb40f02c2ae854330"/>
+    <p:sldId xmlns:r="http://schemas.openxmlformats.org/officeDocument/2006/relationships" id="260" r:id="Rcae30d6e0bd44722"/>
+    <p:sldId xmlns:r="http://schemas.openxmlformats.org/officeDocument/2006/relationships" id="261" r:id="Re56f8ab299964ea2"/>
+    <p:sldId xmlns:r="http://schemas.openxmlformats.org/officeDocument/2006/relationships" id="262" r:id="Rd008ef90d7ad4f37"/>
+    <p:sldId xmlns:r="http://schemas.openxmlformats.org/officeDocument/2006/relationships" id="263" r:id="Rfa3d7f37d654474d"/>
   </p:sldIdLst>
   <p:sldSz cx="12192000" cy="6858000"/>
   <p:notesSz cx="6858000" cy="9144000"/>
@@ -965,6 +966,72 @@
 </p:notes>
 </file>
 
+<file path=ppt/notesSlides/notesSlide8.xml><?xml version="1.0" encoding="utf-8"?>
+<p:notes xmlns:p="http://schemas.openxmlformats.org/presentationml/2006/main">
+  <p:cSld>
+    <p:spTree>
+      <p:nvGrpSpPr>
+        <p:cNvPr id="1" name=""/>
+        <p:cNvGrpSpPr/>
+        <p:nvPr/>
+      </p:nvGrpSpPr>
+      <p:grpSpPr>
+        <a:xfrm xmlns:a="http://schemas.openxmlformats.org/drawingml/2006/main"/>
+      </p:grpSpPr>
+      <p:sp>
+        <p:nvSpPr>
+          <p:cNvPr id="2" name="Slide Image Placeholder 1"/>
+          <p:cNvSpPr>
+            <a:spLocks xmlns:a="http://schemas.openxmlformats.org/drawingml/2006/main" noGrp="1"/>
+          </p:cNvSpPr>
+          <p:nvPr>
+            <p:ph type="sldImg" idx="0"/>
+          </p:nvPr>
+        </p:nvSpPr>
+        <p:spPr/>
+      </p:sp>
+      <p:sp>
+        <p:nvSpPr>
+          <p:cNvPr id="3" name="Notes Placeholder 2"/>
+          <p:cNvSpPr>
+            <a:spLocks xmlns:a="http://schemas.openxmlformats.org/drawingml/2006/main" noGrp="1"/>
+          </p:cNvSpPr>
+          <p:nvPr>
+            <p:ph type="body" idx="1"/>
+          </p:nvPr>
+        </p:nvSpPr>
+        <p:spPr/>
+        <p:txBody>
+          <a:bodyPr xmlns:a="http://schemas.openxmlformats.org/drawingml/2006/main"/>
+          <a:lstStyle xmlns:a="http://schemas.openxmlformats.org/drawingml/2006/main"/>
+          <a:p xmlns:a="http://schemas.openxmlformats.org/drawingml/2006/main"/>
+        </p:txBody>
+      </p:sp>
+      <p:sp>
+        <p:nvSpPr>
+          <p:cNvPr id="4" name="Slide Number Placeholder 3"/>
+          <p:cNvSpPr>
+            <a:spLocks xmlns:a="http://schemas.openxmlformats.org/drawingml/2006/main" noGrp="1"/>
+          </p:cNvSpPr>
+          <p:nvPr>
+            <p:ph type="sldNum" idx="5"/>
+          </p:nvPr>
+        </p:nvSpPr>
+        <p:spPr/>
+        <p:txBody>
+          <a:bodyPr xmlns:a="http://schemas.openxmlformats.org/drawingml/2006/main"/>
+          <a:lstStyle xmlns:a="http://schemas.openxmlformats.org/drawingml/2006/main"/>
+          <a:p xmlns:a="http://schemas.openxmlformats.org/drawingml/2006/main"/>
+        </p:txBody>
+      </p:sp>
+    </p:spTree>
+  </p:cSld>
+  <p:clrMapOvr>
+    <a:masterClrMapping xmlns:a="http://schemas.openxmlformats.org/drawingml/2006/main"/>
+  </p:clrMapOvr>
+</p:notes>
+</file>
+
 <file path=ppt/slideLayouts/slideLayout1.xml><?xml version="1.0" encoding="utf-8"?>
 <p:sldLayout xmlns:p="http://schemas.openxmlformats.org/presentationml/2006/main" type="title">
   <p:cSld name="Title Slide">
@@ -1003,7 +1070,7 @@
   </p:cSld>
   <p:clrMap bg1="lt1" tx1="dk1" bg2="lt2" tx2="dk2" accent1="accent1" accent2="accent2" accent3="accent3" accent4="accent4" accent5="accent5" accent6="accent6" hlink="hlink" folHlink="folHlink"/>
   <p:sldLayoutIdLst>
-    <p:sldLayoutId xmlns:r="http://schemas.openxmlformats.org/officeDocument/2006/relationships" id="2147483649" r:id="R8f05a552acea4d85"/>
+    <p:sldLayoutId xmlns:r="http://schemas.openxmlformats.org/officeDocument/2006/relationships" id="2147483649" r:id="Rfd26f9458ec04d46"/>
   </p:sldLayoutIdLst>
   <p:txStyles>
     <p:titleStyle>
@@ -1558,7 +1625,7 @@
           <p:nvPr/>
         </p:nvPicPr>
         <p:blipFill>
-          <a:blip xmlns:r="http://schemas.openxmlformats.org/officeDocument/2006/relationships" xmlns:a="http://schemas.openxmlformats.org/drawingml/2006/main" r:embed="R471cff879d4a4d11"/>
+          <a:blip xmlns:r="http://schemas.openxmlformats.org/officeDocument/2006/relationships" xmlns:a="http://schemas.openxmlformats.org/drawingml/2006/main" r:embed="Rcb857eae759b41ec"/>
           <a:srcRect xmlns:a="http://schemas.openxmlformats.org/drawingml/2006/main" l="0" t="0" r="0" b="0"/>
           <a:stretch xmlns:a="http://schemas.openxmlformats.org/drawingml/2006/main">
             <a:fillRect l="0" t="0" r="0" b="0"/>
@@ -1579,7 +1646,7 @@
           <p:cNvPr id="2" name="">
             <a:extLst xmlns:a="http://schemas.openxmlformats.org/drawingml/2006/main">
               <a:ext uri="{FF2B5EF4-FFF2-40B4-BE49-F238E27FC236}">
-                <a16:creationId xmlns:a16="http://schemas.microsoft.com/office/drawing/2014/main" id="{AC3EEAF9-5B8A-4C9D-B8D2-706958F562F0}"/>
+                <a16:creationId xmlns:a16="http://schemas.microsoft.com/office/drawing/2014/main" id="{6C0790FA-E5CF-44F3-93F9-AE224A6E193F}"/>
               </a:ext>
             </a:extLst>
           </p:cNvPr>
@@ -1591,7 +1658,7 @@
         <p:spPr>
           <a:xfrm xmlns:a="http://schemas.openxmlformats.org/drawingml/2006/main">
             <a:off x="0" y="0"/>
-            <a:ext cx="4762500" cy="6858000"/>
+            <a:ext cx="4953000" cy="6858000"/>
           </a:xfrm>
           <a:prstGeom xmlns:a="http://schemas.openxmlformats.org/drawingml/2006/main" prst="rect">
             <a:avLst/>
@@ -1610,19 +1677,19 @@
           <p:cNvPr id="3" name="">
             <a:extLst xmlns:a="http://schemas.openxmlformats.org/drawingml/2006/main">
               <a:ext uri="{FF2B5EF4-FFF2-40B4-BE49-F238E27FC236}">
-                <a16:creationId xmlns:a16="http://schemas.microsoft.com/office/drawing/2014/main" id="{F392254A-E297-413E-8F3D-A38FFE835B26}"/>
-              </a:ext>
-            </a:extLst>
-          </p:cNvPr>
-          <p:cNvSpPr>
-            <a:spLocks xmlns:a="http://schemas.openxmlformats.org/drawingml/2006/main" noGrp="1"/>
-          </p:cNvSpPr>
-          <p:nvPr/>
-        </p:nvSpPr>
-        <p:spPr>
-          <a:xfrm xmlns:a="http://schemas.openxmlformats.org/drawingml/2006/main">
-            <a:off x="552450" y="990600"/>
-            <a:ext cx="3857625" cy="1143000"/>
+                <a16:creationId xmlns:a16="http://schemas.microsoft.com/office/drawing/2014/main" id="{177E3204-E964-400E-A449-4511C1C55EE2}"/>
+              </a:ext>
+            </a:extLst>
+          </p:cNvPr>
+          <p:cNvSpPr>
+            <a:spLocks xmlns:a="http://schemas.openxmlformats.org/drawingml/2006/main" noGrp="1"/>
+          </p:cNvSpPr>
+          <p:nvPr/>
+        </p:nvSpPr>
+        <p:spPr>
+          <a:xfrm xmlns:a="http://schemas.openxmlformats.org/drawingml/2006/main">
+            <a:off x="552450" y="952500"/>
+            <a:ext cx="4000500" cy="1104900"/>
           </a:xfrm>
           <a:prstGeom xmlns:a="http://schemas.openxmlformats.org/drawingml/2006/main" prst="rect">
             <a:avLst/>
@@ -1642,6 +1709,9 @@
                 <a:solidFill>
                   <a:srgbClr val="FFFFFF"/>
                 </a:solidFill>
+                <a:latin typeface="Microsoft YaHei"/>
+                <a:ea typeface="Microsoft YaHei"/>
+                <a:cs typeface="Microsoft YaHei"/>
               </a:defRPr>
             </a:pPr>
             <a:r>
@@ -1649,8 +1719,11 @@
                 <a:solidFill>
                   <a:srgbClr val="FFFFFF"/>
                 </a:solidFill>
+                <a:latin typeface="Microsoft YaHei"/>
+                <a:ea typeface="Microsoft YaHei"/>
+                <a:cs typeface="Microsoft YaHei"/>
               </a:rPr>
-              <a:t>能工智人：遗忘工坊</a:t>
+              <a:t>能工智人：糖芯工坊</a:t>
             </a:r>
           </a:p>
         </p:txBody>
@@ -1660,19 +1733,19 @@
           <p:cNvPr id="4" name="">
             <a:extLst xmlns:a="http://schemas.openxmlformats.org/drawingml/2006/main">
               <a:ext uri="{FF2B5EF4-FFF2-40B4-BE49-F238E27FC236}">
-                <a16:creationId xmlns:a16="http://schemas.microsoft.com/office/drawing/2014/main" id="{E2AE2066-1AEF-4CB5-81BA-FCB3EED5B70E}"/>
-              </a:ext>
-            </a:extLst>
-          </p:cNvPr>
-          <p:cNvSpPr>
-            <a:spLocks xmlns:a="http://schemas.openxmlformats.org/drawingml/2006/main" noGrp="1"/>
-          </p:cNvSpPr>
-          <p:nvPr/>
-        </p:nvSpPr>
-        <p:spPr>
-          <a:xfrm xmlns:a="http://schemas.openxmlformats.org/drawingml/2006/main">
-            <a:off x="571500" y="2247900"/>
-            <a:ext cx="3714750" cy="742950"/>
+                <a16:creationId xmlns:a16="http://schemas.microsoft.com/office/drawing/2014/main" id="{53DD3B22-88F7-4F3D-B846-FB51B5FFEAAE}"/>
+              </a:ext>
+            </a:extLst>
+          </p:cNvPr>
+          <p:cNvSpPr>
+            <a:spLocks xmlns:a="http://schemas.openxmlformats.org/drawingml/2006/main" noGrp="1"/>
+          </p:cNvSpPr>
+          <p:nvPr/>
+        </p:nvSpPr>
+        <p:spPr>
+          <a:xfrm xmlns:a="http://schemas.openxmlformats.org/drawingml/2006/main">
+            <a:off x="571500" y="2209800"/>
+            <a:ext cx="3810000" cy="742950"/>
           </a:xfrm>
           <a:prstGeom xmlns:a="http://schemas.openxmlformats.org/drawingml/2006/main" prst="rect">
             <a:avLst/>
@@ -1692,6 +1765,9 @@
                 <a:solidFill>
                   <a:srgbClr val="DDF4FF"/>
                 </a:solidFill>
+                <a:latin typeface="Microsoft YaHei"/>
+                <a:ea typeface="Microsoft YaHei"/>
+                <a:cs typeface="Microsoft YaHei"/>
               </a:defRPr>
             </a:pPr>
             <a:r>
@@ -1699,6 +1775,9 @@
                 <a:solidFill>
                   <a:srgbClr val="DDF4FF"/>
                 </a:solidFill>
+                <a:latin typeface="Microsoft YaHei"/>
+                <a:ea typeface="Microsoft YaHei"/>
+                <a:cs typeface="Microsoft YaHei"/>
               </a:rPr>
               <a:t>Craftsmen and Homo Sapiens:</a:t>
             </a:r>
@@ -1709,6 +1788,9 @@
                 <a:solidFill>
                   <a:srgbClr val="DDF4FF"/>
                 </a:solidFill>
+                <a:latin typeface="Microsoft YaHei"/>
+                <a:ea typeface="Microsoft YaHei"/>
+                <a:cs typeface="Microsoft YaHei"/>
               </a:defRPr>
             </a:pPr>
             <a:r>
@@ -1716,8 +1798,11 @@
                 <a:solidFill>
                   <a:srgbClr val="DDF4FF"/>
                 </a:solidFill>
+                <a:latin typeface="Microsoft YaHei"/>
+                <a:ea typeface="Microsoft YaHei"/>
+                <a:cs typeface="Microsoft YaHei"/>
               </a:rPr>
-              <a:t>The Forgotten Forge</a:t>
+              <a:t>The Candy Forge</a:t>
             </a:r>
           </a:p>
         </p:txBody>
@@ -1727,18 +1812,18 @@
           <p:cNvPr id="5" name="">
             <a:extLst xmlns:a="http://schemas.openxmlformats.org/drawingml/2006/main">
               <a:ext uri="{FF2B5EF4-FFF2-40B4-BE49-F238E27FC236}">
-                <a16:creationId xmlns:a16="http://schemas.microsoft.com/office/drawing/2014/main" id="{D91A2890-1A92-43F1-BAB7-4973292B9140}"/>
-              </a:ext>
-            </a:extLst>
-          </p:cNvPr>
-          <p:cNvSpPr>
-            <a:spLocks xmlns:a="http://schemas.openxmlformats.org/drawingml/2006/main" noGrp="1"/>
-          </p:cNvSpPr>
-          <p:nvPr/>
-        </p:nvSpPr>
-        <p:spPr>
-          <a:xfrm xmlns:a="http://schemas.openxmlformats.org/drawingml/2006/main">
-            <a:off x="590550" y="3238500"/>
+                <a16:creationId xmlns:a16="http://schemas.microsoft.com/office/drawing/2014/main" id="{42A10D8D-58BB-433E-9DA7-815D1D7ED5B9}"/>
+              </a:ext>
+            </a:extLst>
+          </p:cNvPr>
+          <p:cNvSpPr>
+            <a:spLocks xmlns:a="http://schemas.openxmlformats.org/drawingml/2006/main" noGrp="1"/>
+          </p:cNvSpPr>
+          <p:nvPr/>
+        </p:nvSpPr>
+        <p:spPr>
+          <a:xfrm xmlns:a="http://schemas.openxmlformats.org/drawingml/2006/main">
+            <a:off x="590550" y="3200400"/>
             <a:ext cx="3333750" cy="304800"/>
           </a:xfrm>
           <a:prstGeom xmlns:a="http://schemas.openxmlformats.org/drawingml/2006/main" prst="rect">
@@ -1759,6 +1844,9 @@
                 <a:solidFill>
                   <a:srgbClr val="FFB4D1"/>
                 </a:solidFill>
+                <a:latin typeface="Microsoft YaHei"/>
+                <a:ea typeface="Microsoft YaHei"/>
+                <a:cs typeface="Microsoft YaHei"/>
               </a:defRPr>
             </a:pPr>
             <a:r>
@@ -1766,6 +1854,9 @@
                 <a:solidFill>
                   <a:srgbClr val="FFB4D1"/>
                 </a:solidFill>
+                <a:latin typeface="Microsoft YaHei"/>
+                <a:ea typeface="Microsoft YaHei"/>
+                <a:cs typeface="Microsoft YaHei"/>
               </a:rPr>
               <a:t>叙事类游戏 / Narrative Games</a:t>
             </a:r>
@@ -1777,19 +1868,19 @@
           <p:cNvPr id="6" name="">
             <a:extLst xmlns:a="http://schemas.openxmlformats.org/drawingml/2006/main">
               <a:ext uri="{FF2B5EF4-FFF2-40B4-BE49-F238E27FC236}">
-                <a16:creationId xmlns:a16="http://schemas.microsoft.com/office/drawing/2014/main" id="{7A058987-62A0-4396-BDC3-A080046357EF}"/>
-              </a:ext>
-            </a:extLst>
-          </p:cNvPr>
-          <p:cNvSpPr>
-            <a:spLocks xmlns:a="http://schemas.openxmlformats.org/drawingml/2006/main" noGrp="1"/>
-          </p:cNvSpPr>
-          <p:nvPr/>
-        </p:nvSpPr>
-        <p:spPr>
-          <a:xfrm xmlns:a="http://schemas.openxmlformats.org/drawingml/2006/main">
-            <a:off x="590550" y="3829050"/>
-            <a:ext cx="3524250" cy="857250"/>
+                <a16:creationId xmlns:a16="http://schemas.microsoft.com/office/drawing/2014/main" id="{A9798A8D-9149-4335-AC83-7CFC82AFE8A0}"/>
+              </a:ext>
+            </a:extLst>
+          </p:cNvPr>
+          <p:cNvSpPr>
+            <a:spLocks xmlns:a="http://schemas.openxmlformats.org/drawingml/2006/main" noGrp="1"/>
+          </p:cNvSpPr>
+          <p:nvPr/>
+        </p:nvSpPr>
+        <p:spPr>
+          <a:xfrm xmlns:a="http://schemas.openxmlformats.org/drawingml/2006/main">
+            <a:off x="590550" y="3790950"/>
+            <a:ext cx="3638550" cy="990600"/>
           </a:xfrm>
           <a:prstGeom xmlns:a="http://schemas.openxmlformats.org/drawingml/2006/main" prst="rect">
             <a:avLst/>
@@ -1809,6 +1900,9 @@
                 <a:solidFill>
                   <a:srgbClr val="FFFFFF"/>
                 </a:solidFill>
+                <a:latin typeface="Microsoft YaHei"/>
+                <a:ea typeface="Microsoft YaHei"/>
+                <a:cs typeface="Microsoft YaHei"/>
               </a:defRPr>
             </a:pPr>
             <a:r>
@@ -1816,8 +1910,11 @@
                 <a:solidFill>
                   <a:srgbClr val="FFFFFF"/>
                 </a:solidFill>
+                <a:latin typeface="Microsoft YaHei"/>
+                <a:ea typeface="Microsoft YaHei"/>
+                <a:cs typeface="Microsoft YaHei"/>
               </a:rPr>
-              <a:t>AI 叙事驱动的横版动作冒险，在地下工坊的记忆日志中揭开文明冲突真相。</a:t>
+              <a:t>理工男穿越成异世界女仆工程师，用糖果材料搓科技，打败 Boss 找到回家的路。</a:t>
             </a:r>
           </a:p>
         </p:txBody>
@@ -1827,7 +1924,7 @@
           <p:cNvPr id="7" name="">
             <a:extLst xmlns:a="http://schemas.openxmlformats.org/drawingml/2006/main">
               <a:ext uri="{FF2B5EF4-FFF2-40B4-BE49-F238E27FC236}">
-                <a16:creationId xmlns:a16="http://schemas.microsoft.com/office/drawing/2014/main" id="{6375E2D2-9A01-4D2E-B35E-90578F9A7EF9}"/>
+                <a16:creationId xmlns:a16="http://schemas.microsoft.com/office/drawing/2014/main" id="{C86A1BD0-086F-403E-8902-B8F054B4C8B7}"/>
               </a:ext>
             </a:extLst>
           </p:cNvPr>
@@ -1859,6 +1956,9 @@
                 <a:solidFill>
                   <a:srgbClr val="FFF4E4"/>
                 </a:solidFill>
+                <a:latin typeface="Microsoft YaHei"/>
+                <a:ea typeface="Microsoft YaHei"/>
+                <a:cs typeface="Microsoft YaHei"/>
               </a:defRPr>
             </a:pPr>
             <a:r>
@@ -1866,6 +1966,9 @@
                 <a:solidFill>
                   <a:srgbClr val="FFF4E4"/>
                 </a:solidFill>
+                <a:latin typeface="Microsoft YaHei"/>
+                <a:ea typeface="Microsoft YaHei"/>
+                <a:cs typeface="Microsoft YaHei"/>
               </a:rPr>
               <a:t>Team：落云宗    成员：秦天 / 陈磊</a:t>
             </a:r>
@@ -1877,7 +1980,7 @@
           <p:cNvPr id="8" name="">
             <a:extLst xmlns:a="http://schemas.openxmlformats.org/drawingml/2006/main">
               <a:ext uri="{FF2B5EF4-FFF2-40B4-BE49-F238E27FC236}">
-                <a16:creationId xmlns:a16="http://schemas.microsoft.com/office/drawing/2014/main" id="{A4AE6F38-F573-46C6-8603-0E06256841CA}"/>
+                <a16:creationId xmlns:a16="http://schemas.microsoft.com/office/drawing/2014/main" id="{F559EC4A-1556-4B31-8ABE-88158E6CFB27}"/>
               </a:ext>
             </a:extLst>
           </p:cNvPr>
@@ -1909,6 +2012,9 @@
                 <a:solidFill>
                   <a:srgbClr val="FFF4E4"/>
                 </a:solidFill>
+                <a:latin typeface="Microsoft YaHei"/>
+                <a:ea typeface="Microsoft YaHei"/>
+                <a:cs typeface="Microsoft YaHei"/>
               </a:defRPr>
             </a:pPr>
             <a:r>
@@ -1916,6 +2022,9 @@
                 <a:solidFill>
                   <a:srgbClr val="FFF4E4"/>
                 </a:solidFill>
+                <a:latin typeface="Microsoft YaHei"/>
+                <a:ea typeface="Microsoft YaHei"/>
+                <a:cs typeface="Microsoft YaHei"/>
               </a:rPr>
               <a:t>Demo Link：待回填</a:t>
             </a:r>
@@ -1925,7 +2034,7 @@
     </p:spTree>
     <p:extLst>
       <p:ext uri="{BB962C8B-B14F-4D97-AF65-F5344CB8AC3E}">
-        <p14:creationId xmlns:p14="http://schemas.microsoft.com/office/powerpoint/2010/main" val="2113241978"/>
+        <p14:creationId xmlns:p14="http://schemas.microsoft.com/office/powerpoint/2010/main" val="32843933"/>
       </p:ext>
     </p:extLst>
   </p:cSld>
@@ -1951,149 +2060,256 @@
       <p:grpSpPr>
         <a:xfrm xmlns:a="http://schemas.openxmlformats.org/drawingml/2006/main"/>
       </p:grpSpPr>
+      <p:sp>
+        <p:nvSpPr>
+          <p:cNvPr id="1" name="">
+            <a:extLst xmlns:a="http://schemas.openxmlformats.org/drawingml/2006/main">
+              <a:ext uri="{FF2B5EF4-FFF2-40B4-BE49-F238E27FC236}">
+                <a16:creationId xmlns:a16="http://schemas.microsoft.com/office/drawing/2014/main" id="{0E58338F-D05D-4D89-AE0C-2FD792D229B0}"/>
+              </a:ext>
+            </a:extLst>
+          </p:cNvPr>
+          <p:cNvSpPr>
+            <a:spLocks xmlns:a="http://schemas.openxmlformats.org/drawingml/2006/main" noGrp="1"/>
+          </p:cNvSpPr>
+          <p:nvPr/>
+        </p:nvSpPr>
+        <p:spPr>
+          <a:xfrm xmlns:a="http://schemas.openxmlformats.org/drawingml/2006/main">
+            <a:off x="609600" y="514350"/>
+            <a:ext cx="4095750" cy="514350"/>
+          </a:xfrm>
+          <a:prstGeom xmlns:a="http://schemas.openxmlformats.org/drawingml/2006/main" prst="rect">
+            <a:avLst/>
+          </a:prstGeom>
+          <a:noFill xmlns:a="http://schemas.openxmlformats.org/drawingml/2006/main"/>
+          <a:ln xmlns:a="http://schemas.openxmlformats.org/drawingml/2006/main" w="0">
+            <a:noFill/>
+            <a:prstDash val="solid"/>
+          </a:ln>
+        </p:spPr>
+        <p:txBody>
+          <a:bodyPr xmlns:a="http://schemas.openxmlformats.org/drawingml/2006/main"/>
+          <a:lstStyle xmlns:a="http://schemas.openxmlformats.org/drawingml/2006/main"/>
+          <a:p xmlns:a="http://schemas.openxmlformats.org/drawingml/2006/main">
+            <a:pPr>
+              <a:defRPr sz="3150" b="1">
+                <a:solidFill>
+                  <a:srgbClr val="2C2348"/>
+                </a:solidFill>
+                <a:latin typeface="Microsoft YaHei"/>
+                <a:ea typeface="Microsoft YaHei"/>
+                <a:cs typeface="Microsoft YaHei"/>
+              </a:defRPr>
+            </a:pPr>
+            <a:r>
+              <a:rPr sz="3150" b="1">
+                <a:solidFill>
+                  <a:srgbClr val="2C2348"/>
+                </a:solidFill>
+                <a:latin typeface="Microsoft YaHei"/>
+                <a:ea typeface="Microsoft YaHei"/>
+                <a:cs typeface="Microsoft YaHei"/>
+              </a:rPr>
+              <a:t>世界观：糖芯工坊</a:t>
+            </a:r>
+          </a:p>
+        </p:txBody>
+      </p:sp>
+      <p:sp>
+        <p:nvSpPr>
+          <p:cNvPr id="2" name="">
+            <a:extLst xmlns:a="http://schemas.openxmlformats.org/drawingml/2006/main">
+              <a:ext uri="{FF2B5EF4-FFF2-40B4-BE49-F238E27FC236}">
+                <a16:creationId xmlns:a16="http://schemas.microsoft.com/office/drawing/2014/main" id="{63BA0CBB-2547-416C-961B-F5DD78BA5B35}"/>
+              </a:ext>
+            </a:extLst>
+          </p:cNvPr>
+          <p:cNvSpPr>
+            <a:spLocks xmlns:a="http://schemas.openxmlformats.org/drawingml/2006/main" noGrp="1"/>
+          </p:cNvSpPr>
+          <p:nvPr/>
+        </p:nvSpPr>
+        <p:spPr>
+          <a:xfrm xmlns:a="http://schemas.openxmlformats.org/drawingml/2006/main">
+            <a:off x="628650" y="1066800"/>
+            <a:ext cx="8477250" cy="323850"/>
+          </a:xfrm>
+          <a:prstGeom xmlns:a="http://schemas.openxmlformats.org/drawingml/2006/main" prst="rect">
+            <a:avLst/>
+          </a:prstGeom>
+          <a:noFill xmlns:a="http://schemas.openxmlformats.org/drawingml/2006/main"/>
+          <a:ln xmlns:a="http://schemas.openxmlformats.org/drawingml/2006/main" w="0">
+            <a:noFill/>
+            <a:prstDash val="solid"/>
+          </a:ln>
+        </p:spPr>
+        <p:txBody>
+          <a:bodyPr xmlns:a="http://schemas.openxmlformats.org/drawingml/2006/main"/>
+          <a:lstStyle xmlns:a="http://schemas.openxmlformats.org/drawingml/2006/main"/>
+          <a:p xmlns:a="http://schemas.openxmlformats.org/drawingml/2006/main">
+            <a:pPr>
+              <a:defRPr sz="1575">
+                <a:solidFill>
+                  <a:srgbClr val="695F84"/>
+                </a:solidFill>
+                <a:latin typeface="Microsoft YaHei"/>
+                <a:ea typeface="Microsoft YaHei"/>
+                <a:cs typeface="Microsoft YaHei"/>
+              </a:defRPr>
+            </a:pPr>
+            <a:r>
+              <a:rPr sz="1575">
+                <a:solidFill>
+                  <a:srgbClr val="695F84"/>
+                </a:solidFill>
+                <a:latin typeface="Microsoft YaHei"/>
+                <a:ea typeface="Microsoft YaHei"/>
+                <a:cs typeface="Microsoft YaHei"/>
+              </a:rPr>
+              <a:t>理工男穿越成异世界女仆工程师，用工程学、番剧储备和糖果材料搓科技，打败 Boss 找到回家的路。</a:t>
+            </a:r>
+          </a:p>
+        </p:txBody>
+      </p:sp>
       <p:pic>
         <p:nvPicPr>
-          <p:cNvPr id="12" name=""/>
+          <p:cNvPr id="22" name=""/>
           <p:cNvPicPr>
             <a:picLocks xmlns:a="http://schemas.openxmlformats.org/drawingml/2006/main" noChangeAspect="1"/>
           </p:cNvPicPr>
           <p:nvPr/>
         </p:nvPicPr>
         <p:blipFill>
-          <a:blip xmlns:r="http://schemas.openxmlformats.org/officeDocument/2006/relationships" xmlns:a="http://schemas.openxmlformats.org/drawingml/2006/main" r:embed="R48609d8fa1ad4e64"/>
-          <a:srcRect xmlns:a="http://schemas.openxmlformats.org/drawingml/2006/main" l="8984" t="0" r="8984" b="0"/>
+          <a:blip xmlns:r="http://schemas.openxmlformats.org/officeDocument/2006/relationships" xmlns:a="http://schemas.openxmlformats.org/drawingml/2006/main" r:embed="R0a3aa3085d0f4314"/>
+          <a:srcRect xmlns:a="http://schemas.openxmlformats.org/drawingml/2006/main" l="3437" t="0" r="3437" b="0"/>
           <a:stretch xmlns:a="http://schemas.openxmlformats.org/drawingml/2006/main">
             <a:fillRect l="0" t="0" r="0" b="0"/>
           </a:stretch>
         </p:blipFill>
         <p:spPr>
           <a:xfrm xmlns:a="http://schemas.openxmlformats.org/drawingml/2006/main">
-            <a:off x="514350" y="914400"/>
-            <a:ext cx="6667500" cy="4572000"/>
+            <a:off x="552450" y="1638300"/>
+            <a:ext cx="5676900" cy="3429000"/>
           </a:xfrm>
           <a:prstGeom xmlns:a="http://schemas.openxmlformats.org/drawingml/2006/main" prst="rect">
             <a:avLst/>
           </a:prstGeom>
         </p:spPr>
       </p:pic>
-      <p:sp>
-        <p:nvSpPr>
-          <p:cNvPr id="2" name="">
-            <a:extLst xmlns:a="http://schemas.openxmlformats.org/drawingml/2006/main">
-              <a:ext uri="{FF2B5EF4-FFF2-40B4-BE49-F238E27FC236}">
-                <a16:creationId xmlns:a16="http://schemas.microsoft.com/office/drawing/2014/main" id="{EBC8D140-A274-4BD0-A070-1C0707ACD37A}"/>
-              </a:ext>
-            </a:extLst>
-          </p:cNvPr>
-          <p:cNvSpPr>
-            <a:spLocks xmlns:a="http://schemas.openxmlformats.org/drawingml/2006/main" noGrp="1"/>
-          </p:cNvSpPr>
-          <p:nvPr/>
-        </p:nvSpPr>
-        <p:spPr>
-          <a:xfrm xmlns:a="http://schemas.openxmlformats.org/drawingml/2006/main">
-            <a:off x="7810500" y="1047750"/>
-            <a:ext cx="3048000" cy="552450"/>
-          </a:xfrm>
-          <a:prstGeom xmlns:a="http://schemas.openxmlformats.org/drawingml/2006/main" prst="rect">
-            <a:avLst/>
-          </a:prstGeom>
-          <a:noFill xmlns:a="http://schemas.openxmlformats.org/drawingml/2006/main"/>
-          <a:ln xmlns:a="http://schemas.openxmlformats.org/drawingml/2006/main" w="0">
-            <a:noFill/>
-            <a:prstDash val="solid"/>
-          </a:ln>
-        </p:spPr>
-        <p:txBody>
-          <a:bodyPr xmlns:a="http://schemas.openxmlformats.org/drawingml/2006/main"/>
-          <a:lstStyle xmlns:a="http://schemas.openxmlformats.org/drawingml/2006/main"/>
-          <a:p xmlns:a="http://schemas.openxmlformats.org/drawingml/2006/main">
-            <a:pPr>
-              <a:defRPr sz="3300" b="1">
-                <a:solidFill>
-                  <a:srgbClr val="2C2348"/>
-                </a:solidFill>
-              </a:defRPr>
-            </a:pPr>
-            <a:r>
-              <a:rPr sz="3300" b="1">
-                <a:solidFill>
-                  <a:srgbClr val="2C2348"/>
-                </a:solidFill>
-              </a:rPr>
-              <a:t>游戏是什么</a:t>
-            </a:r>
-          </a:p>
-        </p:txBody>
-      </p:sp>
-      <p:sp>
-        <p:nvSpPr>
-          <p:cNvPr id="3" name="">
-            <a:extLst xmlns:a="http://schemas.openxmlformats.org/drawingml/2006/main">
-              <a:ext uri="{FF2B5EF4-FFF2-40B4-BE49-F238E27FC236}">
-                <a16:creationId xmlns:a16="http://schemas.microsoft.com/office/drawing/2014/main" id="{3647AD2D-3C54-4DF7-9D08-F9EC69E2F111}"/>
-              </a:ext>
-            </a:extLst>
-          </p:cNvPr>
-          <p:cNvSpPr>
-            <a:spLocks xmlns:a="http://schemas.openxmlformats.org/drawingml/2006/main" noGrp="1"/>
-          </p:cNvSpPr>
-          <p:nvPr/>
-        </p:nvSpPr>
-        <p:spPr>
-          <a:xfrm xmlns:a="http://schemas.openxmlformats.org/drawingml/2006/main">
-            <a:off x="7829550" y="1752600"/>
-            <a:ext cx="3238500" cy="933450"/>
-          </a:xfrm>
-          <a:prstGeom xmlns:a="http://schemas.openxmlformats.org/drawingml/2006/main" prst="rect">
-            <a:avLst/>
-          </a:prstGeom>
-          <a:noFill xmlns:a="http://schemas.openxmlformats.org/drawingml/2006/main"/>
-          <a:ln xmlns:a="http://schemas.openxmlformats.org/drawingml/2006/main" w="0">
-            <a:noFill/>
-            <a:prstDash val="solid"/>
-          </a:ln>
-        </p:spPr>
-        <p:txBody>
-          <a:bodyPr xmlns:a="http://schemas.openxmlformats.org/drawingml/2006/main"/>
-          <a:lstStyle xmlns:a="http://schemas.openxmlformats.org/drawingml/2006/main"/>
-          <a:p xmlns:a="http://schemas.openxmlformats.org/drawingml/2006/main">
-            <a:pPr>
-              <a:defRPr sz="1650">
-                <a:solidFill>
-                  <a:srgbClr val="695F84"/>
-                </a:solidFill>
-              </a:defRPr>
-            </a:pPr>
-            <a:r>
-              <a:rPr sz="1650">
-                <a:solidFill>
-                  <a:srgbClr val="695F84"/>
-                </a:solidFill>
-              </a:rPr>
-              <a:t>玩家进入一座会留下记忆的地下工坊，在房间推进和动作战斗中拼合文明冲突的真相。</a:t>
-            </a:r>
-          </a:p>
-        </p:txBody>
-      </p:sp>
-      <p:sp>
-        <p:nvSpPr>
-          <p:cNvPr id="4" name="">
-            <a:extLst xmlns:a="http://schemas.openxmlformats.org/drawingml/2006/main">
-              <a:ext uri="{FF2B5EF4-FFF2-40B4-BE49-F238E27FC236}">
-                <a16:creationId xmlns:a16="http://schemas.microsoft.com/office/drawing/2014/main" id="{59696BA8-A112-4B91-86FD-94BEAD8F8B64}"/>
-              </a:ext>
-            </a:extLst>
-          </p:cNvPr>
-          <p:cNvSpPr>
-            <a:spLocks xmlns:a="http://schemas.openxmlformats.org/drawingml/2006/main" noGrp="1"/>
-          </p:cNvSpPr>
-          <p:nvPr/>
-        </p:nvSpPr>
-        <p:spPr>
-          <a:xfrm xmlns:a="http://schemas.openxmlformats.org/drawingml/2006/main">
-            <a:off x="7848600" y="3219450"/>
-            <a:ext cx="95250" cy="95250"/>
+      <p:pic>
+        <p:nvPicPr>
+          <p:cNvPr id="23" name=""/>
+          <p:cNvPicPr>
+            <a:picLocks xmlns:a="http://schemas.openxmlformats.org/drawingml/2006/main" noChangeAspect="1"/>
+          </p:cNvPicPr>
+          <p:nvPr/>
+        </p:nvPicPr>
+        <p:blipFill>
+          <a:blip xmlns:r="http://schemas.openxmlformats.org/officeDocument/2006/relationships" xmlns:a="http://schemas.openxmlformats.org/drawingml/2006/main" r:embed="R270c373780424a1a"/>
+          <a:srcRect xmlns:a="http://schemas.openxmlformats.org/drawingml/2006/main" l="0" t="11331" r="0" b="11331"/>
+          <a:stretch xmlns:a="http://schemas.openxmlformats.org/drawingml/2006/main">
+            <a:fillRect l="0" t="0" r="0" b="0"/>
+          </a:stretch>
+        </p:blipFill>
+        <p:spPr>
+          <a:xfrm xmlns:a="http://schemas.openxmlformats.org/drawingml/2006/main">
+            <a:off x="781050" y="4324350"/>
+            <a:ext cx="3371850" cy="1466850"/>
+          </a:xfrm>
+          <a:prstGeom xmlns:a="http://schemas.openxmlformats.org/drawingml/2006/main" prst="rect">
+            <a:avLst/>
+          </a:prstGeom>
+        </p:spPr>
+      </p:pic>
+      <p:sp>
+        <p:nvSpPr>
+          <p:cNvPr id="5" name="">
+            <a:extLst xmlns:a="http://schemas.openxmlformats.org/drawingml/2006/main">
+              <a:ext uri="{FF2B5EF4-FFF2-40B4-BE49-F238E27FC236}">
+                <a16:creationId xmlns:a16="http://schemas.microsoft.com/office/drawing/2014/main" id="{9FF4C0D0-A48B-405F-A72F-F1C57900889E}"/>
+              </a:ext>
+            </a:extLst>
+          </p:cNvPr>
+          <p:cNvSpPr>
+            <a:spLocks xmlns:a="http://schemas.openxmlformats.org/drawingml/2006/main" noGrp="1"/>
+          </p:cNvSpPr>
+          <p:nvPr/>
+        </p:nvSpPr>
+        <p:spPr>
+          <a:xfrm xmlns:a="http://schemas.openxmlformats.org/drawingml/2006/main">
+            <a:off x="6667500" y="1638300"/>
+            <a:ext cx="4324350" cy="4000500"/>
+          </a:xfrm>
+          <a:prstGeom xmlns:a="http://schemas.openxmlformats.org/drawingml/2006/main" prst="roundRect">
+            <a:avLst>
+              <a:gd name="adj" fmla="val 3810"/>
+            </a:avLst>
+          </a:prstGeom>
+          <a:solidFill xmlns:a="http://schemas.openxmlformats.org/drawingml/2006/main">
+            <a:srgbClr val="FFFFFF"/>
+          </a:solidFill>
+          <a:ln xmlns:a="http://schemas.openxmlformats.org/drawingml/2006/main" w="19050">
+            <a:solidFill>
+              <a:srgbClr val="FF80B8"/>
+            </a:solidFill>
+            <a:prstDash val="solid"/>
+          </a:ln>
+        </p:spPr>
+      </p:sp>
+      <p:sp>
+        <p:nvSpPr>
+          <p:cNvPr id="6" name="">
+            <a:extLst xmlns:a="http://schemas.openxmlformats.org/drawingml/2006/main">
+              <a:ext uri="{FF2B5EF4-FFF2-40B4-BE49-F238E27FC236}">
+                <a16:creationId xmlns:a16="http://schemas.microsoft.com/office/drawing/2014/main" id="{8477A473-1648-4E78-A38D-A16141D1442B}"/>
+              </a:ext>
+            </a:extLst>
+          </p:cNvPr>
+          <p:cNvSpPr>
+            <a:spLocks xmlns:a="http://schemas.openxmlformats.org/drawingml/2006/main" noGrp="1"/>
+          </p:cNvSpPr>
+          <p:nvPr/>
+        </p:nvSpPr>
+        <p:spPr>
+          <a:xfrm xmlns:a="http://schemas.openxmlformats.org/drawingml/2006/main">
+            <a:off x="7239000" y="1943100"/>
+            <a:ext cx="3162300" cy="1257300"/>
+          </a:xfrm>
+          <a:prstGeom xmlns:a="http://schemas.openxmlformats.org/drawingml/2006/main" prst="roundRect">
+            <a:avLst>
+              <a:gd name="adj" fmla="val 12121"/>
+            </a:avLst>
+          </a:prstGeom>
+          <a:solidFill xmlns:a="http://schemas.openxmlformats.org/drawingml/2006/main">
+            <a:srgbClr val="FFFFFF"/>
+          </a:solidFill>
+          <a:ln xmlns:a="http://schemas.openxmlformats.org/drawingml/2006/main" w="19050">
+            <a:solidFill>
+              <a:srgbClr val="FF80B8"/>
+            </a:solidFill>
+            <a:prstDash val="solid"/>
+          </a:ln>
+        </p:spPr>
+      </p:sp>
+      <p:sp>
+        <p:nvSpPr>
+          <p:cNvPr id="7" name="">
+            <a:extLst xmlns:a="http://schemas.openxmlformats.org/drawingml/2006/main">
+              <a:ext uri="{FF2B5EF4-FFF2-40B4-BE49-F238E27FC236}">
+                <a16:creationId xmlns:a16="http://schemas.microsoft.com/office/drawing/2014/main" id="{BFA57327-00ED-4AA8-A17A-0175DE5828CC}"/>
+              </a:ext>
+            </a:extLst>
+          </p:cNvPr>
+          <p:cNvSpPr>
+            <a:spLocks xmlns:a="http://schemas.openxmlformats.org/drawingml/2006/main" noGrp="1"/>
+          </p:cNvSpPr>
+          <p:nvPr/>
+        </p:nvSpPr>
+        <p:spPr>
+          <a:xfrm xmlns:a="http://schemas.openxmlformats.org/drawingml/2006/main">
+            <a:off x="7467600" y="2171700"/>
+            <a:ext cx="133350" cy="133350"/>
           </a:xfrm>
           <a:prstGeom xmlns:a="http://schemas.openxmlformats.org/drawingml/2006/main" prst="rect">
             <a:avLst/>
@@ -2109,22 +2325,22 @@
       </p:sp>
       <p:sp>
         <p:nvSpPr>
-          <p:cNvPr id="5" name="">
-            <a:extLst xmlns:a="http://schemas.openxmlformats.org/drawingml/2006/main">
-              <a:ext uri="{FF2B5EF4-FFF2-40B4-BE49-F238E27FC236}">
-                <a16:creationId xmlns:a16="http://schemas.microsoft.com/office/drawing/2014/main" id="{63D9409C-2830-4E1E-9C2F-92D1763F48B0}"/>
-              </a:ext>
-            </a:extLst>
-          </p:cNvPr>
-          <p:cNvSpPr>
-            <a:spLocks xmlns:a="http://schemas.openxmlformats.org/drawingml/2006/main" noGrp="1"/>
-          </p:cNvSpPr>
-          <p:nvPr/>
-        </p:nvSpPr>
-        <p:spPr>
-          <a:xfrm xmlns:a="http://schemas.openxmlformats.org/drawingml/2006/main">
-            <a:off x="8077200" y="3143250"/>
-            <a:ext cx="3238500" cy="323850"/>
+          <p:cNvPr id="8" name="">
+            <a:extLst xmlns:a="http://schemas.openxmlformats.org/drawingml/2006/main">
+              <a:ext uri="{FF2B5EF4-FFF2-40B4-BE49-F238E27FC236}">
+                <a16:creationId xmlns:a16="http://schemas.microsoft.com/office/drawing/2014/main" id="{9AAE03D0-B874-4424-BC06-6CDE78324B56}"/>
+              </a:ext>
+            </a:extLst>
+          </p:cNvPr>
+          <p:cNvSpPr>
+            <a:spLocks xmlns:a="http://schemas.openxmlformats.org/drawingml/2006/main" noGrp="1"/>
+          </p:cNvSpPr>
+          <p:nvPr/>
+        </p:nvSpPr>
+        <p:spPr>
+          <a:xfrm xmlns:a="http://schemas.openxmlformats.org/drawingml/2006/main">
+            <a:off x="7715250" y="2085975"/>
+            <a:ext cx="2190750" cy="323850"/>
           </a:xfrm>
           <a:prstGeom xmlns:a="http://schemas.openxmlformats.org/drawingml/2006/main" prst="rect">
             <a:avLst/>
@@ -2142,39 +2358,136 @@
             <a:pPr>
               <a:defRPr sz="1800" b="1">
                 <a:solidFill>
-                  <a:srgbClr val="2C2348"/>
-                </a:solidFill>
+                  <a:srgbClr val="634893"/>
+                </a:solidFill>
+                <a:latin typeface="Microsoft YaHei"/>
+                <a:ea typeface="Microsoft YaHei"/>
+                <a:cs typeface="Microsoft YaHei"/>
               </a:defRPr>
             </a:pPr>
             <a:r>
               <a:rPr sz="1800" b="1">
                 <a:solidFill>
-                  <a:srgbClr val="2C2348"/>
-                </a:solidFill>
+                  <a:srgbClr val="634893"/>
+                </a:solidFill>
+                <a:latin typeface="Microsoft YaHei"/>
+                <a:ea typeface="Microsoft YaHei"/>
+                <a:cs typeface="Microsoft YaHei"/>
               </a:rPr>
-              <a:t>横版动作</a:t>
+              <a:t>穿越身份</a:t>
             </a:r>
           </a:p>
         </p:txBody>
       </p:sp>
       <p:sp>
         <p:nvSpPr>
-          <p:cNvPr id="6" name="">
-            <a:extLst xmlns:a="http://schemas.openxmlformats.org/drawingml/2006/main">
-              <a:ext uri="{FF2B5EF4-FFF2-40B4-BE49-F238E27FC236}">
-                <a16:creationId xmlns:a16="http://schemas.microsoft.com/office/drawing/2014/main" id="{FA843C70-4A3F-488D-8971-36AA86B7989A}"/>
-              </a:ext>
-            </a:extLst>
-          </p:cNvPr>
-          <p:cNvSpPr>
-            <a:spLocks xmlns:a="http://schemas.openxmlformats.org/drawingml/2006/main" noGrp="1"/>
-          </p:cNvSpPr>
-          <p:nvPr/>
-        </p:nvSpPr>
-        <p:spPr>
-          <a:xfrm xmlns:a="http://schemas.openxmlformats.org/drawingml/2006/main">
-            <a:off x="7848600" y="3810000"/>
-            <a:ext cx="95250" cy="95250"/>
+          <p:cNvPr id="9" name="">
+            <a:extLst xmlns:a="http://schemas.openxmlformats.org/drawingml/2006/main">
+              <a:ext uri="{FF2B5EF4-FFF2-40B4-BE49-F238E27FC236}">
+                <a16:creationId xmlns:a16="http://schemas.microsoft.com/office/drawing/2014/main" id="{C25B0577-0AFC-4E8B-881E-610D1B9D9E7C}"/>
+              </a:ext>
+            </a:extLst>
+          </p:cNvPr>
+          <p:cNvSpPr>
+            <a:spLocks xmlns:a="http://schemas.openxmlformats.org/drawingml/2006/main" noGrp="1"/>
+          </p:cNvSpPr>
+          <p:nvPr/>
+        </p:nvSpPr>
+        <p:spPr>
+          <a:xfrm xmlns:a="http://schemas.openxmlformats.org/drawingml/2006/main">
+            <a:off x="7505700" y="2495550"/>
+            <a:ext cx="2628900" cy="514350"/>
+          </a:xfrm>
+          <a:prstGeom xmlns:a="http://schemas.openxmlformats.org/drawingml/2006/main" prst="rect">
+            <a:avLst/>
+          </a:prstGeom>
+          <a:noFill xmlns:a="http://schemas.openxmlformats.org/drawingml/2006/main"/>
+          <a:ln xmlns:a="http://schemas.openxmlformats.org/drawingml/2006/main" w="0">
+            <a:noFill/>
+            <a:prstDash val="solid"/>
+          </a:ln>
+        </p:spPr>
+        <p:txBody>
+          <a:bodyPr xmlns:a="http://schemas.openxmlformats.org/drawingml/2006/main"/>
+          <a:lstStyle xmlns:a="http://schemas.openxmlformats.org/drawingml/2006/main"/>
+          <a:p xmlns:a="http://schemas.openxmlformats.org/drawingml/2006/main">
+            <a:pPr>
+              <a:defRPr sz="1350">
+                <a:solidFill>
+                  <a:srgbClr val="695F84"/>
+                </a:solidFill>
+                <a:latin typeface="Microsoft YaHei"/>
+                <a:ea typeface="Microsoft YaHei"/>
+                <a:cs typeface="Microsoft YaHei"/>
+              </a:defRPr>
+            </a:pPr>
+            <a:r>
+              <a:rPr sz="1350">
+                <a:solidFill>
+                  <a:srgbClr val="695F84"/>
+                </a:solidFill>
+                <a:latin typeface="Microsoft YaHei"/>
+                <a:ea typeface="Microsoft YaHei"/>
+                <a:cs typeface="Microsoft YaHei"/>
+              </a:rPr>
+              <a:t>现实世界的理工男大学生意外穿越，被糖芯系统误绑定为“见习女仆工程师”。</a:t>
+            </a:r>
+          </a:p>
+        </p:txBody>
+      </p:sp>
+      <p:sp>
+        <p:nvSpPr>
+          <p:cNvPr id="10" name="">
+            <a:extLst xmlns:a="http://schemas.openxmlformats.org/drawingml/2006/main">
+              <a:ext uri="{FF2B5EF4-FFF2-40B4-BE49-F238E27FC236}">
+                <a16:creationId xmlns:a16="http://schemas.microsoft.com/office/drawing/2014/main" id="{B8281D17-57AE-49A6-9B25-8E74F2B31995}"/>
+              </a:ext>
+            </a:extLst>
+          </p:cNvPr>
+          <p:cNvSpPr>
+            <a:spLocks xmlns:a="http://schemas.openxmlformats.org/drawingml/2006/main" noGrp="1"/>
+          </p:cNvSpPr>
+          <p:nvPr/>
+        </p:nvSpPr>
+        <p:spPr>
+          <a:xfrm xmlns:a="http://schemas.openxmlformats.org/drawingml/2006/main">
+            <a:off x="7239000" y="3181350"/>
+            <a:ext cx="3162300" cy="1257300"/>
+          </a:xfrm>
+          <a:prstGeom xmlns:a="http://schemas.openxmlformats.org/drawingml/2006/main" prst="roundRect">
+            <a:avLst>
+              <a:gd name="adj" fmla="val 12121"/>
+            </a:avLst>
+          </a:prstGeom>
+          <a:solidFill xmlns:a="http://schemas.openxmlformats.org/drawingml/2006/main">
+            <a:srgbClr val="FFFFFF"/>
+          </a:solidFill>
+          <a:ln xmlns:a="http://schemas.openxmlformats.org/drawingml/2006/main" w="19050">
+            <a:solidFill>
+              <a:srgbClr val="74CDFF"/>
+            </a:solidFill>
+            <a:prstDash val="solid"/>
+          </a:ln>
+        </p:spPr>
+      </p:sp>
+      <p:sp>
+        <p:nvSpPr>
+          <p:cNvPr id="11" name="">
+            <a:extLst xmlns:a="http://schemas.openxmlformats.org/drawingml/2006/main">
+              <a:ext uri="{FF2B5EF4-FFF2-40B4-BE49-F238E27FC236}">
+                <a16:creationId xmlns:a16="http://schemas.microsoft.com/office/drawing/2014/main" id="{C16F0772-E5D7-4AF8-9FE8-B109BC8746E4}"/>
+              </a:ext>
+            </a:extLst>
+          </p:cNvPr>
+          <p:cNvSpPr>
+            <a:spLocks xmlns:a="http://schemas.openxmlformats.org/drawingml/2006/main" noGrp="1"/>
+          </p:cNvSpPr>
+          <p:nvPr/>
+        </p:nvSpPr>
+        <p:spPr>
+          <a:xfrm xmlns:a="http://schemas.openxmlformats.org/drawingml/2006/main">
+            <a:off x="7467600" y="3409950"/>
+            <a:ext cx="133350" cy="133350"/>
           </a:xfrm>
           <a:prstGeom xmlns:a="http://schemas.openxmlformats.org/drawingml/2006/main" prst="rect">
             <a:avLst/>
@@ -2190,22 +2503,22 @@
       </p:sp>
       <p:sp>
         <p:nvSpPr>
-          <p:cNvPr id="7" name="">
-            <a:extLst xmlns:a="http://schemas.openxmlformats.org/drawingml/2006/main">
-              <a:ext uri="{FF2B5EF4-FFF2-40B4-BE49-F238E27FC236}">
-                <a16:creationId xmlns:a16="http://schemas.microsoft.com/office/drawing/2014/main" id="{40348008-E664-4CA1-A665-ABE0EE1A77DA}"/>
-              </a:ext>
-            </a:extLst>
-          </p:cNvPr>
-          <p:cNvSpPr>
-            <a:spLocks xmlns:a="http://schemas.openxmlformats.org/drawingml/2006/main" noGrp="1"/>
-          </p:cNvSpPr>
-          <p:nvPr/>
-        </p:nvSpPr>
-        <p:spPr>
-          <a:xfrm xmlns:a="http://schemas.openxmlformats.org/drawingml/2006/main">
-            <a:off x="8077200" y="3733800"/>
-            <a:ext cx="3238500" cy="323850"/>
+          <p:cNvPr id="12" name="">
+            <a:extLst xmlns:a="http://schemas.openxmlformats.org/drawingml/2006/main">
+              <a:ext uri="{FF2B5EF4-FFF2-40B4-BE49-F238E27FC236}">
+                <a16:creationId xmlns:a16="http://schemas.microsoft.com/office/drawing/2014/main" id="{EB2F3DE7-0143-49FC-97D7-74A01D055519}"/>
+              </a:ext>
+            </a:extLst>
+          </p:cNvPr>
+          <p:cNvSpPr>
+            <a:spLocks xmlns:a="http://schemas.openxmlformats.org/drawingml/2006/main" noGrp="1"/>
+          </p:cNvSpPr>
+          <p:nvPr/>
+        </p:nvSpPr>
+        <p:spPr>
+          <a:xfrm xmlns:a="http://schemas.openxmlformats.org/drawingml/2006/main">
+            <a:off x="7715250" y="3324225"/>
+            <a:ext cx="2190750" cy="323850"/>
           </a:xfrm>
           <a:prstGeom xmlns:a="http://schemas.openxmlformats.org/drawingml/2006/main" prst="rect">
             <a:avLst/>
@@ -2223,70 +2536,167 @@
             <a:pPr>
               <a:defRPr sz="1800" b="1">
                 <a:solidFill>
-                  <a:srgbClr val="2C2348"/>
-                </a:solidFill>
+                  <a:srgbClr val="634893"/>
+                </a:solidFill>
+                <a:latin typeface="Microsoft YaHei"/>
+                <a:ea typeface="Microsoft YaHei"/>
+                <a:cs typeface="Microsoft YaHei"/>
               </a:defRPr>
             </a:pPr>
             <a:r>
               <a:rPr sz="1800" b="1">
                 <a:solidFill>
-                  <a:srgbClr val="2C2348"/>
-                </a:solidFill>
+                  <a:srgbClr val="634893"/>
+                </a:solidFill>
+                <a:latin typeface="Microsoft YaHei"/>
+                <a:ea typeface="Microsoft YaHei"/>
+                <a:cs typeface="Microsoft YaHei"/>
               </a:rPr>
-              <a:t>房间推进</a:t>
+              <a:t>糖果规则</a:t>
             </a:r>
           </a:p>
         </p:txBody>
       </p:sp>
       <p:sp>
         <p:nvSpPr>
-          <p:cNvPr id="8" name="">
-            <a:extLst xmlns:a="http://schemas.openxmlformats.org/drawingml/2006/main">
-              <a:ext uri="{FF2B5EF4-FFF2-40B4-BE49-F238E27FC236}">
-                <a16:creationId xmlns:a16="http://schemas.microsoft.com/office/drawing/2014/main" id="{9D00E0EA-4311-4200-A1A8-BFF760D73E0B}"/>
-              </a:ext>
-            </a:extLst>
-          </p:cNvPr>
-          <p:cNvSpPr>
-            <a:spLocks xmlns:a="http://schemas.openxmlformats.org/drawingml/2006/main" noGrp="1"/>
-          </p:cNvSpPr>
-          <p:nvPr/>
-        </p:nvSpPr>
-        <p:spPr>
-          <a:xfrm xmlns:a="http://schemas.openxmlformats.org/drawingml/2006/main">
-            <a:off x="7848600" y="4400550"/>
-            <a:ext cx="95250" cy="95250"/>
-          </a:xfrm>
-          <a:prstGeom xmlns:a="http://schemas.openxmlformats.org/drawingml/2006/main" prst="rect">
-            <a:avLst/>
+          <p:cNvPr id="13" name="">
+            <a:extLst xmlns:a="http://schemas.openxmlformats.org/drawingml/2006/main">
+              <a:ext uri="{FF2B5EF4-FFF2-40B4-BE49-F238E27FC236}">
+                <a16:creationId xmlns:a16="http://schemas.microsoft.com/office/drawing/2014/main" id="{AF06C340-C85A-4E82-9521-07EC20C9E907}"/>
+              </a:ext>
+            </a:extLst>
+          </p:cNvPr>
+          <p:cNvSpPr>
+            <a:spLocks xmlns:a="http://schemas.openxmlformats.org/drawingml/2006/main" noGrp="1"/>
+          </p:cNvSpPr>
+          <p:nvPr/>
+        </p:nvSpPr>
+        <p:spPr>
+          <a:xfrm xmlns:a="http://schemas.openxmlformats.org/drawingml/2006/main">
+            <a:off x="7505700" y="3733800"/>
+            <a:ext cx="2628900" cy="514350"/>
+          </a:xfrm>
+          <a:prstGeom xmlns:a="http://schemas.openxmlformats.org/drawingml/2006/main" prst="rect">
+            <a:avLst/>
+          </a:prstGeom>
+          <a:noFill xmlns:a="http://schemas.openxmlformats.org/drawingml/2006/main"/>
+          <a:ln xmlns:a="http://schemas.openxmlformats.org/drawingml/2006/main" w="0">
+            <a:noFill/>
+            <a:prstDash val="solid"/>
+          </a:ln>
+        </p:spPr>
+        <p:txBody>
+          <a:bodyPr xmlns:a="http://schemas.openxmlformats.org/drawingml/2006/main"/>
+          <a:lstStyle xmlns:a="http://schemas.openxmlformats.org/drawingml/2006/main"/>
+          <a:p xmlns:a="http://schemas.openxmlformats.org/drawingml/2006/main">
+            <a:pPr>
+              <a:defRPr sz="1350">
+                <a:solidFill>
+                  <a:srgbClr val="695F84"/>
+                </a:solidFill>
+                <a:latin typeface="Microsoft YaHei"/>
+                <a:ea typeface="Microsoft YaHei"/>
+                <a:cs typeface="Microsoft YaHei"/>
+              </a:defRPr>
+            </a:pPr>
+            <a:r>
+              <a:rPr sz="1350">
+                <a:solidFill>
+                  <a:srgbClr val="695F84"/>
+                </a:solidFill>
+                <a:latin typeface="Microsoft YaHei"/>
+                <a:ea typeface="Microsoft YaHei"/>
+                <a:cs typeface="Microsoft YaHei"/>
+              </a:rPr>
+              <a:t>甜点不是食物，而是能源、武器、材料和技能。怪物掉落材料可合成装备与道具。</a:t>
+            </a:r>
+          </a:p>
+        </p:txBody>
+      </p:sp>
+      <p:sp>
+        <p:nvSpPr>
+          <p:cNvPr id="14" name="">
+            <a:extLst xmlns:a="http://schemas.openxmlformats.org/drawingml/2006/main">
+              <a:ext uri="{FF2B5EF4-FFF2-40B4-BE49-F238E27FC236}">
+                <a16:creationId xmlns:a16="http://schemas.microsoft.com/office/drawing/2014/main" id="{F89F8167-BE3C-41EE-B552-71981E402483}"/>
+              </a:ext>
+            </a:extLst>
+          </p:cNvPr>
+          <p:cNvSpPr>
+            <a:spLocks xmlns:a="http://schemas.openxmlformats.org/drawingml/2006/main" noGrp="1"/>
+          </p:cNvSpPr>
+          <p:nvPr/>
+        </p:nvSpPr>
+        <p:spPr>
+          <a:xfrm xmlns:a="http://schemas.openxmlformats.org/drawingml/2006/main">
+            <a:off x="7239000" y="4419600"/>
+            <a:ext cx="3162300" cy="1257300"/>
+          </a:xfrm>
+          <a:prstGeom xmlns:a="http://schemas.openxmlformats.org/drawingml/2006/main" prst="roundRect">
+            <a:avLst>
+              <a:gd name="adj" fmla="val 12121"/>
+            </a:avLst>
           </a:prstGeom>
           <a:solidFill xmlns:a="http://schemas.openxmlformats.org/drawingml/2006/main">
-            <a:srgbClr val="634893"/>
+            <a:srgbClr val="FFFFFF"/>
           </a:solidFill>
-          <a:ln xmlns:a="http://schemas.openxmlformats.org/drawingml/2006/main" w="0">
-            <a:noFill/>
-            <a:prstDash val="solid"/>
-          </a:ln>
-        </p:spPr>
-      </p:sp>
-      <p:sp>
-        <p:nvSpPr>
-          <p:cNvPr id="9" name="">
-            <a:extLst xmlns:a="http://schemas.openxmlformats.org/drawingml/2006/main">
-              <a:ext uri="{FF2B5EF4-FFF2-40B4-BE49-F238E27FC236}">
-                <a16:creationId xmlns:a16="http://schemas.microsoft.com/office/drawing/2014/main" id="{CA6345C8-5CDE-41DD-BE3E-F1B4C46F0D07}"/>
-              </a:ext>
-            </a:extLst>
-          </p:cNvPr>
-          <p:cNvSpPr>
-            <a:spLocks xmlns:a="http://schemas.openxmlformats.org/drawingml/2006/main" noGrp="1"/>
-          </p:cNvSpPr>
-          <p:nvPr/>
-        </p:nvSpPr>
-        <p:spPr>
-          <a:xfrm xmlns:a="http://schemas.openxmlformats.org/drawingml/2006/main">
-            <a:off x="8077200" y="4324350"/>
-            <a:ext cx="3238500" cy="323850"/>
+          <a:ln xmlns:a="http://schemas.openxmlformats.org/drawingml/2006/main" w="19050">
+            <a:solidFill>
+              <a:srgbClr val="7FE3B4"/>
+            </a:solidFill>
+            <a:prstDash val="solid"/>
+          </a:ln>
+        </p:spPr>
+      </p:sp>
+      <p:sp>
+        <p:nvSpPr>
+          <p:cNvPr id="15" name="">
+            <a:extLst xmlns:a="http://schemas.openxmlformats.org/drawingml/2006/main">
+              <a:ext uri="{FF2B5EF4-FFF2-40B4-BE49-F238E27FC236}">
+                <a16:creationId xmlns:a16="http://schemas.microsoft.com/office/drawing/2014/main" id="{597BDA47-6779-4461-8763-35F0FEE1E6EB}"/>
+              </a:ext>
+            </a:extLst>
+          </p:cNvPr>
+          <p:cNvSpPr>
+            <a:spLocks xmlns:a="http://schemas.openxmlformats.org/drawingml/2006/main" noGrp="1"/>
+          </p:cNvSpPr>
+          <p:nvPr/>
+        </p:nvSpPr>
+        <p:spPr>
+          <a:xfrm xmlns:a="http://schemas.openxmlformats.org/drawingml/2006/main">
+            <a:off x="7467600" y="4648200"/>
+            <a:ext cx="133350" cy="133350"/>
+          </a:xfrm>
+          <a:prstGeom xmlns:a="http://schemas.openxmlformats.org/drawingml/2006/main" prst="rect">
+            <a:avLst/>
+          </a:prstGeom>
+          <a:solidFill xmlns:a="http://schemas.openxmlformats.org/drawingml/2006/main">
+            <a:srgbClr val="7FE3B4"/>
+          </a:solidFill>
+          <a:ln xmlns:a="http://schemas.openxmlformats.org/drawingml/2006/main" w="0">
+            <a:noFill/>
+            <a:prstDash val="solid"/>
+          </a:ln>
+        </p:spPr>
+      </p:sp>
+      <p:sp>
+        <p:nvSpPr>
+          <p:cNvPr id="16" name="">
+            <a:extLst xmlns:a="http://schemas.openxmlformats.org/drawingml/2006/main">
+              <a:ext uri="{FF2B5EF4-FFF2-40B4-BE49-F238E27FC236}">
+                <a16:creationId xmlns:a16="http://schemas.microsoft.com/office/drawing/2014/main" id="{8A8F7FAA-5111-47DF-AB45-1870F2246A98}"/>
+              </a:ext>
+            </a:extLst>
+          </p:cNvPr>
+          <p:cNvSpPr>
+            <a:spLocks xmlns:a="http://schemas.openxmlformats.org/drawingml/2006/main" noGrp="1"/>
+          </p:cNvSpPr>
+          <p:nvPr/>
+        </p:nvSpPr>
+        <p:spPr>
+          <a:xfrm xmlns:a="http://schemas.openxmlformats.org/drawingml/2006/main">
+            <a:off x="7715250" y="4562475"/>
+            <a:ext cx="2190750" cy="323850"/>
           </a:xfrm>
           <a:prstGeom xmlns:a="http://schemas.openxmlformats.org/drawingml/2006/main" prst="rect">
             <a:avLst/>
@@ -2304,27 +2714,89 @@
             <a:pPr>
               <a:defRPr sz="1800" b="1">
                 <a:solidFill>
-                  <a:srgbClr val="2C2348"/>
-                </a:solidFill>
+                  <a:srgbClr val="634893"/>
+                </a:solidFill>
+                <a:latin typeface="Microsoft YaHei"/>
+                <a:ea typeface="Microsoft YaHei"/>
+                <a:cs typeface="Microsoft YaHei"/>
               </a:defRPr>
             </a:pPr>
             <a:r>
               <a:rPr sz="1800" b="1">
                 <a:solidFill>
-                  <a:srgbClr val="2C2348"/>
-                </a:solidFill>
+                  <a:srgbClr val="634893"/>
+                </a:solidFill>
+                <a:latin typeface="Microsoft YaHei"/>
+                <a:ea typeface="Microsoft YaHei"/>
+                <a:cs typeface="Microsoft YaHei"/>
               </a:rPr>
-              <a:t>AI 记忆日志</a:t>
+              <a:t>回家目标</a:t>
             </a:r>
           </a:p>
         </p:txBody>
       </p:sp>
       <p:sp>
         <p:nvSpPr>
-          <p:cNvPr id="10" name="">
-            <a:extLst xmlns:a="http://schemas.openxmlformats.org/drawingml/2006/main">
-              <a:ext uri="{FF2B5EF4-FFF2-40B4-BE49-F238E27FC236}">
-                <a16:creationId xmlns:a16="http://schemas.microsoft.com/office/drawing/2014/main" id="{8C40C61D-31C3-42AC-B3CD-76E05BE01675}"/>
+          <p:cNvPr id="17" name="">
+            <a:extLst xmlns:a="http://schemas.openxmlformats.org/drawingml/2006/main">
+              <a:ext uri="{FF2B5EF4-FFF2-40B4-BE49-F238E27FC236}">
+                <a16:creationId xmlns:a16="http://schemas.microsoft.com/office/drawing/2014/main" id="{70FCA719-4258-40AD-8262-60E8ED6F3BCF}"/>
+              </a:ext>
+            </a:extLst>
+          </p:cNvPr>
+          <p:cNvSpPr>
+            <a:spLocks xmlns:a="http://schemas.openxmlformats.org/drawingml/2006/main" noGrp="1"/>
+          </p:cNvSpPr>
+          <p:nvPr/>
+        </p:nvSpPr>
+        <p:spPr>
+          <a:xfrm xmlns:a="http://schemas.openxmlformats.org/drawingml/2006/main">
+            <a:off x="7505700" y="4972050"/>
+            <a:ext cx="2628900" cy="514350"/>
+          </a:xfrm>
+          <a:prstGeom xmlns:a="http://schemas.openxmlformats.org/drawingml/2006/main" prst="rect">
+            <a:avLst/>
+          </a:prstGeom>
+          <a:noFill xmlns:a="http://schemas.openxmlformats.org/drawingml/2006/main"/>
+          <a:ln xmlns:a="http://schemas.openxmlformats.org/drawingml/2006/main" w="0">
+            <a:noFill/>
+            <a:prstDash val="solid"/>
+          </a:ln>
+        </p:spPr>
+        <p:txBody>
+          <a:bodyPr xmlns:a="http://schemas.openxmlformats.org/drawingml/2006/main"/>
+          <a:lstStyle xmlns:a="http://schemas.openxmlformats.org/drawingml/2006/main"/>
+          <a:p xmlns:a="http://schemas.openxmlformats.org/drawingml/2006/main">
+            <a:pPr>
+              <a:defRPr sz="1350">
+                <a:solidFill>
+                  <a:srgbClr val="695F84"/>
+                </a:solidFill>
+                <a:latin typeface="Microsoft YaHei"/>
+                <a:ea typeface="Microsoft YaHei"/>
+                <a:cs typeface="Microsoft YaHei"/>
+              </a:defRPr>
+            </a:pPr>
+            <a:r>
+              <a:rPr sz="1350">
+                <a:solidFill>
+                  <a:srgbClr val="695F84"/>
+                </a:solidFill>
+                <a:latin typeface="Microsoft YaHei"/>
+                <a:ea typeface="Microsoft YaHei"/>
+                <a:cs typeface="Microsoft YaHei"/>
+              </a:rPr>
+              <a:t>修复糖芯传送装置，击败污染糖芯炉的糖蚀巫师，重新打开回到现实世界的传送门。</a:t>
+            </a:r>
+          </a:p>
+        </p:txBody>
+      </p:sp>
+      <p:sp>
+        <p:nvSpPr>
+          <p:cNvPr id="18" name="">
+            <a:extLst xmlns:a="http://schemas.openxmlformats.org/drawingml/2006/main">
+              <a:ext uri="{FF2B5EF4-FFF2-40B4-BE49-F238E27FC236}">
+                <a16:creationId xmlns:a16="http://schemas.microsoft.com/office/drawing/2014/main" id="{85B834C2-E08D-43F3-9C49-E6C21C233BEB}"/>
               </a:ext>
             </a:extLst>
           </p:cNvPr>
@@ -2356,6 +2828,9 @@
                 <a:solidFill>
                   <a:srgbClr val="FF80B8"/>
                 </a:solidFill>
+                <a:latin typeface="Microsoft YaHei"/>
+                <a:ea typeface="Microsoft YaHei"/>
+                <a:cs typeface="Microsoft YaHei"/>
               </a:defRPr>
             </a:pPr>
             <a:r>
@@ -2363,18 +2838,21 @@
                 <a:solidFill>
                   <a:srgbClr val="FF80B8"/>
                 </a:solidFill>
+                <a:latin typeface="Microsoft YaHei"/>
+                <a:ea typeface="Microsoft YaHei"/>
+                <a:cs typeface="Microsoft YaHei"/>
               </a:rPr>
-              <a:t>02 / 07</a:t>
+              <a:t>02 / 08</a:t>
             </a:r>
           </a:p>
         </p:txBody>
       </p:sp>
       <p:sp>
         <p:nvSpPr>
-          <p:cNvPr id="11" name="">
-            <a:extLst xmlns:a="http://schemas.openxmlformats.org/drawingml/2006/main">
-              <a:ext uri="{FF2B5EF4-FFF2-40B4-BE49-F238E27FC236}">
-                <a16:creationId xmlns:a16="http://schemas.microsoft.com/office/drawing/2014/main" id="{F9E929E4-299A-49A5-8B0F-D7BE8E67589C}"/>
+          <p:cNvPr id="19" name="">
+            <a:extLst xmlns:a="http://schemas.openxmlformats.org/drawingml/2006/main">
+              <a:ext uri="{FF2B5EF4-FFF2-40B4-BE49-F238E27FC236}">
+                <a16:creationId xmlns:a16="http://schemas.microsoft.com/office/drawing/2014/main" id="{A2F244D8-1C30-4EDB-9665-B15C33AB7BDC}"/>
               </a:ext>
             </a:extLst>
           </p:cNvPr>
@@ -2386,7 +2864,7 @@
         <p:spPr>
           <a:xfrm xmlns:a="http://schemas.openxmlformats.org/drawingml/2006/main">
             <a:off x="1428750" y="6515100"/>
-            <a:ext cx="4191000" cy="209550"/>
+            <a:ext cx="4381500" cy="209550"/>
           </a:xfrm>
           <a:prstGeom xmlns:a="http://schemas.openxmlformats.org/drawingml/2006/main" prst="rect">
             <a:avLst/>
@@ -2406,6 +2884,9 @@
                 <a:solidFill>
                   <a:srgbClr val="695F84"/>
                 </a:solidFill>
+                <a:latin typeface="Microsoft YaHei"/>
+                <a:ea typeface="Microsoft YaHei"/>
+                <a:cs typeface="Microsoft YaHei"/>
               </a:defRPr>
             </a:pPr>
             <a:r>
@@ -2413,8 +2894,11 @@
                 <a:solidFill>
                   <a:srgbClr val="695F84"/>
                 </a:solidFill>
+                <a:latin typeface="Microsoft YaHei"/>
+                <a:ea typeface="Microsoft YaHei"/>
+                <a:cs typeface="Microsoft YaHei"/>
               </a:rPr>
-              <a:t>能工智人：遗忘工坊 | 落云宗：秦天 / 陈磊</a:t>
+              <a:t>能工智人：糖芯工坊 | 落云宗：秦天 / 陈磊</a:t>
             </a:r>
           </a:p>
         </p:txBody>
@@ -2422,7 +2906,7 @@
     </p:spTree>
     <p:extLst>
       <p:ext uri="{BB962C8B-B14F-4D97-AF65-F5344CB8AC3E}">
-        <p14:creationId xmlns:p14="http://schemas.microsoft.com/office/powerpoint/2010/main" val="1947876207"/>
+        <p14:creationId xmlns:p14="http://schemas.microsoft.com/office/powerpoint/2010/main" val="320877088"/>
       </p:ext>
     </p:extLst>
   </p:cSld>
@@ -2430,6 +2914,545 @@
 </file>
 
 <file path=ppt/slides/slide3.xml><?xml version="1.0" encoding="utf-8"?>
+<p:sld xmlns:p="http://schemas.openxmlformats.org/presentationml/2006/main">
+  <p:cSld>
+    <p:bg>
+      <p:bgPr>
+        <a:solidFill xmlns:a="http://schemas.openxmlformats.org/drawingml/2006/main">
+          <a:srgbClr val="FFF8FD"/>
+        </a:solidFill>
+      </p:bgPr>
+    </p:bg>
+    <p:spTree>
+      <p:nvGrpSpPr>
+        <p:cNvPr id="1" name=""/>
+        <p:cNvGrpSpPr/>
+        <p:nvPr/>
+      </p:nvGrpSpPr>
+      <p:grpSpPr>
+        <a:xfrm xmlns:a="http://schemas.openxmlformats.org/drawingml/2006/main"/>
+      </p:grpSpPr>
+      <p:pic>
+        <p:nvPicPr>
+          <p:cNvPr id="12" name=""/>
+          <p:cNvPicPr>
+            <a:picLocks xmlns:a="http://schemas.openxmlformats.org/drawingml/2006/main" noChangeAspect="1"/>
+          </p:cNvPicPr>
+          <p:nvPr/>
+        </p:nvPicPr>
+        <p:blipFill>
+          <a:blip xmlns:r="http://schemas.openxmlformats.org/officeDocument/2006/relationships" xmlns:a="http://schemas.openxmlformats.org/drawingml/2006/main" r:embed="Rf8c5c7d86e60417b"/>
+          <a:srcRect xmlns:a="http://schemas.openxmlformats.org/drawingml/2006/main" l="8984" t="0" r="8984" b="0"/>
+          <a:stretch xmlns:a="http://schemas.openxmlformats.org/drawingml/2006/main">
+            <a:fillRect l="0" t="0" r="0" b="0"/>
+          </a:stretch>
+        </p:blipFill>
+        <p:spPr>
+          <a:xfrm xmlns:a="http://schemas.openxmlformats.org/drawingml/2006/main">
+            <a:off x="514350" y="914400"/>
+            <a:ext cx="6667500" cy="4572000"/>
+          </a:xfrm>
+          <a:prstGeom xmlns:a="http://schemas.openxmlformats.org/drawingml/2006/main" prst="rect">
+            <a:avLst/>
+          </a:prstGeom>
+        </p:spPr>
+      </p:pic>
+      <p:sp>
+        <p:nvSpPr>
+          <p:cNvPr id="2" name="">
+            <a:extLst xmlns:a="http://schemas.openxmlformats.org/drawingml/2006/main">
+              <a:ext uri="{FF2B5EF4-FFF2-40B4-BE49-F238E27FC236}">
+                <a16:creationId xmlns:a16="http://schemas.microsoft.com/office/drawing/2014/main" id="{212331CC-EB1B-44DE-9FA9-D05DFD2EEDB3}"/>
+              </a:ext>
+            </a:extLst>
+          </p:cNvPr>
+          <p:cNvSpPr>
+            <a:spLocks xmlns:a="http://schemas.openxmlformats.org/drawingml/2006/main" noGrp="1"/>
+          </p:cNvSpPr>
+          <p:nvPr/>
+        </p:nvSpPr>
+        <p:spPr>
+          <a:xfrm xmlns:a="http://schemas.openxmlformats.org/drawingml/2006/main">
+            <a:off x="7810500" y="1047750"/>
+            <a:ext cx="3048000" cy="552450"/>
+          </a:xfrm>
+          <a:prstGeom xmlns:a="http://schemas.openxmlformats.org/drawingml/2006/main" prst="rect">
+            <a:avLst/>
+          </a:prstGeom>
+          <a:noFill xmlns:a="http://schemas.openxmlformats.org/drawingml/2006/main"/>
+          <a:ln xmlns:a="http://schemas.openxmlformats.org/drawingml/2006/main" w="0">
+            <a:noFill/>
+            <a:prstDash val="solid"/>
+          </a:ln>
+        </p:spPr>
+        <p:txBody>
+          <a:bodyPr xmlns:a="http://schemas.openxmlformats.org/drawingml/2006/main"/>
+          <a:lstStyle xmlns:a="http://schemas.openxmlformats.org/drawingml/2006/main"/>
+          <a:p xmlns:a="http://schemas.openxmlformats.org/drawingml/2006/main">
+            <a:pPr>
+              <a:defRPr sz="3300" b="1">
+                <a:solidFill>
+                  <a:srgbClr val="2C2348"/>
+                </a:solidFill>
+                <a:latin typeface="Microsoft YaHei"/>
+                <a:ea typeface="Microsoft YaHei"/>
+                <a:cs typeface="Microsoft YaHei"/>
+              </a:defRPr>
+            </a:pPr>
+            <a:r>
+              <a:rPr sz="3300" b="1">
+                <a:solidFill>
+                  <a:srgbClr val="2C2348"/>
+                </a:solidFill>
+                <a:latin typeface="Microsoft YaHei"/>
+                <a:ea typeface="Microsoft YaHei"/>
+                <a:cs typeface="Microsoft YaHei"/>
+              </a:rPr>
+              <a:t>游戏是什么</a:t>
+            </a:r>
+          </a:p>
+        </p:txBody>
+      </p:sp>
+      <p:sp>
+        <p:nvSpPr>
+          <p:cNvPr id="3" name="">
+            <a:extLst xmlns:a="http://schemas.openxmlformats.org/drawingml/2006/main">
+              <a:ext uri="{FF2B5EF4-FFF2-40B4-BE49-F238E27FC236}">
+                <a16:creationId xmlns:a16="http://schemas.microsoft.com/office/drawing/2014/main" id="{64069AA0-B976-4354-BFEA-58D9C502217E}"/>
+              </a:ext>
+            </a:extLst>
+          </p:cNvPr>
+          <p:cNvSpPr>
+            <a:spLocks xmlns:a="http://schemas.openxmlformats.org/drawingml/2006/main" noGrp="1"/>
+          </p:cNvSpPr>
+          <p:nvPr/>
+        </p:nvSpPr>
+        <p:spPr>
+          <a:xfrm xmlns:a="http://schemas.openxmlformats.org/drawingml/2006/main">
+            <a:off x="7829550" y="1752600"/>
+            <a:ext cx="3238500" cy="990600"/>
+          </a:xfrm>
+          <a:prstGeom xmlns:a="http://schemas.openxmlformats.org/drawingml/2006/main" prst="rect">
+            <a:avLst/>
+          </a:prstGeom>
+          <a:noFill xmlns:a="http://schemas.openxmlformats.org/drawingml/2006/main"/>
+          <a:ln xmlns:a="http://schemas.openxmlformats.org/drawingml/2006/main" w="0">
+            <a:noFill/>
+            <a:prstDash val="solid"/>
+          </a:ln>
+        </p:spPr>
+        <p:txBody>
+          <a:bodyPr xmlns:a="http://schemas.openxmlformats.org/drawingml/2006/main"/>
+          <a:lstStyle xmlns:a="http://schemas.openxmlformats.org/drawingml/2006/main"/>
+          <a:p xmlns:a="http://schemas.openxmlformats.org/drawingml/2006/main">
+            <a:pPr>
+              <a:defRPr sz="1650">
+                <a:solidFill>
+                  <a:srgbClr val="695F84"/>
+                </a:solidFill>
+                <a:latin typeface="Microsoft YaHei"/>
+                <a:ea typeface="Microsoft YaHei"/>
+                <a:cs typeface="Microsoft YaHei"/>
+              </a:defRPr>
+            </a:pPr>
+            <a:r>
+              <a:rPr sz="1650">
+                <a:solidFill>
+                  <a:srgbClr val="695F84"/>
+                </a:solidFill>
+                <a:latin typeface="Microsoft YaHei"/>
+                <a:ea typeface="Microsoft YaHei"/>
+                <a:cs typeface="Microsoft YaHei"/>
+              </a:rPr>
+              <a:t>玩家在糖果异世界中推进房间，一边移动、跳跃和战斗，一边读取糖芯工坊日志寻找回家的线索。</a:t>
+            </a:r>
+          </a:p>
+        </p:txBody>
+      </p:sp>
+      <p:sp>
+        <p:nvSpPr>
+          <p:cNvPr id="4" name="">
+            <a:extLst xmlns:a="http://schemas.openxmlformats.org/drawingml/2006/main">
+              <a:ext uri="{FF2B5EF4-FFF2-40B4-BE49-F238E27FC236}">
+                <a16:creationId xmlns:a16="http://schemas.microsoft.com/office/drawing/2014/main" id="{0CEDD4CB-0E32-447C-91E5-D801FF326B7A}"/>
+              </a:ext>
+            </a:extLst>
+          </p:cNvPr>
+          <p:cNvSpPr>
+            <a:spLocks xmlns:a="http://schemas.openxmlformats.org/drawingml/2006/main" noGrp="1"/>
+          </p:cNvSpPr>
+          <p:nvPr/>
+        </p:nvSpPr>
+        <p:spPr>
+          <a:xfrm xmlns:a="http://schemas.openxmlformats.org/drawingml/2006/main">
+            <a:off x="7848600" y="3219450"/>
+            <a:ext cx="95250" cy="95250"/>
+          </a:xfrm>
+          <a:prstGeom xmlns:a="http://schemas.openxmlformats.org/drawingml/2006/main" prst="rect">
+            <a:avLst/>
+          </a:prstGeom>
+          <a:solidFill xmlns:a="http://schemas.openxmlformats.org/drawingml/2006/main">
+            <a:srgbClr val="FF80B8"/>
+          </a:solidFill>
+          <a:ln xmlns:a="http://schemas.openxmlformats.org/drawingml/2006/main" w="0">
+            <a:noFill/>
+            <a:prstDash val="solid"/>
+          </a:ln>
+        </p:spPr>
+      </p:sp>
+      <p:sp>
+        <p:nvSpPr>
+          <p:cNvPr id="5" name="">
+            <a:extLst xmlns:a="http://schemas.openxmlformats.org/drawingml/2006/main">
+              <a:ext uri="{FF2B5EF4-FFF2-40B4-BE49-F238E27FC236}">
+                <a16:creationId xmlns:a16="http://schemas.microsoft.com/office/drawing/2014/main" id="{56A8A1F3-2041-4BA2-97F5-78F271E7CB51}"/>
+              </a:ext>
+            </a:extLst>
+          </p:cNvPr>
+          <p:cNvSpPr>
+            <a:spLocks xmlns:a="http://schemas.openxmlformats.org/drawingml/2006/main" noGrp="1"/>
+          </p:cNvSpPr>
+          <p:nvPr/>
+        </p:nvSpPr>
+        <p:spPr>
+          <a:xfrm xmlns:a="http://schemas.openxmlformats.org/drawingml/2006/main">
+            <a:off x="8077200" y="3143250"/>
+            <a:ext cx="3429000" cy="323850"/>
+          </a:xfrm>
+          <a:prstGeom xmlns:a="http://schemas.openxmlformats.org/drawingml/2006/main" prst="rect">
+            <a:avLst/>
+          </a:prstGeom>
+          <a:noFill xmlns:a="http://schemas.openxmlformats.org/drawingml/2006/main"/>
+          <a:ln xmlns:a="http://schemas.openxmlformats.org/drawingml/2006/main" w="0">
+            <a:noFill/>
+            <a:prstDash val="solid"/>
+          </a:ln>
+        </p:spPr>
+        <p:txBody>
+          <a:bodyPr xmlns:a="http://schemas.openxmlformats.org/drawingml/2006/main"/>
+          <a:lstStyle xmlns:a="http://schemas.openxmlformats.org/drawingml/2006/main"/>
+          <a:p xmlns:a="http://schemas.openxmlformats.org/drawingml/2006/main">
+            <a:pPr>
+              <a:defRPr sz="1800" b="1">
+                <a:solidFill>
+                  <a:srgbClr val="2C2348"/>
+                </a:solidFill>
+                <a:latin typeface="Microsoft YaHei"/>
+                <a:ea typeface="Microsoft YaHei"/>
+                <a:cs typeface="Microsoft YaHei"/>
+              </a:defRPr>
+            </a:pPr>
+            <a:r>
+              <a:rPr sz="1800" b="1">
+                <a:solidFill>
+                  <a:srgbClr val="2C2348"/>
+                </a:solidFill>
+                <a:latin typeface="Microsoft YaHei"/>
+                <a:ea typeface="Microsoft YaHei"/>
+                <a:cs typeface="Microsoft YaHei"/>
+              </a:rPr>
+              <a:t>横版动作</a:t>
+            </a:r>
+          </a:p>
+        </p:txBody>
+      </p:sp>
+      <p:sp>
+        <p:nvSpPr>
+          <p:cNvPr id="6" name="">
+            <a:extLst xmlns:a="http://schemas.openxmlformats.org/drawingml/2006/main">
+              <a:ext uri="{FF2B5EF4-FFF2-40B4-BE49-F238E27FC236}">
+                <a16:creationId xmlns:a16="http://schemas.microsoft.com/office/drawing/2014/main" id="{83450964-2BBF-4E88-A9A3-3D0B7F7F8CE4}"/>
+              </a:ext>
+            </a:extLst>
+          </p:cNvPr>
+          <p:cNvSpPr>
+            <a:spLocks xmlns:a="http://schemas.openxmlformats.org/drawingml/2006/main" noGrp="1"/>
+          </p:cNvSpPr>
+          <p:nvPr/>
+        </p:nvSpPr>
+        <p:spPr>
+          <a:xfrm xmlns:a="http://schemas.openxmlformats.org/drawingml/2006/main">
+            <a:off x="7848600" y="3810000"/>
+            <a:ext cx="95250" cy="95250"/>
+          </a:xfrm>
+          <a:prstGeom xmlns:a="http://schemas.openxmlformats.org/drawingml/2006/main" prst="rect">
+            <a:avLst/>
+          </a:prstGeom>
+          <a:solidFill xmlns:a="http://schemas.openxmlformats.org/drawingml/2006/main">
+            <a:srgbClr val="74CDFF"/>
+          </a:solidFill>
+          <a:ln xmlns:a="http://schemas.openxmlformats.org/drawingml/2006/main" w="0">
+            <a:noFill/>
+            <a:prstDash val="solid"/>
+          </a:ln>
+        </p:spPr>
+      </p:sp>
+      <p:sp>
+        <p:nvSpPr>
+          <p:cNvPr id="7" name="">
+            <a:extLst xmlns:a="http://schemas.openxmlformats.org/drawingml/2006/main">
+              <a:ext uri="{FF2B5EF4-FFF2-40B4-BE49-F238E27FC236}">
+                <a16:creationId xmlns:a16="http://schemas.microsoft.com/office/drawing/2014/main" id="{6A4F044F-EB04-478C-A8AE-C935E2969BA3}"/>
+              </a:ext>
+            </a:extLst>
+          </p:cNvPr>
+          <p:cNvSpPr>
+            <a:spLocks xmlns:a="http://schemas.openxmlformats.org/drawingml/2006/main" noGrp="1"/>
+          </p:cNvSpPr>
+          <p:nvPr/>
+        </p:nvSpPr>
+        <p:spPr>
+          <a:xfrm xmlns:a="http://schemas.openxmlformats.org/drawingml/2006/main">
+            <a:off x="8077200" y="3733800"/>
+            <a:ext cx="3429000" cy="323850"/>
+          </a:xfrm>
+          <a:prstGeom xmlns:a="http://schemas.openxmlformats.org/drawingml/2006/main" prst="rect">
+            <a:avLst/>
+          </a:prstGeom>
+          <a:noFill xmlns:a="http://schemas.openxmlformats.org/drawingml/2006/main"/>
+          <a:ln xmlns:a="http://schemas.openxmlformats.org/drawingml/2006/main" w="0">
+            <a:noFill/>
+            <a:prstDash val="solid"/>
+          </a:ln>
+        </p:spPr>
+        <p:txBody>
+          <a:bodyPr xmlns:a="http://schemas.openxmlformats.org/drawingml/2006/main"/>
+          <a:lstStyle xmlns:a="http://schemas.openxmlformats.org/drawingml/2006/main"/>
+          <a:p xmlns:a="http://schemas.openxmlformats.org/drawingml/2006/main">
+            <a:pPr>
+              <a:defRPr sz="1800" b="1">
+                <a:solidFill>
+                  <a:srgbClr val="2C2348"/>
+                </a:solidFill>
+                <a:latin typeface="Microsoft YaHei"/>
+                <a:ea typeface="Microsoft YaHei"/>
+                <a:cs typeface="Microsoft YaHei"/>
+              </a:defRPr>
+            </a:pPr>
+            <a:r>
+              <a:rPr sz="1800" b="1">
+                <a:solidFill>
+                  <a:srgbClr val="2C2348"/>
+                </a:solidFill>
+                <a:latin typeface="Microsoft YaHei"/>
+                <a:ea typeface="Microsoft YaHei"/>
+                <a:cs typeface="Microsoft YaHei"/>
+              </a:rPr>
+              <a:t>房间推进</a:t>
+            </a:r>
+          </a:p>
+        </p:txBody>
+      </p:sp>
+      <p:sp>
+        <p:nvSpPr>
+          <p:cNvPr id="8" name="">
+            <a:extLst xmlns:a="http://schemas.openxmlformats.org/drawingml/2006/main">
+              <a:ext uri="{FF2B5EF4-FFF2-40B4-BE49-F238E27FC236}">
+                <a16:creationId xmlns:a16="http://schemas.microsoft.com/office/drawing/2014/main" id="{30FD6D7D-881A-4057-B106-A20F77D740DA}"/>
+              </a:ext>
+            </a:extLst>
+          </p:cNvPr>
+          <p:cNvSpPr>
+            <a:spLocks xmlns:a="http://schemas.openxmlformats.org/drawingml/2006/main" noGrp="1"/>
+          </p:cNvSpPr>
+          <p:nvPr/>
+        </p:nvSpPr>
+        <p:spPr>
+          <a:xfrm xmlns:a="http://schemas.openxmlformats.org/drawingml/2006/main">
+            <a:off x="7848600" y="4400550"/>
+            <a:ext cx="95250" cy="95250"/>
+          </a:xfrm>
+          <a:prstGeom xmlns:a="http://schemas.openxmlformats.org/drawingml/2006/main" prst="rect">
+            <a:avLst/>
+          </a:prstGeom>
+          <a:solidFill xmlns:a="http://schemas.openxmlformats.org/drawingml/2006/main">
+            <a:srgbClr val="634893"/>
+          </a:solidFill>
+          <a:ln xmlns:a="http://schemas.openxmlformats.org/drawingml/2006/main" w="0">
+            <a:noFill/>
+            <a:prstDash val="solid"/>
+          </a:ln>
+        </p:spPr>
+      </p:sp>
+      <p:sp>
+        <p:nvSpPr>
+          <p:cNvPr id="9" name="">
+            <a:extLst xmlns:a="http://schemas.openxmlformats.org/drawingml/2006/main">
+              <a:ext uri="{FF2B5EF4-FFF2-40B4-BE49-F238E27FC236}">
+                <a16:creationId xmlns:a16="http://schemas.microsoft.com/office/drawing/2014/main" id="{2AFD9005-FC4B-49C5-B170-474C01B1285A}"/>
+              </a:ext>
+            </a:extLst>
+          </p:cNvPr>
+          <p:cNvSpPr>
+            <a:spLocks xmlns:a="http://schemas.openxmlformats.org/drawingml/2006/main" noGrp="1"/>
+          </p:cNvSpPr>
+          <p:nvPr/>
+        </p:nvSpPr>
+        <p:spPr>
+          <a:xfrm xmlns:a="http://schemas.openxmlformats.org/drawingml/2006/main">
+            <a:off x="8077200" y="4324350"/>
+            <a:ext cx="3429000" cy="323850"/>
+          </a:xfrm>
+          <a:prstGeom xmlns:a="http://schemas.openxmlformats.org/drawingml/2006/main" prst="rect">
+            <a:avLst/>
+          </a:prstGeom>
+          <a:noFill xmlns:a="http://schemas.openxmlformats.org/drawingml/2006/main"/>
+          <a:ln xmlns:a="http://schemas.openxmlformats.org/drawingml/2006/main" w="0">
+            <a:noFill/>
+            <a:prstDash val="solid"/>
+          </a:ln>
+        </p:spPr>
+        <p:txBody>
+          <a:bodyPr xmlns:a="http://schemas.openxmlformats.org/drawingml/2006/main"/>
+          <a:lstStyle xmlns:a="http://schemas.openxmlformats.org/drawingml/2006/main"/>
+          <a:p xmlns:a="http://schemas.openxmlformats.org/drawingml/2006/main">
+            <a:pPr>
+              <a:defRPr sz="1800" b="1">
+                <a:solidFill>
+                  <a:srgbClr val="2C2348"/>
+                </a:solidFill>
+                <a:latin typeface="Microsoft YaHei"/>
+                <a:ea typeface="Microsoft YaHei"/>
+                <a:cs typeface="Microsoft YaHei"/>
+              </a:defRPr>
+            </a:pPr>
+            <a:r>
+              <a:rPr sz="1800" b="1">
+                <a:solidFill>
+                  <a:srgbClr val="2C2348"/>
+                </a:solidFill>
+                <a:latin typeface="Microsoft YaHei"/>
+                <a:ea typeface="Microsoft YaHei"/>
+                <a:cs typeface="Microsoft YaHei"/>
+              </a:rPr>
+              <a:t>AI 记忆日志</a:t>
+            </a:r>
+          </a:p>
+        </p:txBody>
+      </p:sp>
+      <p:sp>
+        <p:nvSpPr>
+          <p:cNvPr id="10" name="">
+            <a:extLst xmlns:a="http://schemas.openxmlformats.org/drawingml/2006/main">
+              <a:ext uri="{FF2B5EF4-FFF2-40B4-BE49-F238E27FC236}">
+                <a16:creationId xmlns:a16="http://schemas.microsoft.com/office/drawing/2014/main" id="{82FB1F9F-612C-476C-86C6-C9D95B4665E8}"/>
+              </a:ext>
+            </a:extLst>
+          </p:cNvPr>
+          <p:cNvSpPr>
+            <a:spLocks xmlns:a="http://schemas.openxmlformats.org/drawingml/2006/main" noGrp="1"/>
+          </p:cNvSpPr>
+          <p:nvPr/>
+        </p:nvSpPr>
+        <p:spPr>
+          <a:xfrm xmlns:a="http://schemas.openxmlformats.org/drawingml/2006/main">
+            <a:off x="533400" y="6515100"/>
+            <a:ext cx="800100" cy="209550"/>
+          </a:xfrm>
+          <a:prstGeom xmlns:a="http://schemas.openxmlformats.org/drawingml/2006/main" prst="rect">
+            <a:avLst/>
+          </a:prstGeom>
+          <a:noFill xmlns:a="http://schemas.openxmlformats.org/drawingml/2006/main"/>
+          <a:ln xmlns:a="http://schemas.openxmlformats.org/drawingml/2006/main" w="0">
+            <a:noFill/>
+            <a:prstDash val="solid"/>
+          </a:ln>
+        </p:spPr>
+        <p:txBody>
+          <a:bodyPr xmlns:a="http://schemas.openxmlformats.org/drawingml/2006/main"/>
+          <a:lstStyle xmlns:a="http://schemas.openxmlformats.org/drawingml/2006/main"/>
+          <a:p xmlns:a="http://schemas.openxmlformats.org/drawingml/2006/main">
+            <a:pPr>
+              <a:defRPr sz="900" b="1">
+                <a:solidFill>
+                  <a:srgbClr val="FF80B8"/>
+                </a:solidFill>
+                <a:latin typeface="Microsoft YaHei"/>
+                <a:ea typeface="Microsoft YaHei"/>
+                <a:cs typeface="Microsoft YaHei"/>
+              </a:defRPr>
+            </a:pPr>
+            <a:r>
+              <a:rPr sz="900" b="1">
+                <a:solidFill>
+                  <a:srgbClr val="FF80B8"/>
+                </a:solidFill>
+                <a:latin typeface="Microsoft YaHei"/>
+                <a:ea typeface="Microsoft YaHei"/>
+                <a:cs typeface="Microsoft YaHei"/>
+              </a:rPr>
+              <a:t>03 / 08</a:t>
+            </a:r>
+          </a:p>
+        </p:txBody>
+      </p:sp>
+      <p:sp>
+        <p:nvSpPr>
+          <p:cNvPr id="11" name="">
+            <a:extLst xmlns:a="http://schemas.openxmlformats.org/drawingml/2006/main">
+              <a:ext uri="{FF2B5EF4-FFF2-40B4-BE49-F238E27FC236}">
+                <a16:creationId xmlns:a16="http://schemas.microsoft.com/office/drawing/2014/main" id="{183D5909-FB99-4311-A8BD-1DCC8F5A9608}"/>
+              </a:ext>
+            </a:extLst>
+          </p:cNvPr>
+          <p:cNvSpPr>
+            <a:spLocks xmlns:a="http://schemas.openxmlformats.org/drawingml/2006/main" noGrp="1"/>
+          </p:cNvSpPr>
+          <p:nvPr/>
+        </p:nvSpPr>
+        <p:spPr>
+          <a:xfrm xmlns:a="http://schemas.openxmlformats.org/drawingml/2006/main">
+            <a:off x="1428750" y="6515100"/>
+            <a:ext cx="4381500" cy="209550"/>
+          </a:xfrm>
+          <a:prstGeom xmlns:a="http://schemas.openxmlformats.org/drawingml/2006/main" prst="rect">
+            <a:avLst/>
+          </a:prstGeom>
+          <a:noFill xmlns:a="http://schemas.openxmlformats.org/drawingml/2006/main"/>
+          <a:ln xmlns:a="http://schemas.openxmlformats.org/drawingml/2006/main" w="0">
+            <a:noFill/>
+            <a:prstDash val="solid"/>
+          </a:ln>
+        </p:spPr>
+        <p:txBody>
+          <a:bodyPr xmlns:a="http://schemas.openxmlformats.org/drawingml/2006/main"/>
+          <a:lstStyle xmlns:a="http://schemas.openxmlformats.org/drawingml/2006/main"/>
+          <a:p xmlns:a="http://schemas.openxmlformats.org/drawingml/2006/main">
+            <a:pPr>
+              <a:defRPr sz="900">
+                <a:solidFill>
+                  <a:srgbClr val="695F84"/>
+                </a:solidFill>
+                <a:latin typeface="Microsoft YaHei"/>
+                <a:ea typeface="Microsoft YaHei"/>
+                <a:cs typeface="Microsoft YaHei"/>
+              </a:defRPr>
+            </a:pPr>
+            <a:r>
+              <a:rPr sz="900">
+                <a:solidFill>
+                  <a:srgbClr val="695F84"/>
+                </a:solidFill>
+                <a:latin typeface="Microsoft YaHei"/>
+                <a:ea typeface="Microsoft YaHei"/>
+                <a:cs typeface="Microsoft YaHei"/>
+              </a:rPr>
+              <a:t>能工智人：糖芯工坊 | 落云宗：秦天 / 陈磊</a:t>
+            </a:r>
+          </a:p>
+        </p:txBody>
+      </p:sp>
+    </p:spTree>
+    <p:extLst>
+      <p:ext uri="{BB962C8B-B14F-4D97-AF65-F5344CB8AC3E}">
+        <p14:creationId xmlns:p14="http://schemas.microsoft.com/office/powerpoint/2010/main" val="1188414887"/>
+      </p:ext>
+    </p:extLst>
+  </p:cSld>
+</p:sld>
+</file>
+
+<file path=ppt/slides/slide4.xml><?xml version="1.0" encoding="utf-8"?>
 <p:sld xmlns:p="http://schemas.openxmlformats.org/presentationml/2006/main">
   <p:cSld>
     <p:bg>
@@ -2453,7 +3476,7 @@
           <p:cNvPr id="1" name="">
             <a:extLst xmlns:a="http://schemas.openxmlformats.org/drawingml/2006/main">
               <a:ext uri="{FF2B5EF4-FFF2-40B4-BE49-F238E27FC236}">
-                <a16:creationId xmlns:a16="http://schemas.microsoft.com/office/drawing/2014/main" id="{BCB8A5F6-1DE4-4BA4-A4C4-49445E035B68}"/>
+                <a16:creationId xmlns:a16="http://schemas.microsoft.com/office/drawing/2014/main" id="{5A571D03-3A0A-446F-B0B0-77995ADE6558}"/>
               </a:ext>
             </a:extLst>
           </p:cNvPr>
@@ -2485,6 +3508,9 @@
                 <a:solidFill>
                   <a:srgbClr val="2C2348"/>
                 </a:solidFill>
+                <a:latin typeface="Microsoft YaHei"/>
+                <a:ea typeface="Microsoft YaHei"/>
+                <a:cs typeface="Microsoft YaHei"/>
               </a:defRPr>
             </a:pPr>
             <a:r>
@@ -2492,6 +3518,9 @@
                 <a:solidFill>
                   <a:srgbClr val="2C2348"/>
                 </a:solidFill>
+                <a:latin typeface="Microsoft YaHei"/>
+                <a:ea typeface="Microsoft YaHei"/>
+                <a:cs typeface="Microsoft YaHei"/>
               </a:rPr>
               <a:t>AI 叙事进入游戏</a:t>
             </a:r>
@@ -2503,7 +3532,7 @@
           <p:cNvPr id="2" name="">
             <a:extLst xmlns:a="http://schemas.openxmlformats.org/drawingml/2006/main">
               <a:ext uri="{FF2B5EF4-FFF2-40B4-BE49-F238E27FC236}">
-                <a16:creationId xmlns:a16="http://schemas.microsoft.com/office/drawing/2014/main" id="{9DB85AA1-88F5-4611-BAC1-ABE3ABB17FF6}"/>
+                <a16:creationId xmlns:a16="http://schemas.microsoft.com/office/drawing/2014/main" id="{6523981A-D0D7-4D85-8C44-7957A62054C1}"/>
               </a:ext>
             </a:extLst>
           </p:cNvPr>
@@ -2515,7 +3544,7 @@
         <p:spPr>
           <a:xfrm xmlns:a="http://schemas.openxmlformats.org/drawingml/2006/main">
             <a:off x="666750" y="1104900"/>
-            <a:ext cx="7239000" cy="323850"/>
+            <a:ext cx="7429500" cy="323850"/>
           </a:xfrm>
           <a:prstGeom xmlns:a="http://schemas.openxmlformats.org/drawingml/2006/main" prst="rect">
             <a:avLst/>
@@ -2535,6 +3564,9 @@
                 <a:solidFill>
                   <a:srgbClr val="695F84"/>
                 </a:solidFill>
+                <a:latin typeface="Microsoft YaHei"/>
+                <a:ea typeface="Microsoft YaHei"/>
+                <a:cs typeface="Microsoft YaHei"/>
               </a:defRPr>
             </a:pPr>
             <a:r>
@@ -2542,6 +3574,9 @@
                 <a:solidFill>
                   <a:srgbClr val="695F84"/>
                 </a:solidFill>
+                <a:latin typeface="Microsoft YaHei"/>
+                <a:ea typeface="Microsoft YaHei"/>
+                <a:cs typeface="Microsoft YaHei"/>
               </a:rPr>
               <a:t>真实 NPC 对话截图说明：AI 生成内容进入 UI 与流程，而不是只停留在文档里。</a:t>
             </a:r>
@@ -2557,7 +3592,7 @@
           <p:nvPr/>
         </p:nvPicPr>
         <p:blipFill>
-          <a:blip xmlns:r="http://schemas.openxmlformats.org/officeDocument/2006/relationships" xmlns:a="http://schemas.openxmlformats.org/drawingml/2006/main" r:embed="R373aa66ed5e84250"/>
+          <a:blip xmlns:r="http://schemas.openxmlformats.org/officeDocument/2006/relationships" xmlns:a="http://schemas.openxmlformats.org/drawingml/2006/main" r:embed="R4a4dbde5277743e4"/>
           <a:srcRect xmlns:a="http://schemas.openxmlformats.org/drawingml/2006/main" l="291" t="0" r="291" b="0"/>
           <a:stretch xmlns:a="http://schemas.openxmlformats.org/drawingml/2006/main">
             <a:fillRect l="0" t="0" r="0" b="0"/>
@@ -2578,7 +3613,7 @@
           <p:cNvPr id="4" name="">
             <a:extLst xmlns:a="http://schemas.openxmlformats.org/drawingml/2006/main">
               <a:ext uri="{FF2B5EF4-FFF2-40B4-BE49-F238E27FC236}">
-                <a16:creationId xmlns:a16="http://schemas.microsoft.com/office/drawing/2014/main" id="{5637277D-3547-420A-B8B3-AA4CF3BDDCA6}"/>
+                <a16:creationId xmlns:a16="http://schemas.microsoft.com/office/drawing/2014/main" id="{5E6CE0A0-880C-4665-ADF5-B87E9CB1CFA4}"/>
               </a:ext>
             </a:extLst>
           </p:cNvPr>
@@ -2613,7 +3648,7 @@
           <p:cNvPr id="5" name="">
             <a:extLst xmlns:a="http://schemas.openxmlformats.org/drawingml/2006/main">
               <a:ext uri="{FF2B5EF4-FFF2-40B4-BE49-F238E27FC236}">
-                <a16:creationId xmlns:a16="http://schemas.microsoft.com/office/drawing/2014/main" id="{BA9BA714-6FC8-4FED-A70E-8E4840EAD01D}"/>
+                <a16:creationId xmlns:a16="http://schemas.microsoft.com/office/drawing/2014/main" id="{E0D4A38B-766A-4855-B768-A43CAFEFC6F7}"/>
               </a:ext>
             </a:extLst>
           </p:cNvPr>
@@ -2645,6 +3680,9 @@
                 <a:solidFill>
                   <a:srgbClr val="634893"/>
                 </a:solidFill>
+                <a:latin typeface="Microsoft YaHei"/>
+                <a:ea typeface="Microsoft YaHei"/>
+                <a:cs typeface="Microsoft YaHei"/>
               </a:defRPr>
             </a:pPr>
             <a:r>
@@ -2652,6 +3690,9 @@
                 <a:solidFill>
                   <a:srgbClr val="634893"/>
                 </a:solidFill>
+                <a:latin typeface="Microsoft YaHei"/>
+                <a:ea typeface="Microsoft YaHei"/>
+                <a:cs typeface="Microsoft YaHei"/>
               </a:rPr>
               <a:t>AI 生成内容</a:t>
             </a:r>
@@ -2663,7 +3704,7 @@
           <p:cNvPr id="6" name="">
             <a:extLst xmlns:a="http://schemas.openxmlformats.org/drawingml/2006/main">
               <a:ext uri="{FF2B5EF4-FFF2-40B4-BE49-F238E27FC236}">
-                <a16:creationId xmlns:a16="http://schemas.microsoft.com/office/drawing/2014/main" id="{FEE23BB1-234A-4844-8C20-4ECE56861B69}"/>
+                <a16:creationId xmlns:a16="http://schemas.microsoft.com/office/drawing/2014/main" id="{70FC220C-0EBD-4BB7-8D47-BFC5DC061AAD}"/>
               </a:ext>
             </a:extLst>
           </p:cNvPr>
@@ -2694,7 +3735,7 @@
           <p:cNvPr id="7" name="">
             <a:extLst xmlns:a="http://schemas.openxmlformats.org/drawingml/2006/main">
               <a:ext uri="{FF2B5EF4-FFF2-40B4-BE49-F238E27FC236}">
-                <a16:creationId xmlns:a16="http://schemas.microsoft.com/office/drawing/2014/main" id="{68DB89AF-65F7-49C8-A253-91C2C0747193}"/>
+                <a16:creationId xmlns:a16="http://schemas.microsoft.com/office/drawing/2014/main" id="{F3DCF51A-16F6-4155-A2F2-16FAE9B0F672}"/>
               </a:ext>
             </a:extLst>
           </p:cNvPr>
@@ -2706,7 +3747,7 @@
         <p:spPr>
           <a:xfrm xmlns:a="http://schemas.openxmlformats.org/drawingml/2006/main">
             <a:off x="8896350" y="2781300"/>
-            <a:ext cx="3238500" cy="323850"/>
+            <a:ext cx="3429000" cy="323850"/>
           </a:xfrm>
           <a:prstGeom xmlns:a="http://schemas.openxmlformats.org/drawingml/2006/main" prst="rect">
             <a:avLst/>
@@ -2726,6 +3767,9 @@
                 <a:solidFill>
                   <a:srgbClr val="2C2348"/>
                 </a:solidFill>
+                <a:latin typeface="Microsoft YaHei"/>
+                <a:ea typeface="Microsoft YaHei"/>
+                <a:cs typeface="Microsoft YaHei"/>
               </a:defRPr>
             </a:pPr>
             <a:r>
@@ -2733,8 +3777,11 @@
                 <a:solidFill>
                   <a:srgbClr val="2C2348"/>
                 </a:solidFill>
+                <a:latin typeface="Microsoft YaHei"/>
+                <a:ea typeface="Microsoft YaHei"/>
+                <a:cs typeface="Microsoft YaHei"/>
               </a:rPr>
-              <a:t>世界观与势力关系</a:t>
+              <a:t>糖果异世界</a:t>
             </a:r>
           </a:p>
         </p:txBody>
@@ -2744,7 +3791,7 @@
           <p:cNvPr id="8" name="">
             <a:extLst xmlns:a="http://schemas.openxmlformats.org/drawingml/2006/main">
               <a:ext uri="{FF2B5EF4-FFF2-40B4-BE49-F238E27FC236}">
-                <a16:creationId xmlns:a16="http://schemas.microsoft.com/office/drawing/2014/main" id="{FF6775E7-6FFD-4BEC-83D7-541D0016DBB6}"/>
+                <a16:creationId xmlns:a16="http://schemas.microsoft.com/office/drawing/2014/main" id="{BDB88847-BCAD-4BC8-BB0E-279B527576B3}"/>
               </a:ext>
             </a:extLst>
           </p:cNvPr>
@@ -2775,7 +3822,7 @@
           <p:cNvPr id="9" name="">
             <a:extLst xmlns:a="http://schemas.openxmlformats.org/drawingml/2006/main">
               <a:ext uri="{FF2B5EF4-FFF2-40B4-BE49-F238E27FC236}">
-                <a16:creationId xmlns:a16="http://schemas.microsoft.com/office/drawing/2014/main" id="{D7792462-0BAC-40AD-8EB4-8DFCD6688566}"/>
+                <a16:creationId xmlns:a16="http://schemas.microsoft.com/office/drawing/2014/main" id="{BEB70ED2-E6BC-4356-81C7-A5B939B328BA}"/>
               </a:ext>
             </a:extLst>
           </p:cNvPr>
@@ -2787,7 +3834,7 @@
         <p:spPr>
           <a:xfrm xmlns:a="http://schemas.openxmlformats.org/drawingml/2006/main">
             <a:off x="8896350" y="3371850"/>
-            <a:ext cx="3238500" cy="323850"/>
+            <a:ext cx="3429000" cy="323850"/>
           </a:xfrm>
           <a:prstGeom xmlns:a="http://schemas.openxmlformats.org/drawingml/2006/main" prst="rect">
             <a:avLst/>
@@ -2807,6 +3854,9 @@
                 <a:solidFill>
                   <a:srgbClr val="2C2348"/>
                 </a:solidFill>
+                <a:latin typeface="Microsoft YaHei"/>
+                <a:ea typeface="Microsoft YaHei"/>
+                <a:cs typeface="Microsoft YaHei"/>
               </a:defRPr>
             </a:pPr>
             <a:r>
@@ -2814,8 +3864,11 @@
                 <a:solidFill>
                   <a:srgbClr val="2C2348"/>
                 </a:solidFill>
+                <a:latin typeface="Microsoft YaHei"/>
+                <a:ea typeface="Microsoft YaHei"/>
+                <a:cs typeface="Microsoft YaHei"/>
               </a:rPr>
-              <a:t>房间记忆日志</a:t>
+              <a:t>糖芯工坊日志</a:t>
             </a:r>
           </a:p>
         </p:txBody>
@@ -2825,7 +3878,7 @@
           <p:cNvPr id="10" name="">
             <a:extLst xmlns:a="http://schemas.openxmlformats.org/drawingml/2006/main">
               <a:ext uri="{FF2B5EF4-FFF2-40B4-BE49-F238E27FC236}">
-                <a16:creationId xmlns:a16="http://schemas.microsoft.com/office/drawing/2014/main" id="{4E577C47-FAE5-4AC1-8DA3-3FE945003399}"/>
+                <a16:creationId xmlns:a16="http://schemas.microsoft.com/office/drawing/2014/main" id="{C4B71074-0D67-4A9D-91C9-3E7EF44F1DD9}"/>
               </a:ext>
             </a:extLst>
           </p:cNvPr>
@@ -2856,7 +3909,7 @@
           <p:cNvPr id="11" name="">
             <a:extLst xmlns:a="http://schemas.openxmlformats.org/drawingml/2006/main">
               <a:ext uri="{FF2B5EF4-FFF2-40B4-BE49-F238E27FC236}">
-                <a16:creationId xmlns:a16="http://schemas.microsoft.com/office/drawing/2014/main" id="{BD6AFA97-A010-4827-AB7D-D5BC2F4CC270}"/>
+                <a16:creationId xmlns:a16="http://schemas.microsoft.com/office/drawing/2014/main" id="{C28FA079-91CC-4F33-A07B-F9D0395116AC}"/>
               </a:ext>
             </a:extLst>
           </p:cNvPr>
@@ -2868,7 +3921,7 @@
         <p:spPr>
           <a:xfrm xmlns:a="http://schemas.openxmlformats.org/drawingml/2006/main">
             <a:off x="8896350" y="3962400"/>
-            <a:ext cx="3238500" cy="323850"/>
+            <a:ext cx="3429000" cy="323850"/>
           </a:xfrm>
           <a:prstGeom xmlns:a="http://schemas.openxmlformats.org/drawingml/2006/main" prst="rect">
             <a:avLst/>
@@ -2888,6 +3941,9 @@
                 <a:solidFill>
                   <a:srgbClr val="2C2348"/>
                 </a:solidFill>
+                <a:latin typeface="Microsoft YaHei"/>
+                <a:ea typeface="Microsoft YaHei"/>
+                <a:cs typeface="Microsoft YaHei"/>
               </a:defRPr>
             </a:pPr>
             <a:r>
@@ -2895,6 +3951,9 @@
                 <a:solidFill>
                   <a:srgbClr val="2C2348"/>
                 </a:solidFill>
+                <a:latin typeface="Microsoft YaHei"/>
+                <a:ea typeface="Microsoft YaHei"/>
+                <a:cs typeface="Microsoft YaHei"/>
               </a:rPr>
               <a:t>Boss 背景</a:t>
             </a:r>
@@ -2906,7 +3965,7 @@
           <p:cNvPr id="12" name="">
             <a:extLst xmlns:a="http://schemas.openxmlformats.org/drawingml/2006/main">
               <a:ext uri="{FF2B5EF4-FFF2-40B4-BE49-F238E27FC236}">
-                <a16:creationId xmlns:a16="http://schemas.microsoft.com/office/drawing/2014/main" id="{10BFF907-BBCA-4847-BC71-849D28998AF8}"/>
+                <a16:creationId xmlns:a16="http://schemas.microsoft.com/office/drawing/2014/main" id="{83965F52-D0A0-4D45-9682-11A74195278F}"/>
               </a:ext>
             </a:extLst>
           </p:cNvPr>
@@ -2937,7 +3996,7 @@
           <p:cNvPr id="13" name="">
             <a:extLst xmlns:a="http://schemas.openxmlformats.org/drawingml/2006/main">
               <a:ext uri="{FF2B5EF4-FFF2-40B4-BE49-F238E27FC236}">
-                <a16:creationId xmlns:a16="http://schemas.microsoft.com/office/drawing/2014/main" id="{1A20FF4D-52CE-4289-9A76-5E834D78C294}"/>
+                <a16:creationId xmlns:a16="http://schemas.microsoft.com/office/drawing/2014/main" id="{D0EE82C2-2439-4D5A-8CBC-57F0A4C8739C}"/>
               </a:ext>
             </a:extLst>
           </p:cNvPr>
@@ -2949,7 +4008,7 @@
         <p:spPr>
           <a:xfrm xmlns:a="http://schemas.openxmlformats.org/drawingml/2006/main">
             <a:off x="8896350" y="4552950"/>
-            <a:ext cx="3238500" cy="323850"/>
+            <a:ext cx="3429000" cy="323850"/>
           </a:xfrm>
           <a:prstGeom xmlns:a="http://schemas.openxmlformats.org/drawingml/2006/main" prst="rect">
             <a:avLst/>
@@ -2969,6 +4028,9 @@
                 <a:solidFill>
                   <a:srgbClr val="2C2348"/>
                 </a:solidFill>
+                <a:latin typeface="Microsoft YaHei"/>
+                <a:ea typeface="Microsoft YaHei"/>
+                <a:cs typeface="Microsoft YaHei"/>
               </a:defRPr>
             </a:pPr>
             <a:r>
@@ -2976,6 +4038,9 @@
                 <a:solidFill>
                   <a:srgbClr val="2C2348"/>
                 </a:solidFill>
+                <a:latin typeface="Microsoft YaHei"/>
+                <a:ea typeface="Microsoft YaHei"/>
+                <a:cs typeface="Microsoft YaHei"/>
               </a:rPr>
               <a:t>结局文本</a:t>
             </a:r>
@@ -2987,7 +4052,7 @@
           <p:cNvPr id="14" name="">
             <a:extLst xmlns:a="http://schemas.openxmlformats.org/drawingml/2006/main">
               <a:ext uri="{FF2B5EF4-FFF2-40B4-BE49-F238E27FC236}">
-                <a16:creationId xmlns:a16="http://schemas.microsoft.com/office/drawing/2014/main" id="{444001C2-A2A8-477A-87DB-0EDA14DD8677}"/>
+                <a16:creationId xmlns:a16="http://schemas.microsoft.com/office/drawing/2014/main" id="{990B2C5F-9EF2-4676-961A-7FB103388EAF}"/>
               </a:ext>
             </a:extLst>
           </p:cNvPr>
@@ -3019,6 +4084,9 @@
                 <a:solidFill>
                   <a:srgbClr val="FF80B8"/>
                 </a:solidFill>
+                <a:latin typeface="Microsoft YaHei"/>
+                <a:ea typeface="Microsoft YaHei"/>
+                <a:cs typeface="Microsoft YaHei"/>
               </a:defRPr>
             </a:pPr>
             <a:r>
@@ -3026,8 +4094,11 @@
                 <a:solidFill>
                   <a:srgbClr val="FF80B8"/>
                 </a:solidFill>
+                <a:latin typeface="Microsoft YaHei"/>
+                <a:ea typeface="Microsoft YaHei"/>
+                <a:cs typeface="Microsoft YaHei"/>
               </a:rPr>
-              <a:t>03 / 07</a:t>
+              <a:t>04 / 08</a:t>
             </a:r>
           </a:p>
         </p:txBody>
@@ -3037,7 +4108,7 @@
           <p:cNvPr id="15" name="">
             <a:extLst xmlns:a="http://schemas.openxmlformats.org/drawingml/2006/main">
               <a:ext uri="{FF2B5EF4-FFF2-40B4-BE49-F238E27FC236}">
-                <a16:creationId xmlns:a16="http://schemas.microsoft.com/office/drawing/2014/main" id="{13A86AF9-83D8-4CF8-9E28-1C55E04522AA}"/>
+                <a16:creationId xmlns:a16="http://schemas.microsoft.com/office/drawing/2014/main" id="{435F4AE2-AF72-4156-8D3F-D504FD72E554}"/>
               </a:ext>
             </a:extLst>
           </p:cNvPr>
@@ -3049,7 +4120,7 @@
         <p:spPr>
           <a:xfrm xmlns:a="http://schemas.openxmlformats.org/drawingml/2006/main">
             <a:off x="1428750" y="6515100"/>
-            <a:ext cx="4191000" cy="209550"/>
+            <a:ext cx="4381500" cy="209550"/>
           </a:xfrm>
           <a:prstGeom xmlns:a="http://schemas.openxmlformats.org/drawingml/2006/main" prst="rect">
             <a:avLst/>
@@ -3069,6 +4140,9 @@
                 <a:solidFill>
                   <a:srgbClr val="695F84"/>
                 </a:solidFill>
+                <a:latin typeface="Microsoft YaHei"/>
+                <a:ea typeface="Microsoft YaHei"/>
+                <a:cs typeface="Microsoft YaHei"/>
               </a:defRPr>
             </a:pPr>
             <a:r>
@@ -3076,8 +4150,11 @@
                 <a:solidFill>
                   <a:srgbClr val="695F84"/>
                 </a:solidFill>
+                <a:latin typeface="Microsoft YaHei"/>
+                <a:ea typeface="Microsoft YaHei"/>
+                <a:cs typeface="Microsoft YaHei"/>
               </a:rPr>
-              <a:t>能工智人：遗忘工坊 | 落云宗：秦天 / 陈磊</a:t>
+              <a:t>能工智人：糖芯工坊 | 落云宗：秦天 / 陈磊</a:t>
             </a:r>
           </a:p>
         </p:txBody>
@@ -3085,14 +4162,14 @@
     </p:spTree>
     <p:extLst>
       <p:ext uri="{BB962C8B-B14F-4D97-AF65-F5344CB8AC3E}">
-        <p14:creationId xmlns:p14="http://schemas.microsoft.com/office/powerpoint/2010/main" val="948387938"/>
+        <p14:creationId xmlns:p14="http://schemas.microsoft.com/office/powerpoint/2010/main" val="271602571"/>
       </p:ext>
     </p:extLst>
   </p:cSld>
 </p:sld>
 </file>
 
-<file path=ppt/slides/slide4.xml><?xml version="1.0" encoding="utf-8"?>
+<file path=ppt/slides/slide5.xml><?xml version="1.0" encoding="utf-8"?>
 <p:sld xmlns:p="http://schemas.openxmlformats.org/presentationml/2006/main">
   <p:cSld>
     <p:bg>
@@ -3116,7 +4193,7 @@
           <p:cNvPr id="1" name="">
             <a:extLst xmlns:a="http://schemas.openxmlformats.org/drawingml/2006/main">
               <a:ext uri="{FF2B5EF4-FFF2-40B4-BE49-F238E27FC236}">
-                <a16:creationId xmlns:a16="http://schemas.microsoft.com/office/drawing/2014/main" id="{51CB6855-D337-45A4-B84B-86D8A9277A73}"/>
+                <a16:creationId xmlns:a16="http://schemas.microsoft.com/office/drawing/2014/main" id="{26010E2D-786E-4008-8E86-494A9EA97169}"/>
               </a:ext>
             </a:extLst>
           </p:cNvPr>
@@ -3148,6 +4225,9 @@
                 <a:solidFill>
                   <a:srgbClr val="2C2348"/>
                 </a:solidFill>
+                <a:latin typeface="Microsoft YaHei"/>
+                <a:ea typeface="Microsoft YaHei"/>
+                <a:cs typeface="Microsoft YaHei"/>
               </a:defRPr>
             </a:pPr>
             <a:r>
@@ -3155,6 +4235,9 @@
                 <a:solidFill>
                   <a:srgbClr val="2C2348"/>
                 </a:solidFill>
+                <a:latin typeface="Microsoft YaHei"/>
+                <a:ea typeface="Microsoft YaHei"/>
+                <a:cs typeface="Microsoft YaHei"/>
               </a:rPr>
               <a:t>背包、装备与成长</a:t>
             </a:r>
@@ -3170,7 +4253,7 @@
           <p:nvPr/>
         </p:nvPicPr>
         <p:blipFill>
-          <a:blip xmlns:r="http://schemas.openxmlformats.org/officeDocument/2006/relationships" xmlns:a="http://schemas.openxmlformats.org/drawingml/2006/main" r:embed="Rc815984df8b34269"/>
+          <a:blip xmlns:r="http://schemas.openxmlformats.org/officeDocument/2006/relationships" xmlns:a="http://schemas.openxmlformats.org/drawingml/2006/main" r:embed="R3439e9ca6620443d"/>
           <a:srcRect xmlns:a="http://schemas.openxmlformats.org/drawingml/2006/main" l="2907" t="0" r="2907" b="0"/>
           <a:stretch xmlns:a="http://schemas.openxmlformats.org/drawingml/2006/main">
             <a:fillRect l="0" t="0" r="0" b="0"/>
@@ -3191,7 +4274,7 @@
           <p:cNvPr id="3" name="">
             <a:extLst xmlns:a="http://schemas.openxmlformats.org/drawingml/2006/main">
               <a:ext uri="{FF2B5EF4-FFF2-40B4-BE49-F238E27FC236}">
-                <a16:creationId xmlns:a16="http://schemas.microsoft.com/office/drawing/2014/main" id="{002C35BC-E78D-43AC-A0D2-4688255CFEF3}"/>
+                <a16:creationId xmlns:a16="http://schemas.microsoft.com/office/drawing/2014/main" id="{AF0B308D-5BE8-409F-804E-4E6431184A00}"/>
               </a:ext>
             </a:extLst>
           </p:cNvPr>
@@ -3223,6 +4306,9 @@
                 <a:solidFill>
                   <a:srgbClr val="2C2348"/>
                 </a:solidFill>
+                <a:latin typeface="Microsoft YaHei"/>
+                <a:ea typeface="Microsoft YaHei"/>
+                <a:cs typeface="Microsoft YaHei"/>
               </a:defRPr>
             </a:pPr>
             <a:r>
@@ -3230,6 +4316,9 @@
                 <a:solidFill>
                   <a:srgbClr val="2C2348"/>
                 </a:solidFill>
+                <a:latin typeface="Microsoft YaHei"/>
+                <a:ea typeface="Microsoft YaHei"/>
+                <a:cs typeface="Microsoft YaHei"/>
               </a:rPr>
               <a:t>系统在 Demo 中承担“变强”的可见反馈。</a:t>
             </a:r>
@@ -3241,7 +4330,7 @@
           <p:cNvPr id="4" name="">
             <a:extLst xmlns:a="http://schemas.openxmlformats.org/drawingml/2006/main">
               <a:ext uri="{FF2B5EF4-FFF2-40B4-BE49-F238E27FC236}">
-                <a16:creationId xmlns:a16="http://schemas.microsoft.com/office/drawing/2014/main" id="{FD7795B0-6946-4C29-B664-B29A3A6CB9C3}"/>
+                <a16:creationId xmlns:a16="http://schemas.microsoft.com/office/drawing/2014/main" id="{825150CE-5F42-40CC-82B6-017C5F2E2239}"/>
               </a:ext>
             </a:extLst>
           </p:cNvPr>
@@ -3272,7 +4361,7 @@
           <p:cNvPr id="5" name="">
             <a:extLst xmlns:a="http://schemas.openxmlformats.org/drawingml/2006/main">
               <a:ext uri="{FF2B5EF4-FFF2-40B4-BE49-F238E27FC236}">
-                <a16:creationId xmlns:a16="http://schemas.microsoft.com/office/drawing/2014/main" id="{F1D40D1C-0A4B-4AE4-B5F8-48A6A281FBE1}"/>
+                <a16:creationId xmlns:a16="http://schemas.microsoft.com/office/drawing/2014/main" id="{CF54460A-89C6-40DF-B9A3-7E102791178B}"/>
               </a:ext>
             </a:extLst>
           </p:cNvPr>
@@ -3284,7 +4373,7 @@
         <p:spPr>
           <a:xfrm xmlns:a="http://schemas.openxmlformats.org/drawingml/2006/main">
             <a:off x="8248650" y="2476500"/>
-            <a:ext cx="3238500" cy="323850"/>
+            <a:ext cx="3429000" cy="323850"/>
           </a:xfrm>
           <a:prstGeom xmlns:a="http://schemas.openxmlformats.org/drawingml/2006/main" prst="rect">
             <a:avLst/>
@@ -3304,6 +4393,9 @@
                 <a:solidFill>
                   <a:srgbClr val="2C2348"/>
                 </a:solidFill>
+                <a:latin typeface="Microsoft YaHei"/>
+                <a:ea typeface="Microsoft YaHei"/>
+                <a:cs typeface="Microsoft YaHei"/>
               </a:defRPr>
             </a:pPr>
             <a:r>
@@ -3311,6 +4403,9 @@
                 <a:solidFill>
                   <a:srgbClr val="2C2348"/>
                 </a:solidFill>
+                <a:latin typeface="Microsoft YaHei"/>
+                <a:ea typeface="Microsoft YaHei"/>
+                <a:cs typeface="Microsoft YaHei"/>
               </a:rPr>
               <a:t>装备说明</a:t>
             </a:r>
@@ -3322,7 +4417,7 @@
           <p:cNvPr id="6" name="">
             <a:extLst xmlns:a="http://schemas.openxmlformats.org/drawingml/2006/main">
               <a:ext uri="{FF2B5EF4-FFF2-40B4-BE49-F238E27FC236}">
-                <a16:creationId xmlns:a16="http://schemas.microsoft.com/office/drawing/2014/main" id="{A7B80588-D80B-4ABD-A194-D83B2F4DAE93}"/>
+                <a16:creationId xmlns:a16="http://schemas.microsoft.com/office/drawing/2014/main" id="{8FE7E4E1-96A0-4A44-93FA-5DCD3CD84D9A}"/>
               </a:ext>
             </a:extLst>
           </p:cNvPr>
@@ -3353,7 +4448,7 @@
           <p:cNvPr id="7" name="">
             <a:extLst xmlns:a="http://schemas.openxmlformats.org/drawingml/2006/main">
               <a:ext uri="{FF2B5EF4-FFF2-40B4-BE49-F238E27FC236}">
-                <a16:creationId xmlns:a16="http://schemas.microsoft.com/office/drawing/2014/main" id="{618D2B64-6A2E-49A1-8E09-4CF495129FCD}"/>
+                <a16:creationId xmlns:a16="http://schemas.microsoft.com/office/drawing/2014/main" id="{C20219B4-A3F0-4F5E-9398-F6363DDA3F15}"/>
               </a:ext>
             </a:extLst>
           </p:cNvPr>
@@ -3365,7 +4460,7 @@
         <p:spPr>
           <a:xfrm xmlns:a="http://schemas.openxmlformats.org/drawingml/2006/main">
             <a:off x="8248650" y="3067050"/>
-            <a:ext cx="3238500" cy="323850"/>
+            <a:ext cx="3429000" cy="323850"/>
           </a:xfrm>
           <a:prstGeom xmlns:a="http://schemas.openxmlformats.org/drawingml/2006/main" prst="rect">
             <a:avLst/>
@@ -3385,6 +4480,9 @@
                 <a:solidFill>
                   <a:srgbClr val="2C2348"/>
                 </a:solidFill>
+                <a:latin typeface="Microsoft YaHei"/>
+                <a:ea typeface="Microsoft YaHei"/>
+                <a:cs typeface="Microsoft YaHei"/>
               </a:defRPr>
             </a:pPr>
             <a:r>
@@ -3392,6 +4490,9 @@
                 <a:solidFill>
                   <a:srgbClr val="2C2348"/>
                 </a:solidFill>
+                <a:latin typeface="Microsoft YaHei"/>
+                <a:ea typeface="Microsoft YaHei"/>
+                <a:cs typeface="Microsoft YaHei"/>
               </a:rPr>
               <a:t>角色属性</a:t>
             </a:r>
@@ -3403,7 +4504,7 @@
           <p:cNvPr id="8" name="">
             <a:extLst xmlns:a="http://schemas.openxmlformats.org/drawingml/2006/main">
               <a:ext uri="{FF2B5EF4-FFF2-40B4-BE49-F238E27FC236}">
-                <a16:creationId xmlns:a16="http://schemas.microsoft.com/office/drawing/2014/main" id="{58AF2F33-149C-431F-BE4A-F0F8DC9BA54A}"/>
+                <a16:creationId xmlns:a16="http://schemas.microsoft.com/office/drawing/2014/main" id="{EB1F4276-9542-4F2D-B8A2-BD80FEFC9A30}"/>
               </a:ext>
             </a:extLst>
           </p:cNvPr>
@@ -3434,7 +4535,7 @@
           <p:cNvPr id="9" name="">
             <a:extLst xmlns:a="http://schemas.openxmlformats.org/drawingml/2006/main">
               <a:ext uri="{FF2B5EF4-FFF2-40B4-BE49-F238E27FC236}">
-                <a16:creationId xmlns:a16="http://schemas.microsoft.com/office/drawing/2014/main" id="{52FA1DEB-BA5C-44B7-98B1-4CB25784F14F}"/>
+                <a16:creationId xmlns:a16="http://schemas.microsoft.com/office/drawing/2014/main" id="{BF69F5AD-279D-4A0C-8206-854554164F70}"/>
               </a:ext>
             </a:extLst>
           </p:cNvPr>
@@ -3446,7 +4547,7 @@
         <p:spPr>
           <a:xfrm xmlns:a="http://schemas.openxmlformats.org/drawingml/2006/main">
             <a:off x="8248650" y="3657600"/>
-            <a:ext cx="3238500" cy="323850"/>
+            <a:ext cx="3429000" cy="323850"/>
           </a:xfrm>
           <a:prstGeom xmlns:a="http://schemas.openxmlformats.org/drawingml/2006/main" prst="rect">
             <a:avLst/>
@@ -3466,6 +4567,9 @@
                 <a:solidFill>
                   <a:srgbClr val="2C2348"/>
                 </a:solidFill>
+                <a:latin typeface="Microsoft YaHei"/>
+                <a:ea typeface="Microsoft YaHei"/>
+                <a:cs typeface="Microsoft YaHei"/>
               </a:defRPr>
             </a:pPr>
             <a:r>
@@ -3473,6 +4577,9 @@
                 <a:solidFill>
                   <a:srgbClr val="2C2348"/>
                 </a:solidFill>
+                <a:latin typeface="Microsoft YaHei"/>
+                <a:ea typeface="Microsoft YaHei"/>
+                <a:cs typeface="Microsoft YaHei"/>
               </a:rPr>
               <a:t>道具与材料</a:t>
             </a:r>
@@ -3484,7 +4591,7 @@
           <p:cNvPr id="10" name="">
             <a:extLst xmlns:a="http://schemas.openxmlformats.org/drawingml/2006/main">
               <a:ext uri="{FF2B5EF4-FFF2-40B4-BE49-F238E27FC236}">
-                <a16:creationId xmlns:a16="http://schemas.microsoft.com/office/drawing/2014/main" id="{BAB34E93-16E9-4207-A990-3B98346EE9AB}"/>
+                <a16:creationId xmlns:a16="http://schemas.microsoft.com/office/drawing/2014/main" id="{8CCFAEDA-FA38-4272-83C0-CE0B7F3463C2}"/>
               </a:ext>
             </a:extLst>
           </p:cNvPr>
@@ -3515,7 +4622,7 @@
           <p:cNvPr id="11" name="">
             <a:extLst xmlns:a="http://schemas.openxmlformats.org/drawingml/2006/main">
               <a:ext uri="{FF2B5EF4-FFF2-40B4-BE49-F238E27FC236}">
-                <a16:creationId xmlns:a16="http://schemas.microsoft.com/office/drawing/2014/main" id="{6793C016-2546-4E75-8194-AC4E557F7181}"/>
+                <a16:creationId xmlns:a16="http://schemas.microsoft.com/office/drawing/2014/main" id="{A7F7F7A7-DFC3-45FF-A411-A3254C3AF485}"/>
               </a:ext>
             </a:extLst>
           </p:cNvPr>
@@ -3527,7 +4634,7 @@
         <p:spPr>
           <a:xfrm xmlns:a="http://schemas.openxmlformats.org/drawingml/2006/main">
             <a:off x="8248650" y="4248150"/>
-            <a:ext cx="3238500" cy="323850"/>
+            <a:ext cx="3429000" cy="323850"/>
           </a:xfrm>
           <a:prstGeom xmlns:a="http://schemas.openxmlformats.org/drawingml/2006/main" prst="rect">
             <a:avLst/>
@@ -3547,6 +4654,9 @@
                 <a:solidFill>
                   <a:srgbClr val="2C2348"/>
                 </a:solidFill>
+                <a:latin typeface="Microsoft YaHei"/>
+                <a:ea typeface="Microsoft YaHei"/>
+                <a:cs typeface="Microsoft YaHei"/>
               </a:defRPr>
             </a:pPr>
             <a:r>
@@ -3554,6 +4664,9 @@
                 <a:solidFill>
                   <a:srgbClr val="2C2348"/>
                 </a:solidFill>
+                <a:latin typeface="Microsoft YaHei"/>
+                <a:ea typeface="Microsoft YaHei"/>
+                <a:cs typeface="Microsoft YaHei"/>
               </a:rPr>
               <a:t>战斗数值成长</a:t>
             </a:r>
@@ -3565,7 +4678,7 @@
           <p:cNvPr id="12" name="">
             <a:extLst xmlns:a="http://schemas.openxmlformats.org/drawingml/2006/main">
               <a:ext uri="{FF2B5EF4-FFF2-40B4-BE49-F238E27FC236}">
-                <a16:creationId xmlns:a16="http://schemas.microsoft.com/office/drawing/2014/main" id="{4CA58294-BBD9-49E0-BDA6-E576FB8208B0}"/>
+                <a16:creationId xmlns:a16="http://schemas.microsoft.com/office/drawing/2014/main" id="{E75E2C86-5E65-4D65-A3D6-2E5BA32A8276}"/>
               </a:ext>
             </a:extLst>
           </p:cNvPr>
@@ -3597,6 +4710,9 @@
                 <a:solidFill>
                   <a:srgbClr val="FF80B8"/>
                 </a:solidFill>
+                <a:latin typeface="Microsoft YaHei"/>
+                <a:ea typeface="Microsoft YaHei"/>
+                <a:cs typeface="Microsoft YaHei"/>
               </a:defRPr>
             </a:pPr>
             <a:r>
@@ -3604,8 +4720,11 @@
                 <a:solidFill>
                   <a:srgbClr val="FF80B8"/>
                 </a:solidFill>
+                <a:latin typeface="Microsoft YaHei"/>
+                <a:ea typeface="Microsoft YaHei"/>
+                <a:cs typeface="Microsoft YaHei"/>
               </a:rPr>
-              <a:t>04 / 07</a:t>
+              <a:t>05 / 08</a:t>
             </a:r>
           </a:p>
         </p:txBody>
@@ -3615,7 +4734,7 @@
           <p:cNvPr id="13" name="">
             <a:extLst xmlns:a="http://schemas.openxmlformats.org/drawingml/2006/main">
               <a:ext uri="{FF2B5EF4-FFF2-40B4-BE49-F238E27FC236}">
-                <a16:creationId xmlns:a16="http://schemas.microsoft.com/office/drawing/2014/main" id="{3DA7D9AB-6C61-4064-831B-7978E71960B6}"/>
+                <a16:creationId xmlns:a16="http://schemas.microsoft.com/office/drawing/2014/main" id="{A226166A-FE42-4C42-90BC-E1D3D43B559C}"/>
               </a:ext>
             </a:extLst>
           </p:cNvPr>
@@ -3627,7 +4746,7 @@
         <p:spPr>
           <a:xfrm xmlns:a="http://schemas.openxmlformats.org/drawingml/2006/main">
             <a:off x="1428750" y="6515100"/>
-            <a:ext cx="4191000" cy="209550"/>
+            <a:ext cx="4381500" cy="209550"/>
           </a:xfrm>
           <a:prstGeom xmlns:a="http://schemas.openxmlformats.org/drawingml/2006/main" prst="rect">
             <a:avLst/>
@@ -3647,6 +4766,9 @@
                 <a:solidFill>
                   <a:srgbClr val="695F84"/>
                 </a:solidFill>
+                <a:latin typeface="Microsoft YaHei"/>
+                <a:ea typeface="Microsoft YaHei"/>
+                <a:cs typeface="Microsoft YaHei"/>
               </a:defRPr>
             </a:pPr>
             <a:r>
@@ -3654,8 +4776,11 @@
                 <a:solidFill>
                   <a:srgbClr val="695F84"/>
                 </a:solidFill>
+                <a:latin typeface="Microsoft YaHei"/>
+                <a:ea typeface="Microsoft YaHei"/>
+                <a:cs typeface="Microsoft YaHei"/>
               </a:rPr>
-              <a:t>能工智人：遗忘工坊 | 落云宗：秦天 / 陈磊</a:t>
+              <a:t>能工智人：糖芯工坊 | 落云宗：秦天 / 陈磊</a:t>
             </a:r>
           </a:p>
         </p:txBody>
@@ -3663,14 +4788,14 @@
     </p:spTree>
     <p:extLst>
       <p:ext uri="{BB962C8B-B14F-4D97-AF65-F5344CB8AC3E}">
-        <p14:creationId xmlns:p14="http://schemas.microsoft.com/office/powerpoint/2010/main" val="1083513367"/>
+        <p14:creationId xmlns:p14="http://schemas.microsoft.com/office/powerpoint/2010/main" val="642603745"/>
       </p:ext>
     </p:extLst>
   </p:cSld>
 </p:sld>
 </file>
 
-<file path=ppt/slides/slide5.xml><?xml version="1.0" encoding="utf-8"?>
+<file path=ppt/slides/slide6.xml><?xml version="1.0" encoding="utf-8"?>
 <p:sld xmlns:p="http://schemas.openxmlformats.org/presentationml/2006/main">
   <p:cSld>
     <p:bg>
@@ -3694,7 +4819,7 @@
           <p:cNvPr id="1" name="">
             <a:extLst xmlns:a="http://schemas.openxmlformats.org/drawingml/2006/main">
               <a:ext uri="{FF2B5EF4-FFF2-40B4-BE49-F238E27FC236}">
-                <a16:creationId xmlns:a16="http://schemas.microsoft.com/office/drawing/2014/main" id="{1AA407E0-505C-4CE8-8568-72E25EF8C29A}"/>
+                <a16:creationId xmlns:a16="http://schemas.microsoft.com/office/drawing/2014/main" id="{A5F6618F-B6C3-4D49-BFB8-D4B26F8727F2}"/>
               </a:ext>
             </a:extLst>
           </p:cNvPr>
@@ -3726,6 +4851,9 @@
                 <a:solidFill>
                   <a:srgbClr val="2C2348"/>
                 </a:solidFill>
+                <a:latin typeface="Microsoft YaHei"/>
+                <a:ea typeface="Microsoft YaHei"/>
+                <a:cs typeface="Microsoft YaHei"/>
               </a:defRPr>
             </a:pPr>
             <a:r>
@@ -3733,6 +4861,9 @@
                 <a:solidFill>
                   <a:srgbClr val="2C2348"/>
                 </a:solidFill>
+                <a:latin typeface="Microsoft YaHei"/>
+                <a:ea typeface="Microsoft YaHei"/>
+                <a:cs typeface="Microsoft YaHei"/>
               </a:rPr>
               <a:t>合成与技能树</a:t>
             </a:r>
@@ -3744,7 +4875,7 @@
           <p:cNvPr id="2" name="">
             <a:extLst xmlns:a="http://schemas.openxmlformats.org/drawingml/2006/main">
               <a:ext uri="{FF2B5EF4-FFF2-40B4-BE49-F238E27FC236}">
-                <a16:creationId xmlns:a16="http://schemas.microsoft.com/office/drawing/2014/main" id="{4F53804E-087F-4591-9973-B6EBCB8DBDE2}"/>
+                <a16:creationId xmlns:a16="http://schemas.microsoft.com/office/drawing/2014/main" id="{7735CA5D-1225-434E-AB1C-6823AF3BC5F6}"/>
               </a:ext>
             </a:extLst>
           </p:cNvPr>
@@ -3776,6 +4907,9 @@
                 <a:solidFill>
                   <a:srgbClr val="634893"/>
                 </a:solidFill>
+                <a:latin typeface="Microsoft YaHei"/>
+                <a:ea typeface="Microsoft YaHei"/>
+                <a:cs typeface="Microsoft YaHei"/>
               </a:defRPr>
             </a:pPr>
             <a:r>
@@ -3783,6 +4917,9 @@
                 <a:solidFill>
                   <a:srgbClr val="634893"/>
                 </a:solidFill>
+                <a:latin typeface="Microsoft YaHei"/>
+                <a:ea typeface="Microsoft YaHei"/>
+                <a:cs typeface="Microsoft YaHei"/>
               </a:rPr>
               <a:t>材料掉落 -&gt; 合成道具 -&gt; 学习技能 -&gt; 强化战斗</a:t>
             </a:r>
@@ -3798,7 +4935,7 @@
           <p:nvPr/>
         </p:nvPicPr>
         <p:blipFill>
-          <a:blip xmlns:r="http://schemas.openxmlformats.org/officeDocument/2006/relationships" xmlns:a="http://schemas.openxmlformats.org/drawingml/2006/main" r:embed="R205f78019f064913"/>
+          <a:blip xmlns:r="http://schemas.openxmlformats.org/officeDocument/2006/relationships" xmlns:a="http://schemas.openxmlformats.org/drawingml/2006/main" r:embed="R0e53fb9588a44fa1"/>
           <a:srcRect xmlns:a="http://schemas.openxmlformats.org/drawingml/2006/main" l="10473" t="0" r="10473" b="0"/>
           <a:stretch xmlns:a="http://schemas.openxmlformats.org/drawingml/2006/main">
             <a:fillRect l="0" t="0" r="0" b="0"/>
@@ -3819,7 +4956,7 @@
           <p:cNvPr id="4" name="">
             <a:extLst xmlns:a="http://schemas.openxmlformats.org/drawingml/2006/main">
               <a:ext uri="{FF2B5EF4-FFF2-40B4-BE49-F238E27FC236}">
-                <a16:creationId xmlns:a16="http://schemas.microsoft.com/office/drawing/2014/main" id="{86051D07-139D-475D-A352-8FEB8E0C828D}"/>
+                <a16:creationId xmlns:a16="http://schemas.microsoft.com/office/drawing/2014/main" id="{6D24FC52-429D-4CB7-8032-21F10BD64E89}"/>
               </a:ext>
             </a:extLst>
           </p:cNvPr>
@@ -3851,6 +4988,9 @@
                 <a:solidFill>
                   <a:srgbClr val="634893"/>
                 </a:solidFill>
+                <a:latin typeface="Microsoft YaHei"/>
+                <a:ea typeface="Microsoft YaHei"/>
+                <a:cs typeface="Microsoft YaHei"/>
               </a:defRPr>
             </a:pPr>
             <a:r>
@@ -3858,6 +4998,9 @@
                 <a:solidFill>
                   <a:srgbClr val="634893"/>
                 </a:solidFill>
+                <a:latin typeface="Microsoft YaHei"/>
+                <a:ea typeface="Microsoft YaHei"/>
+                <a:cs typeface="Microsoft YaHei"/>
               </a:rPr>
               <a:t>Crafting</a:t>
             </a:r>
@@ -3869,7 +5012,7 @@
           <p:cNvPr id="5" name="">
             <a:extLst xmlns:a="http://schemas.openxmlformats.org/drawingml/2006/main">
               <a:ext uri="{FF2B5EF4-FFF2-40B4-BE49-F238E27FC236}">
-                <a16:creationId xmlns:a16="http://schemas.microsoft.com/office/drawing/2014/main" id="{B014DD68-A890-4597-A37B-B30F44B9DEF7}"/>
+                <a16:creationId xmlns:a16="http://schemas.microsoft.com/office/drawing/2014/main" id="{417F9158-04A5-474C-91A4-9BE13021C234}"/>
               </a:ext>
             </a:extLst>
           </p:cNvPr>
@@ -3901,6 +5044,9 @@
                 <a:solidFill>
                   <a:srgbClr val="FF80B8"/>
                 </a:solidFill>
+                <a:latin typeface="Microsoft YaHei"/>
+                <a:ea typeface="Microsoft YaHei"/>
+                <a:cs typeface="Microsoft YaHei"/>
               </a:defRPr>
             </a:pPr>
             <a:r>
@@ -3908,8 +5054,11 @@
                 <a:solidFill>
                   <a:srgbClr val="FF80B8"/>
                 </a:solidFill>
+                <a:latin typeface="Microsoft YaHei"/>
+                <a:ea typeface="Microsoft YaHei"/>
+                <a:cs typeface="Microsoft YaHei"/>
               </a:rPr>
-              <a:t>➜</a:t>
+              <a:t>→</a:t>
             </a:r>
           </a:p>
         </p:txBody>
@@ -3923,7 +5072,7 @@
           <p:nvPr/>
         </p:nvPicPr>
         <p:blipFill>
-          <a:blip xmlns:r="http://schemas.openxmlformats.org/officeDocument/2006/relationships" xmlns:a="http://schemas.openxmlformats.org/drawingml/2006/main" r:embed="Rc96c5f54761d475d"/>
+          <a:blip xmlns:r="http://schemas.openxmlformats.org/officeDocument/2006/relationships" xmlns:a="http://schemas.openxmlformats.org/drawingml/2006/main" r:embed="R1c8dbdadd61044cc"/>
           <a:srcRect xmlns:a="http://schemas.openxmlformats.org/drawingml/2006/main" l="10473" t="0" r="10473" b="0"/>
           <a:stretch xmlns:a="http://schemas.openxmlformats.org/drawingml/2006/main">
             <a:fillRect l="0" t="0" r="0" b="0"/>
@@ -3944,7 +5093,7 @@
           <p:cNvPr id="7" name="">
             <a:extLst xmlns:a="http://schemas.openxmlformats.org/drawingml/2006/main">
               <a:ext uri="{FF2B5EF4-FFF2-40B4-BE49-F238E27FC236}">
-                <a16:creationId xmlns:a16="http://schemas.microsoft.com/office/drawing/2014/main" id="{F4DA4858-6455-4E03-81C2-7B57F60E651B}"/>
+                <a16:creationId xmlns:a16="http://schemas.microsoft.com/office/drawing/2014/main" id="{1CF7089B-9C5C-46A5-97D5-175B3EC978A6}"/>
               </a:ext>
             </a:extLst>
           </p:cNvPr>
@@ -3976,6 +5125,9 @@
                 <a:solidFill>
                   <a:srgbClr val="634893"/>
                 </a:solidFill>
+                <a:latin typeface="Microsoft YaHei"/>
+                <a:ea typeface="Microsoft YaHei"/>
+                <a:cs typeface="Microsoft YaHei"/>
               </a:defRPr>
             </a:pPr>
             <a:r>
@@ -3983,6 +5135,9 @@
                 <a:solidFill>
                   <a:srgbClr val="634893"/>
                 </a:solidFill>
+                <a:latin typeface="Microsoft YaHei"/>
+                <a:ea typeface="Microsoft YaHei"/>
+                <a:cs typeface="Microsoft YaHei"/>
               </a:rPr>
               <a:t>Skill Tree</a:t>
             </a:r>
@@ -3994,7 +5149,7 @@
           <p:cNvPr id="8" name="">
             <a:extLst xmlns:a="http://schemas.openxmlformats.org/drawingml/2006/main">
               <a:ext uri="{FF2B5EF4-FFF2-40B4-BE49-F238E27FC236}">
-                <a16:creationId xmlns:a16="http://schemas.microsoft.com/office/drawing/2014/main" id="{96704CF1-E090-4ACB-99C6-2B2F542FD2D1}"/>
+                <a16:creationId xmlns:a16="http://schemas.microsoft.com/office/drawing/2014/main" id="{8F546C04-FEE0-43AE-8CAD-4F1E376E3D2F}"/>
               </a:ext>
             </a:extLst>
           </p:cNvPr>
@@ -4026,6 +5181,9 @@
                 <a:solidFill>
                   <a:srgbClr val="FF80B8"/>
                 </a:solidFill>
+                <a:latin typeface="Microsoft YaHei"/>
+                <a:ea typeface="Microsoft YaHei"/>
+                <a:cs typeface="Microsoft YaHei"/>
               </a:defRPr>
             </a:pPr>
             <a:r>
@@ -4033,8 +5191,11 @@
                 <a:solidFill>
                   <a:srgbClr val="FF80B8"/>
                 </a:solidFill>
+                <a:latin typeface="Microsoft YaHei"/>
+                <a:ea typeface="Microsoft YaHei"/>
+                <a:cs typeface="Microsoft YaHei"/>
               </a:rPr>
-              <a:t>05 / 07</a:t>
+              <a:t>06 / 08</a:t>
             </a:r>
           </a:p>
         </p:txBody>
@@ -4044,7 +5205,7 @@
           <p:cNvPr id="9" name="">
             <a:extLst xmlns:a="http://schemas.openxmlformats.org/drawingml/2006/main">
               <a:ext uri="{FF2B5EF4-FFF2-40B4-BE49-F238E27FC236}">
-                <a16:creationId xmlns:a16="http://schemas.microsoft.com/office/drawing/2014/main" id="{A13C9E43-E0B2-4016-90B7-16F096C4797C}"/>
+                <a16:creationId xmlns:a16="http://schemas.microsoft.com/office/drawing/2014/main" id="{B8394539-70B9-4ED7-94DE-4214DCE0BD3F}"/>
               </a:ext>
             </a:extLst>
           </p:cNvPr>
@@ -4056,7 +5217,7 @@
         <p:spPr>
           <a:xfrm xmlns:a="http://schemas.openxmlformats.org/drawingml/2006/main">
             <a:off x="1428750" y="6515100"/>
-            <a:ext cx="4191000" cy="209550"/>
+            <a:ext cx="4381500" cy="209550"/>
           </a:xfrm>
           <a:prstGeom xmlns:a="http://schemas.openxmlformats.org/drawingml/2006/main" prst="rect">
             <a:avLst/>
@@ -4076,6 +5237,9 @@
                 <a:solidFill>
                   <a:srgbClr val="695F84"/>
                 </a:solidFill>
+                <a:latin typeface="Microsoft YaHei"/>
+                <a:ea typeface="Microsoft YaHei"/>
+                <a:cs typeface="Microsoft YaHei"/>
               </a:defRPr>
             </a:pPr>
             <a:r>
@@ -4083,8 +5247,11 @@
                 <a:solidFill>
                   <a:srgbClr val="695F84"/>
                 </a:solidFill>
+                <a:latin typeface="Microsoft YaHei"/>
+                <a:ea typeface="Microsoft YaHei"/>
+                <a:cs typeface="Microsoft YaHei"/>
               </a:rPr>
-              <a:t>能工智人：遗忘工坊 | 落云宗：秦天 / 陈磊</a:t>
+              <a:t>能工智人：糖芯工坊 | 落云宗：秦天 / 陈磊</a:t>
             </a:r>
           </a:p>
         </p:txBody>
@@ -4092,14 +5259,14 @@
     </p:spTree>
     <p:extLst>
       <p:ext uri="{BB962C8B-B14F-4D97-AF65-F5344CB8AC3E}">
-        <p14:creationId xmlns:p14="http://schemas.microsoft.com/office/powerpoint/2010/main" val="1982670363"/>
+        <p14:creationId xmlns:p14="http://schemas.microsoft.com/office/powerpoint/2010/main" val="545883949"/>
       </p:ext>
     </p:extLst>
   </p:cSld>
 </p:sld>
 </file>
 
-<file path=ppt/slides/slide6.xml><?xml version="1.0" encoding="utf-8"?>
+<file path=ppt/slides/slide7.xml><?xml version="1.0" encoding="utf-8"?>
 <p:sld xmlns:p="http://schemas.openxmlformats.org/presentationml/2006/main">
   <p:cSld>
     <p:bg>
@@ -4123,7 +5290,7 @@
           <p:cNvPr id="1" name="">
             <a:extLst xmlns:a="http://schemas.openxmlformats.org/drawingml/2006/main">
               <a:ext uri="{FF2B5EF4-FFF2-40B4-BE49-F238E27FC236}">
-                <a16:creationId xmlns:a16="http://schemas.microsoft.com/office/drawing/2014/main" id="{2CCE6370-5D6D-45FD-AB7C-ECB5C7B78F32}"/>
+                <a16:creationId xmlns:a16="http://schemas.microsoft.com/office/drawing/2014/main" id="{1B09C913-49E7-40EF-AF49-CC83BD1982E6}"/>
               </a:ext>
             </a:extLst>
           </p:cNvPr>
@@ -4155,6 +5322,9 @@
                 <a:solidFill>
                   <a:srgbClr val="2C2348"/>
                 </a:solidFill>
+                <a:latin typeface="Microsoft YaHei"/>
+                <a:ea typeface="Microsoft YaHei"/>
+                <a:cs typeface="Microsoft YaHei"/>
               </a:defRPr>
             </a:pPr>
             <a:r>
@@ -4162,8 +5332,11 @@
                 <a:solidFill>
                   <a:srgbClr val="2C2348"/>
                 </a:solidFill>
+                <a:latin typeface="Microsoft YaHei"/>
+                <a:ea typeface="Microsoft YaHei"/>
+                <a:cs typeface="Microsoft YaHei"/>
               </a:rPr>
-              <a:t>Demo 录屏路线</a:t>
+              <a:t>Demo 体验流程</a:t>
             </a:r>
           </a:p>
         </p:txBody>
@@ -4173,7 +5346,7 @@
           <p:cNvPr id="2" name="">
             <a:extLst xmlns:a="http://schemas.openxmlformats.org/drawingml/2006/main">
               <a:ext uri="{FF2B5EF4-FFF2-40B4-BE49-F238E27FC236}">
-                <a16:creationId xmlns:a16="http://schemas.microsoft.com/office/drawing/2014/main" id="{41331091-5E38-45B7-95D3-946309A1688F}"/>
+                <a16:creationId xmlns:a16="http://schemas.microsoft.com/office/drawing/2014/main" id="{397B2F08-518C-4F96-AA78-3A0DC74141DC}"/>
               </a:ext>
             </a:extLst>
           </p:cNvPr>
@@ -4185,7 +5358,7 @@
         <p:spPr>
           <a:xfrm xmlns:a="http://schemas.openxmlformats.org/drawingml/2006/main">
             <a:off x="628650" y="1028700"/>
-            <a:ext cx="6477000" cy="304800"/>
+            <a:ext cx="8191500" cy="304800"/>
           </a:xfrm>
           <a:prstGeom xmlns:a="http://schemas.openxmlformats.org/drawingml/2006/main" prst="rect">
             <a:avLst/>
@@ -4205,6 +5378,9 @@
                 <a:solidFill>
                   <a:srgbClr val="695F84"/>
                 </a:solidFill>
+                <a:latin typeface="Microsoft YaHei"/>
+                <a:ea typeface="Microsoft YaHei"/>
+                <a:cs typeface="Microsoft YaHei"/>
               </a:defRPr>
             </a:pPr>
             <a:r>
@@ -4212,8 +5388,11 @@
                 <a:solidFill>
                   <a:srgbClr val="695F84"/>
                 </a:solidFill>
+                <a:latin typeface="Microsoft YaHei"/>
+                <a:ea typeface="Microsoft YaHei"/>
+                <a:cs typeface="Microsoft YaHei"/>
               </a:rPr>
-              <a:t>按这个顺序录，评委 3–5 分钟可以看懂完整闭环。</a:t>
+              <a:t>3–5 分钟展示完整游戏闭环：穿越开场、NPC 对话、战斗、成长、合成、Boss 战与结局。</a:t>
             </a:r>
           </a:p>
         </p:txBody>
@@ -4227,7 +5406,7 @@
           <p:nvPr/>
         </p:nvPicPr>
         <p:blipFill>
-          <a:blip xmlns:r="http://schemas.openxmlformats.org/officeDocument/2006/relationships" xmlns:a="http://schemas.openxmlformats.org/drawingml/2006/main" r:embed="R78c74e4e52e447d6"/>
+          <a:blip xmlns:r="http://schemas.openxmlformats.org/officeDocument/2006/relationships" xmlns:a="http://schemas.openxmlformats.org/drawingml/2006/main" r:embed="R9296ac92d9204bb3"/>
           <a:srcRect xmlns:a="http://schemas.openxmlformats.org/drawingml/2006/main" l="0" t="5556" r="0" b="5556"/>
           <a:stretch xmlns:a="http://schemas.openxmlformats.org/drawingml/2006/main">
             <a:fillRect l="0" t="0" r="0" b="0"/>
@@ -4248,7 +5427,7 @@
           <p:cNvPr id="4" name="">
             <a:extLst xmlns:a="http://schemas.openxmlformats.org/drawingml/2006/main">
               <a:ext uri="{FF2B5EF4-FFF2-40B4-BE49-F238E27FC236}">
-                <a16:creationId xmlns:a16="http://schemas.microsoft.com/office/drawing/2014/main" id="{C1969A95-EA7C-4FE3-80DF-89F5E9C983DA}"/>
+                <a16:creationId xmlns:a16="http://schemas.microsoft.com/office/drawing/2014/main" id="{E5B29531-DA3F-4C6B-B167-5A639E96E2F0}"/>
               </a:ext>
             </a:extLst>
           </p:cNvPr>
@@ -4280,6 +5459,9 @@
                 <a:solidFill>
                   <a:srgbClr val="2C2348"/>
                 </a:solidFill>
+                <a:latin typeface="Microsoft YaHei"/>
+                <a:ea typeface="Microsoft YaHei"/>
+                <a:cs typeface="Microsoft YaHei"/>
               </a:defRPr>
             </a:pPr>
             <a:r>
@@ -4287,6 +5469,9 @@
                 <a:solidFill>
                   <a:srgbClr val="2C2348"/>
                 </a:solidFill>
+                <a:latin typeface="Microsoft YaHei"/>
+                <a:ea typeface="Microsoft YaHei"/>
+                <a:cs typeface="Microsoft YaHei"/>
               </a:rPr>
               <a:t>0:00 移动</a:t>
             </a:r>
@@ -4302,7 +5487,7 @@
           <p:nvPr/>
         </p:nvPicPr>
         <p:blipFill>
-          <a:blip xmlns:r="http://schemas.openxmlformats.org/officeDocument/2006/relationships" xmlns:a="http://schemas.openxmlformats.org/drawingml/2006/main" r:embed="R4dfd7fbc7bb84f49"/>
+          <a:blip xmlns:r="http://schemas.openxmlformats.org/officeDocument/2006/relationships" xmlns:a="http://schemas.openxmlformats.org/drawingml/2006/main" r:embed="R189a1fe1c6e546ed"/>
           <a:srcRect xmlns:a="http://schemas.openxmlformats.org/drawingml/2006/main" l="0" t="5556" r="0" b="5556"/>
           <a:stretch xmlns:a="http://schemas.openxmlformats.org/drawingml/2006/main">
             <a:fillRect l="0" t="0" r="0" b="0"/>
@@ -4323,7 +5508,7 @@
           <p:cNvPr id="6" name="">
             <a:extLst xmlns:a="http://schemas.openxmlformats.org/drawingml/2006/main">
               <a:ext uri="{FF2B5EF4-FFF2-40B4-BE49-F238E27FC236}">
-                <a16:creationId xmlns:a16="http://schemas.microsoft.com/office/drawing/2014/main" id="{CCAF921F-4373-43C1-8029-7358F7BB76DD}"/>
+                <a16:creationId xmlns:a16="http://schemas.microsoft.com/office/drawing/2014/main" id="{2CCEB1E8-6912-4BB2-9FD2-AA460E9D05BB}"/>
               </a:ext>
             </a:extLst>
           </p:cNvPr>
@@ -4355,6 +5540,9 @@
                 <a:solidFill>
                   <a:srgbClr val="2C2348"/>
                 </a:solidFill>
+                <a:latin typeface="Microsoft YaHei"/>
+                <a:ea typeface="Microsoft YaHei"/>
+                <a:cs typeface="Microsoft YaHei"/>
               </a:defRPr>
             </a:pPr>
             <a:r>
@@ -4362,6 +5550,9 @@
                 <a:solidFill>
                   <a:srgbClr val="2C2348"/>
                 </a:solidFill>
+                <a:latin typeface="Microsoft YaHei"/>
+                <a:ea typeface="Microsoft YaHei"/>
+                <a:cs typeface="Microsoft YaHei"/>
               </a:rPr>
               <a:t>0:30 对话</a:t>
             </a:r>
@@ -4377,7 +5568,7 @@
           <p:nvPr/>
         </p:nvPicPr>
         <p:blipFill>
-          <a:blip xmlns:r="http://schemas.openxmlformats.org/officeDocument/2006/relationships" xmlns:a="http://schemas.openxmlformats.org/drawingml/2006/main" r:embed="Re221589b14334054"/>
+          <a:blip xmlns:r="http://schemas.openxmlformats.org/officeDocument/2006/relationships" xmlns:a="http://schemas.openxmlformats.org/drawingml/2006/main" r:embed="R864dfae6de764400"/>
           <a:srcRect xmlns:a="http://schemas.openxmlformats.org/drawingml/2006/main" l="0" t="5556" r="0" b="5556"/>
           <a:stretch xmlns:a="http://schemas.openxmlformats.org/drawingml/2006/main">
             <a:fillRect l="0" t="0" r="0" b="0"/>
@@ -4398,7 +5589,7 @@
           <p:cNvPr id="8" name="">
             <a:extLst xmlns:a="http://schemas.openxmlformats.org/drawingml/2006/main">
               <a:ext uri="{FF2B5EF4-FFF2-40B4-BE49-F238E27FC236}">
-                <a16:creationId xmlns:a16="http://schemas.microsoft.com/office/drawing/2014/main" id="{EBE8602D-F403-4622-88FB-6210B219C3D4}"/>
+                <a16:creationId xmlns:a16="http://schemas.microsoft.com/office/drawing/2014/main" id="{FC738026-C483-4278-9B44-61592576D7B7}"/>
               </a:ext>
             </a:extLst>
           </p:cNvPr>
@@ -4430,6 +5621,9 @@
                 <a:solidFill>
                   <a:srgbClr val="2C2348"/>
                 </a:solidFill>
+                <a:latin typeface="Microsoft YaHei"/>
+                <a:ea typeface="Microsoft YaHei"/>
+                <a:cs typeface="Microsoft YaHei"/>
               </a:defRPr>
             </a:pPr>
             <a:r>
@@ -4437,6 +5631,9 @@
                 <a:solidFill>
                   <a:srgbClr val="2C2348"/>
                 </a:solidFill>
+                <a:latin typeface="Microsoft YaHei"/>
+                <a:ea typeface="Microsoft YaHei"/>
+                <a:cs typeface="Microsoft YaHei"/>
               </a:rPr>
               <a:t>1:30 背包</a:t>
             </a:r>
@@ -4452,7 +5649,7 @@
           <p:nvPr/>
         </p:nvPicPr>
         <p:blipFill>
-          <a:blip xmlns:r="http://schemas.openxmlformats.org/officeDocument/2006/relationships" xmlns:a="http://schemas.openxmlformats.org/drawingml/2006/main" r:embed="Rd2c4a36fcb774ea4"/>
+          <a:blip xmlns:r="http://schemas.openxmlformats.org/officeDocument/2006/relationships" xmlns:a="http://schemas.openxmlformats.org/drawingml/2006/main" r:embed="R0effa891b20c4c6b"/>
           <a:srcRect xmlns:a="http://schemas.openxmlformats.org/drawingml/2006/main" l="0" t="5556" r="0" b="5556"/>
           <a:stretch xmlns:a="http://schemas.openxmlformats.org/drawingml/2006/main">
             <a:fillRect l="0" t="0" r="0" b="0"/>
@@ -4473,7 +5670,7 @@
           <p:cNvPr id="10" name="">
             <a:extLst xmlns:a="http://schemas.openxmlformats.org/drawingml/2006/main">
               <a:ext uri="{FF2B5EF4-FFF2-40B4-BE49-F238E27FC236}">
-                <a16:creationId xmlns:a16="http://schemas.microsoft.com/office/drawing/2014/main" id="{E9045BB5-3FBE-4098-8A9E-D6286F05CFBE}"/>
+                <a16:creationId xmlns:a16="http://schemas.microsoft.com/office/drawing/2014/main" id="{07C20B19-209C-4756-88A8-989681744081}"/>
               </a:ext>
             </a:extLst>
           </p:cNvPr>
@@ -4505,6 +5702,9 @@
                 <a:solidFill>
                   <a:srgbClr val="2C2348"/>
                 </a:solidFill>
+                <a:latin typeface="Microsoft YaHei"/>
+                <a:ea typeface="Microsoft YaHei"/>
+                <a:cs typeface="Microsoft YaHei"/>
               </a:defRPr>
             </a:pPr>
             <a:r>
@@ -4512,6 +5712,9 @@
                 <a:solidFill>
                   <a:srgbClr val="2C2348"/>
                 </a:solidFill>
+                <a:latin typeface="Microsoft YaHei"/>
+                <a:ea typeface="Microsoft YaHei"/>
+                <a:cs typeface="Microsoft YaHei"/>
               </a:rPr>
               <a:t>2:00 合成</a:t>
             </a:r>
@@ -4527,7 +5730,7 @@
           <p:nvPr/>
         </p:nvPicPr>
         <p:blipFill>
-          <a:blip xmlns:r="http://schemas.openxmlformats.org/officeDocument/2006/relationships" xmlns:a="http://schemas.openxmlformats.org/drawingml/2006/main" r:embed="R0550b6aa0df7400b"/>
+          <a:blip xmlns:r="http://schemas.openxmlformats.org/officeDocument/2006/relationships" xmlns:a="http://schemas.openxmlformats.org/drawingml/2006/main" r:embed="R537ee63054524980"/>
           <a:srcRect xmlns:a="http://schemas.openxmlformats.org/drawingml/2006/main" l="0" t="5556" r="0" b="5556"/>
           <a:stretch xmlns:a="http://schemas.openxmlformats.org/drawingml/2006/main">
             <a:fillRect l="0" t="0" r="0" b="0"/>
@@ -4548,7 +5751,7 @@
           <p:cNvPr id="12" name="">
             <a:extLst xmlns:a="http://schemas.openxmlformats.org/drawingml/2006/main">
               <a:ext uri="{FF2B5EF4-FFF2-40B4-BE49-F238E27FC236}">
-                <a16:creationId xmlns:a16="http://schemas.microsoft.com/office/drawing/2014/main" id="{2EB94F0C-4472-41A5-A299-71FF9D36BB87}"/>
+                <a16:creationId xmlns:a16="http://schemas.microsoft.com/office/drawing/2014/main" id="{4138E1EA-7426-4AEA-8200-D9488FB5ED4E}"/>
               </a:ext>
             </a:extLst>
           </p:cNvPr>
@@ -4580,6 +5783,9 @@
                 <a:solidFill>
                   <a:srgbClr val="2C2348"/>
                 </a:solidFill>
+                <a:latin typeface="Microsoft YaHei"/>
+                <a:ea typeface="Microsoft YaHei"/>
+                <a:cs typeface="Microsoft YaHei"/>
               </a:defRPr>
             </a:pPr>
             <a:r>
@@ -4587,6 +5793,9 @@
                 <a:solidFill>
                   <a:srgbClr val="2C2348"/>
                 </a:solidFill>
+                <a:latin typeface="Microsoft YaHei"/>
+                <a:ea typeface="Microsoft YaHei"/>
+                <a:cs typeface="Microsoft YaHei"/>
               </a:rPr>
               <a:t>2:30 技能</a:t>
             </a:r>
@@ -4602,7 +5811,7 @@
           <p:nvPr/>
         </p:nvPicPr>
         <p:blipFill>
-          <a:blip xmlns:r="http://schemas.openxmlformats.org/officeDocument/2006/relationships" xmlns:a="http://schemas.openxmlformats.org/drawingml/2006/main" r:embed="Rad1da7ed25d94ee3"/>
+          <a:blip xmlns:r="http://schemas.openxmlformats.org/officeDocument/2006/relationships" xmlns:a="http://schemas.openxmlformats.org/drawingml/2006/main" r:embed="R674ab5fb9fce4570"/>
           <a:srcRect xmlns:a="http://schemas.openxmlformats.org/drawingml/2006/main" l="0" t="5556" r="0" b="5556"/>
           <a:stretch xmlns:a="http://schemas.openxmlformats.org/drawingml/2006/main">
             <a:fillRect l="0" t="0" r="0" b="0"/>
@@ -4623,7 +5832,7 @@
           <p:cNvPr id="14" name="">
             <a:extLst xmlns:a="http://schemas.openxmlformats.org/drawingml/2006/main">
               <a:ext uri="{FF2B5EF4-FFF2-40B4-BE49-F238E27FC236}">
-                <a16:creationId xmlns:a16="http://schemas.microsoft.com/office/drawing/2014/main" id="{B1081F2D-CA5B-448C-A89A-26D368646911}"/>
+                <a16:creationId xmlns:a16="http://schemas.microsoft.com/office/drawing/2014/main" id="{84F2FC39-4F43-4D7E-ADC7-288BC1933CF8}"/>
               </a:ext>
             </a:extLst>
           </p:cNvPr>
@@ -4655,6 +5864,9 @@
                 <a:solidFill>
                   <a:srgbClr val="2C2348"/>
                 </a:solidFill>
+                <a:latin typeface="Microsoft YaHei"/>
+                <a:ea typeface="Microsoft YaHei"/>
+                <a:cs typeface="Microsoft YaHei"/>
               </a:defRPr>
             </a:pPr>
             <a:r>
@@ -4662,6 +5874,9 @@
                 <a:solidFill>
                   <a:srgbClr val="2C2348"/>
                 </a:solidFill>
+                <a:latin typeface="Microsoft YaHei"/>
+                <a:ea typeface="Microsoft YaHei"/>
+                <a:cs typeface="Microsoft YaHei"/>
               </a:rPr>
               <a:t>3:30 Boss</a:t>
             </a:r>
@@ -4673,7 +5888,7 @@
           <p:cNvPr id="15" name="">
             <a:extLst xmlns:a="http://schemas.openxmlformats.org/drawingml/2006/main">
               <a:ext uri="{FF2B5EF4-FFF2-40B4-BE49-F238E27FC236}">
-                <a16:creationId xmlns:a16="http://schemas.microsoft.com/office/drawing/2014/main" id="{353144B7-9BBB-43AF-A89F-275405674F8D}"/>
+                <a16:creationId xmlns:a16="http://schemas.microsoft.com/office/drawing/2014/main" id="{5E0B4882-3BFB-4AC2-AAA8-6514FA1A714A}"/>
               </a:ext>
             </a:extLst>
           </p:cNvPr>
@@ -4705,6 +5920,9 @@
                 <a:solidFill>
                   <a:srgbClr val="FF80B8"/>
                 </a:solidFill>
+                <a:latin typeface="Microsoft YaHei"/>
+                <a:ea typeface="Microsoft YaHei"/>
+                <a:cs typeface="Microsoft YaHei"/>
               </a:defRPr>
             </a:pPr>
             <a:r>
@@ -4712,8 +5930,11 @@
                 <a:solidFill>
                   <a:srgbClr val="FF80B8"/>
                 </a:solidFill>
+                <a:latin typeface="Microsoft YaHei"/>
+                <a:ea typeface="Microsoft YaHei"/>
+                <a:cs typeface="Microsoft YaHei"/>
               </a:rPr>
-              <a:t>06 / 07</a:t>
+              <a:t>07 / 08</a:t>
             </a:r>
           </a:p>
         </p:txBody>
@@ -4723,7 +5944,7 @@
           <p:cNvPr id="16" name="">
             <a:extLst xmlns:a="http://schemas.openxmlformats.org/drawingml/2006/main">
               <a:ext uri="{FF2B5EF4-FFF2-40B4-BE49-F238E27FC236}">
-                <a16:creationId xmlns:a16="http://schemas.microsoft.com/office/drawing/2014/main" id="{BF8F2C28-B6E2-4D6D-B957-A7CE6EFF1161}"/>
+                <a16:creationId xmlns:a16="http://schemas.microsoft.com/office/drawing/2014/main" id="{BA5560E4-2981-4AD5-A8B2-306323FF8FA9}"/>
               </a:ext>
             </a:extLst>
           </p:cNvPr>
@@ -4735,7 +5956,7 @@
         <p:spPr>
           <a:xfrm xmlns:a="http://schemas.openxmlformats.org/drawingml/2006/main">
             <a:off x="1428750" y="6515100"/>
-            <a:ext cx="4191000" cy="209550"/>
+            <a:ext cx="4381500" cy="209550"/>
           </a:xfrm>
           <a:prstGeom xmlns:a="http://schemas.openxmlformats.org/drawingml/2006/main" prst="rect">
             <a:avLst/>
@@ -4755,6 +5976,9 @@
                 <a:solidFill>
                   <a:srgbClr val="695F84"/>
                 </a:solidFill>
+                <a:latin typeface="Microsoft YaHei"/>
+                <a:ea typeface="Microsoft YaHei"/>
+                <a:cs typeface="Microsoft YaHei"/>
               </a:defRPr>
             </a:pPr>
             <a:r>
@@ -4762,8 +5986,11 @@
                 <a:solidFill>
                   <a:srgbClr val="695F84"/>
                 </a:solidFill>
+                <a:latin typeface="Microsoft YaHei"/>
+                <a:ea typeface="Microsoft YaHei"/>
+                <a:cs typeface="Microsoft YaHei"/>
               </a:rPr>
-              <a:t>能工智人：遗忘工坊 | 落云宗：秦天 / 陈磊</a:t>
+              <a:t>能工智人：糖芯工坊 | 落云宗：秦天 / 陈磊</a:t>
             </a:r>
           </a:p>
         </p:txBody>
@@ -4771,14 +5998,14 @@
     </p:spTree>
     <p:extLst>
       <p:ext uri="{BB962C8B-B14F-4D97-AF65-F5344CB8AC3E}">
-        <p14:creationId xmlns:p14="http://schemas.microsoft.com/office/powerpoint/2010/main" val="1369363917"/>
+        <p14:creationId xmlns:p14="http://schemas.microsoft.com/office/powerpoint/2010/main" val="466253113"/>
       </p:ext>
     </p:extLst>
   </p:cSld>
 </p:sld>
 </file>
 
-<file path=ppt/slides/slide7.xml><?xml version="1.0" encoding="utf-8"?>
+<file path=ppt/slides/slide8.xml><?xml version="1.0" encoding="utf-8"?>
 <p:sld xmlns:p="http://schemas.openxmlformats.org/presentationml/2006/main">
   <p:cSld>
     <p:bg>
@@ -4802,7 +6029,7 @@
           <p:cNvPr id="1" name="">
             <a:extLst xmlns:a="http://schemas.openxmlformats.org/drawingml/2006/main">
               <a:ext uri="{FF2B5EF4-FFF2-40B4-BE49-F238E27FC236}">
-                <a16:creationId xmlns:a16="http://schemas.microsoft.com/office/drawing/2014/main" id="{F0F02F58-778D-4264-A006-4A8165F684F8}"/>
+                <a16:creationId xmlns:a16="http://schemas.microsoft.com/office/drawing/2014/main" id="{739E7170-6AE1-4F79-9690-2E7EB73D0DC0}"/>
               </a:ext>
             </a:extLst>
           </p:cNvPr>
@@ -4834,6 +6061,9 @@
                 <a:solidFill>
                   <a:srgbClr val="2C2348"/>
                 </a:solidFill>
+                <a:latin typeface="Microsoft YaHei"/>
+                <a:ea typeface="Microsoft YaHei"/>
+                <a:cs typeface="Microsoft YaHei"/>
               </a:defRPr>
             </a:pPr>
             <a:r>
@@ -4841,6 +6071,9 @@
                 <a:solidFill>
                   <a:srgbClr val="2C2348"/>
                 </a:solidFill>
+                <a:latin typeface="Microsoft YaHei"/>
+                <a:ea typeface="Microsoft YaHei"/>
+                <a:cs typeface="Microsoft YaHei"/>
               </a:rPr>
               <a:t>技术结构与部署准备</a:t>
             </a:r>
@@ -4856,7 +6089,7 @@
           <p:nvPr/>
         </p:nvPicPr>
         <p:blipFill>
-          <a:blip xmlns:r="http://schemas.openxmlformats.org/officeDocument/2006/relationships" xmlns:a="http://schemas.openxmlformats.org/drawingml/2006/main" r:embed="Rec980da1b67a44ba"/>
+          <a:blip xmlns:r="http://schemas.openxmlformats.org/officeDocument/2006/relationships" xmlns:a="http://schemas.openxmlformats.org/drawingml/2006/main" r:embed="R70d9433792e84eb1"/>
           <a:stretch xmlns:a="http://schemas.openxmlformats.org/drawingml/2006/main"/>
         </p:blipFill>
         <p:spPr>
@@ -4878,7 +6111,7 @@
           <p:nvPr/>
         </p:nvPicPr>
         <p:blipFill>
-          <a:blip xmlns:r="http://schemas.openxmlformats.org/officeDocument/2006/relationships" xmlns:a="http://schemas.openxmlformats.org/drawingml/2006/main" r:embed="R38d82cb2f59f4a06"/>
+          <a:blip xmlns:r="http://schemas.openxmlformats.org/officeDocument/2006/relationships" xmlns:a="http://schemas.openxmlformats.org/drawingml/2006/main" r:embed="Rdd4a6b6a2fe9489b"/>
           <a:srcRect xmlns:a="http://schemas.openxmlformats.org/drawingml/2006/main" l="1042" t="0" r="1042" b="0"/>
           <a:stretch xmlns:a="http://schemas.openxmlformats.org/drawingml/2006/main">
             <a:fillRect l="0" t="0" r="0" b="0"/>
@@ -4899,7 +6132,7 @@
           <p:cNvPr id="4" name="">
             <a:extLst xmlns:a="http://schemas.openxmlformats.org/drawingml/2006/main">
               <a:ext uri="{FF2B5EF4-FFF2-40B4-BE49-F238E27FC236}">
-                <a16:creationId xmlns:a16="http://schemas.microsoft.com/office/drawing/2014/main" id="{89DF0C98-FE04-4779-A161-064A9F73637C}"/>
+                <a16:creationId xmlns:a16="http://schemas.microsoft.com/office/drawing/2014/main" id="{BDF352AD-2786-444E-9312-F43E5DA3F0DE}"/>
               </a:ext>
             </a:extLst>
           </p:cNvPr>
@@ -4931,6 +6164,9 @@
                 <a:solidFill>
                   <a:srgbClr val="634893"/>
                 </a:solidFill>
+                <a:latin typeface="Microsoft YaHei"/>
+                <a:ea typeface="Microsoft YaHei"/>
+                <a:cs typeface="Microsoft YaHei"/>
               </a:defRPr>
             </a:pPr>
             <a:r>
@@ -4938,6 +6174,9 @@
                 <a:solidFill>
                   <a:srgbClr val="634893"/>
                 </a:solidFill>
+                <a:latin typeface="Microsoft YaHei"/>
+                <a:ea typeface="Microsoft YaHei"/>
+                <a:cs typeface="Microsoft YaHei"/>
               </a:rPr>
               <a:t>Unity 2D 模块</a:t>
             </a:r>
@@ -4949,7 +6188,7 @@
           <p:cNvPr id="5" name="">
             <a:extLst xmlns:a="http://schemas.openxmlformats.org/drawingml/2006/main">
               <a:ext uri="{FF2B5EF4-FFF2-40B4-BE49-F238E27FC236}">
-                <a16:creationId xmlns:a16="http://schemas.microsoft.com/office/drawing/2014/main" id="{C760CFD5-EE8A-4D02-B70E-759379472341}"/>
+                <a16:creationId xmlns:a16="http://schemas.microsoft.com/office/drawing/2014/main" id="{157A4129-F5A6-4AD8-91A3-8BE49A4581FE}"/>
               </a:ext>
             </a:extLst>
           </p:cNvPr>
@@ -4981,6 +6220,9 @@
                 <a:solidFill>
                   <a:srgbClr val="695F84"/>
                 </a:solidFill>
+                <a:latin typeface="Microsoft YaHei"/>
+                <a:ea typeface="Microsoft YaHei"/>
+                <a:cs typeface="Microsoft YaHei"/>
               </a:defRPr>
             </a:pPr>
             <a:r>
@@ -4988,6 +6230,9 @@
                 <a:solidFill>
                   <a:srgbClr val="695F84"/>
                 </a:solidFill>
+                <a:latin typeface="Microsoft YaHei"/>
+                <a:ea typeface="Microsoft YaHei"/>
+                <a:cs typeface="Microsoft YaHei"/>
               </a:rPr>
               <a:t>Player / Combat / Enemy / Rooms / UI / Dialogue / Craft / Skill</a:t>
             </a:r>
@@ -4999,7 +6244,7 @@
           <p:cNvPr id="6" name="">
             <a:extLst xmlns:a="http://schemas.openxmlformats.org/drawingml/2006/main">
               <a:ext uri="{FF2B5EF4-FFF2-40B4-BE49-F238E27FC236}">
-                <a16:creationId xmlns:a16="http://schemas.microsoft.com/office/drawing/2014/main" id="{A80D0940-87F8-49B1-B578-2BDD2245EDC9}"/>
+                <a16:creationId xmlns:a16="http://schemas.microsoft.com/office/drawing/2014/main" id="{B3595FB6-B740-44C4-9171-A9180423F772}"/>
               </a:ext>
             </a:extLst>
           </p:cNvPr>
@@ -5031,6 +6276,9 @@
                 <a:solidFill>
                   <a:srgbClr val="2C2348"/>
                 </a:solidFill>
+                <a:latin typeface="Microsoft YaHei"/>
+                <a:ea typeface="Microsoft YaHei"/>
+                <a:cs typeface="Microsoft YaHei"/>
               </a:defRPr>
             </a:pPr>
             <a:r>
@@ -5038,6 +6286,9 @@
                 <a:solidFill>
                   <a:srgbClr val="2C2348"/>
                 </a:solidFill>
+                <a:latin typeface="Microsoft YaHei"/>
+                <a:ea typeface="Microsoft YaHei"/>
+                <a:cs typeface="Microsoft YaHei"/>
               </a:rPr>
               <a:t>WebGL Build 可部署到 Render、Cloudflare Pages 或 GitHub Pages。</a:t>
             </a:r>
@@ -5049,7 +6300,7 @@
           <p:cNvPr id="7" name="">
             <a:extLst xmlns:a="http://schemas.openxmlformats.org/drawingml/2006/main">
               <a:ext uri="{FF2B5EF4-FFF2-40B4-BE49-F238E27FC236}">
-                <a16:creationId xmlns:a16="http://schemas.microsoft.com/office/drawing/2014/main" id="{B0682858-B301-4969-8AB0-7B03DDEFA29A}"/>
+                <a16:creationId xmlns:a16="http://schemas.microsoft.com/office/drawing/2014/main" id="{7668AB5F-ABC4-4068-BBCE-3D245B834BEF}"/>
               </a:ext>
             </a:extLst>
           </p:cNvPr>
@@ -5081,6 +6332,9 @@
                 <a:solidFill>
                   <a:srgbClr val="FF80B8"/>
                 </a:solidFill>
+                <a:latin typeface="Microsoft YaHei"/>
+                <a:ea typeface="Microsoft YaHei"/>
+                <a:cs typeface="Microsoft YaHei"/>
               </a:defRPr>
             </a:pPr>
             <a:r>
@@ -5088,8 +6342,11 @@
                 <a:solidFill>
                   <a:srgbClr val="FF80B8"/>
                 </a:solidFill>
+                <a:latin typeface="Microsoft YaHei"/>
+                <a:ea typeface="Microsoft YaHei"/>
+                <a:cs typeface="Microsoft YaHei"/>
               </a:rPr>
-              <a:t>07 / 07</a:t>
+              <a:t>08 / 08</a:t>
             </a:r>
           </a:p>
         </p:txBody>
@@ -5099,7 +6356,7 @@
           <p:cNvPr id="8" name="">
             <a:extLst xmlns:a="http://schemas.openxmlformats.org/drawingml/2006/main">
               <a:ext uri="{FF2B5EF4-FFF2-40B4-BE49-F238E27FC236}">
-                <a16:creationId xmlns:a16="http://schemas.microsoft.com/office/drawing/2014/main" id="{285B409D-7DE3-461A-AC8E-B1340593D5F1}"/>
+                <a16:creationId xmlns:a16="http://schemas.microsoft.com/office/drawing/2014/main" id="{E6B08CBE-E95E-418F-AC92-E276DB6C26B8}"/>
               </a:ext>
             </a:extLst>
           </p:cNvPr>
@@ -5111,7 +6368,7 @@
         <p:spPr>
           <a:xfrm xmlns:a="http://schemas.openxmlformats.org/drawingml/2006/main">
             <a:off x="1428750" y="6515100"/>
-            <a:ext cx="4191000" cy="209550"/>
+            <a:ext cx="4381500" cy="209550"/>
           </a:xfrm>
           <a:prstGeom xmlns:a="http://schemas.openxmlformats.org/drawingml/2006/main" prst="rect">
             <a:avLst/>
@@ -5131,6 +6388,9 @@
                 <a:solidFill>
                   <a:srgbClr val="695F84"/>
                 </a:solidFill>
+                <a:latin typeface="Microsoft YaHei"/>
+                <a:ea typeface="Microsoft YaHei"/>
+                <a:cs typeface="Microsoft YaHei"/>
               </a:defRPr>
             </a:pPr>
             <a:r>
@@ -5138,8 +6398,11 @@
                 <a:solidFill>
                   <a:srgbClr val="695F84"/>
                 </a:solidFill>
+                <a:latin typeface="Microsoft YaHei"/>
+                <a:ea typeface="Microsoft YaHei"/>
+                <a:cs typeface="Microsoft YaHei"/>
               </a:rPr>
-              <a:t>能工智人：遗忘工坊 | 落云宗：秦天 / 陈磊</a:t>
+              <a:t>能工智人：糖芯工坊 | 落云宗：秦天 / 陈磊</a:t>
             </a:r>
           </a:p>
         </p:txBody>
@@ -5147,7 +6410,7 @@
     </p:spTree>
     <p:extLst>
       <p:ext uri="{BB962C8B-B14F-4D97-AF65-F5344CB8AC3E}">
-        <p14:creationId xmlns:p14="http://schemas.microsoft.com/office/powerpoint/2010/main" val="2048389050"/>
+        <p14:creationId xmlns:p14="http://schemas.microsoft.com/office/powerpoint/2010/main" val="1490891718"/>
       </p:ext>
     </p:extLst>
   </p:cSld>

</xml_diff>

<commit_message>
Refine submission poster layout
</commit_message>
<xml_diff>
--- a/Submission/project_deck.pptx
+++ b/Submission/project_deck.pptx
@@ -2,20 +2,20 @@
 <file path=ppt/presentation.xml><?xml version="1.0" encoding="utf-8"?>
 <p:presentation xmlns:p="http://schemas.openxmlformats.org/presentationml/2006/main">
   <p:sldMasterIdLst>
-    <p:sldMasterId xmlns:r="http://schemas.openxmlformats.org/officeDocument/2006/relationships" id="2147483648" r:id="R7d9038a072354d03"/>
+    <p:sldMasterId xmlns:r="http://schemas.openxmlformats.org/officeDocument/2006/relationships" id="2147483648" r:id="Ra0ea9d9ad5a842b2"/>
   </p:sldMasterIdLst>
   <p:notesMasterIdLst>
-    <p:notesMasterId xmlns:r="http://schemas.openxmlformats.org/officeDocument/2006/relationships" r:id="Rf5a4c4a73aa34455"/>
+    <p:notesMasterId xmlns:r="http://schemas.openxmlformats.org/officeDocument/2006/relationships" r:id="Ra77f2976a27f4d5c"/>
   </p:notesMasterIdLst>
   <p:sldIdLst>
-    <p:sldId xmlns:r="http://schemas.openxmlformats.org/officeDocument/2006/relationships" id="256" r:id="R104c2c5b92ed4ba5"/>
-    <p:sldId xmlns:r="http://schemas.openxmlformats.org/officeDocument/2006/relationships" id="257" r:id="R23cc204d3eb84e8e"/>
-    <p:sldId xmlns:r="http://schemas.openxmlformats.org/officeDocument/2006/relationships" id="258" r:id="Re63e292f50694892"/>
-    <p:sldId xmlns:r="http://schemas.openxmlformats.org/officeDocument/2006/relationships" id="259" r:id="Rb40f02c2ae854330"/>
-    <p:sldId xmlns:r="http://schemas.openxmlformats.org/officeDocument/2006/relationships" id="260" r:id="Rcae30d6e0bd44722"/>
-    <p:sldId xmlns:r="http://schemas.openxmlformats.org/officeDocument/2006/relationships" id="261" r:id="Re56f8ab299964ea2"/>
-    <p:sldId xmlns:r="http://schemas.openxmlformats.org/officeDocument/2006/relationships" id="262" r:id="Rd008ef90d7ad4f37"/>
-    <p:sldId xmlns:r="http://schemas.openxmlformats.org/officeDocument/2006/relationships" id="263" r:id="Rfa3d7f37d654474d"/>
+    <p:sldId xmlns:r="http://schemas.openxmlformats.org/officeDocument/2006/relationships" id="256" r:id="R3833e31487f24cca"/>
+    <p:sldId xmlns:r="http://schemas.openxmlformats.org/officeDocument/2006/relationships" id="257" r:id="R9ff554b2b6724e96"/>
+    <p:sldId xmlns:r="http://schemas.openxmlformats.org/officeDocument/2006/relationships" id="258" r:id="R88c8e208d91c4228"/>
+    <p:sldId xmlns:r="http://schemas.openxmlformats.org/officeDocument/2006/relationships" id="259" r:id="R2602fcb8dfc94441"/>
+    <p:sldId xmlns:r="http://schemas.openxmlformats.org/officeDocument/2006/relationships" id="260" r:id="Ra0cd86423aa6444c"/>
+    <p:sldId xmlns:r="http://schemas.openxmlformats.org/officeDocument/2006/relationships" id="261" r:id="Re388f3d4f1b14b24"/>
+    <p:sldId xmlns:r="http://schemas.openxmlformats.org/officeDocument/2006/relationships" id="262" r:id="R51403b895196457b"/>
+    <p:sldId xmlns:r="http://schemas.openxmlformats.org/officeDocument/2006/relationships" id="263" r:id="R08edf79f9cef4158"/>
   </p:sldIdLst>
   <p:sldSz cx="12192000" cy="6858000"/>
   <p:notesSz cx="6858000" cy="9144000"/>
@@ -1070,7 +1070,7 @@
   </p:cSld>
   <p:clrMap bg1="lt1" tx1="dk1" bg2="lt2" tx2="dk2" accent1="accent1" accent2="accent2" accent3="accent3" accent4="accent4" accent5="accent5" accent6="accent6" hlink="hlink" folHlink="folHlink"/>
   <p:sldLayoutIdLst>
-    <p:sldLayoutId xmlns:r="http://schemas.openxmlformats.org/officeDocument/2006/relationships" id="2147483649" r:id="Rfd26f9458ec04d46"/>
+    <p:sldLayoutId xmlns:r="http://schemas.openxmlformats.org/officeDocument/2006/relationships" id="2147483649" r:id="R0cd866dcbc6346e5"/>
   </p:sldLayoutIdLst>
   <p:txStyles>
     <p:titleStyle>
@@ -1625,7 +1625,7 @@
           <p:nvPr/>
         </p:nvPicPr>
         <p:blipFill>
-          <a:blip xmlns:r="http://schemas.openxmlformats.org/officeDocument/2006/relationships" xmlns:a="http://schemas.openxmlformats.org/drawingml/2006/main" r:embed="Rcb857eae759b41ec"/>
+          <a:blip xmlns:r="http://schemas.openxmlformats.org/officeDocument/2006/relationships" xmlns:a="http://schemas.openxmlformats.org/drawingml/2006/main" r:embed="R95c3e51902b9427d"/>
           <a:srcRect xmlns:a="http://schemas.openxmlformats.org/drawingml/2006/main" l="0" t="0" r="0" b="0"/>
           <a:stretch xmlns:a="http://schemas.openxmlformats.org/drawingml/2006/main">
             <a:fillRect l="0" t="0" r="0" b="0"/>
@@ -1646,7 +1646,7 @@
           <p:cNvPr id="2" name="">
             <a:extLst xmlns:a="http://schemas.openxmlformats.org/drawingml/2006/main">
               <a:ext uri="{FF2B5EF4-FFF2-40B4-BE49-F238E27FC236}">
-                <a16:creationId xmlns:a16="http://schemas.microsoft.com/office/drawing/2014/main" id="{6C0790FA-E5CF-44F3-93F9-AE224A6E193F}"/>
+                <a16:creationId xmlns:a16="http://schemas.microsoft.com/office/drawing/2014/main" id="{598ED3CF-906D-4ABB-90AA-C476B8573A4A}"/>
               </a:ext>
             </a:extLst>
           </p:cNvPr>
@@ -1677,7 +1677,7 @@
           <p:cNvPr id="3" name="">
             <a:extLst xmlns:a="http://schemas.openxmlformats.org/drawingml/2006/main">
               <a:ext uri="{FF2B5EF4-FFF2-40B4-BE49-F238E27FC236}">
-                <a16:creationId xmlns:a16="http://schemas.microsoft.com/office/drawing/2014/main" id="{177E3204-E964-400E-A449-4511C1C55EE2}"/>
+                <a16:creationId xmlns:a16="http://schemas.microsoft.com/office/drawing/2014/main" id="{CBDB8529-8F31-4355-BC6D-3416017D772D}"/>
               </a:ext>
             </a:extLst>
           </p:cNvPr>
@@ -1733,7 +1733,7 @@
           <p:cNvPr id="4" name="">
             <a:extLst xmlns:a="http://schemas.openxmlformats.org/drawingml/2006/main">
               <a:ext uri="{FF2B5EF4-FFF2-40B4-BE49-F238E27FC236}">
-                <a16:creationId xmlns:a16="http://schemas.microsoft.com/office/drawing/2014/main" id="{53DD3B22-88F7-4F3D-B846-FB51B5FFEAAE}"/>
+                <a16:creationId xmlns:a16="http://schemas.microsoft.com/office/drawing/2014/main" id="{818E9F08-EA8C-4058-B4C1-6D21392C3A97}"/>
               </a:ext>
             </a:extLst>
           </p:cNvPr>
@@ -1812,7 +1812,7 @@
           <p:cNvPr id="5" name="">
             <a:extLst xmlns:a="http://schemas.openxmlformats.org/drawingml/2006/main">
               <a:ext uri="{FF2B5EF4-FFF2-40B4-BE49-F238E27FC236}">
-                <a16:creationId xmlns:a16="http://schemas.microsoft.com/office/drawing/2014/main" id="{42A10D8D-58BB-433E-9DA7-815D1D7ED5B9}"/>
+                <a16:creationId xmlns:a16="http://schemas.microsoft.com/office/drawing/2014/main" id="{34EFE48E-91C6-4C23-BA2F-24A606D3F477}"/>
               </a:ext>
             </a:extLst>
           </p:cNvPr>
@@ -1868,7 +1868,7 @@
           <p:cNvPr id="6" name="">
             <a:extLst xmlns:a="http://schemas.openxmlformats.org/drawingml/2006/main">
               <a:ext uri="{FF2B5EF4-FFF2-40B4-BE49-F238E27FC236}">
-                <a16:creationId xmlns:a16="http://schemas.microsoft.com/office/drawing/2014/main" id="{A9798A8D-9149-4335-AC83-7CFC82AFE8A0}"/>
+                <a16:creationId xmlns:a16="http://schemas.microsoft.com/office/drawing/2014/main" id="{C842118E-857D-4D66-8B26-B23E89D86736}"/>
               </a:ext>
             </a:extLst>
           </p:cNvPr>
@@ -1924,7 +1924,7 @@
           <p:cNvPr id="7" name="">
             <a:extLst xmlns:a="http://schemas.openxmlformats.org/drawingml/2006/main">
               <a:ext uri="{FF2B5EF4-FFF2-40B4-BE49-F238E27FC236}">
-                <a16:creationId xmlns:a16="http://schemas.microsoft.com/office/drawing/2014/main" id="{C86A1BD0-086F-403E-8902-B8F054B4C8B7}"/>
+                <a16:creationId xmlns:a16="http://schemas.microsoft.com/office/drawing/2014/main" id="{B61606F9-4BFF-441E-A030-1EDE860E5A7C}"/>
               </a:ext>
             </a:extLst>
           </p:cNvPr>
@@ -1980,7 +1980,7 @@
           <p:cNvPr id="8" name="">
             <a:extLst xmlns:a="http://schemas.openxmlformats.org/drawingml/2006/main">
               <a:ext uri="{FF2B5EF4-FFF2-40B4-BE49-F238E27FC236}">
-                <a16:creationId xmlns:a16="http://schemas.microsoft.com/office/drawing/2014/main" id="{F559EC4A-1556-4B31-8ABE-88158E6CFB27}"/>
+                <a16:creationId xmlns:a16="http://schemas.microsoft.com/office/drawing/2014/main" id="{BED0B4A5-3F46-4DFD-A906-6B0503C16A20}"/>
               </a:ext>
             </a:extLst>
           </p:cNvPr>
@@ -2034,7 +2034,7 @@
     </p:spTree>
     <p:extLst>
       <p:ext uri="{BB962C8B-B14F-4D97-AF65-F5344CB8AC3E}">
-        <p14:creationId xmlns:p14="http://schemas.microsoft.com/office/powerpoint/2010/main" val="32843933"/>
+        <p14:creationId xmlns:p14="http://schemas.microsoft.com/office/powerpoint/2010/main" val="1963512742"/>
       </p:ext>
     </p:extLst>
   </p:cSld>
@@ -2065,7 +2065,7 @@
           <p:cNvPr id="1" name="">
             <a:extLst xmlns:a="http://schemas.openxmlformats.org/drawingml/2006/main">
               <a:ext uri="{FF2B5EF4-FFF2-40B4-BE49-F238E27FC236}">
-                <a16:creationId xmlns:a16="http://schemas.microsoft.com/office/drawing/2014/main" id="{0E58338F-D05D-4D89-AE0C-2FD792D229B0}"/>
+                <a16:creationId xmlns:a16="http://schemas.microsoft.com/office/drawing/2014/main" id="{1EEC19ED-74B5-4A13-B955-DB7102D27F54}"/>
               </a:ext>
             </a:extLst>
           </p:cNvPr>
@@ -2121,7 +2121,7 @@
           <p:cNvPr id="2" name="">
             <a:extLst xmlns:a="http://schemas.openxmlformats.org/drawingml/2006/main">
               <a:ext uri="{FF2B5EF4-FFF2-40B4-BE49-F238E27FC236}">
-                <a16:creationId xmlns:a16="http://schemas.microsoft.com/office/drawing/2014/main" id="{63BA0CBB-2547-416C-961B-F5DD78BA5B35}"/>
+                <a16:creationId xmlns:a16="http://schemas.microsoft.com/office/drawing/2014/main" id="{299A9E03-20E2-46F4-8523-C7FED423EBC4}"/>
               </a:ext>
             </a:extLst>
           </p:cNvPr>
@@ -2181,7 +2181,7 @@
           <p:nvPr/>
         </p:nvPicPr>
         <p:blipFill>
-          <a:blip xmlns:r="http://schemas.openxmlformats.org/officeDocument/2006/relationships" xmlns:a="http://schemas.openxmlformats.org/drawingml/2006/main" r:embed="R0a3aa3085d0f4314"/>
+          <a:blip xmlns:r="http://schemas.openxmlformats.org/officeDocument/2006/relationships" xmlns:a="http://schemas.openxmlformats.org/drawingml/2006/main" r:embed="Ra22f403ef029433f"/>
           <a:srcRect xmlns:a="http://schemas.openxmlformats.org/drawingml/2006/main" l="3437" t="0" r="3437" b="0"/>
           <a:stretch xmlns:a="http://schemas.openxmlformats.org/drawingml/2006/main">
             <a:fillRect l="0" t="0" r="0" b="0"/>
@@ -2206,7 +2206,7 @@
           <p:nvPr/>
         </p:nvPicPr>
         <p:blipFill>
-          <a:blip xmlns:r="http://schemas.openxmlformats.org/officeDocument/2006/relationships" xmlns:a="http://schemas.openxmlformats.org/drawingml/2006/main" r:embed="R270c373780424a1a"/>
+          <a:blip xmlns:r="http://schemas.openxmlformats.org/officeDocument/2006/relationships" xmlns:a="http://schemas.openxmlformats.org/drawingml/2006/main" r:embed="R59a966f8e22e4215"/>
           <a:srcRect xmlns:a="http://schemas.openxmlformats.org/drawingml/2006/main" l="0" t="11331" r="0" b="11331"/>
           <a:stretch xmlns:a="http://schemas.openxmlformats.org/drawingml/2006/main">
             <a:fillRect l="0" t="0" r="0" b="0"/>
@@ -2227,7 +2227,7 @@
           <p:cNvPr id="5" name="">
             <a:extLst xmlns:a="http://schemas.openxmlformats.org/drawingml/2006/main">
               <a:ext uri="{FF2B5EF4-FFF2-40B4-BE49-F238E27FC236}">
-                <a16:creationId xmlns:a16="http://schemas.microsoft.com/office/drawing/2014/main" id="{9FF4C0D0-A48B-405F-A72F-F1C57900889E}"/>
+                <a16:creationId xmlns:a16="http://schemas.microsoft.com/office/drawing/2014/main" id="{2E504F70-82B3-4CAB-907C-87AC6ECAFE07}"/>
               </a:ext>
             </a:extLst>
           </p:cNvPr>
@@ -2262,7 +2262,7 @@
           <p:cNvPr id="6" name="">
             <a:extLst xmlns:a="http://schemas.openxmlformats.org/drawingml/2006/main">
               <a:ext uri="{FF2B5EF4-FFF2-40B4-BE49-F238E27FC236}">
-                <a16:creationId xmlns:a16="http://schemas.microsoft.com/office/drawing/2014/main" id="{8477A473-1648-4E78-A38D-A16141D1442B}"/>
+                <a16:creationId xmlns:a16="http://schemas.microsoft.com/office/drawing/2014/main" id="{F7B03512-EDA4-4C64-9110-50A759964381}"/>
               </a:ext>
             </a:extLst>
           </p:cNvPr>
@@ -2297,7 +2297,7 @@
           <p:cNvPr id="7" name="">
             <a:extLst xmlns:a="http://schemas.openxmlformats.org/drawingml/2006/main">
               <a:ext uri="{FF2B5EF4-FFF2-40B4-BE49-F238E27FC236}">
-                <a16:creationId xmlns:a16="http://schemas.microsoft.com/office/drawing/2014/main" id="{BFA57327-00ED-4AA8-A17A-0175DE5828CC}"/>
+                <a16:creationId xmlns:a16="http://schemas.microsoft.com/office/drawing/2014/main" id="{73F7B5AA-071A-485E-BB65-E8920C95EDD7}"/>
               </a:ext>
             </a:extLst>
           </p:cNvPr>
@@ -2328,7 +2328,7 @@
           <p:cNvPr id="8" name="">
             <a:extLst xmlns:a="http://schemas.openxmlformats.org/drawingml/2006/main">
               <a:ext uri="{FF2B5EF4-FFF2-40B4-BE49-F238E27FC236}">
-                <a16:creationId xmlns:a16="http://schemas.microsoft.com/office/drawing/2014/main" id="{9AAE03D0-B874-4424-BC06-6CDE78324B56}"/>
+                <a16:creationId xmlns:a16="http://schemas.microsoft.com/office/drawing/2014/main" id="{E8306D1D-D9E8-4016-8E82-6FD2302FA10A}"/>
               </a:ext>
             </a:extLst>
           </p:cNvPr>
@@ -2384,7 +2384,7 @@
           <p:cNvPr id="9" name="">
             <a:extLst xmlns:a="http://schemas.openxmlformats.org/drawingml/2006/main">
               <a:ext uri="{FF2B5EF4-FFF2-40B4-BE49-F238E27FC236}">
-                <a16:creationId xmlns:a16="http://schemas.microsoft.com/office/drawing/2014/main" id="{C25B0577-0AFC-4E8B-881E-610D1B9D9E7C}"/>
+                <a16:creationId xmlns:a16="http://schemas.microsoft.com/office/drawing/2014/main" id="{5782D722-20D7-4522-BEC5-B8B05E9401CA}"/>
               </a:ext>
             </a:extLst>
           </p:cNvPr>
@@ -2440,7 +2440,7 @@
           <p:cNvPr id="10" name="">
             <a:extLst xmlns:a="http://schemas.openxmlformats.org/drawingml/2006/main">
               <a:ext uri="{FF2B5EF4-FFF2-40B4-BE49-F238E27FC236}">
-                <a16:creationId xmlns:a16="http://schemas.microsoft.com/office/drawing/2014/main" id="{B8281D17-57AE-49A6-9B25-8E74F2B31995}"/>
+                <a16:creationId xmlns:a16="http://schemas.microsoft.com/office/drawing/2014/main" id="{A0F180E0-9DD7-4E96-978E-E675F2B16DCF}"/>
               </a:ext>
             </a:extLst>
           </p:cNvPr>
@@ -2475,7 +2475,7 @@
           <p:cNvPr id="11" name="">
             <a:extLst xmlns:a="http://schemas.openxmlformats.org/drawingml/2006/main">
               <a:ext uri="{FF2B5EF4-FFF2-40B4-BE49-F238E27FC236}">
-                <a16:creationId xmlns:a16="http://schemas.microsoft.com/office/drawing/2014/main" id="{C16F0772-E5D7-4AF8-9FE8-B109BC8746E4}"/>
+                <a16:creationId xmlns:a16="http://schemas.microsoft.com/office/drawing/2014/main" id="{D4F461CA-0F12-4B89-BFD5-D3EB84F792BA}"/>
               </a:ext>
             </a:extLst>
           </p:cNvPr>
@@ -2506,7 +2506,7 @@
           <p:cNvPr id="12" name="">
             <a:extLst xmlns:a="http://schemas.openxmlformats.org/drawingml/2006/main">
               <a:ext uri="{FF2B5EF4-FFF2-40B4-BE49-F238E27FC236}">
-                <a16:creationId xmlns:a16="http://schemas.microsoft.com/office/drawing/2014/main" id="{EB2F3DE7-0143-49FC-97D7-74A01D055519}"/>
+                <a16:creationId xmlns:a16="http://schemas.microsoft.com/office/drawing/2014/main" id="{DED9B956-1849-49E2-A8CA-E26BE10EC346}"/>
               </a:ext>
             </a:extLst>
           </p:cNvPr>
@@ -2562,7 +2562,7 @@
           <p:cNvPr id="13" name="">
             <a:extLst xmlns:a="http://schemas.openxmlformats.org/drawingml/2006/main">
               <a:ext uri="{FF2B5EF4-FFF2-40B4-BE49-F238E27FC236}">
-                <a16:creationId xmlns:a16="http://schemas.microsoft.com/office/drawing/2014/main" id="{AF06C340-C85A-4E82-9521-07EC20C9E907}"/>
+                <a16:creationId xmlns:a16="http://schemas.microsoft.com/office/drawing/2014/main" id="{B927BD8A-2CDD-4487-A66A-6493EA5EEA30}"/>
               </a:ext>
             </a:extLst>
           </p:cNvPr>
@@ -2618,7 +2618,7 @@
           <p:cNvPr id="14" name="">
             <a:extLst xmlns:a="http://schemas.openxmlformats.org/drawingml/2006/main">
               <a:ext uri="{FF2B5EF4-FFF2-40B4-BE49-F238E27FC236}">
-                <a16:creationId xmlns:a16="http://schemas.microsoft.com/office/drawing/2014/main" id="{F89F8167-BE3C-41EE-B552-71981E402483}"/>
+                <a16:creationId xmlns:a16="http://schemas.microsoft.com/office/drawing/2014/main" id="{7E4973B7-FB60-4447-AE3C-3D46349E6C83}"/>
               </a:ext>
             </a:extLst>
           </p:cNvPr>
@@ -2653,7 +2653,7 @@
           <p:cNvPr id="15" name="">
             <a:extLst xmlns:a="http://schemas.openxmlformats.org/drawingml/2006/main">
               <a:ext uri="{FF2B5EF4-FFF2-40B4-BE49-F238E27FC236}">
-                <a16:creationId xmlns:a16="http://schemas.microsoft.com/office/drawing/2014/main" id="{597BDA47-6779-4461-8763-35F0FEE1E6EB}"/>
+                <a16:creationId xmlns:a16="http://schemas.microsoft.com/office/drawing/2014/main" id="{55C6C7C0-B7DD-4D49-B719-4766AB289249}"/>
               </a:ext>
             </a:extLst>
           </p:cNvPr>
@@ -2684,7 +2684,7 @@
           <p:cNvPr id="16" name="">
             <a:extLst xmlns:a="http://schemas.openxmlformats.org/drawingml/2006/main">
               <a:ext uri="{FF2B5EF4-FFF2-40B4-BE49-F238E27FC236}">
-                <a16:creationId xmlns:a16="http://schemas.microsoft.com/office/drawing/2014/main" id="{8A8F7FAA-5111-47DF-AB45-1870F2246A98}"/>
+                <a16:creationId xmlns:a16="http://schemas.microsoft.com/office/drawing/2014/main" id="{EB0F5F28-D2E7-4A7D-9568-B2E86649FE8E}"/>
               </a:ext>
             </a:extLst>
           </p:cNvPr>
@@ -2740,7 +2740,7 @@
           <p:cNvPr id="17" name="">
             <a:extLst xmlns:a="http://schemas.openxmlformats.org/drawingml/2006/main">
               <a:ext uri="{FF2B5EF4-FFF2-40B4-BE49-F238E27FC236}">
-                <a16:creationId xmlns:a16="http://schemas.microsoft.com/office/drawing/2014/main" id="{70FCA719-4258-40AD-8262-60E8ED6F3BCF}"/>
+                <a16:creationId xmlns:a16="http://schemas.microsoft.com/office/drawing/2014/main" id="{83D6191E-3B93-443D-8B6D-53EAD4848950}"/>
               </a:ext>
             </a:extLst>
           </p:cNvPr>
@@ -2796,7 +2796,7 @@
           <p:cNvPr id="18" name="">
             <a:extLst xmlns:a="http://schemas.openxmlformats.org/drawingml/2006/main">
               <a:ext uri="{FF2B5EF4-FFF2-40B4-BE49-F238E27FC236}">
-                <a16:creationId xmlns:a16="http://schemas.microsoft.com/office/drawing/2014/main" id="{85B834C2-E08D-43F3-9C49-E6C21C233BEB}"/>
+                <a16:creationId xmlns:a16="http://schemas.microsoft.com/office/drawing/2014/main" id="{F66E9675-5FDB-456A-9AEA-7BB42FD53011}"/>
               </a:ext>
             </a:extLst>
           </p:cNvPr>
@@ -2852,7 +2852,7 @@
           <p:cNvPr id="19" name="">
             <a:extLst xmlns:a="http://schemas.openxmlformats.org/drawingml/2006/main">
               <a:ext uri="{FF2B5EF4-FFF2-40B4-BE49-F238E27FC236}">
-                <a16:creationId xmlns:a16="http://schemas.microsoft.com/office/drawing/2014/main" id="{A2F244D8-1C30-4EDB-9665-B15C33AB7BDC}"/>
+                <a16:creationId xmlns:a16="http://schemas.microsoft.com/office/drawing/2014/main" id="{92919129-4B74-44B6-A094-8D4FBBF57F1A}"/>
               </a:ext>
             </a:extLst>
           </p:cNvPr>
@@ -2906,7 +2906,7 @@
     </p:spTree>
     <p:extLst>
       <p:ext uri="{BB962C8B-B14F-4D97-AF65-F5344CB8AC3E}">
-        <p14:creationId xmlns:p14="http://schemas.microsoft.com/office/powerpoint/2010/main" val="320877088"/>
+        <p14:creationId xmlns:p14="http://schemas.microsoft.com/office/powerpoint/2010/main" val="192417695"/>
       </p:ext>
     </p:extLst>
   </p:cSld>
@@ -2941,7 +2941,7 @@
           <p:nvPr/>
         </p:nvPicPr>
         <p:blipFill>
-          <a:blip xmlns:r="http://schemas.openxmlformats.org/officeDocument/2006/relationships" xmlns:a="http://schemas.openxmlformats.org/drawingml/2006/main" r:embed="Rf8c5c7d86e60417b"/>
+          <a:blip xmlns:r="http://schemas.openxmlformats.org/officeDocument/2006/relationships" xmlns:a="http://schemas.openxmlformats.org/drawingml/2006/main" r:embed="Rbaa490ca272c4a5b"/>
           <a:srcRect xmlns:a="http://schemas.openxmlformats.org/drawingml/2006/main" l="8984" t="0" r="8984" b="0"/>
           <a:stretch xmlns:a="http://schemas.openxmlformats.org/drawingml/2006/main">
             <a:fillRect l="0" t="0" r="0" b="0"/>
@@ -2962,7 +2962,7 @@
           <p:cNvPr id="2" name="">
             <a:extLst xmlns:a="http://schemas.openxmlformats.org/drawingml/2006/main">
               <a:ext uri="{FF2B5EF4-FFF2-40B4-BE49-F238E27FC236}">
-                <a16:creationId xmlns:a16="http://schemas.microsoft.com/office/drawing/2014/main" id="{212331CC-EB1B-44DE-9FA9-D05DFD2EEDB3}"/>
+                <a16:creationId xmlns:a16="http://schemas.microsoft.com/office/drawing/2014/main" id="{F10D7E63-EBF8-4F11-BAA8-5FE7AE310783}"/>
               </a:ext>
             </a:extLst>
           </p:cNvPr>
@@ -3018,7 +3018,7 @@
           <p:cNvPr id="3" name="">
             <a:extLst xmlns:a="http://schemas.openxmlformats.org/drawingml/2006/main">
               <a:ext uri="{FF2B5EF4-FFF2-40B4-BE49-F238E27FC236}">
-                <a16:creationId xmlns:a16="http://schemas.microsoft.com/office/drawing/2014/main" id="{64069AA0-B976-4354-BFEA-58D9C502217E}"/>
+                <a16:creationId xmlns:a16="http://schemas.microsoft.com/office/drawing/2014/main" id="{08187965-3ABB-4AEB-BD56-0D5E5A4F98BB}"/>
               </a:ext>
             </a:extLst>
           </p:cNvPr>
@@ -3074,7 +3074,7 @@
           <p:cNvPr id="4" name="">
             <a:extLst xmlns:a="http://schemas.openxmlformats.org/drawingml/2006/main">
               <a:ext uri="{FF2B5EF4-FFF2-40B4-BE49-F238E27FC236}">
-                <a16:creationId xmlns:a16="http://schemas.microsoft.com/office/drawing/2014/main" id="{0CEDD4CB-0E32-447C-91E5-D801FF326B7A}"/>
+                <a16:creationId xmlns:a16="http://schemas.microsoft.com/office/drawing/2014/main" id="{65DF050D-4B4C-46A9-A593-0690D36DA123}"/>
               </a:ext>
             </a:extLst>
           </p:cNvPr>
@@ -3105,7 +3105,7 @@
           <p:cNvPr id="5" name="">
             <a:extLst xmlns:a="http://schemas.openxmlformats.org/drawingml/2006/main">
               <a:ext uri="{FF2B5EF4-FFF2-40B4-BE49-F238E27FC236}">
-                <a16:creationId xmlns:a16="http://schemas.microsoft.com/office/drawing/2014/main" id="{56A8A1F3-2041-4BA2-97F5-78F271E7CB51}"/>
+                <a16:creationId xmlns:a16="http://schemas.microsoft.com/office/drawing/2014/main" id="{4400A7B1-5F62-47DF-841E-25337A2372B9}"/>
               </a:ext>
             </a:extLst>
           </p:cNvPr>
@@ -3161,7 +3161,7 @@
           <p:cNvPr id="6" name="">
             <a:extLst xmlns:a="http://schemas.openxmlformats.org/drawingml/2006/main">
               <a:ext uri="{FF2B5EF4-FFF2-40B4-BE49-F238E27FC236}">
-                <a16:creationId xmlns:a16="http://schemas.microsoft.com/office/drawing/2014/main" id="{83450964-2BBF-4E88-A9A3-3D0B7F7F8CE4}"/>
+                <a16:creationId xmlns:a16="http://schemas.microsoft.com/office/drawing/2014/main" id="{B3B40882-3F93-480A-849A-B9AE335B6582}"/>
               </a:ext>
             </a:extLst>
           </p:cNvPr>
@@ -3192,7 +3192,7 @@
           <p:cNvPr id="7" name="">
             <a:extLst xmlns:a="http://schemas.openxmlformats.org/drawingml/2006/main">
               <a:ext uri="{FF2B5EF4-FFF2-40B4-BE49-F238E27FC236}">
-                <a16:creationId xmlns:a16="http://schemas.microsoft.com/office/drawing/2014/main" id="{6A4F044F-EB04-478C-A8AE-C935E2969BA3}"/>
+                <a16:creationId xmlns:a16="http://schemas.microsoft.com/office/drawing/2014/main" id="{AD2EC422-53B6-421D-97CA-9EBD40CE367C}"/>
               </a:ext>
             </a:extLst>
           </p:cNvPr>
@@ -3248,7 +3248,7 @@
           <p:cNvPr id="8" name="">
             <a:extLst xmlns:a="http://schemas.openxmlformats.org/drawingml/2006/main">
               <a:ext uri="{FF2B5EF4-FFF2-40B4-BE49-F238E27FC236}">
-                <a16:creationId xmlns:a16="http://schemas.microsoft.com/office/drawing/2014/main" id="{30FD6D7D-881A-4057-B106-A20F77D740DA}"/>
+                <a16:creationId xmlns:a16="http://schemas.microsoft.com/office/drawing/2014/main" id="{35D33E5D-B089-4B24-9A53-A13E3D510270}"/>
               </a:ext>
             </a:extLst>
           </p:cNvPr>
@@ -3279,7 +3279,7 @@
           <p:cNvPr id="9" name="">
             <a:extLst xmlns:a="http://schemas.openxmlformats.org/drawingml/2006/main">
               <a:ext uri="{FF2B5EF4-FFF2-40B4-BE49-F238E27FC236}">
-                <a16:creationId xmlns:a16="http://schemas.microsoft.com/office/drawing/2014/main" id="{2AFD9005-FC4B-49C5-B170-474C01B1285A}"/>
+                <a16:creationId xmlns:a16="http://schemas.microsoft.com/office/drawing/2014/main" id="{3CDAEFF6-241D-4136-AC58-ACC0B1B34630}"/>
               </a:ext>
             </a:extLst>
           </p:cNvPr>
@@ -3335,7 +3335,7 @@
           <p:cNvPr id="10" name="">
             <a:extLst xmlns:a="http://schemas.openxmlformats.org/drawingml/2006/main">
               <a:ext uri="{FF2B5EF4-FFF2-40B4-BE49-F238E27FC236}">
-                <a16:creationId xmlns:a16="http://schemas.microsoft.com/office/drawing/2014/main" id="{82FB1F9F-612C-476C-86C6-C9D95B4665E8}"/>
+                <a16:creationId xmlns:a16="http://schemas.microsoft.com/office/drawing/2014/main" id="{277BE26D-B25D-41C9-83E6-C30B9F012BF4}"/>
               </a:ext>
             </a:extLst>
           </p:cNvPr>
@@ -3391,7 +3391,7 @@
           <p:cNvPr id="11" name="">
             <a:extLst xmlns:a="http://schemas.openxmlformats.org/drawingml/2006/main">
               <a:ext uri="{FF2B5EF4-FFF2-40B4-BE49-F238E27FC236}">
-                <a16:creationId xmlns:a16="http://schemas.microsoft.com/office/drawing/2014/main" id="{183D5909-FB99-4311-A8BD-1DCC8F5A9608}"/>
+                <a16:creationId xmlns:a16="http://schemas.microsoft.com/office/drawing/2014/main" id="{863C1616-9787-43B3-96C0-A14A7322728B}"/>
               </a:ext>
             </a:extLst>
           </p:cNvPr>
@@ -3445,7 +3445,7 @@
     </p:spTree>
     <p:extLst>
       <p:ext uri="{BB962C8B-B14F-4D97-AF65-F5344CB8AC3E}">
-        <p14:creationId xmlns:p14="http://schemas.microsoft.com/office/powerpoint/2010/main" val="1188414887"/>
+        <p14:creationId xmlns:p14="http://schemas.microsoft.com/office/powerpoint/2010/main" val="395702995"/>
       </p:ext>
     </p:extLst>
   </p:cSld>
@@ -3476,7 +3476,7 @@
           <p:cNvPr id="1" name="">
             <a:extLst xmlns:a="http://schemas.openxmlformats.org/drawingml/2006/main">
               <a:ext uri="{FF2B5EF4-FFF2-40B4-BE49-F238E27FC236}">
-                <a16:creationId xmlns:a16="http://schemas.microsoft.com/office/drawing/2014/main" id="{5A571D03-3A0A-446F-B0B0-77995ADE6558}"/>
+                <a16:creationId xmlns:a16="http://schemas.microsoft.com/office/drawing/2014/main" id="{48612395-566B-40BA-BD6A-A1C1F5C08DD1}"/>
               </a:ext>
             </a:extLst>
           </p:cNvPr>
@@ -3532,7 +3532,7 @@
           <p:cNvPr id="2" name="">
             <a:extLst xmlns:a="http://schemas.openxmlformats.org/drawingml/2006/main">
               <a:ext uri="{FF2B5EF4-FFF2-40B4-BE49-F238E27FC236}">
-                <a16:creationId xmlns:a16="http://schemas.microsoft.com/office/drawing/2014/main" id="{6523981A-D0D7-4D85-8C44-7957A62054C1}"/>
+                <a16:creationId xmlns:a16="http://schemas.microsoft.com/office/drawing/2014/main" id="{ABE96ADF-F807-474B-B8FD-D95862883E78}"/>
               </a:ext>
             </a:extLst>
           </p:cNvPr>
@@ -3592,7 +3592,7 @@
           <p:nvPr/>
         </p:nvPicPr>
         <p:blipFill>
-          <a:blip xmlns:r="http://schemas.openxmlformats.org/officeDocument/2006/relationships" xmlns:a="http://schemas.openxmlformats.org/drawingml/2006/main" r:embed="R4a4dbde5277743e4"/>
+          <a:blip xmlns:r="http://schemas.openxmlformats.org/officeDocument/2006/relationships" xmlns:a="http://schemas.openxmlformats.org/drawingml/2006/main" r:embed="R1d5222a295b74ead"/>
           <a:srcRect xmlns:a="http://schemas.openxmlformats.org/drawingml/2006/main" l="291" t="0" r="291" b="0"/>
           <a:stretch xmlns:a="http://schemas.openxmlformats.org/drawingml/2006/main">
             <a:fillRect l="0" t="0" r="0" b="0"/>
@@ -3613,7 +3613,7 @@
           <p:cNvPr id="4" name="">
             <a:extLst xmlns:a="http://schemas.openxmlformats.org/drawingml/2006/main">
               <a:ext uri="{FF2B5EF4-FFF2-40B4-BE49-F238E27FC236}">
-                <a16:creationId xmlns:a16="http://schemas.microsoft.com/office/drawing/2014/main" id="{5E6CE0A0-880C-4665-ADF5-B87E9CB1CFA4}"/>
+                <a16:creationId xmlns:a16="http://schemas.microsoft.com/office/drawing/2014/main" id="{BCF377C9-7950-43C4-A077-05EF1613D2E2}"/>
               </a:ext>
             </a:extLst>
           </p:cNvPr>
@@ -3648,7 +3648,7 @@
           <p:cNvPr id="5" name="">
             <a:extLst xmlns:a="http://schemas.openxmlformats.org/drawingml/2006/main">
               <a:ext uri="{FF2B5EF4-FFF2-40B4-BE49-F238E27FC236}">
-                <a16:creationId xmlns:a16="http://schemas.microsoft.com/office/drawing/2014/main" id="{E0D4A38B-766A-4855-B768-A43CAFEFC6F7}"/>
+                <a16:creationId xmlns:a16="http://schemas.microsoft.com/office/drawing/2014/main" id="{F1226C08-8CE2-463C-A2DF-99A472F2DA6F}"/>
               </a:ext>
             </a:extLst>
           </p:cNvPr>
@@ -3704,7 +3704,7 @@
           <p:cNvPr id="6" name="">
             <a:extLst xmlns:a="http://schemas.openxmlformats.org/drawingml/2006/main">
               <a:ext uri="{FF2B5EF4-FFF2-40B4-BE49-F238E27FC236}">
-                <a16:creationId xmlns:a16="http://schemas.microsoft.com/office/drawing/2014/main" id="{70FC220C-0EBD-4BB7-8D47-BFC5DC061AAD}"/>
+                <a16:creationId xmlns:a16="http://schemas.microsoft.com/office/drawing/2014/main" id="{1EE798E2-E55E-4439-B65B-55B0F58CE663}"/>
               </a:ext>
             </a:extLst>
           </p:cNvPr>
@@ -3735,7 +3735,7 @@
           <p:cNvPr id="7" name="">
             <a:extLst xmlns:a="http://schemas.openxmlformats.org/drawingml/2006/main">
               <a:ext uri="{FF2B5EF4-FFF2-40B4-BE49-F238E27FC236}">
-                <a16:creationId xmlns:a16="http://schemas.microsoft.com/office/drawing/2014/main" id="{F3DCF51A-16F6-4155-A2F2-16FAE9B0F672}"/>
+                <a16:creationId xmlns:a16="http://schemas.microsoft.com/office/drawing/2014/main" id="{A082111B-7421-4DBA-93F4-61AC03C14202}"/>
               </a:ext>
             </a:extLst>
           </p:cNvPr>
@@ -3791,7 +3791,7 @@
           <p:cNvPr id="8" name="">
             <a:extLst xmlns:a="http://schemas.openxmlformats.org/drawingml/2006/main">
               <a:ext uri="{FF2B5EF4-FFF2-40B4-BE49-F238E27FC236}">
-                <a16:creationId xmlns:a16="http://schemas.microsoft.com/office/drawing/2014/main" id="{BDB88847-BCAD-4BC8-BB0E-279B527576B3}"/>
+                <a16:creationId xmlns:a16="http://schemas.microsoft.com/office/drawing/2014/main" id="{712B7EFF-609E-4DA0-B637-6A940993A111}"/>
               </a:ext>
             </a:extLst>
           </p:cNvPr>
@@ -3822,7 +3822,7 @@
           <p:cNvPr id="9" name="">
             <a:extLst xmlns:a="http://schemas.openxmlformats.org/drawingml/2006/main">
               <a:ext uri="{FF2B5EF4-FFF2-40B4-BE49-F238E27FC236}">
-                <a16:creationId xmlns:a16="http://schemas.microsoft.com/office/drawing/2014/main" id="{BEB70ED2-E6BC-4356-81C7-A5B939B328BA}"/>
+                <a16:creationId xmlns:a16="http://schemas.microsoft.com/office/drawing/2014/main" id="{8BB28E9D-0A57-4507-906E-94580D238783}"/>
               </a:ext>
             </a:extLst>
           </p:cNvPr>
@@ -3878,7 +3878,7 @@
           <p:cNvPr id="10" name="">
             <a:extLst xmlns:a="http://schemas.openxmlformats.org/drawingml/2006/main">
               <a:ext uri="{FF2B5EF4-FFF2-40B4-BE49-F238E27FC236}">
-                <a16:creationId xmlns:a16="http://schemas.microsoft.com/office/drawing/2014/main" id="{C4B71074-0D67-4A9D-91C9-3E7EF44F1DD9}"/>
+                <a16:creationId xmlns:a16="http://schemas.microsoft.com/office/drawing/2014/main" id="{9A0D3BA7-0CDB-488E-9DF6-9352DF57FAFF}"/>
               </a:ext>
             </a:extLst>
           </p:cNvPr>
@@ -3909,7 +3909,7 @@
           <p:cNvPr id="11" name="">
             <a:extLst xmlns:a="http://schemas.openxmlformats.org/drawingml/2006/main">
               <a:ext uri="{FF2B5EF4-FFF2-40B4-BE49-F238E27FC236}">
-                <a16:creationId xmlns:a16="http://schemas.microsoft.com/office/drawing/2014/main" id="{C28FA079-91CC-4F33-A07B-F9D0395116AC}"/>
+                <a16:creationId xmlns:a16="http://schemas.microsoft.com/office/drawing/2014/main" id="{E5DBBAC9-D470-47E9-BB1E-259D6A6B84B1}"/>
               </a:ext>
             </a:extLst>
           </p:cNvPr>
@@ -3965,7 +3965,7 @@
           <p:cNvPr id="12" name="">
             <a:extLst xmlns:a="http://schemas.openxmlformats.org/drawingml/2006/main">
               <a:ext uri="{FF2B5EF4-FFF2-40B4-BE49-F238E27FC236}">
-                <a16:creationId xmlns:a16="http://schemas.microsoft.com/office/drawing/2014/main" id="{83965F52-D0A0-4D45-9682-11A74195278F}"/>
+                <a16:creationId xmlns:a16="http://schemas.microsoft.com/office/drawing/2014/main" id="{7379B2B3-764B-421F-8B34-A1D6544C8C87}"/>
               </a:ext>
             </a:extLst>
           </p:cNvPr>
@@ -3996,7 +3996,7 @@
           <p:cNvPr id="13" name="">
             <a:extLst xmlns:a="http://schemas.openxmlformats.org/drawingml/2006/main">
               <a:ext uri="{FF2B5EF4-FFF2-40B4-BE49-F238E27FC236}">
-                <a16:creationId xmlns:a16="http://schemas.microsoft.com/office/drawing/2014/main" id="{D0EE82C2-2439-4D5A-8CBC-57F0A4C8739C}"/>
+                <a16:creationId xmlns:a16="http://schemas.microsoft.com/office/drawing/2014/main" id="{22AA104E-9ED7-442F-B198-F9C09614443A}"/>
               </a:ext>
             </a:extLst>
           </p:cNvPr>
@@ -4052,7 +4052,7 @@
           <p:cNvPr id="14" name="">
             <a:extLst xmlns:a="http://schemas.openxmlformats.org/drawingml/2006/main">
               <a:ext uri="{FF2B5EF4-FFF2-40B4-BE49-F238E27FC236}">
-                <a16:creationId xmlns:a16="http://schemas.microsoft.com/office/drawing/2014/main" id="{990B2C5F-9EF2-4676-961A-7FB103388EAF}"/>
+                <a16:creationId xmlns:a16="http://schemas.microsoft.com/office/drawing/2014/main" id="{9707EA1C-941D-4821-B307-7214B1C0FC5D}"/>
               </a:ext>
             </a:extLst>
           </p:cNvPr>
@@ -4108,7 +4108,7 @@
           <p:cNvPr id="15" name="">
             <a:extLst xmlns:a="http://schemas.openxmlformats.org/drawingml/2006/main">
               <a:ext uri="{FF2B5EF4-FFF2-40B4-BE49-F238E27FC236}">
-                <a16:creationId xmlns:a16="http://schemas.microsoft.com/office/drawing/2014/main" id="{435F4AE2-AF72-4156-8D3F-D504FD72E554}"/>
+                <a16:creationId xmlns:a16="http://schemas.microsoft.com/office/drawing/2014/main" id="{871DD1D6-A00E-472A-A39D-18745514BFC0}"/>
               </a:ext>
             </a:extLst>
           </p:cNvPr>
@@ -4162,7 +4162,7 @@
     </p:spTree>
     <p:extLst>
       <p:ext uri="{BB962C8B-B14F-4D97-AF65-F5344CB8AC3E}">
-        <p14:creationId xmlns:p14="http://schemas.microsoft.com/office/powerpoint/2010/main" val="271602571"/>
+        <p14:creationId xmlns:p14="http://schemas.microsoft.com/office/powerpoint/2010/main" val="1583252100"/>
       </p:ext>
     </p:extLst>
   </p:cSld>
@@ -4193,7 +4193,7 @@
           <p:cNvPr id="1" name="">
             <a:extLst xmlns:a="http://schemas.openxmlformats.org/drawingml/2006/main">
               <a:ext uri="{FF2B5EF4-FFF2-40B4-BE49-F238E27FC236}">
-                <a16:creationId xmlns:a16="http://schemas.microsoft.com/office/drawing/2014/main" id="{26010E2D-786E-4008-8E86-494A9EA97169}"/>
+                <a16:creationId xmlns:a16="http://schemas.microsoft.com/office/drawing/2014/main" id="{BA652907-1527-445C-9D34-275F4E12862F}"/>
               </a:ext>
             </a:extLst>
           </p:cNvPr>
@@ -4253,7 +4253,7 @@
           <p:nvPr/>
         </p:nvPicPr>
         <p:blipFill>
-          <a:blip xmlns:r="http://schemas.openxmlformats.org/officeDocument/2006/relationships" xmlns:a="http://schemas.openxmlformats.org/drawingml/2006/main" r:embed="R3439e9ca6620443d"/>
+          <a:blip xmlns:r="http://schemas.openxmlformats.org/officeDocument/2006/relationships" xmlns:a="http://schemas.openxmlformats.org/drawingml/2006/main" r:embed="R5dc996e5552843e3"/>
           <a:srcRect xmlns:a="http://schemas.openxmlformats.org/drawingml/2006/main" l="2907" t="0" r="2907" b="0"/>
           <a:stretch xmlns:a="http://schemas.openxmlformats.org/drawingml/2006/main">
             <a:fillRect l="0" t="0" r="0" b="0"/>
@@ -4274,7 +4274,7 @@
           <p:cNvPr id="3" name="">
             <a:extLst xmlns:a="http://schemas.openxmlformats.org/drawingml/2006/main">
               <a:ext uri="{FF2B5EF4-FFF2-40B4-BE49-F238E27FC236}">
-                <a16:creationId xmlns:a16="http://schemas.microsoft.com/office/drawing/2014/main" id="{AF0B308D-5BE8-409F-804E-4E6431184A00}"/>
+                <a16:creationId xmlns:a16="http://schemas.microsoft.com/office/drawing/2014/main" id="{B8A2F386-5458-49A4-9D6A-7DCD8CC3C478}"/>
               </a:ext>
             </a:extLst>
           </p:cNvPr>
@@ -4330,7 +4330,7 @@
           <p:cNvPr id="4" name="">
             <a:extLst xmlns:a="http://schemas.openxmlformats.org/drawingml/2006/main">
               <a:ext uri="{FF2B5EF4-FFF2-40B4-BE49-F238E27FC236}">
-                <a16:creationId xmlns:a16="http://schemas.microsoft.com/office/drawing/2014/main" id="{825150CE-5F42-40CC-82B6-017C5F2E2239}"/>
+                <a16:creationId xmlns:a16="http://schemas.microsoft.com/office/drawing/2014/main" id="{4DDB17C4-4BFD-4D98-A92A-41D41F0E55A9}"/>
               </a:ext>
             </a:extLst>
           </p:cNvPr>
@@ -4361,7 +4361,7 @@
           <p:cNvPr id="5" name="">
             <a:extLst xmlns:a="http://schemas.openxmlformats.org/drawingml/2006/main">
               <a:ext uri="{FF2B5EF4-FFF2-40B4-BE49-F238E27FC236}">
-                <a16:creationId xmlns:a16="http://schemas.microsoft.com/office/drawing/2014/main" id="{CF54460A-89C6-40DF-B9A3-7E102791178B}"/>
+                <a16:creationId xmlns:a16="http://schemas.microsoft.com/office/drawing/2014/main" id="{B0C2D451-D17E-4292-872D-DD8A086F1BA8}"/>
               </a:ext>
             </a:extLst>
           </p:cNvPr>
@@ -4417,7 +4417,7 @@
           <p:cNvPr id="6" name="">
             <a:extLst xmlns:a="http://schemas.openxmlformats.org/drawingml/2006/main">
               <a:ext uri="{FF2B5EF4-FFF2-40B4-BE49-F238E27FC236}">
-                <a16:creationId xmlns:a16="http://schemas.microsoft.com/office/drawing/2014/main" id="{8FE7E4E1-96A0-4A44-93FA-5DCD3CD84D9A}"/>
+                <a16:creationId xmlns:a16="http://schemas.microsoft.com/office/drawing/2014/main" id="{318F47F5-84D8-4B68-89EF-182E184E512F}"/>
               </a:ext>
             </a:extLst>
           </p:cNvPr>
@@ -4448,7 +4448,7 @@
           <p:cNvPr id="7" name="">
             <a:extLst xmlns:a="http://schemas.openxmlformats.org/drawingml/2006/main">
               <a:ext uri="{FF2B5EF4-FFF2-40B4-BE49-F238E27FC236}">
-                <a16:creationId xmlns:a16="http://schemas.microsoft.com/office/drawing/2014/main" id="{C20219B4-A3F0-4F5E-9398-F6363DDA3F15}"/>
+                <a16:creationId xmlns:a16="http://schemas.microsoft.com/office/drawing/2014/main" id="{700DC5FC-702D-408E-ADE3-F03B78780E47}"/>
               </a:ext>
             </a:extLst>
           </p:cNvPr>
@@ -4504,7 +4504,7 @@
           <p:cNvPr id="8" name="">
             <a:extLst xmlns:a="http://schemas.openxmlformats.org/drawingml/2006/main">
               <a:ext uri="{FF2B5EF4-FFF2-40B4-BE49-F238E27FC236}">
-                <a16:creationId xmlns:a16="http://schemas.microsoft.com/office/drawing/2014/main" id="{EB1F4276-9542-4F2D-B8A2-BD80FEFC9A30}"/>
+                <a16:creationId xmlns:a16="http://schemas.microsoft.com/office/drawing/2014/main" id="{8EE8AC20-B645-48AE-8CF6-BAC0942DDF3E}"/>
               </a:ext>
             </a:extLst>
           </p:cNvPr>
@@ -4535,7 +4535,7 @@
           <p:cNvPr id="9" name="">
             <a:extLst xmlns:a="http://schemas.openxmlformats.org/drawingml/2006/main">
               <a:ext uri="{FF2B5EF4-FFF2-40B4-BE49-F238E27FC236}">
-                <a16:creationId xmlns:a16="http://schemas.microsoft.com/office/drawing/2014/main" id="{BF69F5AD-279D-4A0C-8206-854554164F70}"/>
+                <a16:creationId xmlns:a16="http://schemas.microsoft.com/office/drawing/2014/main" id="{C33F4BDB-526D-49D4-BF36-04E9F3B3F32F}"/>
               </a:ext>
             </a:extLst>
           </p:cNvPr>
@@ -4591,7 +4591,7 @@
           <p:cNvPr id="10" name="">
             <a:extLst xmlns:a="http://schemas.openxmlformats.org/drawingml/2006/main">
               <a:ext uri="{FF2B5EF4-FFF2-40B4-BE49-F238E27FC236}">
-                <a16:creationId xmlns:a16="http://schemas.microsoft.com/office/drawing/2014/main" id="{8CCFAEDA-FA38-4272-83C0-CE0B7F3463C2}"/>
+                <a16:creationId xmlns:a16="http://schemas.microsoft.com/office/drawing/2014/main" id="{E7B4B2C0-1DE6-4D79-A018-6F2F8E9F7524}"/>
               </a:ext>
             </a:extLst>
           </p:cNvPr>
@@ -4622,7 +4622,7 @@
           <p:cNvPr id="11" name="">
             <a:extLst xmlns:a="http://schemas.openxmlformats.org/drawingml/2006/main">
               <a:ext uri="{FF2B5EF4-FFF2-40B4-BE49-F238E27FC236}">
-                <a16:creationId xmlns:a16="http://schemas.microsoft.com/office/drawing/2014/main" id="{A7F7F7A7-DFC3-45FF-A411-A3254C3AF485}"/>
+                <a16:creationId xmlns:a16="http://schemas.microsoft.com/office/drawing/2014/main" id="{E1F4B861-FBDB-4860-9D78-9FB017D7B650}"/>
               </a:ext>
             </a:extLst>
           </p:cNvPr>
@@ -4678,7 +4678,7 @@
           <p:cNvPr id="12" name="">
             <a:extLst xmlns:a="http://schemas.openxmlformats.org/drawingml/2006/main">
               <a:ext uri="{FF2B5EF4-FFF2-40B4-BE49-F238E27FC236}">
-                <a16:creationId xmlns:a16="http://schemas.microsoft.com/office/drawing/2014/main" id="{E75E2C86-5E65-4D65-A3D6-2E5BA32A8276}"/>
+                <a16:creationId xmlns:a16="http://schemas.microsoft.com/office/drawing/2014/main" id="{11BB9712-ABAD-475D-A754-15F4090A5871}"/>
               </a:ext>
             </a:extLst>
           </p:cNvPr>
@@ -4734,7 +4734,7 @@
           <p:cNvPr id="13" name="">
             <a:extLst xmlns:a="http://schemas.openxmlformats.org/drawingml/2006/main">
               <a:ext uri="{FF2B5EF4-FFF2-40B4-BE49-F238E27FC236}">
-                <a16:creationId xmlns:a16="http://schemas.microsoft.com/office/drawing/2014/main" id="{A226166A-FE42-4C42-90BC-E1D3D43B559C}"/>
+                <a16:creationId xmlns:a16="http://schemas.microsoft.com/office/drawing/2014/main" id="{1F528C3B-66DC-4F34-A9DB-39B0D736A942}"/>
               </a:ext>
             </a:extLst>
           </p:cNvPr>
@@ -4788,7 +4788,7 @@
     </p:spTree>
     <p:extLst>
       <p:ext uri="{BB962C8B-B14F-4D97-AF65-F5344CB8AC3E}">
-        <p14:creationId xmlns:p14="http://schemas.microsoft.com/office/powerpoint/2010/main" val="642603745"/>
+        <p14:creationId xmlns:p14="http://schemas.microsoft.com/office/powerpoint/2010/main" val="343281083"/>
       </p:ext>
     </p:extLst>
   </p:cSld>
@@ -4819,7 +4819,7 @@
           <p:cNvPr id="1" name="">
             <a:extLst xmlns:a="http://schemas.openxmlformats.org/drawingml/2006/main">
               <a:ext uri="{FF2B5EF4-FFF2-40B4-BE49-F238E27FC236}">
-                <a16:creationId xmlns:a16="http://schemas.microsoft.com/office/drawing/2014/main" id="{A5F6618F-B6C3-4D49-BFB8-D4B26F8727F2}"/>
+                <a16:creationId xmlns:a16="http://schemas.microsoft.com/office/drawing/2014/main" id="{8DDE60F7-AAA9-4AC9-B5D9-C0C0FF7B0326}"/>
               </a:ext>
             </a:extLst>
           </p:cNvPr>
@@ -4875,7 +4875,7 @@
           <p:cNvPr id="2" name="">
             <a:extLst xmlns:a="http://schemas.openxmlformats.org/drawingml/2006/main">
               <a:ext uri="{FF2B5EF4-FFF2-40B4-BE49-F238E27FC236}">
-                <a16:creationId xmlns:a16="http://schemas.microsoft.com/office/drawing/2014/main" id="{7735CA5D-1225-434E-AB1C-6823AF3BC5F6}"/>
+                <a16:creationId xmlns:a16="http://schemas.microsoft.com/office/drawing/2014/main" id="{63FD47E6-4491-42FF-BD44-7F8FC272B098}"/>
               </a:ext>
             </a:extLst>
           </p:cNvPr>
@@ -4935,7 +4935,7 @@
           <p:nvPr/>
         </p:nvPicPr>
         <p:blipFill>
-          <a:blip xmlns:r="http://schemas.openxmlformats.org/officeDocument/2006/relationships" xmlns:a="http://schemas.openxmlformats.org/drawingml/2006/main" r:embed="R0e53fb9588a44fa1"/>
+          <a:blip xmlns:r="http://schemas.openxmlformats.org/officeDocument/2006/relationships" xmlns:a="http://schemas.openxmlformats.org/drawingml/2006/main" r:embed="Rf1acca1593db4ef1"/>
           <a:srcRect xmlns:a="http://schemas.openxmlformats.org/drawingml/2006/main" l="10473" t="0" r="10473" b="0"/>
           <a:stretch xmlns:a="http://schemas.openxmlformats.org/drawingml/2006/main">
             <a:fillRect l="0" t="0" r="0" b="0"/>
@@ -4956,7 +4956,7 @@
           <p:cNvPr id="4" name="">
             <a:extLst xmlns:a="http://schemas.openxmlformats.org/drawingml/2006/main">
               <a:ext uri="{FF2B5EF4-FFF2-40B4-BE49-F238E27FC236}">
-                <a16:creationId xmlns:a16="http://schemas.microsoft.com/office/drawing/2014/main" id="{6D24FC52-429D-4CB7-8032-21F10BD64E89}"/>
+                <a16:creationId xmlns:a16="http://schemas.microsoft.com/office/drawing/2014/main" id="{A69F68EA-7703-4323-A66D-68F78E6F4F24}"/>
               </a:ext>
             </a:extLst>
           </p:cNvPr>
@@ -5012,7 +5012,7 @@
           <p:cNvPr id="5" name="">
             <a:extLst xmlns:a="http://schemas.openxmlformats.org/drawingml/2006/main">
               <a:ext uri="{FF2B5EF4-FFF2-40B4-BE49-F238E27FC236}">
-                <a16:creationId xmlns:a16="http://schemas.microsoft.com/office/drawing/2014/main" id="{417F9158-04A5-474C-91A4-9BE13021C234}"/>
+                <a16:creationId xmlns:a16="http://schemas.microsoft.com/office/drawing/2014/main" id="{0E04F2BF-1D70-419F-9BA0-9444F9DA373B}"/>
               </a:ext>
             </a:extLst>
           </p:cNvPr>
@@ -5072,7 +5072,7 @@
           <p:nvPr/>
         </p:nvPicPr>
         <p:blipFill>
-          <a:blip xmlns:r="http://schemas.openxmlformats.org/officeDocument/2006/relationships" xmlns:a="http://schemas.openxmlformats.org/drawingml/2006/main" r:embed="R1c8dbdadd61044cc"/>
+          <a:blip xmlns:r="http://schemas.openxmlformats.org/officeDocument/2006/relationships" xmlns:a="http://schemas.openxmlformats.org/drawingml/2006/main" r:embed="R1afe6f6c86be4755"/>
           <a:srcRect xmlns:a="http://schemas.openxmlformats.org/drawingml/2006/main" l="10473" t="0" r="10473" b="0"/>
           <a:stretch xmlns:a="http://schemas.openxmlformats.org/drawingml/2006/main">
             <a:fillRect l="0" t="0" r="0" b="0"/>
@@ -5093,7 +5093,7 @@
           <p:cNvPr id="7" name="">
             <a:extLst xmlns:a="http://schemas.openxmlformats.org/drawingml/2006/main">
               <a:ext uri="{FF2B5EF4-FFF2-40B4-BE49-F238E27FC236}">
-                <a16:creationId xmlns:a16="http://schemas.microsoft.com/office/drawing/2014/main" id="{1CF7089B-9C5C-46A5-97D5-175B3EC978A6}"/>
+                <a16:creationId xmlns:a16="http://schemas.microsoft.com/office/drawing/2014/main" id="{9117E326-6ADB-4210-8C03-B7702A4CF4C9}"/>
               </a:ext>
             </a:extLst>
           </p:cNvPr>
@@ -5149,7 +5149,7 @@
           <p:cNvPr id="8" name="">
             <a:extLst xmlns:a="http://schemas.openxmlformats.org/drawingml/2006/main">
               <a:ext uri="{FF2B5EF4-FFF2-40B4-BE49-F238E27FC236}">
-                <a16:creationId xmlns:a16="http://schemas.microsoft.com/office/drawing/2014/main" id="{8F546C04-FEE0-43AE-8CAD-4F1E376E3D2F}"/>
+                <a16:creationId xmlns:a16="http://schemas.microsoft.com/office/drawing/2014/main" id="{55F3DD4B-C866-4815-9E9F-53361F4E2F2C}"/>
               </a:ext>
             </a:extLst>
           </p:cNvPr>
@@ -5205,7 +5205,7 @@
           <p:cNvPr id="9" name="">
             <a:extLst xmlns:a="http://schemas.openxmlformats.org/drawingml/2006/main">
               <a:ext uri="{FF2B5EF4-FFF2-40B4-BE49-F238E27FC236}">
-                <a16:creationId xmlns:a16="http://schemas.microsoft.com/office/drawing/2014/main" id="{B8394539-70B9-4ED7-94DE-4214DCE0BD3F}"/>
+                <a16:creationId xmlns:a16="http://schemas.microsoft.com/office/drawing/2014/main" id="{72215DAB-389D-4889-BD30-DEC1A8959022}"/>
               </a:ext>
             </a:extLst>
           </p:cNvPr>
@@ -5259,7 +5259,7 @@
     </p:spTree>
     <p:extLst>
       <p:ext uri="{BB962C8B-B14F-4D97-AF65-F5344CB8AC3E}">
-        <p14:creationId xmlns:p14="http://schemas.microsoft.com/office/powerpoint/2010/main" val="545883949"/>
+        <p14:creationId xmlns:p14="http://schemas.microsoft.com/office/powerpoint/2010/main" val="1043564775"/>
       </p:ext>
     </p:extLst>
   </p:cSld>
@@ -5290,7 +5290,7 @@
           <p:cNvPr id="1" name="">
             <a:extLst xmlns:a="http://schemas.openxmlformats.org/drawingml/2006/main">
               <a:ext uri="{FF2B5EF4-FFF2-40B4-BE49-F238E27FC236}">
-                <a16:creationId xmlns:a16="http://schemas.microsoft.com/office/drawing/2014/main" id="{1B09C913-49E7-40EF-AF49-CC83BD1982E6}"/>
+                <a16:creationId xmlns:a16="http://schemas.microsoft.com/office/drawing/2014/main" id="{59953624-99EF-407A-830B-F998BCE8EB55}"/>
               </a:ext>
             </a:extLst>
           </p:cNvPr>
@@ -5336,7 +5336,7 @@
                 <a:ea typeface="Microsoft YaHei"/>
                 <a:cs typeface="Microsoft YaHei"/>
               </a:rPr>
-              <a:t>Demo 体验流程</a:t>
+              <a:t>Demo 视频讲解</a:t>
             </a:r>
           </a:p>
         </p:txBody>
@@ -5346,7 +5346,7 @@
           <p:cNvPr id="2" name="">
             <a:extLst xmlns:a="http://schemas.openxmlformats.org/drawingml/2006/main">
               <a:ext uri="{FF2B5EF4-FFF2-40B4-BE49-F238E27FC236}">
-                <a16:creationId xmlns:a16="http://schemas.microsoft.com/office/drawing/2014/main" id="{397B2F08-518C-4F96-AA78-3A0DC74141DC}"/>
+                <a16:creationId xmlns:a16="http://schemas.microsoft.com/office/drawing/2014/main" id="{A3C89937-254F-42F0-AB3C-58C0241D5085}"/>
               </a:ext>
             </a:extLst>
           </p:cNvPr>
@@ -5358,7 +5358,7 @@
         <p:spPr>
           <a:xfrm xmlns:a="http://schemas.openxmlformats.org/drawingml/2006/main">
             <a:off x="628650" y="1028700"/>
-            <a:ext cx="8191500" cy="304800"/>
+            <a:ext cx="8572500" cy="304800"/>
           </a:xfrm>
           <a:prstGeom xmlns:a="http://schemas.openxmlformats.org/drawingml/2006/main" prst="rect">
             <a:avLst/>
@@ -5392,7 +5392,7 @@
                 <a:ea typeface="Microsoft YaHei"/>
                 <a:cs typeface="Microsoft YaHei"/>
               </a:rPr>
-              <a:t>3–5 分钟展示完整游戏闭环：穿越开场、NPC 对话、战斗、成长、合成、Boss 战与结局。</a:t>
+              <a:t>3–5 分钟视频展示完整游戏闭环：穿越开场、NPC 对话、战斗、成长、合成、Boss 战与结局。</a:t>
             </a:r>
           </a:p>
         </p:txBody>
@@ -5406,7 +5406,7 @@
           <p:nvPr/>
         </p:nvPicPr>
         <p:blipFill>
-          <a:blip xmlns:r="http://schemas.openxmlformats.org/officeDocument/2006/relationships" xmlns:a="http://schemas.openxmlformats.org/drawingml/2006/main" r:embed="R9296ac92d9204bb3"/>
+          <a:blip xmlns:r="http://schemas.openxmlformats.org/officeDocument/2006/relationships" xmlns:a="http://schemas.openxmlformats.org/drawingml/2006/main" r:embed="Rc053998faa564c3f"/>
           <a:srcRect xmlns:a="http://schemas.openxmlformats.org/drawingml/2006/main" l="0" t="5556" r="0" b="5556"/>
           <a:stretch xmlns:a="http://schemas.openxmlformats.org/drawingml/2006/main">
             <a:fillRect l="0" t="0" r="0" b="0"/>
@@ -5427,7 +5427,7 @@
           <p:cNvPr id="4" name="">
             <a:extLst xmlns:a="http://schemas.openxmlformats.org/drawingml/2006/main">
               <a:ext uri="{FF2B5EF4-FFF2-40B4-BE49-F238E27FC236}">
-                <a16:creationId xmlns:a16="http://schemas.microsoft.com/office/drawing/2014/main" id="{E5B29531-DA3F-4C6B-B167-5A639E96E2F0}"/>
+                <a16:creationId xmlns:a16="http://schemas.microsoft.com/office/drawing/2014/main" id="{3F234669-64C6-442A-9507-94F5F5DE7E15}"/>
               </a:ext>
             </a:extLst>
           </p:cNvPr>
@@ -5487,7 +5487,7 @@
           <p:nvPr/>
         </p:nvPicPr>
         <p:blipFill>
-          <a:blip xmlns:r="http://schemas.openxmlformats.org/officeDocument/2006/relationships" xmlns:a="http://schemas.openxmlformats.org/drawingml/2006/main" r:embed="R189a1fe1c6e546ed"/>
+          <a:blip xmlns:r="http://schemas.openxmlformats.org/officeDocument/2006/relationships" xmlns:a="http://schemas.openxmlformats.org/drawingml/2006/main" r:embed="R29803dc01b184719"/>
           <a:srcRect xmlns:a="http://schemas.openxmlformats.org/drawingml/2006/main" l="0" t="5556" r="0" b="5556"/>
           <a:stretch xmlns:a="http://schemas.openxmlformats.org/drawingml/2006/main">
             <a:fillRect l="0" t="0" r="0" b="0"/>
@@ -5508,7 +5508,7 @@
           <p:cNvPr id="6" name="">
             <a:extLst xmlns:a="http://schemas.openxmlformats.org/drawingml/2006/main">
               <a:ext uri="{FF2B5EF4-FFF2-40B4-BE49-F238E27FC236}">
-                <a16:creationId xmlns:a16="http://schemas.microsoft.com/office/drawing/2014/main" id="{2CCEB1E8-6912-4BB2-9FD2-AA460E9D05BB}"/>
+                <a16:creationId xmlns:a16="http://schemas.microsoft.com/office/drawing/2014/main" id="{F79F8A50-4D95-4B80-B35A-9AAA9C585BDD}"/>
               </a:ext>
             </a:extLst>
           </p:cNvPr>
@@ -5568,7 +5568,7 @@
           <p:nvPr/>
         </p:nvPicPr>
         <p:blipFill>
-          <a:blip xmlns:r="http://schemas.openxmlformats.org/officeDocument/2006/relationships" xmlns:a="http://schemas.openxmlformats.org/drawingml/2006/main" r:embed="R864dfae6de764400"/>
+          <a:blip xmlns:r="http://schemas.openxmlformats.org/officeDocument/2006/relationships" xmlns:a="http://schemas.openxmlformats.org/drawingml/2006/main" r:embed="R266caec460934e8b"/>
           <a:srcRect xmlns:a="http://schemas.openxmlformats.org/drawingml/2006/main" l="0" t="5556" r="0" b="5556"/>
           <a:stretch xmlns:a="http://schemas.openxmlformats.org/drawingml/2006/main">
             <a:fillRect l="0" t="0" r="0" b="0"/>
@@ -5589,7 +5589,7 @@
           <p:cNvPr id="8" name="">
             <a:extLst xmlns:a="http://schemas.openxmlformats.org/drawingml/2006/main">
               <a:ext uri="{FF2B5EF4-FFF2-40B4-BE49-F238E27FC236}">
-                <a16:creationId xmlns:a16="http://schemas.microsoft.com/office/drawing/2014/main" id="{FC738026-C483-4278-9B44-61592576D7B7}"/>
+                <a16:creationId xmlns:a16="http://schemas.microsoft.com/office/drawing/2014/main" id="{27857167-5563-4A6D-8D40-7B5DABC6FB01}"/>
               </a:ext>
             </a:extLst>
           </p:cNvPr>
@@ -5649,7 +5649,7 @@
           <p:nvPr/>
         </p:nvPicPr>
         <p:blipFill>
-          <a:blip xmlns:r="http://schemas.openxmlformats.org/officeDocument/2006/relationships" xmlns:a="http://schemas.openxmlformats.org/drawingml/2006/main" r:embed="R0effa891b20c4c6b"/>
+          <a:blip xmlns:r="http://schemas.openxmlformats.org/officeDocument/2006/relationships" xmlns:a="http://schemas.openxmlformats.org/drawingml/2006/main" r:embed="R078ccc10a19d46ca"/>
           <a:srcRect xmlns:a="http://schemas.openxmlformats.org/drawingml/2006/main" l="0" t="5556" r="0" b="5556"/>
           <a:stretch xmlns:a="http://schemas.openxmlformats.org/drawingml/2006/main">
             <a:fillRect l="0" t="0" r="0" b="0"/>
@@ -5670,7 +5670,7 @@
           <p:cNvPr id="10" name="">
             <a:extLst xmlns:a="http://schemas.openxmlformats.org/drawingml/2006/main">
               <a:ext uri="{FF2B5EF4-FFF2-40B4-BE49-F238E27FC236}">
-                <a16:creationId xmlns:a16="http://schemas.microsoft.com/office/drawing/2014/main" id="{07C20B19-209C-4756-88A8-989681744081}"/>
+                <a16:creationId xmlns:a16="http://schemas.microsoft.com/office/drawing/2014/main" id="{F366A824-B178-4DEA-BD23-88E1A137853A}"/>
               </a:ext>
             </a:extLst>
           </p:cNvPr>
@@ -5730,7 +5730,7 @@
           <p:nvPr/>
         </p:nvPicPr>
         <p:blipFill>
-          <a:blip xmlns:r="http://schemas.openxmlformats.org/officeDocument/2006/relationships" xmlns:a="http://schemas.openxmlformats.org/drawingml/2006/main" r:embed="R537ee63054524980"/>
+          <a:blip xmlns:r="http://schemas.openxmlformats.org/officeDocument/2006/relationships" xmlns:a="http://schemas.openxmlformats.org/drawingml/2006/main" r:embed="R6c9761e6d8194575"/>
           <a:srcRect xmlns:a="http://schemas.openxmlformats.org/drawingml/2006/main" l="0" t="5556" r="0" b="5556"/>
           <a:stretch xmlns:a="http://schemas.openxmlformats.org/drawingml/2006/main">
             <a:fillRect l="0" t="0" r="0" b="0"/>
@@ -5751,7 +5751,7 @@
           <p:cNvPr id="12" name="">
             <a:extLst xmlns:a="http://schemas.openxmlformats.org/drawingml/2006/main">
               <a:ext uri="{FF2B5EF4-FFF2-40B4-BE49-F238E27FC236}">
-                <a16:creationId xmlns:a16="http://schemas.microsoft.com/office/drawing/2014/main" id="{4138E1EA-7426-4AEA-8200-D9488FB5ED4E}"/>
+                <a16:creationId xmlns:a16="http://schemas.microsoft.com/office/drawing/2014/main" id="{FDC15B62-259C-4DB2-A9A9-BBB708557ED1}"/>
               </a:ext>
             </a:extLst>
           </p:cNvPr>
@@ -5811,7 +5811,7 @@
           <p:nvPr/>
         </p:nvPicPr>
         <p:blipFill>
-          <a:blip xmlns:r="http://schemas.openxmlformats.org/officeDocument/2006/relationships" xmlns:a="http://schemas.openxmlformats.org/drawingml/2006/main" r:embed="R674ab5fb9fce4570"/>
+          <a:blip xmlns:r="http://schemas.openxmlformats.org/officeDocument/2006/relationships" xmlns:a="http://schemas.openxmlformats.org/drawingml/2006/main" r:embed="Rc0d1b8d7d22b4181"/>
           <a:srcRect xmlns:a="http://schemas.openxmlformats.org/drawingml/2006/main" l="0" t="5556" r="0" b="5556"/>
           <a:stretch xmlns:a="http://schemas.openxmlformats.org/drawingml/2006/main">
             <a:fillRect l="0" t="0" r="0" b="0"/>
@@ -5832,7 +5832,7 @@
           <p:cNvPr id="14" name="">
             <a:extLst xmlns:a="http://schemas.openxmlformats.org/drawingml/2006/main">
               <a:ext uri="{FF2B5EF4-FFF2-40B4-BE49-F238E27FC236}">
-                <a16:creationId xmlns:a16="http://schemas.microsoft.com/office/drawing/2014/main" id="{84F2FC39-4F43-4D7E-ADC7-288BC1933CF8}"/>
+                <a16:creationId xmlns:a16="http://schemas.microsoft.com/office/drawing/2014/main" id="{155806DD-10C9-41FC-B0CE-31EA64810625}"/>
               </a:ext>
             </a:extLst>
           </p:cNvPr>
@@ -5888,7 +5888,7 @@
           <p:cNvPr id="15" name="">
             <a:extLst xmlns:a="http://schemas.openxmlformats.org/drawingml/2006/main">
               <a:ext uri="{FF2B5EF4-FFF2-40B4-BE49-F238E27FC236}">
-                <a16:creationId xmlns:a16="http://schemas.microsoft.com/office/drawing/2014/main" id="{5E0B4882-3BFB-4AC2-AAA8-6514FA1A714A}"/>
+                <a16:creationId xmlns:a16="http://schemas.microsoft.com/office/drawing/2014/main" id="{4B961B74-CC82-4FBF-99A6-79D6A7EFDABB}"/>
               </a:ext>
             </a:extLst>
           </p:cNvPr>
@@ -5944,7 +5944,7 @@
           <p:cNvPr id="16" name="">
             <a:extLst xmlns:a="http://schemas.openxmlformats.org/drawingml/2006/main">
               <a:ext uri="{FF2B5EF4-FFF2-40B4-BE49-F238E27FC236}">
-                <a16:creationId xmlns:a16="http://schemas.microsoft.com/office/drawing/2014/main" id="{BA5560E4-2981-4AD5-A8B2-306323FF8FA9}"/>
+                <a16:creationId xmlns:a16="http://schemas.microsoft.com/office/drawing/2014/main" id="{6AA785F3-D5C4-478C-887A-B0BA37EC422F}"/>
               </a:ext>
             </a:extLst>
           </p:cNvPr>
@@ -5998,7 +5998,7 @@
     </p:spTree>
     <p:extLst>
       <p:ext uri="{BB962C8B-B14F-4D97-AF65-F5344CB8AC3E}">
-        <p14:creationId xmlns:p14="http://schemas.microsoft.com/office/powerpoint/2010/main" val="466253113"/>
+        <p14:creationId xmlns:p14="http://schemas.microsoft.com/office/powerpoint/2010/main" val="914564409"/>
       </p:ext>
     </p:extLst>
   </p:cSld>
@@ -6029,7 +6029,7 @@
           <p:cNvPr id="1" name="">
             <a:extLst xmlns:a="http://schemas.openxmlformats.org/drawingml/2006/main">
               <a:ext uri="{FF2B5EF4-FFF2-40B4-BE49-F238E27FC236}">
-                <a16:creationId xmlns:a16="http://schemas.microsoft.com/office/drawing/2014/main" id="{739E7170-6AE1-4F79-9690-2E7EB73D0DC0}"/>
+                <a16:creationId xmlns:a16="http://schemas.microsoft.com/office/drawing/2014/main" id="{2964289F-B8A8-4817-A14A-5C0B3F1E16FE}"/>
               </a:ext>
             </a:extLst>
           </p:cNvPr>
@@ -6080,47 +6080,117 @@
           </a:p>
         </p:txBody>
       </p:sp>
+      <p:sp>
+        <p:nvSpPr>
+          <p:cNvPr id="2" name="">
+            <a:extLst xmlns:a="http://schemas.openxmlformats.org/drawingml/2006/main">
+              <a:ext uri="{FF2B5EF4-FFF2-40B4-BE49-F238E27FC236}">
+                <a16:creationId xmlns:a16="http://schemas.microsoft.com/office/drawing/2014/main" id="{B7D5E2B8-C39C-4301-88D0-D6FA56406601}"/>
+              </a:ext>
+            </a:extLst>
+          </p:cNvPr>
+          <p:cNvSpPr>
+            <a:spLocks xmlns:a="http://schemas.openxmlformats.org/drawingml/2006/main" noGrp="1"/>
+          </p:cNvSpPr>
+          <p:nvPr/>
+        </p:nvSpPr>
+        <p:spPr>
+          <a:xfrm xmlns:a="http://schemas.openxmlformats.org/drawingml/2006/main">
+            <a:off x="457200" y="1219200"/>
+            <a:ext cx="6191250" cy="4762500"/>
+          </a:xfrm>
+          <a:prstGeom xmlns:a="http://schemas.openxmlformats.org/drawingml/2006/main" prst="roundRect">
+            <a:avLst>
+              <a:gd name="adj" fmla="val 3200"/>
+            </a:avLst>
+          </a:prstGeom>
+          <a:solidFill xmlns:a="http://schemas.openxmlformats.org/drawingml/2006/main">
+            <a:srgbClr val="FFFFFF"/>
+          </a:solidFill>
+          <a:ln xmlns:a="http://schemas.openxmlformats.org/drawingml/2006/main" w="19050">
+            <a:solidFill>
+              <a:srgbClr val="74CDFF"/>
+            </a:solidFill>
+            <a:prstDash val="solid"/>
+          </a:ln>
+        </p:spPr>
+      </p:sp>
       <p:pic>
         <p:nvPicPr>
-          <p:cNvPr id="10" name=""/>
+          <p:cNvPr id="14" name=""/>
           <p:cNvPicPr>
             <a:picLocks xmlns:a="http://schemas.openxmlformats.org/drawingml/2006/main" noChangeAspect="1"/>
           </p:cNvPicPr>
           <p:nvPr/>
         </p:nvPicPr>
         <p:blipFill>
-          <a:blip xmlns:r="http://schemas.openxmlformats.org/officeDocument/2006/relationships" xmlns:a="http://schemas.openxmlformats.org/drawingml/2006/main" r:embed="R70d9433792e84eb1"/>
+          <a:blip xmlns:r="http://schemas.openxmlformats.org/officeDocument/2006/relationships" xmlns:a="http://schemas.openxmlformats.org/drawingml/2006/main" r:embed="R81fee69794074545"/>
           <a:stretch xmlns:a="http://schemas.openxmlformats.org/drawingml/2006/main"/>
         </p:blipFill>
         <p:spPr>
           <a:xfrm xmlns:a="http://schemas.openxmlformats.org/drawingml/2006/main">
-            <a:off x="571500" y="1821656"/>
-            <a:ext cx="5715000" cy="3214688"/>
+            <a:off x="628650" y="1955602"/>
+            <a:ext cx="5848350" cy="3289697"/>
           </a:xfrm>
           <a:prstGeom xmlns:a="http://schemas.openxmlformats.org/drawingml/2006/main" prst="rect">
             <a:avLst/>
           </a:prstGeom>
         </p:spPr>
       </p:pic>
+      <p:sp>
+        <p:nvSpPr>
+          <p:cNvPr id="4" name="">
+            <a:extLst xmlns:a="http://schemas.openxmlformats.org/drawingml/2006/main">
+              <a:ext uri="{FF2B5EF4-FFF2-40B4-BE49-F238E27FC236}">
+                <a16:creationId xmlns:a16="http://schemas.microsoft.com/office/drawing/2014/main" id="{B3A76B59-D5C7-4008-A6D5-DE7DD6F99E69}"/>
+              </a:ext>
+            </a:extLst>
+          </p:cNvPr>
+          <p:cNvSpPr>
+            <a:spLocks xmlns:a="http://schemas.openxmlformats.org/drawingml/2006/main" noGrp="1"/>
+          </p:cNvSpPr>
+          <p:nvPr/>
+        </p:nvSpPr>
+        <p:spPr>
+          <a:xfrm xmlns:a="http://schemas.openxmlformats.org/drawingml/2006/main">
+            <a:off x="6934200" y="1219200"/>
+            <a:ext cx="4762500" cy="4762500"/>
+          </a:xfrm>
+          <a:prstGeom xmlns:a="http://schemas.openxmlformats.org/drawingml/2006/main" prst="roundRect">
+            <a:avLst>
+              <a:gd name="adj" fmla="val 3200"/>
+            </a:avLst>
+          </a:prstGeom>
+          <a:solidFill xmlns:a="http://schemas.openxmlformats.org/drawingml/2006/main">
+            <a:srgbClr val="FFFFFF"/>
+          </a:solidFill>
+          <a:ln xmlns:a="http://schemas.openxmlformats.org/drawingml/2006/main" w="19050">
+            <a:solidFill>
+              <a:srgbClr val="FF80B8"/>
+            </a:solidFill>
+            <a:prstDash val="solid"/>
+          </a:ln>
+        </p:spPr>
+      </p:sp>
       <p:pic>
         <p:nvPicPr>
-          <p:cNvPr id="11" name=""/>
+          <p:cNvPr id="16" name=""/>
           <p:cNvPicPr>
             <a:picLocks xmlns:a="http://schemas.openxmlformats.org/drawingml/2006/main" noChangeAspect="1"/>
           </p:cNvPicPr>
           <p:nvPr/>
         </p:nvPicPr>
         <p:blipFill>
-          <a:blip xmlns:r="http://schemas.openxmlformats.org/officeDocument/2006/relationships" xmlns:a="http://schemas.openxmlformats.org/drawingml/2006/main" r:embed="Rdd4a6b6a2fe9489b"/>
-          <a:srcRect xmlns:a="http://schemas.openxmlformats.org/drawingml/2006/main" l="1042" t="0" r="1042" b="0"/>
+          <a:blip xmlns:r="http://schemas.openxmlformats.org/officeDocument/2006/relationships" xmlns:a="http://schemas.openxmlformats.org/drawingml/2006/main" r:embed="R17926133a3a94ed2"/>
+          <a:srcRect xmlns:a="http://schemas.openxmlformats.org/drawingml/2006/main" l="727" t="0" r="727" b="0"/>
           <a:stretch xmlns:a="http://schemas.openxmlformats.org/drawingml/2006/main">
             <a:fillRect l="0" t="0" r="0" b="0"/>
           </a:stretch>
         </p:blipFill>
         <p:spPr>
           <a:xfrm xmlns:a="http://schemas.openxmlformats.org/drawingml/2006/main">
-            <a:off x="6819900" y="1504950"/>
-            <a:ext cx="4476750" cy="2571750"/>
+            <a:off x="7162800" y="1466850"/>
+            <a:ext cx="4305300" cy="2457450"/>
           </a:xfrm>
           <a:prstGeom xmlns:a="http://schemas.openxmlformats.org/drawingml/2006/main" prst="rect">
             <a:avLst/>
@@ -6129,21 +6199,21 @@
       </p:pic>
       <p:sp>
         <p:nvSpPr>
-          <p:cNvPr id="4" name="">
-            <a:extLst xmlns:a="http://schemas.openxmlformats.org/drawingml/2006/main">
-              <a:ext uri="{FF2B5EF4-FFF2-40B4-BE49-F238E27FC236}">
-                <a16:creationId xmlns:a16="http://schemas.microsoft.com/office/drawing/2014/main" id="{BDF352AD-2786-444E-9312-F43E5DA3F0DE}"/>
-              </a:ext>
-            </a:extLst>
-          </p:cNvPr>
-          <p:cNvSpPr>
-            <a:spLocks xmlns:a="http://schemas.openxmlformats.org/drawingml/2006/main" noGrp="1"/>
-          </p:cNvSpPr>
-          <p:nvPr/>
-        </p:nvSpPr>
-        <p:spPr>
-          <a:xfrm xmlns:a="http://schemas.openxmlformats.org/drawingml/2006/main">
-            <a:off x="6953250" y="4457700"/>
+          <p:cNvPr id="6" name="">
+            <a:extLst xmlns:a="http://schemas.openxmlformats.org/drawingml/2006/main">
+              <a:ext uri="{FF2B5EF4-FFF2-40B4-BE49-F238E27FC236}">
+                <a16:creationId xmlns:a16="http://schemas.microsoft.com/office/drawing/2014/main" id="{82C90912-4FD2-443C-ACA9-AFFA62D7AF34}"/>
+              </a:ext>
+            </a:extLst>
+          </p:cNvPr>
+          <p:cNvSpPr>
+            <a:spLocks xmlns:a="http://schemas.openxmlformats.org/drawingml/2006/main" noGrp="1"/>
+          </p:cNvSpPr>
+          <p:nvPr/>
+        </p:nvSpPr>
+        <p:spPr>
+          <a:xfrm xmlns:a="http://schemas.openxmlformats.org/drawingml/2006/main">
+            <a:off x="7239000" y="4210050"/>
             <a:ext cx="2476500" cy="285750"/>
           </a:xfrm>
           <a:prstGeom xmlns:a="http://schemas.openxmlformats.org/drawingml/2006/main" prst="rect">
@@ -6185,22 +6255,22 @@
       </p:sp>
       <p:sp>
         <p:nvSpPr>
-          <p:cNvPr id="5" name="">
-            <a:extLst xmlns:a="http://schemas.openxmlformats.org/drawingml/2006/main">
-              <a:ext uri="{FF2B5EF4-FFF2-40B4-BE49-F238E27FC236}">
-                <a16:creationId xmlns:a16="http://schemas.microsoft.com/office/drawing/2014/main" id="{157A4129-F5A6-4AD8-91A3-8BE49A4581FE}"/>
-              </a:ext>
-            </a:extLst>
-          </p:cNvPr>
-          <p:cNvSpPr>
-            <a:spLocks xmlns:a="http://schemas.openxmlformats.org/drawingml/2006/main" noGrp="1"/>
-          </p:cNvSpPr>
-          <p:nvPr/>
-        </p:nvSpPr>
-        <p:spPr>
-          <a:xfrm xmlns:a="http://schemas.openxmlformats.org/drawingml/2006/main">
-            <a:off x="6953250" y="4857750"/>
-            <a:ext cx="4095750" cy="514350"/>
+          <p:cNvPr id="7" name="">
+            <a:extLst xmlns:a="http://schemas.openxmlformats.org/drawingml/2006/main">
+              <a:ext uri="{FF2B5EF4-FFF2-40B4-BE49-F238E27FC236}">
+                <a16:creationId xmlns:a16="http://schemas.microsoft.com/office/drawing/2014/main" id="{F9663E47-5A92-4EBF-A03D-FE65117F4EAA}"/>
+              </a:ext>
+            </a:extLst>
+          </p:cNvPr>
+          <p:cNvSpPr>
+            <a:spLocks xmlns:a="http://schemas.openxmlformats.org/drawingml/2006/main" noGrp="1"/>
+          </p:cNvSpPr>
+          <p:nvPr/>
+        </p:nvSpPr>
+        <p:spPr>
+          <a:xfrm xmlns:a="http://schemas.openxmlformats.org/drawingml/2006/main">
+            <a:off x="7239000" y="4610100"/>
+            <a:ext cx="3905250" cy="514350"/>
           </a:xfrm>
           <a:prstGeom xmlns:a="http://schemas.openxmlformats.org/drawingml/2006/main" prst="rect">
             <a:avLst/>
@@ -6216,7 +6286,7 @@
           <a:lstStyle xmlns:a="http://schemas.openxmlformats.org/drawingml/2006/main"/>
           <a:p xmlns:a="http://schemas.openxmlformats.org/drawingml/2006/main">
             <a:pPr>
-              <a:defRPr sz="1500">
+              <a:defRPr sz="1425">
                 <a:solidFill>
                   <a:srgbClr val="695F84"/>
                 </a:solidFill>
@@ -6226,7 +6296,7 @@
               </a:defRPr>
             </a:pPr>
             <a:r>
-              <a:rPr sz="1500">
+              <a:rPr sz="1425">
                 <a:solidFill>
                   <a:srgbClr val="695F84"/>
                 </a:solidFill>
@@ -6241,22 +6311,55 @@
       </p:sp>
       <p:sp>
         <p:nvSpPr>
-          <p:cNvPr id="6" name="">
-            <a:extLst xmlns:a="http://schemas.openxmlformats.org/drawingml/2006/main">
-              <a:ext uri="{FF2B5EF4-FFF2-40B4-BE49-F238E27FC236}">
-                <a16:creationId xmlns:a16="http://schemas.microsoft.com/office/drawing/2014/main" id="{B3595FB6-B740-44C4-9171-A9180423F772}"/>
-              </a:ext>
-            </a:extLst>
-          </p:cNvPr>
-          <p:cNvSpPr>
-            <a:spLocks xmlns:a="http://schemas.openxmlformats.org/drawingml/2006/main" noGrp="1"/>
-          </p:cNvSpPr>
-          <p:nvPr/>
-        </p:nvSpPr>
-        <p:spPr>
-          <a:xfrm xmlns:a="http://schemas.openxmlformats.org/drawingml/2006/main">
-            <a:off x="6953250" y="5543550"/>
-            <a:ext cx="4000500" cy="400050"/>
+          <p:cNvPr id="8" name="">
+            <a:extLst xmlns:a="http://schemas.openxmlformats.org/drawingml/2006/main">
+              <a:ext uri="{FF2B5EF4-FFF2-40B4-BE49-F238E27FC236}">
+                <a16:creationId xmlns:a16="http://schemas.microsoft.com/office/drawing/2014/main" id="{BF7778C7-A43B-4998-BE55-2FE0B855F79E}"/>
+              </a:ext>
+            </a:extLst>
+          </p:cNvPr>
+          <p:cNvSpPr>
+            <a:spLocks xmlns:a="http://schemas.openxmlformats.org/drawingml/2006/main" noGrp="1"/>
+          </p:cNvSpPr>
+          <p:nvPr/>
+        </p:nvSpPr>
+        <p:spPr>
+          <a:xfrm xmlns:a="http://schemas.openxmlformats.org/drawingml/2006/main">
+            <a:off x="7239000" y="5257800"/>
+            <a:ext cx="3905250" cy="476250"/>
+          </a:xfrm>
+          <a:prstGeom xmlns:a="http://schemas.openxmlformats.org/drawingml/2006/main" prst="roundRect">
+            <a:avLst>
+              <a:gd name="adj" fmla="val 24000"/>
+            </a:avLst>
+          </a:prstGeom>
+          <a:solidFill xmlns:a="http://schemas.openxmlformats.org/drawingml/2006/main">
+            <a:srgbClr val="211B33"/>
+          </a:solidFill>
+          <a:ln xmlns:a="http://schemas.openxmlformats.org/drawingml/2006/main" w="0">
+            <a:noFill/>
+            <a:prstDash val="solid"/>
+          </a:ln>
+        </p:spPr>
+      </p:sp>
+      <p:sp>
+        <p:nvSpPr>
+          <p:cNvPr id="9" name="">
+            <a:extLst xmlns:a="http://schemas.openxmlformats.org/drawingml/2006/main">
+              <a:ext uri="{FF2B5EF4-FFF2-40B4-BE49-F238E27FC236}">
+                <a16:creationId xmlns:a16="http://schemas.microsoft.com/office/drawing/2014/main" id="{8AF75648-2158-4BAE-BB5E-A58AAE0AD40F}"/>
+              </a:ext>
+            </a:extLst>
+          </p:cNvPr>
+          <p:cNvSpPr>
+            <a:spLocks xmlns:a="http://schemas.openxmlformats.org/drawingml/2006/main" noGrp="1"/>
+          </p:cNvSpPr>
+          <p:nvPr/>
+        </p:nvSpPr>
+        <p:spPr>
+          <a:xfrm xmlns:a="http://schemas.openxmlformats.org/drawingml/2006/main">
+            <a:off x="7429500" y="5381625"/>
+            <a:ext cx="3429000" cy="228600"/>
           </a:xfrm>
           <a:prstGeom xmlns:a="http://schemas.openxmlformats.org/drawingml/2006/main" prst="rect">
             <a:avLst/>
@@ -6272,9 +6375,9 @@
           <a:lstStyle xmlns:a="http://schemas.openxmlformats.org/drawingml/2006/main"/>
           <a:p xmlns:a="http://schemas.openxmlformats.org/drawingml/2006/main">
             <a:pPr>
-              <a:defRPr sz="1350">
-                <a:solidFill>
-                  <a:srgbClr val="2C2348"/>
+              <a:defRPr sz="1125" b="1">
+                <a:solidFill>
+                  <a:srgbClr val="FFFFFF"/>
                 </a:solidFill>
                 <a:latin typeface="Microsoft YaHei"/>
                 <a:ea typeface="Microsoft YaHei"/>
@@ -6282,25 +6385,25 @@
               </a:defRPr>
             </a:pPr>
             <a:r>
-              <a:rPr sz="1350">
-                <a:solidFill>
-                  <a:srgbClr val="2C2348"/>
+              <a:rPr sz="1125" b="1">
+                <a:solidFill>
+                  <a:srgbClr val="FFFFFF"/>
                 </a:solidFill>
                 <a:latin typeface="Microsoft YaHei"/>
                 <a:ea typeface="Microsoft YaHei"/>
                 <a:cs typeface="Microsoft YaHei"/>
               </a:rPr>
-              <a:t>WebGL Build 可部署到 Render、Cloudflare Pages 或 GitHub Pages。</a:t>
+              <a:t>WebGL Build：Render / Cloudflare Pages / GitHub Pages</a:t>
             </a:r>
           </a:p>
         </p:txBody>
       </p:sp>
       <p:sp>
         <p:nvSpPr>
-          <p:cNvPr id="7" name="">
-            <a:extLst xmlns:a="http://schemas.openxmlformats.org/drawingml/2006/main">
-              <a:ext uri="{FF2B5EF4-FFF2-40B4-BE49-F238E27FC236}">
-                <a16:creationId xmlns:a16="http://schemas.microsoft.com/office/drawing/2014/main" id="{7668AB5F-ABC4-4068-BBCE-3D245B834BEF}"/>
+          <p:cNvPr id="10" name="">
+            <a:extLst xmlns:a="http://schemas.openxmlformats.org/drawingml/2006/main">
+              <a:ext uri="{FF2B5EF4-FFF2-40B4-BE49-F238E27FC236}">
+                <a16:creationId xmlns:a16="http://schemas.microsoft.com/office/drawing/2014/main" id="{773E7B2A-BA7F-4767-A2C3-01A67C8102D9}"/>
               </a:ext>
             </a:extLst>
           </p:cNvPr>
@@ -6353,10 +6456,10 @@
       </p:sp>
       <p:sp>
         <p:nvSpPr>
-          <p:cNvPr id="8" name="">
-            <a:extLst xmlns:a="http://schemas.openxmlformats.org/drawingml/2006/main">
-              <a:ext uri="{FF2B5EF4-FFF2-40B4-BE49-F238E27FC236}">
-                <a16:creationId xmlns:a16="http://schemas.microsoft.com/office/drawing/2014/main" id="{E6B08CBE-E95E-418F-AC92-E276DB6C26B8}"/>
+          <p:cNvPr id="11" name="">
+            <a:extLst xmlns:a="http://schemas.openxmlformats.org/drawingml/2006/main">
+              <a:ext uri="{FF2B5EF4-FFF2-40B4-BE49-F238E27FC236}">
+                <a16:creationId xmlns:a16="http://schemas.microsoft.com/office/drawing/2014/main" id="{D77B568E-8EF7-4B9D-89A7-80BB164320C2}"/>
               </a:ext>
             </a:extLst>
           </p:cNvPr>
@@ -6410,7 +6513,7 @@
     </p:spTree>
     <p:extLst>
       <p:ext uri="{BB962C8B-B14F-4D97-AF65-F5344CB8AC3E}">
-        <p14:creationId xmlns:p14="http://schemas.microsoft.com/office/powerpoint/2010/main" val="1490891718"/>
+        <p14:creationId xmlns:p14="http://schemas.microsoft.com/office/powerpoint/2010/main" val="1352178607"/>
       </p:ext>
     </p:extLst>
   </p:cSld>

</xml_diff>

<commit_message>
Fix submission deck overlap issues
</commit_message>
<xml_diff>
--- a/Submission/project_deck.pptx
+++ b/Submission/project_deck.pptx
@@ -2,20 +2,20 @@
 <file path=ppt/presentation.xml><?xml version="1.0" encoding="utf-8"?>
 <p:presentation xmlns:p="http://schemas.openxmlformats.org/presentationml/2006/main">
   <p:sldMasterIdLst>
-    <p:sldMasterId xmlns:r="http://schemas.openxmlformats.org/officeDocument/2006/relationships" id="2147483648" r:id="Ra0ea9d9ad5a842b2"/>
+    <p:sldMasterId xmlns:r="http://schemas.openxmlformats.org/officeDocument/2006/relationships" id="2147483648" r:id="R613b6414b3c74570"/>
   </p:sldMasterIdLst>
   <p:notesMasterIdLst>
-    <p:notesMasterId xmlns:r="http://schemas.openxmlformats.org/officeDocument/2006/relationships" r:id="Ra77f2976a27f4d5c"/>
+    <p:notesMasterId xmlns:r="http://schemas.openxmlformats.org/officeDocument/2006/relationships" r:id="R314a2857da034014"/>
   </p:notesMasterIdLst>
   <p:sldIdLst>
-    <p:sldId xmlns:r="http://schemas.openxmlformats.org/officeDocument/2006/relationships" id="256" r:id="R3833e31487f24cca"/>
-    <p:sldId xmlns:r="http://schemas.openxmlformats.org/officeDocument/2006/relationships" id="257" r:id="R9ff554b2b6724e96"/>
-    <p:sldId xmlns:r="http://schemas.openxmlformats.org/officeDocument/2006/relationships" id="258" r:id="R88c8e208d91c4228"/>
-    <p:sldId xmlns:r="http://schemas.openxmlformats.org/officeDocument/2006/relationships" id="259" r:id="R2602fcb8dfc94441"/>
-    <p:sldId xmlns:r="http://schemas.openxmlformats.org/officeDocument/2006/relationships" id="260" r:id="Ra0cd86423aa6444c"/>
-    <p:sldId xmlns:r="http://schemas.openxmlformats.org/officeDocument/2006/relationships" id="261" r:id="Re388f3d4f1b14b24"/>
-    <p:sldId xmlns:r="http://schemas.openxmlformats.org/officeDocument/2006/relationships" id="262" r:id="R51403b895196457b"/>
-    <p:sldId xmlns:r="http://schemas.openxmlformats.org/officeDocument/2006/relationships" id="263" r:id="R08edf79f9cef4158"/>
+    <p:sldId xmlns:r="http://schemas.openxmlformats.org/officeDocument/2006/relationships" id="256" r:id="R6c2477715c014785"/>
+    <p:sldId xmlns:r="http://schemas.openxmlformats.org/officeDocument/2006/relationships" id="257" r:id="Rbd7f003110084bba"/>
+    <p:sldId xmlns:r="http://schemas.openxmlformats.org/officeDocument/2006/relationships" id="258" r:id="R145c82726d144410"/>
+    <p:sldId xmlns:r="http://schemas.openxmlformats.org/officeDocument/2006/relationships" id="259" r:id="Rc56b982d2f704932"/>
+    <p:sldId xmlns:r="http://schemas.openxmlformats.org/officeDocument/2006/relationships" id="260" r:id="R63d7360fd3a44737"/>
+    <p:sldId xmlns:r="http://schemas.openxmlformats.org/officeDocument/2006/relationships" id="261" r:id="Raf600e77034d4fb9"/>
+    <p:sldId xmlns:r="http://schemas.openxmlformats.org/officeDocument/2006/relationships" id="262" r:id="R715054c253aa4cd1"/>
+    <p:sldId xmlns:r="http://schemas.openxmlformats.org/officeDocument/2006/relationships" id="263" r:id="R828668ef39734412"/>
   </p:sldIdLst>
   <p:sldSz cx="12192000" cy="6858000"/>
   <p:notesSz cx="6858000" cy="9144000"/>
@@ -1070,7 +1070,7 @@
   </p:cSld>
   <p:clrMap bg1="lt1" tx1="dk1" bg2="lt2" tx2="dk2" accent1="accent1" accent2="accent2" accent3="accent3" accent4="accent4" accent5="accent5" accent6="accent6" hlink="hlink" folHlink="folHlink"/>
   <p:sldLayoutIdLst>
-    <p:sldLayoutId xmlns:r="http://schemas.openxmlformats.org/officeDocument/2006/relationships" id="2147483649" r:id="R0cd866dcbc6346e5"/>
+    <p:sldLayoutId xmlns:r="http://schemas.openxmlformats.org/officeDocument/2006/relationships" id="2147483649" r:id="Ra10a40145b294676"/>
   </p:sldLayoutIdLst>
   <p:txStyles>
     <p:titleStyle>
@@ -1625,7 +1625,7 @@
           <p:nvPr/>
         </p:nvPicPr>
         <p:blipFill>
-          <a:blip xmlns:r="http://schemas.openxmlformats.org/officeDocument/2006/relationships" xmlns:a="http://schemas.openxmlformats.org/drawingml/2006/main" r:embed="R95c3e51902b9427d"/>
+          <a:blip xmlns:r="http://schemas.openxmlformats.org/officeDocument/2006/relationships" xmlns:a="http://schemas.openxmlformats.org/drawingml/2006/main" r:embed="R8a4d916a8fd74173"/>
           <a:srcRect xmlns:a="http://schemas.openxmlformats.org/drawingml/2006/main" l="0" t="0" r="0" b="0"/>
           <a:stretch xmlns:a="http://schemas.openxmlformats.org/drawingml/2006/main">
             <a:fillRect l="0" t="0" r="0" b="0"/>
@@ -1646,7 +1646,7 @@
           <p:cNvPr id="2" name="">
             <a:extLst xmlns:a="http://schemas.openxmlformats.org/drawingml/2006/main">
               <a:ext uri="{FF2B5EF4-FFF2-40B4-BE49-F238E27FC236}">
-                <a16:creationId xmlns:a16="http://schemas.microsoft.com/office/drawing/2014/main" id="{598ED3CF-906D-4ABB-90AA-C476B8573A4A}"/>
+                <a16:creationId xmlns:a16="http://schemas.microsoft.com/office/drawing/2014/main" id="{1C94AF7B-3E29-4069-B20C-024ACBD5C0B2}"/>
               </a:ext>
             </a:extLst>
           </p:cNvPr>
@@ -1677,7 +1677,7 @@
           <p:cNvPr id="3" name="">
             <a:extLst xmlns:a="http://schemas.openxmlformats.org/drawingml/2006/main">
               <a:ext uri="{FF2B5EF4-FFF2-40B4-BE49-F238E27FC236}">
-                <a16:creationId xmlns:a16="http://schemas.microsoft.com/office/drawing/2014/main" id="{CBDB8529-8F31-4355-BC6D-3416017D772D}"/>
+                <a16:creationId xmlns:a16="http://schemas.microsoft.com/office/drawing/2014/main" id="{74AB4EBA-F05F-4BD2-8009-DCAA020D5752}"/>
               </a:ext>
             </a:extLst>
           </p:cNvPr>
@@ -1733,7 +1733,7 @@
           <p:cNvPr id="4" name="">
             <a:extLst xmlns:a="http://schemas.openxmlformats.org/drawingml/2006/main">
               <a:ext uri="{FF2B5EF4-FFF2-40B4-BE49-F238E27FC236}">
-                <a16:creationId xmlns:a16="http://schemas.microsoft.com/office/drawing/2014/main" id="{818E9F08-EA8C-4058-B4C1-6D21392C3A97}"/>
+                <a16:creationId xmlns:a16="http://schemas.microsoft.com/office/drawing/2014/main" id="{58A7AFD8-02CA-4057-B757-0F61C3F44979}"/>
               </a:ext>
             </a:extLst>
           </p:cNvPr>
@@ -1812,7 +1812,7 @@
           <p:cNvPr id="5" name="">
             <a:extLst xmlns:a="http://schemas.openxmlformats.org/drawingml/2006/main">
               <a:ext uri="{FF2B5EF4-FFF2-40B4-BE49-F238E27FC236}">
-                <a16:creationId xmlns:a16="http://schemas.microsoft.com/office/drawing/2014/main" id="{34EFE48E-91C6-4C23-BA2F-24A606D3F477}"/>
+                <a16:creationId xmlns:a16="http://schemas.microsoft.com/office/drawing/2014/main" id="{AD84C8AB-F114-477F-B5DD-6BAD18EE4E12}"/>
               </a:ext>
             </a:extLst>
           </p:cNvPr>
@@ -1868,7 +1868,7 @@
           <p:cNvPr id="6" name="">
             <a:extLst xmlns:a="http://schemas.openxmlformats.org/drawingml/2006/main">
               <a:ext uri="{FF2B5EF4-FFF2-40B4-BE49-F238E27FC236}">
-                <a16:creationId xmlns:a16="http://schemas.microsoft.com/office/drawing/2014/main" id="{C842118E-857D-4D66-8B26-B23E89D86736}"/>
+                <a16:creationId xmlns:a16="http://schemas.microsoft.com/office/drawing/2014/main" id="{5465BFC9-F955-43E7-9997-62E3CD6636F2}"/>
               </a:ext>
             </a:extLst>
           </p:cNvPr>
@@ -1924,7 +1924,7 @@
           <p:cNvPr id="7" name="">
             <a:extLst xmlns:a="http://schemas.openxmlformats.org/drawingml/2006/main">
               <a:ext uri="{FF2B5EF4-FFF2-40B4-BE49-F238E27FC236}">
-                <a16:creationId xmlns:a16="http://schemas.microsoft.com/office/drawing/2014/main" id="{B61606F9-4BFF-441E-A030-1EDE860E5A7C}"/>
+                <a16:creationId xmlns:a16="http://schemas.microsoft.com/office/drawing/2014/main" id="{5018AC46-DA3B-48ED-ACA4-600708A415EE}"/>
               </a:ext>
             </a:extLst>
           </p:cNvPr>
@@ -1980,7 +1980,7 @@
           <p:cNvPr id="8" name="">
             <a:extLst xmlns:a="http://schemas.openxmlformats.org/drawingml/2006/main">
               <a:ext uri="{FF2B5EF4-FFF2-40B4-BE49-F238E27FC236}">
-                <a16:creationId xmlns:a16="http://schemas.microsoft.com/office/drawing/2014/main" id="{BED0B4A5-3F46-4DFD-A906-6B0503C16A20}"/>
+                <a16:creationId xmlns:a16="http://schemas.microsoft.com/office/drawing/2014/main" id="{30C225DE-E866-477E-BE1D-721B2200E207}"/>
               </a:ext>
             </a:extLst>
           </p:cNvPr>
@@ -2034,7 +2034,7 @@
     </p:spTree>
     <p:extLst>
       <p:ext uri="{BB962C8B-B14F-4D97-AF65-F5344CB8AC3E}">
-        <p14:creationId xmlns:p14="http://schemas.microsoft.com/office/powerpoint/2010/main" val="1963512742"/>
+        <p14:creationId xmlns:p14="http://schemas.microsoft.com/office/powerpoint/2010/main" val="148495535"/>
       </p:ext>
     </p:extLst>
   </p:cSld>
@@ -2065,7 +2065,7 @@
           <p:cNvPr id="1" name="">
             <a:extLst xmlns:a="http://schemas.openxmlformats.org/drawingml/2006/main">
               <a:ext uri="{FF2B5EF4-FFF2-40B4-BE49-F238E27FC236}">
-                <a16:creationId xmlns:a16="http://schemas.microsoft.com/office/drawing/2014/main" id="{1EEC19ED-74B5-4A13-B955-DB7102D27F54}"/>
+                <a16:creationId xmlns:a16="http://schemas.microsoft.com/office/drawing/2014/main" id="{B5887435-D742-4DDD-AA55-BB8BE705D399}"/>
               </a:ext>
             </a:extLst>
           </p:cNvPr>
@@ -2121,7 +2121,7 @@
           <p:cNvPr id="2" name="">
             <a:extLst xmlns:a="http://schemas.openxmlformats.org/drawingml/2006/main">
               <a:ext uri="{FF2B5EF4-FFF2-40B4-BE49-F238E27FC236}">
-                <a16:creationId xmlns:a16="http://schemas.microsoft.com/office/drawing/2014/main" id="{299A9E03-20E2-46F4-8523-C7FED423EBC4}"/>
+                <a16:creationId xmlns:a16="http://schemas.microsoft.com/office/drawing/2014/main" id="{B8D5C7EF-F930-4DF9-9CDE-A2C10A822BC2}"/>
               </a:ext>
             </a:extLst>
           </p:cNvPr>
@@ -2174,15 +2174,15 @@
       </p:sp>
       <p:pic>
         <p:nvPicPr>
-          <p:cNvPr id="22" name=""/>
+          <p:cNvPr id="21" name=""/>
           <p:cNvPicPr>
             <a:picLocks xmlns:a="http://schemas.openxmlformats.org/drawingml/2006/main" noChangeAspect="1"/>
           </p:cNvPicPr>
           <p:nvPr/>
         </p:nvPicPr>
         <p:blipFill>
-          <a:blip xmlns:r="http://schemas.openxmlformats.org/officeDocument/2006/relationships" xmlns:a="http://schemas.openxmlformats.org/drawingml/2006/main" r:embed="Ra22f403ef029433f"/>
-          <a:srcRect xmlns:a="http://schemas.openxmlformats.org/drawingml/2006/main" l="3437" t="0" r="3437" b="0"/>
+          <a:blip xmlns:r="http://schemas.openxmlformats.org/officeDocument/2006/relationships" xmlns:a="http://schemas.openxmlformats.org/drawingml/2006/main" r:embed="R12a7de920e474284"/>
+          <a:srcRect xmlns:a="http://schemas.openxmlformats.org/drawingml/2006/main" l="7019" t="0" r="7019" b="0"/>
           <a:stretch xmlns:a="http://schemas.openxmlformats.org/drawingml/2006/main">
             <a:fillRect l="0" t="0" r="0" b="0"/>
           </a:stretch>
@@ -2190,44 +2190,19 @@
         <p:spPr>
           <a:xfrm xmlns:a="http://schemas.openxmlformats.org/drawingml/2006/main">
             <a:off x="552450" y="1638300"/>
-            <a:ext cx="5676900" cy="3429000"/>
+            <a:ext cx="5676900" cy="3714750"/>
           </a:xfrm>
           <a:prstGeom xmlns:a="http://schemas.openxmlformats.org/drawingml/2006/main" prst="rect">
             <a:avLst/>
           </a:prstGeom>
         </p:spPr>
       </p:pic>
-      <p:pic>
-        <p:nvPicPr>
-          <p:cNvPr id="23" name=""/>
-          <p:cNvPicPr>
-            <a:picLocks xmlns:a="http://schemas.openxmlformats.org/drawingml/2006/main" noChangeAspect="1"/>
-          </p:cNvPicPr>
-          <p:nvPr/>
-        </p:nvPicPr>
-        <p:blipFill>
-          <a:blip xmlns:r="http://schemas.openxmlformats.org/officeDocument/2006/relationships" xmlns:a="http://schemas.openxmlformats.org/drawingml/2006/main" r:embed="R59a966f8e22e4215"/>
-          <a:srcRect xmlns:a="http://schemas.openxmlformats.org/drawingml/2006/main" l="0" t="11331" r="0" b="11331"/>
-          <a:stretch xmlns:a="http://schemas.openxmlformats.org/drawingml/2006/main">
-            <a:fillRect l="0" t="0" r="0" b="0"/>
-          </a:stretch>
-        </p:blipFill>
-        <p:spPr>
-          <a:xfrm xmlns:a="http://schemas.openxmlformats.org/drawingml/2006/main">
-            <a:off x="781050" y="4324350"/>
-            <a:ext cx="3371850" cy="1466850"/>
-          </a:xfrm>
-          <a:prstGeom xmlns:a="http://schemas.openxmlformats.org/drawingml/2006/main" prst="rect">
-            <a:avLst/>
-          </a:prstGeom>
-        </p:spPr>
-      </p:pic>
-      <p:sp>
-        <p:nvSpPr>
-          <p:cNvPr id="5" name="">
-            <a:extLst xmlns:a="http://schemas.openxmlformats.org/drawingml/2006/main">
-              <a:ext uri="{FF2B5EF4-FFF2-40B4-BE49-F238E27FC236}">
-                <a16:creationId xmlns:a16="http://schemas.microsoft.com/office/drawing/2014/main" id="{2E504F70-82B3-4CAB-907C-87AC6ECAFE07}"/>
+      <p:sp>
+        <p:nvSpPr>
+          <p:cNvPr id="4" name="">
+            <a:extLst xmlns:a="http://schemas.openxmlformats.org/drawingml/2006/main">
+              <a:ext uri="{FF2B5EF4-FFF2-40B4-BE49-F238E27FC236}">
+                <a16:creationId xmlns:a16="http://schemas.microsoft.com/office/drawing/2014/main" id="{4F0E298D-DF42-4DFB-88EC-89534B8E9903}"/>
               </a:ext>
             </a:extLst>
           </p:cNvPr>
@@ -2239,11 +2214,11 @@
         <p:spPr>
           <a:xfrm xmlns:a="http://schemas.openxmlformats.org/drawingml/2006/main">
             <a:off x="6667500" y="1638300"/>
-            <a:ext cx="4324350" cy="4000500"/>
+            <a:ext cx="4324350" cy="4191000"/>
           </a:xfrm>
           <a:prstGeom xmlns:a="http://schemas.openxmlformats.org/drawingml/2006/main" prst="roundRect">
             <a:avLst>
-              <a:gd name="adj" fmla="val 3810"/>
+              <a:gd name="adj" fmla="val 3636"/>
             </a:avLst>
           </a:prstGeom>
           <a:solidFill xmlns:a="http://schemas.openxmlformats.org/drawingml/2006/main">
@@ -2259,26 +2234,26 @@
       </p:sp>
       <p:sp>
         <p:nvSpPr>
-          <p:cNvPr id="6" name="">
-            <a:extLst xmlns:a="http://schemas.openxmlformats.org/drawingml/2006/main">
-              <a:ext uri="{FF2B5EF4-FFF2-40B4-BE49-F238E27FC236}">
-                <a16:creationId xmlns:a16="http://schemas.microsoft.com/office/drawing/2014/main" id="{F7B03512-EDA4-4C64-9110-50A759964381}"/>
-              </a:ext>
-            </a:extLst>
-          </p:cNvPr>
-          <p:cNvSpPr>
-            <a:spLocks xmlns:a="http://schemas.openxmlformats.org/drawingml/2006/main" noGrp="1"/>
-          </p:cNvSpPr>
-          <p:nvPr/>
-        </p:nvSpPr>
-        <p:spPr>
-          <a:xfrm xmlns:a="http://schemas.openxmlformats.org/drawingml/2006/main">
-            <a:off x="7239000" y="1943100"/>
-            <a:ext cx="3162300" cy="1257300"/>
+          <p:cNvPr id="5" name="">
+            <a:extLst xmlns:a="http://schemas.openxmlformats.org/drawingml/2006/main">
+              <a:ext uri="{FF2B5EF4-FFF2-40B4-BE49-F238E27FC236}">
+                <a16:creationId xmlns:a16="http://schemas.microsoft.com/office/drawing/2014/main" id="{D35911E7-BF6E-4367-B559-9B94A8ED4067}"/>
+              </a:ext>
+            </a:extLst>
+          </p:cNvPr>
+          <p:cNvSpPr>
+            <a:spLocks xmlns:a="http://schemas.openxmlformats.org/drawingml/2006/main" noGrp="1"/>
+          </p:cNvSpPr>
+          <p:nvPr/>
+        </p:nvSpPr>
+        <p:spPr>
+          <a:xfrm xmlns:a="http://schemas.openxmlformats.org/drawingml/2006/main">
+            <a:off x="7029450" y="1924050"/>
+            <a:ext cx="3619500" cy="1066800"/>
           </a:xfrm>
           <a:prstGeom xmlns:a="http://schemas.openxmlformats.org/drawingml/2006/main" prst="roundRect">
             <a:avLst>
-              <a:gd name="adj" fmla="val 12121"/>
+              <a:gd name="adj" fmla="val 14286"/>
             </a:avLst>
           </a:prstGeom>
           <a:solidFill xmlns:a="http://schemas.openxmlformats.org/drawingml/2006/main">
@@ -2294,22 +2269,22 @@
       </p:sp>
       <p:sp>
         <p:nvSpPr>
-          <p:cNvPr id="7" name="">
-            <a:extLst xmlns:a="http://schemas.openxmlformats.org/drawingml/2006/main">
-              <a:ext uri="{FF2B5EF4-FFF2-40B4-BE49-F238E27FC236}">
-                <a16:creationId xmlns:a16="http://schemas.microsoft.com/office/drawing/2014/main" id="{73F7B5AA-071A-485E-BB65-E8920C95EDD7}"/>
-              </a:ext>
-            </a:extLst>
-          </p:cNvPr>
-          <p:cNvSpPr>
-            <a:spLocks xmlns:a="http://schemas.openxmlformats.org/drawingml/2006/main" noGrp="1"/>
-          </p:cNvSpPr>
-          <p:nvPr/>
-        </p:nvSpPr>
-        <p:spPr>
-          <a:xfrm xmlns:a="http://schemas.openxmlformats.org/drawingml/2006/main">
-            <a:off x="7467600" y="2171700"/>
-            <a:ext cx="133350" cy="133350"/>
+          <p:cNvPr id="6" name="">
+            <a:extLst xmlns:a="http://schemas.openxmlformats.org/drawingml/2006/main">
+              <a:ext uri="{FF2B5EF4-FFF2-40B4-BE49-F238E27FC236}">
+                <a16:creationId xmlns:a16="http://schemas.microsoft.com/office/drawing/2014/main" id="{540DDFCB-2B49-436A-8110-0D3FAB2E6A40}"/>
+              </a:ext>
+            </a:extLst>
+          </p:cNvPr>
+          <p:cNvSpPr>
+            <a:spLocks xmlns:a="http://schemas.openxmlformats.org/drawingml/2006/main" noGrp="1"/>
+          </p:cNvSpPr>
+          <p:nvPr/>
+        </p:nvSpPr>
+        <p:spPr>
+          <a:xfrm xmlns:a="http://schemas.openxmlformats.org/drawingml/2006/main">
+            <a:off x="7239000" y="2133600"/>
+            <a:ext cx="114300" cy="114300"/>
           </a:xfrm>
           <a:prstGeom xmlns:a="http://schemas.openxmlformats.org/drawingml/2006/main" prst="rect">
             <a:avLst/>
@@ -2325,22 +2300,22 @@
       </p:sp>
       <p:sp>
         <p:nvSpPr>
-          <p:cNvPr id="8" name="">
-            <a:extLst xmlns:a="http://schemas.openxmlformats.org/drawingml/2006/main">
-              <a:ext uri="{FF2B5EF4-FFF2-40B4-BE49-F238E27FC236}">
-                <a16:creationId xmlns:a16="http://schemas.microsoft.com/office/drawing/2014/main" id="{E8306D1D-D9E8-4016-8E82-6FD2302FA10A}"/>
-              </a:ext>
-            </a:extLst>
-          </p:cNvPr>
-          <p:cNvSpPr>
-            <a:spLocks xmlns:a="http://schemas.openxmlformats.org/drawingml/2006/main" noGrp="1"/>
-          </p:cNvSpPr>
-          <p:nvPr/>
-        </p:nvSpPr>
-        <p:spPr>
-          <a:xfrm xmlns:a="http://schemas.openxmlformats.org/drawingml/2006/main">
-            <a:off x="7715250" y="2085975"/>
-            <a:ext cx="2190750" cy="323850"/>
+          <p:cNvPr id="7" name="">
+            <a:extLst xmlns:a="http://schemas.openxmlformats.org/drawingml/2006/main">
+              <a:ext uri="{FF2B5EF4-FFF2-40B4-BE49-F238E27FC236}">
+                <a16:creationId xmlns:a16="http://schemas.microsoft.com/office/drawing/2014/main" id="{14D84A08-8398-499A-A0D1-030247EC5DD6}"/>
+              </a:ext>
+            </a:extLst>
+          </p:cNvPr>
+          <p:cNvSpPr>
+            <a:spLocks xmlns:a="http://schemas.openxmlformats.org/drawingml/2006/main" noGrp="1"/>
+          </p:cNvSpPr>
+          <p:nvPr/>
+        </p:nvSpPr>
+        <p:spPr>
+          <a:xfrm xmlns:a="http://schemas.openxmlformats.org/drawingml/2006/main">
+            <a:off x="7467600" y="2057400"/>
+            <a:ext cx="2476500" cy="285750"/>
           </a:xfrm>
           <a:prstGeom xmlns:a="http://schemas.openxmlformats.org/drawingml/2006/main" prst="rect">
             <a:avLst/>
@@ -2356,7 +2331,7 @@
           <a:lstStyle xmlns:a="http://schemas.openxmlformats.org/drawingml/2006/main"/>
           <a:p xmlns:a="http://schemas.openxmlformats.org/drawingml/2006/main">
             <a:pPr>
-              <a:defRPr sz="1800" b="1">
+              <a:defRPr sz="1650" b="1">
                 <a:solidFill>
                   <a:srgbClr val="634893"/>
                 </a:solidFill>
@@ -2366,7 +2341,7 @@
               </a:defRPr>
             </a:pPr>
             <a:r>
-              <a:rPr sz="1800" b="1">
+              <a:rPr sz="1650" b="1">
                 <a:solidFill>
                   <a:srgbClr val="634893"/>
                 </a:solidFill>
@@ -2381,22 +2356,22 @@
       </p:sp>
       <p:sp>
         <p:nvSpPr>
-          <p:cNvPr id="9" name="">
-            <a:extLst xmlns:a="http://schemas.openxmlformats.org/drawingml/2006/main">
-              <a:ext uri="{FF2B5EF4-FFF2-40B4-BE49-F238E27FC236}">
-                <a16:creationId xmlns:a16="http://schemas.microsoft.com/office/drawing/2014/main" id="{5782D722-20D7-4522-BEC5-B8B05E9401CA}"/>
-              </a:ext>
-            </a:extLst>
-          </p:cNvPr>
-          <p:cNvSpPr>
-            <a:spLocks xmlns:a="http://schemas.openxmlformats.org/drawingml/2006/main" noGrp="1"/>
-          </p:cNvSpPr>
-          <p:nvPr/>
-        </p:nvSpPr>
-        <p:spPr>
-          <a:xfrm xmlns:a="http://schemas.openxmlformats.org/drawingml/2006/main">
-            <a:off x="7505700" y="2495550"/>
-            <a:ext cx="2628900" cy="514350"/>
+          <p:cNvPr id="8" name="">
+            <a:extLst xmlns:a="http://schemas.openxmlformats.org/drawingml/2006/main">
+              <a:ext uri="{FF2B5EF4-FFF2-40B4-BE49-F238E27FC236}">
+                <a16:creationId xmlns:a16="http://schemas.microsoft.com/office/drawing/2014/main" id="{5ABB1C58-7AC9-4189-88C2-7DCEC5EB18FD}"/>
+              </a:ext>
+            </a:extLst>
+          </p:cNvPr>
+          <p:cNvSpPr>
+            <a:spLocks xmlns:a="http://schemas.openxmlformats.org/drawingml/2006/main" noGrp="1"/>
+          </p:cNvSpPr>
+          <p:nvPr/>
+        </p:nvSpPr>
+        <p:spPr>
+          <a:xfrm xmlns:a="http://schemas.openxmlformats.org/drawingml/2006/main">
+            <a:off x="7277100" y="2419350"/>
+            <a:ext cx="3048000" cy="419100"/>
           </a:xfrm>
           <a:prstGeom xmlns:a="http://schemas.openxmlformats.org/drawingml/2006/main" prst="rect">
             <a:avLst/>
@@ -2412,7 +2387,7 @@
           <a:lstStyle xmlns:a="http://schemas.openxmlformats.org/drawingml/2006/main"/>
           <a:p xmlns:a="http://schemas.openxmlformats.org/drawingml/2006/main">
             <a:pPr>
-              <a:defRPr sz="1350">
+              <a:defRPr sz="1125">
                 <a:solidFill>
                   <a:srgbClr val="695F84"/>
                 </a:solidFill>
@@ -2422,7 +2397,7 @@
               </a:defRPr>
             </a:pPr>
             <a:r>
-              <a:rPr sz="1350">
+              <a:rPr sz="1125">
                 <a:solidFill>
                   <a:srgbClr val="695F84"/>
                 </a:solidFill>
@@ -2437,26 +2412,26 @@
       </p:sp>
       <p:sp>
         <p:nvSpPr>
-          <p:cNvPr id="10" name="">
-            <a:extLst xmlns:a="http://schemas.openxmlformats.org/drawingml/2006/main">
-              <a:ext uri="{FF2B5EF4-FFF2-40B4-BE49-F238E27FC236}">
-                <a16:creationId xmlns:a16="http://schemas.microsoft.com/office/drawing/2014/main" id="{A0F180E0-9DD7-4E96-978E-E675F2B16DCF}"/>
-              </a:ext>
-            </a:extLst>
-          </p:cNvPr>
-          <p:cNvSpPr>
-            <a:spLocks xmlns:a="http://schemas.openxmlformats.org/drawingml/2006/main" noGrp="1"/>
-          </p:cNvSpPr>
-          <p:nvPr/>
-        </p:nvSpPr>
-        <p:spPr>
-          <a:xfrm xmlns:a="http://schemas.openxmlformats.org/drawingml/2006/main">
-            <a:off x="7239000" y="3181350"/>
-            <a:ext cx="3162300" cy="1257300"/>
+          <p:cNvPr id="9" name="">
+            <a:extLst xmlns:a="http://schemas.openxmlformats.org/drawingml/2006/main">
+              <a:ext uri="{FF2B5EF4-FFF2-40B4-BE49-F238E27FC236}">
+                <a16:creationId xmlns:a16="http://schemas.microsoft.com/office/drawing/2014/main" id="{E0DDDD5A-0E0D-464C-8DC9-6124173B2A4D}"/>
+              </a:ext>
+            </a:extLst>
+          </p:cNvPr>
+          <p:cNvSpPr>
+            <a:spLocks xmlns:a="http://schemas.openxmlformats.org/drawingml/2006/main" noGrp="1"/>
+          </p:cNvSpPr>
+          <p:nvPr/>
+        </p:nvSpPr>
+        <p:spPr>
+          <a:xfrm xmlns:a="http://schemas.openxmlformats.org/drawingml/2006/main">
+            <a:off x="7029450" y="3257550"/>
+            <a:ext cx="3619500" cy="1066800"/>
           </a:xfrm>
           <a:prstGeom xmlns:a="http://schemas.openxmlformats.org/drawingml/2006/main" prst="roundRect">
             <a:avLst>
-              <a:gd name="adj" fmla="val 12121"/>
+              <a:gd name="adj" fmla="val 14286"/>
             </a:avLst>
           </a:prstGeom>
           <a:solidFill xmlns:a="http://schemas.openxmlformats.org/drawingml/2006/main">
@@ -2472,22 +2447,22 @@
       </p:sp>
       <p:sp>
         <p:nvSpPr>
-          <p:cNvPr id="11" name="">
-            <a:extLst xmlns:a="http://schemas.openxmlformats.org/drawingml/2006/main">
-              <a:ext uri="{FF2B5EF4-FFF2-40B4-BE49-F238E27FC236}">
-                <a16:creationId xmlns:a16="http://schemas.microsoft.com/office/drawing/2014/main" id="{D4F461CA-0F12-4B89-BFD5-D3EB84F792BA}"/>
-              </a:ext>
-            </a:extLst>
-          </p:cNvPr>
-          <p:cNvSpPr>
-            <a:spLocks xmlns:a="http://schemas.openxmlformats.org/drawingml/2006/main" noGrp="1"/>
-          </p:cNvSpPr>
-          <p:nvPr/>
-        </p:nvSpPr>
-        <p:spPr>
-          <a:xfrm xmlns:a="http://schemas.openxmlformats.org/drawingml/2006/main">
-            <a:off x="7467600" y="3409950"/>
-            <a:ext cx="133350" cy="133350"/>
+          <p:cNvPr id="10" name="">
+            <a:extLst xmlns:a="http://schemas.openxmlformats.org/drawingml/2006/main">
+              <a:ext uri="{FF2B5EF4-FFF2-40B4-BE49-F238E27FC236}">
+                <a16:creationId xmlns:a16="http://schemas.microsoft.com/office/drawing/2014/main" id="{463FACF9-D031-4AA4-909E-31AD2EE2D9B4}"/>
+              </a:ext>
+            </a:extLst>
+          </p:cNvPr>
+          <p:cNvSpPr>
+            <a:spLocks xmlns:a="http://schemas.openxmlformats.org/drawingml/2006/main" noGrp="1"/>
+          </p:cNvSpPr>
+          <p:nvPr/>
+        </p:nvSpPr>
+        <p:spPr>
+          <a:xfrm xmlns:a="http://schemas.openxmlformats.org/drawingml/2006/main">
+            <a:off x="7239000" y="3467100"/>
+            <a:ext cx="114300" cy="114300"/>
           </a:xfrm>
           <a:prstGeom xmlns:a="http://schemas.openxmlformats.org/drawingml/2006/main" prst="rect">
             <a:avLst/>
@@ -2503,22 +2478,22 @@
       </p:sp>
       <p:sp>
         <p:nvSpPr>
-          <p:cNvPr id="12" name="">
-            <a:extLst xmlns:a="http://schemas.openxmlformats.org/drawingml/2006/main">
-              <a:ext uri="{FF2B5EF4-FFF2-40B4-BE49-F238E27FC236}">
-                <a16:creationId xmlns:a16="http://schemas.microsoft.com/office/drawing/2014/main" id="{DED9B956-1849-49E2-A8CA-E26BE10EC346}"/>
-              </a:ext>
-            </a:extLst>
-          </p:cNvPr>
-          <p:cNvSpPr>
-            <a:spLocks xmlns:a="http://schemas.openxmlformats.org/drawingml/2006/main" noGrp="1"/>
-          </p:cNvSpPr>
-          <p:nvPr/>
-        </p:nvSpPr>
-        <p:spPr>
-          <a:xfrm xmlns:a="http://schemas.openxmlformats.org/drawingml/2006/main">
-            <a:off x="7715250" y="3324225"/>
-            <a:ext cx="2190750" cy="323850"/>
+          <p:cNvPr id="11" name="">
+            <a:extLst xmlns:a="http://schemas.openxmlformats.org/drawingml/2006/main">
+              <a:ext uri="{FF2B5EF4-FFF2-40B4-BE49-F238E27FC236}">
+                <a16:creationId xmlns:a16="http://schemas.microsoft.com/office/drawing/2014/main" id="{E10A74EF-02B5-4E7A-97E4-638B4127027E}"/>
+              </a:ext>
+            </a:extLst>
+          </p:cNvPr>
+          <p:cNvSpPr>
+            <a:spLocks xmlns:a="http://schemas.openxmlformats.org/drawingml/2006/main" noGrp="1"/>
+          </p:cNvSpPr>
+          <p:nvPr/>
+        </p:nvSpPr>
+        <p:spPr>
+          <a:xfrm xmlns:a="http://schemas.openxmlformats.org/drawingml/2006/main">
+            <a:off x="7467600" y="3390900"/>
+            <a:ext cx="2476500" cy="285750"/>
           </a:xfrm>
           <a:prstGeom xmlns:a="http://schemas.openxmlformats.org/drawingml/2006/main" prst="rect">
             <a:avLst/>
@@ -2534,7 +2509,7 @@
           <a:lstStyle xmlns:a="http://schemas.openxmlformats.org/drawingml/2006/main"/>
           <a:p xmlns:a="http://schemas.openxmlformats.org/drawingml/2006/main">
             <a:pPr>
-              <a:defRPr sz="1800" b="1">
+              <a:defRPr sz="1650" b="1">
                 <a:solidFill>
                   <a:srgbClr val="634893"/>
                 </a:solidFill>
@@ -2544,7 +2519,7 @@
               </a:defRPr>
             </a:pPr>
             <a:r>
-              <a:rPr sz="1800" b="1">
+              <a:rPr sz="1650" b="1">
                 <a:solidFill>
                   <a:srgbClr val="634893"/>
                 </a:solidFill>
@@ -2559,22 +2534,22 @@
       </p:sp>
       <p:sp>
         <p:nvSpPr>
-          <p:cNvPr id="13" name="">
-            <a:extLst xmlns:a="http://schemas.openxmlformats.org/drawingml/2006/main">
-              <a:ext uri="{FF2B5EF4-FFF2-40B4-BE49-F238E27FC236}">
-                <a16:creationId xmlns:a16="http://schemas.microsoft.com/office/drawing/2014/main" id="{B927BD8A-2CDD-4487-A66A-6493EA5EEA30}"/>
-              </a:ext>
-            </a:extLst>
-          </p:cNvPr>
-          <p:cNvSpPr>
-            <a:spLocks xmlns:a="http://schemas.openxmlformats.org/drawingml/2006/main" noGrp="1"/>
-          </p:cNvSpPr>
-          <p:nvPr/>
-        </p:nvSpPr>
-        <p:spPr>
-          <a:xfrm xmlns:a="http://schemas.openxmlformats.org/drawingml/2006/main">
-            <a:off x="7505700" y="3733800"/>
-            <a:ext cx="2628900" cy="514350"/>
+          <p:cNvPr id="12" name="">
+            <a:extLst xmlns:a="http://schemas.openxmlformats.org/drawingml/2006/main">
+              <a:ext uri="{FF2B5EF4-FFF2-40B4-BE49-F238E27FC236}">
+                <a16:creationId xmlns:a16="http://schemas.microsoft.com/office/drawing/2014/main" id="{2A9D2863-62CE-4660-A641-8ECC5C37262C}"/>
+              </a:ext>
+            </a:extLst>
+          </p:cNvPr>
+          <p:cNvSpPr>
+            <a:spLocks xmlns:a="http://schemas.openxmlformats.org/drawingml/2006/main" noGrp="1"/>
+          </p:cNvSpPr>
+          <p:nvPr/>
+        </p:nvSpPr>
+        <p:spPr>
+          <a:xfrm xmlns:a="http://schemas.openxmlformats.org/drawingml/2006/main">
+            <a:off x="7277100" y="3752850"/>
+            <a:ext cx="3048000" cy="419100"/>
           </a:xfrm>
           <a:prstGeom xmlns:a="http://schemas.openxmlformats.org/drawingml/2006/main" prst="rect">
             <a:avLst/>
@@ -2590,7 +2565,7 @@
           <a:lstStyle xmlns:a="http://schemas.openxmlformats.org/drawingml/2006/main"/>
           <a:p xmlns:a="http://schemas.openxmlformats.org/drawingml/2006/main">
             <a:pPr>
-              <a:defRPr sz="1350">
+              <a:defRPr sz="1125">
                 <a:solidFill>
                   <a:srgbClr val="695F84"/>
                 </a:solidFill>
@@ -2600,7 +2575,7 @@
               </a:defRPr>
             </a:pPr>
             <a:r>
-              <a:rPr sz="1350">
+              <a:rPr sz="1125">
                 <a:solidFill>
                   <a:srgbClr val="695F84"/>
                 </a:solidFill>
@@ -2615,26 +2590,26 @@
       </p:sp>
       <p:sp>
         <p:nvSpPr>
-          <p:cNvPr id="14" name="">
-            <a:extLst xmlns:a="http://schemas.openxmlformats.org/drawingml/2006/main">
-              <a:ext uri="{FF2B5EF4-FFF2-40B4-BE49-F238E27FC236}">
-                <a16:creationId xmlns:a16="http://schemas.microsoft.com/office/drawing/2014/main" id="{7E4973B7-FB60-4447-AE3C-3D46349E6C83}"/>
-              </a:ext>
-            </a:extLst>
-          </p:cNvPr>
-          <p:cNvSpPr>
-            <a:spLocks xmlns:a="http://schemas.openxmlformats.org/drawingml/2006/main" noGrp="1"/>
-          </p:cNvSpPr>
-          <p:nvPr/>
-        </p:nvSpPr>
-        <p:spPr>
-          <a:xfrm xmlns:a="http://schemas.openxmlformats.org/drawingml/2006/main">
-            <a:off x="7239000" y="4419600"/>
-            <a:ext cx="3162300" cy="1257300"/>
+          <p:cNvPr id="13" name="">
+            <a:extLst xmlns:a="http://schemas.openxmlformats.org/drawingml/2006/main">
+              <a:ext uri="{FF2B5EF4-FFF2-40B4-BE49-F238E27FC236}">
+                <a16:creationId xmlns:a16="http://schemas.microsoft.com/office/drawing/2014/main" id="{8BE4BBB1-E87A-400D-B3D0-64F6FB0CE679}"/>
+              </a:ext>
+            </a:extLst>
+          </p:cNvPr>
+          <p:cNvSpPr>
+            <a:spLocks xmlns:a="http://schemas.openxmlformats.org/drawingml/2006/main" noGrp="1"/>
+          </p:cNvSpPr>
+          <p:nvPr/>
+        </p:nvSpPr>
+        <p:spPr>
+          <a:xfrm xmlns:a="http://schemas.openxmlformats.org/drawingml/2006/main">
+            <a:off x="7029450" y="4591050"/>
+            <a:ext cx="3619500" cy="1066800"/>
           </a:xfrm>
           <a:prstGeom xmlns:a="http://schemas.openxmlformats.org/drawingml/2006/main" prst="roundRect">
             <a:avLst>
-              <a:gd name="adj" fmla="val 12121"/>
+              <a:gd name="adj" fmla="val 14286"/>
             </a:avLst>
           </a:prstGeom>
           <a:solidFill xmlns:a="http://schemas.openxmlformats.org/drawingml/2006/main">
@@ -2650,22 +2625,22 @@
       </p:sp>
       <p:sp>
         <p:nvSpPr>
-          <p:cNvPr id="15" name="">
-            <a:extLst xmlns:a="http://schemas.openxmlformats.org/drawingml/2006/main">
-              <a:ext uri="{FF2B5EF4-FFF2-40B4-BE49-F238E27FC236}">
-                <a16:creationId xmlns:a16="http://schemas.microsoft.com/office/drawing/2014/main" id="{55C6C7C0-B7DD-4D49-B719-4766AB289249}"/>
-              </a:ext>
-            </a:extLst>
-          </p:cNvPr>
-          <p:cNvSpPr>
-            <a:spLocks xmlns:a="http://schemas.openxmlformats.org/drawingml/2006/main" noGrp="1"/>
-          </p:cNvSpPr>
-          <p:nvPr/>
-        </p:nvSpPr>
-        <p:spPr>
-          <a:xfrm xmlns:a="http://schemas.openxmlformats.org/drawingml/2006/main">
-            <a:off x="7467600" y="4648200"/>
-            <a:ext cx="133350" cy="133350"/>
+          <p:cNvPr id="14" name="">
+            <a:extLst xmlns:a="http://schemas.openxmlformats.org/drawingml/2006/main">
+              <a:ext uri="{FF2B5EF4-FFF2-40B4-BE49-F238E27FC236}">
+                <a16:creationId xmlns:a16="http://schemas.microsoft.com/office/drawing/2014/main" id="{6BBAB347-915A-4F50-9834-0EF68A80E4E0}"/>
+              </a:ext>
+            </a:extLst>
+          </p:cNvPr>
+          <p:cNvSpPr>
+            <a:spLocks xmlns:a="http://schemas.openxmlformats.org/drawingml/2006/main" noGrp="1"/>
+          </p:cNvSpPr>
+          <p:nvPr/>
+        </p:nvSpPr>
+        <p:spPr>
+          <a:xfrm xmlns:a="http://schemas.openxmlformats.org/drawingml/2006/main">
+            <a:off x="7239000" y="4800600"/>
+            <a:ext cx="114300" cy="114300"/>
           </a:xfrm>
           <a:prstGeom xmlns:a="http://schemas.openxmlformats.org/drawingml/2006/main" prst="rect">
             <a:avLst/>
@@ -2681,22 +2656,22 @@
       </p:sp>
       <p:sp>
         <p:nvSpPr>
-          <p:cNvPr id="16" name="">
-            <a:extLst xmlns:a="http://schemas.openxmlformats.org/drawingml/2006/main">
-              <a:ext uri="{FF2B5EF4-FFF2-40B4-BE49-F238E27FC236}">
-                <a16:creationId xmlns:a16="http://schemas.microsoft.com/office/drawing/2014/main" id="{EB0F5F28-D2E7-4A7D-9568-B2E86649FE8E}"/>
-              </a:ext>
-            </a:extLst>
-          </p:cNvPr>
-          <p:cNvSpPr>
-            <a:spLocks xmlns:a="http://schemas.openxmlformats.org/drawingml/2006/main" noGrp="1"/>
-          </p:cNvSpPr>
-          <p:nvPr/>
-        </p:nvSpPr>
-        <p:spPr>
-          <a:xfrm xmlns:a="http://schemas.openxmlformats.org/drawingml/2006/main">
-            <a:off x="7715250" y="4562475"/>
-            <a:ext cx="2190750" cy="323850"/>
+          <p:cNvPr id="15" name="">
+            <a:extLst xmlns:a="http://schemas.openxmlformats.org/drawingml/2006/main">
+              <a:ext uri="{FF2B5EF4-FFF2-40B4-BE49-F238E27FC236}">
+                <a16:creationId xmlns:a16="http://schemas.microsoft.com/office/drawing/2014/main" id="{2BFAD90F-7B47-46A2-8FB0-9AC7BBAB328C}"/>
+              </a:ext>
+            </a:extLst>
+          </p:cNvPr>
+          <p:cNvSpPr>
+            <a:spLocks xmlns:a="http://schemas.openxmlformats.org/drawingml/2006/main" noGrp="1"/>
+          </p:cNvSpPr>
+          <p:nvPr/>
+        </p:nvSpPr>
+        <p:spPr>
+          <a:xfrm xmlns:a="http://schemas.openxmlformats.org/drawingml/2006/main">
+            <a:off x="7467600" y="4724400"/>
+            <a:ext cx="2476500" cy="285750"/>
           </a:xfrm>
           <a:prstGeom xmlns:a="http://schemas.openxmlformats.org/drawingml/2006/main" prst="rect">
             <a:avLst/>
@@ -2712,7 +2687,7 @@
           <a:lstStyle xmlns:a="http://schemas.openxmlformats.org/drawingml/2006/main"/>
           <a:p xmlns:a="http://schemas.openxmlformats.org/drawingml/2006/main">
             <a:pPr>
-              <a:defRPr sz="1800" b="1">
+              <a:defRPr sz="1650" b="1">
                 <a:solidFill>
                   <a:srgbClr val="634893"/>
                 </a:solidFill>
@@ -2722,7 +2697,7 @@
               </a:defRPr>
             </a:pPr>
             <a:r>
-              <a:rPr sz="1800" b="1">
+              <a:rPr sz="1650" b="1">
                 <a:solidFill>
                   <a:srgbClr val="634893"/>
                 </a:solidFill>
@@ -2737,22 +2712,22 @@
       </p:sp>
       <p:sp>
         <p:nvSpPr>
-          <p:cNvPr id="17" name="">
-            <a:extLst xmlns:a="http://schemas.openxmlformats.org/drawingml/2006/main">
-              <a:ext uri="{FF2B5EF4-FFF2-40B4-BE49-F238E27FC236}">
-                <a16:creationId xmlns:a16="http://schemas.microsoft.com/office/drawing/2014/main" id="{83D6191E-3B93-443D-8B6D-53EAD4848950}"/>
-              </a:ext>
-            </a:extLst>
-          </p:cNvPr>
-          <p:cNvSpPr>
-            <a:spLocks xmlns:a="http://schemas.openxmlformats.org/drawingml/2006/main" noGrp="1"/>
-          </p:cNvSpPr>
-          <p:nvPr/>
-        </p:nvSpPr>
-        <p:spPr>
-          <a:xfrm xmlns:a="http://schemas.openxmlformats.org/drawingml/2006/main">
-            <a:off x="7505700" y="4972050"/>
-            <a:ext cx="2628900" cy="514350"/>
+          <p:cNvPr id="16" name="">
+            <a:extLst xmlns:a="http://schemas.openxmlformats.org/drawingml/2006/main">
+              <a:ext uri="{FF2B5EF4-FFF2-40B4-BE49-F238E27FC236}">
+                <a16:creationId xmlns:a16="http://schemas.microsoft.com/office/drawing/2014/main" id="{D4CA68C8-245B-4705-8D45-7572F611DF85}"/>
+              </a:ext>
+            </a:extLst>
+          </p:cNvPr>
+          <p:cNvSpPr>
+            <a:spLocks xmlns:a="http://schemas.openxmlformats.org/drawingml/2006/main" noGrp="1"/>
+          </p:cNvSpPr>
+          <p:nvPr/>
+        </p:nvSpPr>
+        <p:spPr>
+          <a:xfrm xmlns:a="http://schemas.openxmlformats.org/drawingml/2006/main">
+            <a:off x="7277100" y="5086350"/>
+            <a:ext cx="3048000" cy="419100"/>
           </a:xfrm>
           <a:prstGeom xmlns:a="http://schemas.openxmlformats.org/drawingml/2006/main" prst="rect">
             <a:avLst/>
@@ -2768,7 +2743,7 @@
           <a:lstStyle xmlns:a="http://schemas.openxmlformats.org/drawingml/2006/main"/>
           <a:p xmlns:a="http://schemas.openxmlformats.org/drawingml/2006/main">
             <a:pPr>
-              <a:defRPr sz="1350">
+              <a:defRPr sz="1125">
                 <a:solidFill>
                   <a:srgbClr val="695F84"/>
                 </a:solidFill>
@@ -2778,7 +2753,7 @@
               </a:defRPr>
             </a:pPr>
             <a:r>
-              <a:rPr sz="1350">
+              <a:rPr sz="1125">
                 <a:solidFill>
                   <a:srgbClr val="695F84"/>
                 </a:solidFill>
@@ -2793,10 +2768,10 @@
       </p:sp>
       <p:sp>
         <p:nvSpPr>
-          <p:cNvPr id="18" name="">
-            <a:extLst xmlns:a="http://schemas.openxmlformats.org/drawingml/2006/main">
-              <a:ext uri="{FF2B5EF4-FFF2-40B4-BE49-F238E27FC236}">
-                <a16:creationId xmlns:a16="http://schemas.microsoft.com/office/drawing/2014/main" id="{F66E9675-5FDB-456A-9AEA-7BB42FD53011}"/>
+          <p:cNvPr id="17" name="">
+            <a:extLst xmlns:a="http://schemas.openxmlformats.org/drawingml/2006/main">
+              <a:ext uri="{FF2B5EF4-FFF2-40B4-BE49-F238E27FC236}">
+                <a16:creationId xmlns:a16="http://schemas.microsoft.com/office/drawing/2014/main" id="{91F681BF-F984-44F2-B2E5-CF5F319F6175}"/>
               </a:ext>
             </a:extLst>
           </p:cNvPr>
@@ -2849,10 +2824,10 @@
       </p:sp>
       <p:sp>
         <p:nvSpPr>
-          <p:cNvPr id="19" name="">
-            <a:extLst xmlns:a="http://schemas.openxmlformats.org/drawingml/2006/main">
-              <a:ext uri="{FF2B5EF4-FFF2-40B4-BE49-F238E27FC236}">
-                <a16:creationId xmlns:a16="http://schemas.microsoft.com/office/drawing/2014/main" id="{92919129-4B74-44B6-A094-8D4FBBF57F1A}"/>
+          <p:cNvPr id="18" name="">
+            <a:extLst xmlns:a="http://schemas.openxmlformats.org/drawingml/2006/main">
+              <a:ext uri="{FF2B5EF4-FFF2-40B4-BE49-F238E27FC236}">
+                <a16:creationId xmlns:a16="http://schemas.microsoft.com/office/drawing/2014/main" id="{140BD1CA-AC9F-46F1-8096-BCB08FCFD8B8}"/>
               </a:ext>
             </a:extLst>
           </p:cNvPr>
@@ -2906,7 +2881,7 @@
     </p:spTree>
     <p:extLst>
       <p:ext uri="{BB962C8B-B14F-4D97-AF65-F5344CB8AC3E}">
-        <p14:creationId xmlns:p14="http://schemas.microsoft.com/office/powerpoint/2010/main" val="192417695"/>
+        <p14:creationId xmlns:p14="http://schemas.microsoft.com/office/powerpoint/2010/main" val="1727576200"/>
       </p:ext>
     </p:extLst>
   </p:cSld>
@@ -2941,7 +2916,7 @@
           <p:nvPr/>
         </p:nvPicPr>
         <p:blipFill>
-          <a:blip xmlns:r="http://schemas.openxmlformats.org/officeDocument/2006/relationships" xmlns:a="http://schemas.openxmlformats.org/drawingml/2006/main" r:embed="Rbaa490ca272c4a5b"/>
+          <a:blip xmlns:r="http://schemas.openxmlformats.org/officeDocument/2006/relationships" xmlns:a="http://schemas.openxmlformats.org/drawingml/2006/main" r:embed="Rcbc5782dc74a43db"/>
           <a:srcRect xmlns:a="http://schemas.openxmlformats.org/drawingml/2006/main" l="8984" t="0" r="8984" b="0"/>
           <a:stretch xmlns:a="http://schemas.openxmlformats.org/drawingml/2006/main">
             <a:fillRect l="0" t="0" r="0" b="0"/>
@@ -2962,7 +2937,7 @@
           <p:cNvPr id="2" name="">
             <a:extLst xmlns:a="http://schemas.openxmlformats.org/drawingml/2006/main">
               <a:ext uri="{FF2B5EF4-FFF2-40B4-BE49-F238E27FC236}">
-                <a16:creationId xmlns:a16="http://schemas.microsoft.com/office/drawing/2014/main" id="{F10D7E63-EBF8-4F11-BAA8-5FE7AE310783}"/>
+                <a16:creationId xmlns:a16="http://schemas.microsoft.com/office/drawing/2014/main" id="{9CAB9FE8-7600-4328-BDA1-D4128B354D37}"/>
               </a:ext>
             </a:extLst>
           </p:cNvPr>
@@ -3018,7 +2993,7 @@
           <p:cNvPr id="3" name="">
             <a:extLst xmlns:a="http://schemas.openxmlformats.org/drawingml/2006/main">
               <a:ext uri="{FF2B5EF4-FFF2-40B4-BE49-F238E27FC236}">
-                <a16:creationId xmlns:a16="http://schemas.microsoft.com/office/drawing/2014/main" id="{08187965-3ABB-4AEB-BD56-0D5E5A4F98BB}"/>
+                <a16:creationId xmlns:a16="http://schemas.microsoft.com/office/drawing/2014/main" id="{09BA7243-ACE9-489C-88BA-2910686AFC80}"/>
               </a:ext>
             </a:extLst>
           </p:cNvPr>
@@ -3074,7 +3049,7 @@
           <p:cNvPr id="4" name="">
             <a:extLst xmlns:a="http://schemas.openxmlformats.org/drawingml/2006/main">
               <a:ext uri="{FF2B5EF4-FFF2-40B4-BE49-F238E27FC236}">
-                <a16:creationId xmlns:a16="http://schemas.microsoft.com/office/drawing/2014/main" id="{65DF050D-4B4C-46A9-A593-0690D36DA123}"/>
+                <a16:creationId xmlns:a16="http://schemas.microsoft.com/office/drawing/2014/main" id="{38126B00-6BE9-4AE4-AA67-7149099935AB}"/>
               </a:ext>
             </a:extLst>
           </p:cNvPr>
@@ -3105,7 +3080,7 @@
           <p:cNvPr id="5" name="">
             <a:extLst xmlns:a="http://schemas.openxmlformats.org/drawingml/2006/main">
               <a:ext uri="{FF2B5EF4-FFF2-40B4-BE49-F238E27FC236}">
-                <a16:creationId xmlns:a16="http://schemas.microsoft.com/office/drawing/2014/main" id="{4400A7B1-5F62-47DF-841E-25337A2372B9}"/>
+                <a16:creationId xmlns:a16="http://schemas.microsoft.com/office/drawing/2014/main" id="{C50A7E87-E0ED-48CD-9178-785D12D1BF46}"/>
               </a:ext>
             </a:extLst>
           </p:cNvPr>
@@ -3161,7 +3136,7 @@
           <p:cNvPr id="6" name="">
             <a:extLst xmlns:a="http://schemas.openxmlformats.org/drawingml/2006/main">
               <a:ext uri="{FF2B5EF4-FFF2-40B4-BE49-F238E27FC236}">
-                <a16:creationId xmlns:a16="http://schemas.microsoft.com/office/drawing/2014/main" id="{B3B40882-3F93-480A-849A-B9AE335B6582}"/>
+                <a16:creationId xmlns:a16="http://schemas.microsoft.com/office/drawing/2014/main" id="{9B6CFB19-CC80-4604-B2E0-F8F27F55497A}"/>
               </a:ext>
             </a:extLst>
           </p:cNvPr>
@@ -3192,7 +3167,7 @@
           <p:cNvPr id="7" name="">
             <a:extLst xmlns:a="http://schemas.openxmlformats.org/drawingml/2006/main">
               <a:ext uri="{FF2B5EF4-FFF2-40B4-BE49-F238E27FC236}">
-                <a16:creationId xmlns:a16="http://schemas.microsoft.com/office/drawing/2014/main" id="{AD2EC422-53B6-421D-97CA-9EBD40CE367C}"/>
+                <a16:creationId xmlns:a16="http://schemas.microsoft.com/office/drawing/2014/main" id="{D45FB60F-5595-4108-A27A-16C2E6626811}"/>
               </a:ext>
             </a:extLst>
           </p:cNvPr>
@@ -3248,7 +3223,7 @@
           <p:cNvPr id="8" name="">
             <a:extLst xmlns:a="http://schemas.openxmlformats.org/drawingml/2006/main">
               <a:ext uri="{FF2B5EF4-FFF2-40B4-BE49-F238E27FC236}">
-                <a16:creationId xmlns:a16="http://schemas.microsoft.com/office/drawing/2014/main" id="{35D33E5D-B089-4B24-9A53-A13E3D510270}"/>
+                <a16:creationId xmlns:a16="http://schemas.microsoft.com/office/drawing/2014/main" id="{73C5B8B9-BD55-48DD-A894-D780780863BA}"/>
               </a:ext>
             </a:extLst>
           </p:cNvPr>
@@ -3279,7 +3254,7 @@
           <p:cNvPr id="9" name="">
             <a:extLst xmlns:a="http://schemas.openxmlformats.org/drawingml/2006/main">
               <a:ext uri="{FF2B5EF4-FFF2-40B4-BE49-F238E27FC236}">
-                <a16:creationId xmlns:a16="http://schemas.microsoft.com/office/drawing/2014/main" id="{3CDAEFF6-241D-4136-AC58-ACC0B1B34630}"/>
+                <a16:creationId xmlns:a16="http://schemas.microsoft.com/office/drawing/2014/main" id="{BB3D71E2-C758-44EC-8111-9047C6358983}"/>
               </a:ext>
             </a:extLst>
           </p:cNvPr>
@@ -3335,7 +3310,7 @@
           <p:cNvPr id="10" name="">
             <a:extLst xmlns:a="http://schemas.openxmlformats.org/drawingml/2006/main">
               <a:ext uri="{FF2B5EF4-FFF2-40B4-BE49-F238E27FC236}">
-                <a16:creationId xmlns:a16="http://schemas.microsoft.com/office/drawing/2014/main" id="{277BE26D-B25D-41C9-83E6-C30B9F012BF4}"/>
+                <a16:creationId xmlns:a16="http://schemas.microsoft.com/office/drawing/2014/main" id="{A261C820-FAA5-4148-A2D1-E8513D66C445}"/>
               </a:ext>
             </a:extLst>
           </p:cNvPr>
@@ -3391,7 +3366,7 @@
           <p:cNvPr id="11" name="">
             <a:extLst xmlns:a="http://schemas.openxmlformats.org/drawingml/2006/main">
               <a:ext uri="{FF2B5EF4-FFF2-40B4-BE49-F238E27FC236}">
-                <a16:creationId xmlns:a16="http://schemas.microsoft.com/office/drawing/2014/main" id="{863C1616-9787-43B3-96C0-A14A7322728B}"/>
+                <a16:creationId xmlns:a16="http://schemas.microsoft.com/office/drawing/2014/main" id="{EC89D22D-F04B-48F8-BE50-56FEAB2B691C}"/>
               </a:ext>
             </a:extLst>
           </p:cNvPr>
@@ -3445,7 +3420,7 @@
     </p:spTree>
     <p:extLst>
       <p:ext uri="{BB962C8B-B14F-4D97-AF65-F5344CB8AC3E}">
-        <p14:creationId xmlns:p14="http://schemas.microsoft.com/office/powerpoint/2010/main" val="395702995"/>
+        <p14:creationId xmlns:p14="http://schemas.microsoft.com/office/powerpoint/2010/main" val="1170270807"/>
       </p:ext>
     </p:extLst>
   </p:cSld>
@@ -3476,7 +3451,7 @@
           <p:cNvPr id="1" name="">
             <a:extLst xmlns:a="http://schemas.openxmlformats.org/drawingml/2006/main">
               <a:ext uri="{FF2B5EF4-FFF2-40B4-BE49-F238E27FC236}">
-                <a16:creationId xmlns:a16="http://schemas.microsoft.com/office/drawing/2014/main" id="{48612395-566B-40BA-BD6A-A1C1F5C08DD1}"/>
+                <a16:creationId xmlns:a16="http://schemas.microsoft.com/office/drawing/2014/main" id="{AE424BD5-1054-41B5-8882-17A193623AE9}"/>
               </a:ext>
             </a:extLst>
           </p:cNvPr>
@@ -3532,7 +3507,7 @@
           <p:cNvPr id="2" name="">
             <a:extLst xmlns:a="http://schemas.openxmlformats.org/drawingml/2006/main">
               <a:ext uri="{FF2B5EF4-FFF2-40B4-BE49-F238E27FC236}">
-                <a16:creationId xmlns:a16="http://schemas.microsoft.com/office/drawing/2014/main" id="{ABE96ADF-F807-474B-B8FD-D95862883E78}"/>
+                <a16:creationId xmlns:a16="http://schemas.microsoft.com/office/drawing/2014/main" id="{720C2D26-CF52-4AAA-A547-DF359E8AB695}"/>
               </a:ext>
             </a:extLst>
           </p:cNvPr>
@@ -3592,7 +3567,7 @@
           <p:nvPr/>
         </p:nvPicPr>
         <p:blipFill>
-          <a:blip xmlns:r="http://schemas.openxmlformats.org/officeDocument/2006/relationships" xmlns:a="http://schemas.openxmlformats.org/drawingml/2006/main" r:embed="R1d5222a295b74ead"/>
+          <a:blip xmlns:r="http://schemas.openxmlformats.org/officeDocument/2006/relationships" xmlns:a="http://schemas.openxmlformats.org/drawingml/2006/main" r:embed="R5185ec0c12134531"/>
           <a:srcRect xmlns:a="http://schemas.openxmlformats.org/drawingml/2006/main" l="291" t="0" r="291" b="0"/>
           <a:stretch xmlns:a="http://schemas.openxmlformats.org/drawingml/2006/main">
             <a:fillRect l="0" t="0" r="0" b="0"/>
@@ -3613,7 +3588,7 @@
           <p:cNvPr id="4" name="">
             <a:extLst xmlns:a="http://schemas.openxmlformats.org/drawingml/2006/main">
               <a:ext uri="{FF2B5EF4-FFF2-40B4-BE49-F238E27FC236}">
-                <a16:creationId xmlns:a16="http://schemas.microsoft.com/office/drawing/2014/main" id="{BCF377C9-7950-43C4-A077-05EF1613D2E2}"/>
+                <a16:creationId xmlns:a16="http://schemas.microsoft.com/office/drawing/2014/main" id="{9C9F0665-8FA3-4DEA-A7BB-01D4F559A26C}"/>
               </a:ext>
             </a:extLst>
           </p:cNvPr>
@@ -3648,7 +3623,7 @@
           <p:cNvPr id="5" name="">
             <a:extLst xmlns:a="http://schemas.openxmlformats.org/drawingml/2006/main">
               <a:ext uri="{FF2B5EF4-FFF2-40B4-BE49-F238E27FC236}">
-                <a16:creationId xmlns:a16="http://schemas.microsoft.com/office/drawing/2014/main" id="{F1226C08-8CE2-463C-A2DF-99A472F2DA6F}"/>
+                <a16:creationId xmlns:a16="http://schemas.microsoft.com/office/drawing/2014/main" id="{0014219B-AB2A-44F1-A766-EC0899733AE3}"/>
               </a:ext>
             </a:extLst>
           </p:cNvPr>
@@ -3704,7 +3679,7 @@
           <p:cNvPr id="6" name="">
             <a:extLst xmlns:a="http://schemas.openxmlformats.org/drawingml/2006/main">
               <a:ext uri="{FF2B5EF4-FFF2-40B4-BE49-F238E27FC236}">
-                <a16:creationId xmlns:a16="http://schemas.microsoft.com/office/drawing/2014/main" id="{1EE798E2-E55E-4439-B65B-55B0F58CE663}"/>
+                <a16:creationId xmlns:a16="http://schemas.microsoft.com/office/drawing/2014/main" id="{FB091545-1F6E-43EE-95AF-98CD2634B9AE}"/>
               </a:ext>
             </a:extLst>
           </p:cNvPr>
@@ -3735,7 +3710,7 @@
           <p:cNvPr id="7" name="">
             <a:extLst xmlns:a="http://schemas.openxmlformats.org/drawingml/2006/main">
               <a:ext uri="{FF2B5EF4-FFF2-40B4-BE49-F238E27FC236}">
-                <a16:creationId xmlns:a16="http://schemas.microsoft.com/office/drawing/2014/main" id="{A082111B-7421-4DBA-93F4-61AC03C14202}"/>
+                <a16:creationId xmlns:a16="http://schemas.microsoft.com/office/drawing/2014/main" id="{1D35CEAA-101F-4044-954D-C653FA6D1C07}"/>
               </a:ext>
             </a:extLst>
           </p:cNvPr>
@@ -3791,7 +3766,7 @@
           <p:cNvPr id="8" name="">
             <a:extLst xmlns:a="http://schemas.openxmlformats.org/drawingml/2006/main">
               <a:ext uri="{FF2B5EF4-FFF2-40B4-BE49-F238E27FC236}">
-                <a16:creationId xmlns:a16="http://schemas.microsoft.com/office/drawing/2014/main" id="{712B7EFF-609E-4DA0-B637-6A940993A111}"/>
+                <a16:creationId xmlns:a16="http://schemas.microsoft.com/office/drawing/2014/main" id="{8F474D2E-69A4-408E-BC74-D6B98E7AAE9A}"/>
               </a:ext>
             </a:extLst>
           </p:cNvPr>
@@ -3822,7 +3797,7 @@
           <p:cNvPr id="9" name="">
             <a:extLst xmlns:a="http://schemas.openxmlformats.org/drawingml/2006/main">
               <a:ext uri="{FF2B5EF4-FFF2-40B4-BE49-F238E27FC236}">
-                <a16:creationId xmlns:a16="http://schemas.microsoft.com/office/drawing/2014/main" id="{8BB28E9D-0A57-4507-906E-94580D238783}"/>
+                <a16:creationId xmlns:a16="http://schemas.microsoft.com/office/drawing/2014/main" id="{732B8EEE-FADB-4A51-AE7D-FB86418C0EFC}"/>
               </a:ext>
             </a:extLst>
           </p:cNvPr>
@@ -3878,7 +3853,7 @@
           <p:cNvPr id="10" name="">
             <a:extLst xmlns:a="http://schemas.openxmlformats.org/drawingml/2006/main">
               <a:ext uri="{FF2B5EF4-FFF2-40B4-BE49-F238E27FC236}">
-                <a16:creationId xmlns:a16="http://schemas.microsoft.com/office/drawing/2014/main" id="{9A0D3BA7-0CDB-488E-9DF6-9352DF57FAFF}"/>
+                <a16:creationId xmlns:a16="http://schemas.microsoft.com/office/drawing/2014/main" id="{EDE18C21-D341-48A0-8B67-AD0AC0F54340}"/>
               </a:ext>
             </a:extLst>
           </p:cNvPr>
@@ -3909,7 +3884,7 @@
           <p:cNvPr id="11" name="">
             <a:extLst xmlns:a="http://schemas.openxmlformats.org/drawingml/2006/main">
               <a:ext uri="{FF2B5EF4-FFF2-40B4-BE49-F238E27FC236}">
-                <a16:creationId xmlns:a16="http://schemas.microsoft.com/office/drawing/2014/main" id="{E5DBBAC9-D470-47E9-BB1E-259D6A6B84B1}"/>
+                <a16:creationId xmlns:a16="http://schemas.microsoft.com/office/drawing/2014/main" id="{939D9929-B2F5-4648-B159-1B1F489DF44C}"/>
               </a:ext>
             </a:extLst>
           </p:cNvPr>
@@ -3965,7 +3940,7 @@
           <p:cNvPr id="12" name="">
             <a:extLst xmlns:a="http://schemas.openxmlformats.org/drawingml/2006/main">
               <a:ext uri="{FF2B5EF4-FFF2-40B4-BE49-F238E27FC236}">
-                <a16:creationId xmlns:a16="http://schemas.microsoft.com/office/drawing/2014/main" id="{7379B2B3-764B-421F-8B34-A1D6544C8C87}"/>
+                <a16:creationId xmlns:a16="http://schemas.microsoft.com/office/drawing/2014/main" id="{42E8599B-FA7F-4834-81FA-EE450B8F430E}"/>
               </a:ext>
             </a:extLst>
           </p:cNvPr>
@@ -3996,7 +3971,7 @@
           <p:cNvPr id="13" name="">
             <a:extLst xmlns:a="http://schemas.openxmlformats.org/drawingml/2006/main">
               <a:ext uri="{FF2B5EF4-FFF2-40B4-BE49-F238E27FC236}">
-                <a16:creationId xmlns:a16="http://schemas.microsoft.com/office/drawing/2014/main" id="{22AA104E-9ED7-442F-B198-F9C09614443A}"/>
+                <a16:creationId xmlns:a16="http://schemas.microsoft.com/office/drawing/2014/main" id="{D5EFAF3F-1FB3-405F-813D-F610D3FCBBA1}"/>
               </a:ext>
             </a:extLst>
           </p:cNvPr>
@@ -4052,7 +4027,7 @@
           <p:cNvPr id="14" name="">
             <a:extLst xmlns:a="http://schemas.openxmlformats.org/drawingml/2006/main">
               <a:ext uri="{FF2B5EF4-FFF2-40B4-BE49-F238E27FC236}">
-                <a16:creationId xmlns:a16="http://schemas.microsoft.com/office/drawing/2014/main" id="{9707EA1C-941D-4821-B307-7214B1C0FC5D}"/>
+                <a16:creationId xmlns:a16="http://schemas.microsoft.com/office/drawing/2014/main" id="{571051B1-A7CE-46F8-87A8-7E47F3534EC9}"/>
               </a:ext>
             </a:extLst>
           </p:cNvPr>
@@ -4108,7 +4083,7 @@
           <p:cNvPr id="15" name="">
             <a:extLst xmlns:a="http://schemas.openxmlformats.org/drawingml/2006/main">
               <a:ext uri="{FF2B5EF4-FFF2-40B4-BE49-F238E27FC236}">
-                <a16:creationId xmlns:a16="http://schemas.microsoft.com/office/drawing/2014/main" id="{871DD1D6-A00E-472A-A39D-18745514BFC0}"/>
+                <a16:creationId xmlns:a16="http://schemas.microsoft.com/office/drawing/2014/main" id="{0FE3E49D-6D18-4EE0-A585-73AD789E7870}"/>
               </a:ext>
             </a:extLst>
           </p:cNvPr>
@@ -4162,7 +4137,7 @@
     </p:spTree>
     <p:extLst>
       <p:ext uri="{BB962C8B-B14F-4D97-AF65-F5344CB8AC3E}">
-        <p14:creationId xmlns:p14="http://schemas.microsoft.com/office/powerpoint/2010/main" val="1583252100"/>
+        <p14:creationId xmlns:p14="http://schemas.microsoft.com/office/powerpoint/2010/main" val="1738772104"/>
       </p:ext>
     </p:extLst>
   </p:cSld>
@@ -4193,7 +4168,7 @@
           <p:cNvPr id="1" name="">
             <a:extLst xmlns:a="http://schemas.openxmlformats.org/drawingml/2006/main">
               <a:ext uri="{FF2B5EF4-FFF2-40B4-BE49-F238E27FC236}">
-                <a16:creationId xmlns:a16="http://schemas.microsoft.com/office/drawing/2014/main" id="{BA652907-1527-445C-9D34-275F4E12862F}"/>
+                <a16:creationId xmlns:a16="http://schemas.microsoft.com/office/drawing/2014/main" id="{12FEF7C3-D3CE-4AB9-B5AC-CF2C9FDDF522}"/>
               </a:ext>
             </a:extLst>
           </p:cNvPr>
@@ -4253,7 +4228,7 @@
           <p:nvPr/>
         </p:nvPicPr>
         <p:blipFill>
-          <a:blip xmlns:r="http://schemas.openxmlformats.org/officeDocument/2006/relationships" xmlns:a="http://schemas.openxmlformats.org/drawingml/2006/main" r:embed="R5dc996e5552843e3"/>
+          <a:blip xmlns:r="http://schemas.openxmlformats.org/officeDocument/2006/relationships" xmlns:a="http://schemas.openxmlformats.org/drawingml/2006/main" r:embed="R92fca445d07d4be2"/>
           <a:srcRect xmlns:a="http://schemas.openxmlformats.org/drawingml/2006/main" l="2907" t="0" r="2907" b="0"/>
           <a:stretch xmlns:a="http://schemas.openxmlformats.org/drawingml/2006/main">
             <a:fillRect l="0" t="0" r="0" b="0"/>
@@ -4274,7 +4249,7 @@
           <p:cNvPr id="3" name="">
             <a:extLst xmlns:a="http://schemas.openxmlformats.org/drawingml/2006/main">
               <a:ext uri="{FF2B5EF4-FFF2-40B4-BE49-F238E27FC236}">
-                <a16:creationId xmlns:a16="http://schemas.microsoft.com/office/drawing/2014/main" id="{B8A2F386-5458-49A4-9D6A-7DCD8CC3C478}"/>
+                <a16:creationId xmlns:a16="http://schemas.microsoft.com/office/drawing/2014/main" id="{ABE8C6F1-77C6-433C-AE92-512F58174229}"/>
               </a:ext>
             </a:extLst>
           </p:cNvPr>
@@ -4330,7 +4305,7 @@
           <p:cNvPr id="4" name="">
             <a:extLst xmlns:a="http://schemas.openxmlformats.org/drawingml/2006/main">
               <a:ext uri="{FF2B5EF4-FFF2-40B4-BE49-F238E27FC236}">
-                <a16:creationId xmlns:a16="http://schemas.microsoft.com/office/drawing/2014/main" id="{4DDB17C4-4BFD-4D98-A92A-41D41F0E55A9}"/>
+                <a16:creationId xmlns:a16="http://schemas.microsoft.com/office/drawing/2014/main" id="{DF77FA60-5D21-434A-95F4-9C200B2D69D9}"/>
               </a:ext>
             </a:extLst>
           </p:cNvPr>
@@ -4361,7 +4336,7 @@
           <p:cNvPr id="5" name="">
             <a:extLst xmlns:a="http://schemas.openxmlformats.org/drawingml/2006/main">
               <a:ext uri="{FF2B5EF4-FFF2-40B4-BE49-F238E27FC236}">
-                <a16:creationId xmlns:a16="http://schemas.microsoft.com/office/drawing/2014/main" id="{B0C2D451-D17E-4292-872D-DD8A086F1BA8}"/>
+                <a16:creationId xmlns:a16="http://schemas.microsoft.com/office/drawing/2014/main" id="{B1D7C9D3-E312-473D-AADE-D05685ACF813}"/>
               </a:ext>
             </a:extLst>
           </p:cNvPr>
@@ -4417,7 +4392,7 @@
           <p:cNvPr id="6" name="">
             <a:extLst xmlns:a="http://schemas.openxmlformats.org/drawingml/2006/main">
               <a:ext uri="{FF2B5EF4-FFF2-40B4-BE49-F238E27FC236}">
-                <a16:creationId xmlns:a16="http://schemas.microsoft.com/office/drawing/2014/main" id="{318F47F5-84D8-4B68-89EF-182E184E512F}"/>
+                <a16:creationId xmlns:a16="http://schemas.microsoft.com/office/drawing/2014/main" id="{231DED7A-C884-40CC-BEF7-32160CD967A1}"/>
               </a:ext>
             </a:extLst>
           </p:cNvPr>
@@ -4448,7 +4423,7 @@
           <p:cNvPr id="7" name="">
             <a:extLst xmlns:a="http://schemas.openxmlformats.org/drawingml/2006/main">
               <a:ext uri="{FF2B5EF4-FFF2-40B4-BE49-F238E27FC236}">
-                <a16:creationId xmlns:a16="http://schemas.microsoft.com/office/drawing/2014/main" id="{700DC5FC-702D-408E-ADE3-F03B78780E47}"/>
+                <a16:creationId xmlns:a16="http://schemas.microsoft.com/office/drawing/2014/main" id="{4C368694-DB7A-4D3E-9E0D-17163552E50F}"/>
               </a:ext>
             </a:extLst>
           </p:cNvPr>
@@ -4504,7 +4479,7 @@
           <p:cNvPr id="8" name="">
             <a:extLst xmlns:a="http://schemas.openxmlformats.org/drawingml/2006/main">
               <a:ext uri="{FF2B5EF4-FFF2-40B4-BE49-F238E27FC236}">
-                <a16:creationId xmlns:a16="http://schemas.microsoft.com/office/drawing/2014/main" id="{8EE8AC20-B645-48AE-8CF6-BAC0942DDF3E}"/>
+                <a16:creationId xmlns:a16="http://schemas.microsoft.com/office/drawing/2014/main" id="{14A31D02-4A0E-411B-8351-F10D4DF877FE}"/>
               </a:ext>
             </a:extLst>
           </p:cNvPr>
@@ -4535,7 +4510,7 @@
           <p:cNvPr id="9" name="">
             <a:extLst xmlns:a="http://schemas.openxmlformats.org/drawingml/2006/main">
               <a:ext uri="{FF2B5EF4-FFF2-40B4-BE49-F238E27FC236}">
-                <a16:creationId xmlns:a16="http://schemas.microsoft.com/office/drawing/2014/main" id="{C33F4BDB-526D-49D4-BF36-04E9F3B3F32F}"/>
+                <a16:creationId xmlns:a16="http://schemas.microsoft.com/office/drawing/2014/main" id="{12DF93E1-CACA-43B3-B4D2-8723EFFBDD4C}"/>
               </a:ext>
             </a:extLst>
           </p:cNvPr>
@@ -4591,7 +4566,7 @@
           <p:cNvPr id="10" name="">
             <a:extLst xmlns:a="http://schemas.openxmlformats.org/drawingml/2006/main">
               <a:ext uri="{FF2B5EF4-FFF2-40B4-BE49-F238E27FC236}">
-                <a16:creationId xmlns:a16="http://schemas.microsoft.com/office/drawing/2014/main" id="{E7B4B2C0-1DE6-4D79-A018-6F2F8E9F7524}"/>
+                <a16:creationId xmlns:a16="http://schemas.microsoft.com/office/drawing/2014/main" id="{1C88BC43-2B8B-4948-85EA-12110F3CF604}"/>
               </a:ext>
             </a:extLst>
           </p:cNvPr>
@@ -4622,7 +4597,7 @@
           <p:cNvPr id="11" name="">
             <a:extLst xmlns:a="http://schemas.openxmlformats.org/drawingml/2006/main">
               <a:ext uri="{FF2B5EF4-FFF2-40B4-BE49-F238E27FC236}">
-                <a16:creationId xmlns:a16="http://schemas.microsoft.com/office/drawing/2014/main" id="{E1F4B861-FBDB-4860-9D78-9FB017D7B650}"/>
+                <a16:creationId xmlns:a16="http://schemas.microsoft.com/office/drawing/2014/main" id="{9742AFD7-6616-4106-94FC-37E526B28FD2}"/>
               </a:ext>
             </a:extLst>
           </p:cNvPr>
@@ -4678,7 +4653,7 @@
           <p:cNvPr id="12" name="">
             <a:extLst xmlns:a="http://schemas.openxmlformats.org/drawingml/2006/main">
               <a:ext uri="{FF2B5EF4-FFF2-40B4-BE49-F238E27FC236}">
-                <a16:creationId xmlns:a16="http://schemas.microsoft.com/office/drawing/2014/main" id="{11BB9712-ABAD-475D-A754-15F4090A5871}"/>
+                <a16:creationId xmlns:a16="http://schemas.microsoft.com/office/drawing/2014/main" id="{F4614325-37F6-47C1-9A1A-A9675FF99D2A}"/>
               </a:ext>
             </a:extLst>
           </p:cNvPr>
@@ -4734,7 +4709,7 @@
           <p:cNvPr id="13" name="">
             <a:extLst xmlns:a="http://schemas.openxmlformats.org/drawingml/2006/main">
               <a:ext uri="{FF2B5EF4-FFF2-40B4-BE49-F238E27FC236}">
-                <a16:creationId xmlns:a16="http://schemas.microsoft.com/office/drawing/2014/main" id="{1F528C3B-66DC-4F34-A9DB-39B0D736A942}"/>
+                <a16:creationId xmlns:a16="http://schemas.microsoft.com/office/drawing/2014/main" id="{7E24DCD7-F822-4DAA-8D27-2DA10DDAE420}"/>
               </a:ext>
             </a:extLst>
           </p:cNvPr>
@@ -4788,7 +4763,7 @@
     </p:spTree>
     <p:extLst>
       <p:ext uri="{BB962C8B-B14F-4D97-AF65-F5344CB8AC3E}">
-        <p14:creationId xmlns:p14="http://schemas.microsoft.com/office/powerpoint/2010/main" val="343281083"/>
+        <p14:creationId xmlns:p14="http://schemas.microsoft.com/office/powerpoint/2010/main" val="1002704178"/>
       </p:ext>
     </p:extLst>
   </p:cSld>
@@ -4819,7 +4794,7 @@
           <p:cNvPr id="1" name="">
             <a:extLst xmlns:a="http://schemas.openxmlformats.org/drawingml/2006/main">
               <a:ext uri="{FF2B5EF4-FFF2-40B4-BE49-F238E27FC236}">
-                <a16:creationId xmlns:a16="http://schemas.microsoft.com/office/drawing/2014/main" id="{8DDE60F7-AAA9-4AC9-B5D9-C0C0FF7B0326}"/>
+                <a16:creationId xmlns:a16="http://schemas.microsoft.com/office/drawing/2014/main" id="{D5948B50-6934-4022-9DEE-6C8D9873817F}"/>
               </a:ext>
             </a:extLst>
           </p:cNvPr>
@@ -4875,7 +4850,7 @@
           <p:cNvPr id="2" name="">
             <a:extLst xmlns:a="http://schemas.openxmlformats.org/drawingml/2006/main">
               <a:ext uri="{FF2B5EF4-FFF2-40B4-BE49-F238E27FC236}">
-                <a16:creationId xmlns:a16="http://schemas.microsoft.com/office/drawing/2014/main" id="{63FD47E6-4491-42FF-BD44-7F8FC272B098}"/>
+                <a16:creationId xmlns:a16="http://schemas.microsoft.com/office/drawing/2014/main" id="{E8737EFA-E9D3-4FF6-8307-5B2C98A7296B}"/>
               </a:ext>
             </a:extLst>
           </p:cNvPr>
@@ -4935,7 +4910,7 @@
           <p:nvPr/>
         </p:nvPicPr>
         <p:blipFill>
-          <a:blip xmlns:r="http://schemas.openxmlformats.org/officeDocument/2006/relationships" xmlns:a="http://schemas.openxmlformats.org/drawingml/2006/main" r:embed="Rf1acca1593db4ef1"/>
+          <a:blip xmlns:r="http://schemas.openxmlformats.org/officeDocument/2006/relationships" xmlns:a="http://schemas.openxmlformats.org/drawingml/2006/main" r:embed="Rc3de4d8828614e7f"/>
           <a:srcRect xmlns:a="http://schemas.openxmlformats.org/drawingml/2006/main" l="10473" t="0" r="10473" b="0"/>
           <a:stretch xmlns:a="http://schemas.openxmlformats.org/drawingml/2006/main">
             <a:fillRect l="0" t="0" r="0" b="0"/>
@@ -4956,7 +4931,7 @@
           <p:cNvPr id="4" name="">
             <a:extLst xmlns:a="http://schemas.openxmlformats.org/drawingml/2006/main">
               <a:ext uri="{FF2B5EF4-FFF2-40B4-BE49-F238E27FC236}">
-                <a16:creationId xmlns:a16="http://schemas.microsoft.com/office/drawing/2014/main" id="{A69F68EA-7703-4323-A66D-68F78E6F4F24}"/>
+                <a16:creationId xmlns:a16="http://schemas.microsoft.com/office/drawing/2014/main" id="{A1A7C501-ED63-48B9-B5F7-B84A51013189}"/>
               </a:ext>
             </a:extLst>
           </p:cNvPr>
@@ -5012,7 +4987,7 @@
           <p:cNvPr id="5" name="">
             <a:extLst xmlns:a="http://schemas.openxmlformats.org/drawingml/2006/main">
               <a:ext uri="{FF2B5EF4-FFF2-40B4-BE49-F238E27FC236}">
-                <a16:creationId xmlns:a16="http://schemas.microsoft.com/office/drawing/2014/main" id="{0E04F2BF-1D70-419F-9BA0-9444F9DA373B}"/>
+                <a16:creationId xmlns:a16="http://schemas.microsoft.com/office/drawing/2014/main" id="{7A93B766-0EC3-4DED-A347-2B0823DF602C}"/>
               </a:ext>
             </a:extLst>
           </p:cNvPr>
@@ -5072,7 +5047,7 @@
           <p:nvPr/>
         </p:nvPicPr>
         <p:blipFill>
-          <a:blip xmlns:r="http://schemas.openxmlformats.org/officeDocument/2006/relationships" xmlns:a="http://schemas.openxmlformats.org/drawingml/2006/main" r:embed="R1afe6f6c86be4755"/>
+          <a:blip xmlns:r="http://schemas.openxmlformats.org/officeDocument/2006/relationships" xmlns:a="http://schemas.openxmlformats.org/drawingml/2006/main" r:embed="R7d9ab4f0466d4693"/>
           <a:srcRect xmlns:a="http://schemas.openxmlformats.org/drawingml/2006/main" l="10473" t="0" r="10473" b="0"/>
           <a:stretch xmlns:a="http://schemas.openxmlformats.org/drawingml/2006/main">
             <a:fillRect l="0" t="0" r="0" b="0"/>
@@ -5093,7 +5068,7 @@
           <p:cNvPr id="7" name="">
             <a:extLst xmlns:a="http://schemas.openxmlformats.org/drawingml/2006/main">
               <a:ext uri="{FF2B5EF4-FFF2-40B4-BE49-F238E27FC236}">
-                <a16:creationId xmlns:a16="http://schemas.microsoft.com/office/drawing/2014/main" id="{9117E326-6ADB-4210-8C03-B7702A4CF4C9}"/>
+                <a16:creationId xmlns:a16="http://schemas.microsoft.com/office/drawing/2014/main" id="{4C8EF185-87F9-432F-B87F-3FA0AD5334A5}"/>
               </a:ext>
             </a:extLst>
           </p:cNvPr>
@@ -5149,7 +5124,7 @@
           <p:cNvPr id="8" name="">
             <a:extLst xmlns:a="http://schemas.openxmlformats.org/drawingml/2006/main">
               <a:ext uri="{FF2B5EF4-FFF2-40B4-BE49-F238E27FC236}">
-                <a16:creationId xmlns:a16="http://schemas.microsoft.com/office/drawing/2014/main" id="{55F3DD4B-C866-4815-9E9F-53361F4E2F2C}"/>
+                <a16:creationId xmlns:a16="http://schemas.microsoft.com/office/drawing/2014/main" id="{D4C84336-BD44-4403-B541-51D0AFDEDF33}"/>
               </a:ext>
             </a:extLst>
           </p:cNvPr>
@@ -5205,7 +5180,7 @@
           <p:cNvPr id="9" name="">
             <a:extLst xmlns:a="http://schemas.openxmlformats.org/drawingml/2006/main">
               <a:ext uri="{FF2B5EF4-FFF2-40B4-BE49-F238E27FC236}">
-                <a16:creationId xmlns:a16="http://schemas.microsoft.com/office/drawing/2014/main" id="{72215DAB-389D-4889-BD30-DEC1A8959022}"/>
+                <a16:creationId xmlns:a16="http://schemas.microsoft.com/office/drawing/2014/main" id="{D2C9DCB6-EDCA-4B52-8317-7CE67E64EF47}"/>
               </a:ext>
             </a:extLst>
           </p:cNvPr>
@@ -5259,7 +5234,7 @@
     </p:spTree>
     <p:extLst>
       <p:ext uri="{BB962C8B-B14F-4D97-AF65-F5344CB8AC3E}">
-        <p14:creationId xmlns:p14="http://schemas.microsoft.com/office/powerpoint/2010/main" val="1043564775"/>
+        <p14:creationId xmlns:p14="http://schemas.microsoft.com/office/powerpoint/2010/main" val="678779111"/>
       </p:ext>
     </p:extLst>
   </p:cSld>
@@ -5290,7 +5265,7 @@
           <p:cNvPr id="1" name="">
             <a:extLst xmlns:a="http://schemas.openxmlformats.org/drawingml/2006/main">
               <a:ext uri="{FF2B5EF4-FFF2-40B4-BE49-F238E27FC236}">
-                <a16:creationId xmlns:a16="http://schemas.microsoft.com/office/drawing/2014/main" id="{59953624-99EF-407A-830B-F998BCE8EB55}"/>
+                <a16:creationId xmlns:a16="http://schemas.microsoft.com/office/drawing/2014/main" id="{C59E8022-51F5-49FB-839E-08AF3BC1B031}"/>
               </a:ext>
             </a:extLst>
           </p:cNvPr>
@@ -5346,7 +5321,7 @@
           <p:cNvPr id="2" name="">
             <a:extLst xmlns:a="http://schemas.openxmlformats.org/drawingml/2006/main">
               <a:ext uri="{FF2B5EF4-FFF2-40B4-BE49-F238E27FC236}">
-                <a16:creationId xmlns:a16="http://schemas.microsoft.com/office/drawing/2014/main" id="{A3C89937-254F-42F0-AB3C-58C0241D5085}"/>
+                <a16:creationId xmlns:a16="http://schemas.microsoft.com/office/drawing/2014/main" id="{CE9E35D3-94DD-4EC8-9F2A-78FA908FBDD4}"/>
               </a:ext>
             </a:extLst>
           </p:cNvPr>
@@ -5406,7 +5381,7 @@
           <p:nvPr/>
         </p:nvPicPr>
         <p:blipFill>
-          <a:blip xmlns:r="http://schemas.openxmlformats.org/officeDocument/2006/relationships" xmlns:a="http://schemas.openxmlformats.org/drawingml/2006/main" r:embed="Rc053998faa564c3f"/>
+          <a:blip xmlns:r="http://schemas.openxmlformats.org/officeDocument/2006/relationships" xmlns:a="http://schemas.openxmlformats.org/drawingml/2006/main" r:embed="R9766f76f3cb24acf"/>
           <a:srcRect xmlns:a="http://schemas.openxmlformats.org/drawingml/2006/main" l="0" t="5556" r="0" b="5556"/>
           <a:stretch xmlns:a="http://schemas.openxmlformats.org/drawingml/2006/main">
             <a:fillRect l="0" t="0" r="0" b="0"/>
@@ -5427,7 +5402,7 @@
           <p:cNvPr id="4" name="">
             <a:extLst xmlns:a="http://schemas.openxmlformats.org/drawingml/2006/main">
               <a:ext uri="{FF2B5EF4-FFF2-40B4-BE49-F238E27FC236}">
-                <a16:creationId xmlns:a16="http://schemas.microsoft.com/office/drawing/2014/main" id="{3F234669-64C6-442A-9507-94F5F5DE7E15}"/>
+                <a16:creationId xmlns:a16="http://schemas.microsoft.com/office/drawing/2014/main" id="{8AB61532-723E-4014-95C6-643F76EC6BF3}"/>
               </a:ext>
             </a:extLst>
           </p:cNvPr>
@@ -5487,7 +5462,7 @@
           <p:nvPr/>
         </p:nvPicPr>
         <p:blipFill>
-          <a:blip xmlns:r="http://schemas.openxmlformats.org/officeDocument/2006/relationships" xmlns:a="http://schemas.openxmlformats.org/drawingml/2006/main" r:embed="R29803dc01b184719"/>
+          <a:blip xmlns:r="http://schemas.openxmlformats.org/officeDocument/2006/relationships" xmlns:a="http://schemas.openxmlformats.org/drawingml/2006/main" r:embed="R84f2115217844fb9"/>
           <a:srcRect xmlns:a="http://schemas.openxmlformats.org/drawingml/2006/main" l="0" t="5556" r="0" b="5556"/>
           <a:stretch xmlns:a="http://schemas.openxmlformats.org/drawingml/2006/main">
             <a:fillRect l="0" t="0" r="0" b="0"/>
@@ -5508,7 +5483,7 @@
           <p:cNvPr id="6" name="">
             <a:extLst xmlns:a="http://schemas.openxmlformats.org/drawingml/2006/main">
               <a:ext uri="{FF2B5EF4-FFF2-40B4-BE49-F238E27FC236}">
-                <a16:creationId xmlns:a16="http://schemas.microsoft.com/office/drawing/2014/main" id="{F79F8A50-4D95-4B80-B35A-9AAA9C585BDD}"/>
+                <a16:creationId xmlns:a16="http://schemas.microsoft.com/office/drawing/2014/main" id="{102D2F57-4B40-4C1E-AE8B-5DDB8D571195}"/>
               </a:ext>
             </a:extLst>
           </p:cNvPr>
@@ -5568,7 +5543,7 @@
           <p:nvPr/>
         </p:nvPicPr>
         <p:blipFill>
-          <a:blip xmlns:r="http://schemas.openxmlformats.org/officeDocument/2006/relationships" xmlns:a="http://schemas.openxmlformats.org/drawingml/2006/main" r:embed="R266caec460934e8b"/>
+          <a:blip xmlns:r="http://schemas.openxmlformats.org/officeDocument/2006/relationships" xmlns:a="http://schemas.openxmlformats.org/drawingml/2006/main" r:embed="R35638a015f074aa0"/>
           <a:srcRect xmlns:a="http://schemas.openxmlformats.org/drawingml/2006/main" l="0" t="5556" r="0" b="5556"/>
           <a:stretch xmlns:a="http://schemas.openxmlformats.org/drawingml/2006/main">
             <a:fillRect l="0" t="0" r="0" b="0"/>
@@ -5589,7 +5564,7 @@
           <p:cNvPr id="8" name="">
             <a:extLst xmlns:a="http://schemas.openxmlformats.org/drawingml/2006/main">
               <a:ext uri="{FF2B5EF4-FFF2-40B4-BE49-F238E27FC236}">
-                <a16:creationId xmlns:a16="http://schemas.microsoft.com/office/drawing/2014/main" id="{27857167-5563-4A6D-8D40-7B5DABC6FB01}"/>
+                <a16:creationId xmlns:a16="http://schemas.microsoft.com/office/drawing/2014/main" id="{15A5DF67-16E7-4E12-B0EC-7E8263DE20B7}"/>
               </a:ext>
             </a:extLst>
           </p:cNvPr>
@@ -5649,7 +5624,7 @@
           <p:nvPr/>
         </p:nvPicPr>
         <p:blipFill>
-          <a:blip xmlns:r="http://schemas.openxmlformats.org/officeDocument/2006/relationships" xmlns:a="http://schemas.openxmlformats.org/drawingml/2006/main" r:embed="R078ccc10a19d46ca"/>
+          <a:blip xmlns:r="http://schemas.openxmlformats.org/officeDocument/2006/relationships" xmlns:a="http://schemas.openxmlformats.org/drawingml/2006/main" r:embed="R7daaa4819735451f"/>
           <a:srcRect xmlns:a="http://schemas.openxmlformats.org/drawingml/2006/main" l="0" t="5556" r="0" b="5556"/>
           <a:stretch xmlns:a="http://schemas.openxmlformats.org/drawingml/2006/main">
             <a:fillRect l="0" t="0" r="0" b="0"/>
@@ -5670,7 +5645,7 @@
           <p:cNvPr id="10" name="">
             <a:extLst xmlns:a="http://schemas.openxmlformats.org/drawingml/2006/main">
               <a:ext uri="{FF2B5EF4-FFF2-40B4-BE49-F238E27FC236}">
-                <a16:creationId xmlns:a16="http://schemas.microsoft.com/office/drawing/2014/main" id="{F366A824-B178-4DEA-BD23-88E1A137853A}"/>
+                <a16:creationId xmlns:a16="http://schemas.microsoft.com/office/drawing/2014/main" id="{9BD274E7-86D9-44BC-A5D5-B92A6FF25623}"/>
               </a:ext>
             </a:extLst>
           </p:cNvPr>
@@ -5730,7 +5705,7 @@
           <p:nvPr/>
         </p:nvPicPr>
         <p:blipFill>
-          <a:blip xmlns:r="http://schemas.openxmlformats.org/officeDocument/2006/relationships" xmlns:a="http://schemas.openxmlformats.org/drawingml/2006/main" r:embed="R6c9761e6d8194575"/>
+          <a:blip xmlns:r="http://schemas.openxmlformats.org/officeDocument/2006/relationships" xmlns:a="http://schemas.openxmlformats.org/drawingml/2006/main" r:embed="R547001f54d2c46b1"/>
           <a:srcRect xmlns:a="http://schemas.openxmlformats.org/drawingml/2006/main" l="0" t="5556" r="0" b="5556"/>
           <a:stretch xmlns:a="http://schemas.openxmlformats.org/drawingml/2006/main">
             <a:fillRect l="0" t="0" r="0" b="0"/>
@@ -5751,7 +5726,7 @@
           <p:cNvPr id="12" name="">
             <a:extLst xmlns:a="http://schemas.openxmlformats.org/drawingml/2006/main">
               <a:ext uri="{FF2B5EF4-FFF2-40B4-BE49-F238E27FC236}">
-                <a16:creationId xmlns:a16="http://schemas.microsoft.com/office/drawing/2014/main" id="{FDC15B62-259C-4DB2-A9A9-BBB708557ED1}"/>
+                <a16:creationId xmlns:a16="http://schemas.microsoft.com/office/drawing/2014/main" id="{CD3465BD-1C3E-46D7-AFF2-D7EAE5052CA9}"/>
               </a:ext>
             </a:extLst>
           </p:cNvPr>
@@ -5811,7 +5786,7 @@
           <p:nvPr/>
         </p:nvPicPr>
         <p:blipFill>
-          <a:blip xmlns:r="http://schemas.openxmlformats.org/officeDocument/2006/relationships" xmlns:a="http://schemas.openxmlformats.org/drawingml/2006/main" r:embed="Rc0d1b8d7d22b4181"/>
+          <a:blip xmlns:r="http://schemas.openxmlformats.org/officeDocument/2006/relationships" xmlns:a="http://schemas.openxmlformats.org/drawingml/2006/main" r:embed="R7cffd0437a454d75"/>
           <a:srcRect xmlns:a="http://schemas.openxmlformats.org/drawingml/2006/main" l="0" t="5556" r="0" b="5556"/>
           <a:stretch xmlns:a="http://schemas.openxmlformats.org/drawingml/2006/main">
             <a:fillRect l="0" t="0" r="0" b="0"/>
@@ -5832,7 +5807,7 @@
           <p:cNvPr id="14" name="">
             <a:extLst xmlns:a="http://schemas.openxmlformats.org/drawingml/2006/main">
               <a:ext uri="{FF2B5EF4-FFF2-40B4-BE49-F238E27FC236}">
-                <a16:creationId xmlns:a16="http://schemas.microsoft.com/office/drawing/2014/main" id="{155806DD-10C9-41FC-B0CE-31EA64810625}"/>
+                <a16:creationId xmlns:a16="http://schemas.microsoft.com/office/drawing/2014/main" id="{30ECDEDD-D6CD-40B8-AE50-54C1722CB987}"/>
               </a:ext>
             </a:extLst>
           </p:cNvPr>
@@ -5888,7 +5863,7 @@
           <p:cNvPr id="15" name="">
             <a:extLst xmlns:a="http://schemas.openxmlformats.org/drawingml/2006/main">
               <a:ext uri="{FF2B5EF4-FFF2-40B4-BE49-F238E27FC236}">
-                <a16:creationId xmlns:a16="http://schemas.microsoft.com/office/drawing/2014/main" id="{4B961B74-CC82-4FBF-99A6-79D6A7EFDABB}"/>
+                <a16:creationId xmlns:a16="http://schemas.microsoft.com/office/drawing/2014/main" id="{3E0694FC-5282-47A6-9866-D3CB0825377A}"/>
               </a:ext>
             </a:extLst>
           </p:cNvPr>
@@ -5944,7 +5919,7 @@
           <p:cNvPr id="16" name="">
             <a:extLst xmlns:a="http://schemas.openxmlformats.org/drawingml/2006/main">
               <a:ext uri="{FF2B5EF4-FFF2-40B4-BE49-F238E27FC236}">
-                <a16:creationId xmlns:a16="http://schemas.microsoft.com/office/drawing/2014/main" id="{6AA785F3-D5C4-478C-887A-B0BA37EC422F}"/>
+                <a16:creationId xmlns:a16="http://schemas.microsoft.com/office/drawing/2014/main" id="{8D944E4B-FE9C-432F-B60D-A517B0569837}"/>
               </a:ext>
             </a:extLst>
           </p:cNvPr>
@@ -5998,7 +5973,7 @@
     </p:spTree>
     <p:extLst>
       <p:ext uri="{BB962C8B-B14F-4D97-AF65-F5344CB8AC3E}">
-        <p14:creationId xmlns:p14="http://schemas.microsoft.com/office/powerpoint/2010/main" val="914564409"/>
+        <p14:creationId xmlns:p14="http://schemas.microsoft.com/office/powerpoint/2010/main" val="2006956231"/>
       </p:ext>
     </p:extLst>
   </p:cSld>
@@ -6029,7 +6004,7 @@
           <p:cNvPr id="1" name="">
             <a:extLst xmlns:a="http://schemas.openxmlformats.org/drawingml/2006/main">
               <a:ext uri="{FF2B5EF4-FFF2-40B4-BE49-F238E27FC236}">
-                <a16:creationId xmlns:a16="http://schemas.microsoft.com/office/drawing/2014/main" id="{2964289F-B8A8-4817-A14A-5C0B3F1E16FE}"/>
+                <a16:creationId xmlns:a16="http://schemas.microsoft.com/office/drawing/2014/main" id="{E6B8F686-BD8F-4482-94A1-E9C603B1FE5D}"/>
               </a:ext>
             </a:extLst>
           </p:cNvPr>
@@ -6085,7 +6060,7 @@
           <p:cNvPr id="2" name="">
             <a:extLst xmlns:a="http://schemas.openxmlformats.org/drawingml/2006/main">
               <a:ext uri="{FF2B5EF4-FFF2-40B4-BE49-F238E27FC236}">
-                <a16:creationId xmlns:a16="http://schemas.microsoft.com/office/drawing/2014/main" id="{B7D5E2B8-C39C-4301-88D0-D6FA56406601}"/>
+                <a16:creationId xmlns:a16="http://schemas.microsoft.com/office/drawing/2014/main" id="{FD470D94-053B-4160-B551-DA469CF16F86}"/>
               </a:ext>
             </a:extLst>
           </p:cNvPr>
@@ -6124,7 +6099,7 @@
           <p:nvPr/>
         </p:nvPicPr>
         <p:blipFill>
-          <a:blip xmlns:r="http://schemas.openxmlformats.org/officeDocument/2006/relationships" xmlns:a="http://schemas.openxmlformats.org/drawingml/2006/main" r:embed="R81fee69794074545"/>
+          <a:blip xmlns:r="http://schemas.openxmlformats.org/officeDocument/2006/relationships" xmlns:a="http://schemas.openxmlformats.org/drawingml/2006/main" r:embed="R4bfd0ad94dfb4a14"/>
           <a:stretch xmlns:a="http://schemas.openxmlformats.org/drawingml/2006/main"/>
         </p:blipFill>
         <p:spPr>
@@ -6142,7 +6117,7 @@
           <p:cNvPr id="4" name="">
             <a:extLst xmlns:a="http://schemas.openxmlformats.org/drawingml/2006/main">
               <a:ext uri="{FF2B5EF4-FFF2-40B4-BE49-F238E27FC236}">
-                <a16:creationId xmlns:a16="http://schemas.microsoft.com/office/drawing/2014/main" id="{B3A76B59-D5C7-4008-A6D5-DE7DD6F99E69}"/>
+                <a16:creationId xmlns:a16="http://schemas.microsoft.com/office/drawing/2014/main" id="{6D79E6D8-DF50-4D38-9D85-31439EC9BDA8}"/>
               </a:ext>
             </a:extLst>
           </p:cNvPr>
@@ -6181,7 +6156,7 @@
           <p:nvPr/>
         </p:nvPicPr>
         <p:blipFill>
-          <a:blip xmlns:r="http://schemas.openxmlformats.org/officeDocument/2006/relationships" xmlns:a="http://schemas.openxmlformats.org/drawingml/2006/main" r:embed="R17926133a3a94ed2"/>
+          <a:blip xmlns:r="http://schemas.openxmlformats.org/officeDocument/2006/relationships" xmlns:a="http://schemas.openxmlformats.org/drawingml/2006/main" r:embed="R527efd4a0e594280"/>
           <a:srcRect xmlns:a="http://schemas.openxmlformats.org/drawingml/2006/main" l="727" t="0" r="727" b="0"/>
           <a:stretch xmlns:a="http://schemas.openxmlformats.org/drawingml/2006/main">
             <a:fillRect l="0" t="0" r="0" b="0"/>
@@ -6202,7 +6177,7 @@
           <p:cNvPr id="6" name="">
             <a:extLst xmlns:a="http://schemas.openxmlformats.org/drawingml/2006/main">
               <a:ext uri="{FF2B5EF4-FFF2-40B4-BE49-F238E27FC236}">
-                <a16:creationId xmlns:a16="http://schemas.microsoft.com/office/drawing/2014/main" id="{82C90912-4FD2-443C-ACA9-AFFA62D7AF34}"/>
+                <a16:creationId xmlns:a16="http://schemas.microsoft.com/office/drawing/2014/main" id="{FA8D604A-331C-4C06-A41A-46795FECF2DA}"/>
               </a:ext>
             </a:extLst>
           </p:cNvPr>
@@ -6258,7 +6233,7 @@
           <p:cNvPr id="7" name="">
             <a:extLst xmlns:a="http://schemas.openxmlformats.org/drawingml/2006/main">
               <a:ext uri="{FF2B5EF4-FFF2-40B4-BE49-F238E27FC236}">
-                <a16:creationId xmlns:a16="http://schemas.microsoft.com/office/drawing/2014/main" id="{F9663E47-5A92-4EBF-A03D-FE65117F4EAA}"/>
+                <a16:creationId xmlns:a16="http://schemas.microsoft.com/office/drawing/2014/main" id="{5B3A689D-E590-4155-A648-B711172D0BC5}"/>
               </a:ext>
             </a:extLst>
           </p:cNvPr>
@@ -6314,23 +6289,23 @@
           <p:cNvPr id="8" name="">
             <a:extLst xmlns:a="http://schemas.openxmlformats.org/drawingml/2006/main">
               <a:ext uri="{FF2B5EF4-FFF2-40B4-BE49-F238E27FC236}">
-                <a16:creationId xmlns:a16="http://schemas.microsoft.com/office/drawing/2014/main" id="{BF7778C7-A43B-4998-BE55-2FE0B855F79E}"/>
-              </a:ext>
-            </a:extLst>
-          </p:cNvPr>
-          <p:cNvSpPr>
-            <a:spLocks xmlns:a="http://schemas.openxmlformats.org/drawingml/2006/main" noGrp="1"/>
-          </p:cNvSpPr>
-          <p:nvPr/>
-        </p:nvSpPr>
-        <p:spPr>
-          <a:xfrm xmlns:a="http://schemas.openxmlformats.org/drawingml/2006/main">
-            <a:off x="7239000" y="5257800"/>
-            <a:ext cx="3905250" cy="476250"/>
+                <a16:creationId xmlns:a16="http://schemas.microsoft.com/office/drawing/2014/main" id="{9B7919CA-7158-4267-94D5-C066465462A2}"/>
+              </a:ext>
+            </a:extLst>
+          </p:cNvPr>
+          <p:cNvSpPr>
+            <a:spLocks xmlns:a="http://schemas.openxmlformats.org/drawingml/2006/main" noGrp="1"/>
+          </p:cNvSpPr>
+          <p:nvPr/>
+        </p:nvSpPr>
+        <p:spPr>
+          <a:xfrm xmlns:a="http://schemas.openxmlformats.org/drawingml/2006/main">
+            <a:off x="7239000" y="5219700"/>
+            <a:ext cx="3905250" cy="590550"/>
           </a:xfrm>
           <a:prstGeom xmlns:a="http://schemas.openxmlformats.org/drawingml/2006/main" prst="roundRect">
             <a:avLst>
-              <a:gd name="adj" fmla="val 24000"/>
+              <a:gd name="adj" fmla="val 19355"/>
             </a:avLst>
           </a:prstGeom>
           <a:solidFill xmlns:a="http://schemas.openxmlformats.org/drawingml/2006/main">
@@ -6347,19 +6322,19 @@
           <p:cNvPr id="9" name="">
             <a:extLst xmlns:a="http://schemas.openxmlformats.org/drawingml/2006/main">
               <a:ext uri="{FF2B5EF4-FFF2-40B4-BE49-F238E27FC236}">
-                <a16:creationId xmlns:a16="http://schemas.microsoft.com/office/drawing/2014/main" id="{8AF75648-2158-4BAE-BB5E-A58AAE0AD40F}"/>
-              </a:ext>
-            </a:extLst>
-          </p:cNvPr>
-          <p:cNvSpPr>
-            <a:spLocks xmlns:a="http://schemas.openxmlformats.org/drawingml/2006/main" noGrp="1"/>
-          </p:cNvSpPr>
-          <p:nvPr/>
-        </p:nvSpPr>
-        <p:spPr>
-          <a:xfrm xmlns:a="http://schemas.openxmlformats.org/drawingml/2006/main">
-            <a:off x="7429500" y="5381625"/>
-            <a:ext cx="3429000" cy="228600"/>
+                <a16:creationId xmlns:a16="http://schemas.microsoft.com/office/drawing/2014/main" id="{FAA3C5C0-EE85-4F94-8952-A80A63E40151}"/>
+              </a:ext>
+            </a:extLst>
+          </p:cNvPr>
+          <p:cNvSpPr>
+            <a:spLocks xmlns:a="http://schemas.openxmlformats.org/drawingml/2006/main" noGrp="1"/>
+          </p:cNvSpPr>
+          <p:nvPr/>
+        </p:nvSpPr>
+        <p:spPr>
+          <a:xfrm xmlns:a="http://schemas.openxmlformats.org/drawingml/2006/main">
+            <a:off x="7467600" y="5314950"/>
+            <a:ext cx="3371850" cy="400050"/>
           </a:xfrm>
           <a:prstGeom xmlns:a="http://schemas.openxmlformats.org/drawingml/2006/main" prst="rect">
             <a:avLst/>
@@ -6375,7 +6350,7 @@
           <a:lstStyle xmlns:a="http://schemas.openxmlformats.org/drawingml/2006/main"/>
           <a:p xmlns:a="http://schemas.openxmlformats.org/drawingml/2006/main">
             <a:pPr>
-              <a:defRPr sz="1125" b="1">
+              <a:defRPr sz="1050" b="1">
                 <a:solidFill>
                   <a:srgbClr val="FFFFFF"/>
                 </a:solidFill>
@@ -6385,7 +6360,7 @@
               </a:defRPr>
             </a:pPr>
             <a:r>
-              <a:rPr sz="1125" b="1">
+              <a:rPr sz="1050" b="1">
                 <a:solidFill>
                   <a:srgbClr val="FFFFFF"/>
                 </a:solidFill>
@@ -6393,9 +6368,32 @@
                 <a:ea typeface="Microsoft YaHei"/>
                 <a:cs typeface="Microsoft YaHei"/>
               </a:rPr>
-              <a:t>WebGL Build：Render / Cloudflare Pages / GitHub Pages</a:t>
+              <a:t>WebGL Build</a:t>
             </a:r>
           </a:p>
+          <a:p xmlns:a="http://schemas.openxmlformats.org/drawingml/2006/main">
+            <a:pPr>
+              <a:defRPr sz="1050" b="1">
+                <a:solidFill>
+                  <a:srgbClr val="FFFFFF"/>
+                </a:solidFill>
+                <a:latin typeface="Microsoft YaHei"/>
+                <a:ea typeface="Microsoft YaHei"/>
+                <a:cs typeface="Microsoft YaHei"/>
+              </a:defRPr>
+            </a:pPr>
+            <a:r>
+              <a:rPr sz="1050" b="1">
+                <a:solidFill>
+                  <a:srgbClr val="FFFFFF"/>
+                </a:solidFill>
+                <a:latin typeface="Microsoft YaHei"/>
+                <a:ea typeface="Microsoft YaHei"/>
+                <a:cs typeface="Microsoft YaHei"/>
+              </a:rPr>
+              <a:t>Render / Cloudflare Pages / GitHub Pages</a:t>
+            </a:r>
+          </a:p>
         </p:txBody>
       </p:sp>
       <p:sp>
@@ -6403,7 +6401,7 @@
           <p:cNvPr id="10" name="">
             <a:extLst xmlns:a="http://schemas.openxmlformats.org/drawingml/2006/main">
               <a:ext uri="{FF2B5EF4-FFF2-40B4-BE49-F238E27FC236}">
-                <a16:creationId xmlns:a16="http://schemas.microsoft.com/office/drawing/2014/main" id="{773E7B2A-BA7F-4767-A2C3-01A67C8102D9}"/>
+                <a16:creationId xmlns:a16="http://schemas.microsoft.com/office/drawing/2014/main" id="{6EEFDB7C-D1A1-4E64-9925-9D7E5D584F28}"/>
               </a:ext>
             </a:extLst>
           </p:cNvPr>
@@ -6459,7 +6457,7 @@
           <p:cNvPr id="11" name="">
             <a:extLst xmlns:a="http://schemas.openxmlformats.org/drawingml/2006/main">
               <a:ext uri="{FF2B5EF4-FFF2-40B4-BE49-F238E27FC236}">
-                <a16:creationId xmlns:a16="http://schemas.microsoft.com/office/drawing/2014/main" id="{D77B568E-8EF7-4B9D-89A7-80BB164320C2}"/>
+                <a16:creationId xmlns:a16="http://schemas.microsoft.com/office/drawing/2014/main" id="{C78AA382-C46F-4C9D-9410-6C91973A4B90}"/>
               </a:ext>
             </a:extLst>
           </p:cNvPr>
@@ -6513,7 +6511,7 @@
     </p:spTree>
     <p:extLst>
       <p:ext uri="{BB962C8B-B14F-4D97-AF65-F5344CB8AC3E}">
-        <p14:creationId xmlns:p14="http://schemas.microsoft.com/office/powerpoint/2010/main" val="1352178607"/>
+        <p14:creationId xmlns:p14="http://schemas.microsoft.com/office/powerpoint/2010/main" val="2137611072"/>
       </p:ext>
     </p:extLst>
   </p:cSld>

</xml_diff>

<commit_message>
Backfill Render playable demo link
</commit_message>
<xml_diff>
--- a/Submission/project_deck.pptx
+++ b/Submission/project_deck.pptx
@@ -2,20 +2,20 @@
 <file path=ppt/presentation.xml><?xml version="1.0" encoding="utf-8"?>
 <p:presentation xmlns:p="http://schemas.openxmlformats.org/presentationml/2006/main">
   <p:sldMasterIdLst>
-    <p:sldMasterId xmlns:r="http://schemas.openxmlformats.org/officeDocument/2006/relationships" id="2147483648" r:id="R613b6414b3c74570"/>
+    <p:sldMasterId xmlns:r="http://schemas.openxmlformats.org/officeDocument/2006/relationships" id="2147483648" r:id="R11f7e7415a674bf8"/>
   </p:sldMasterIdLst>
   <p:notesMasterIdLst>
-    <p:notesMasterId xmlns:r="http://schemas.openxmlformats.org/officeDocument/2006/relationships" r:id="R314a2857da034014"/>
+    <p:notesMasterId xmlns:r="http://schemas.openxmlformats.org/officeDocument/2006/relationships" r:id="R9437b8a525cc4a93"/>
   </p:notesMasterIdLst>
   <p:sldIdLst>
-    <p:sldId xmlns:r="http://schemas.openxmlformats.org/officeDocument/2006/relationships" id="256" r:id="R6c2477715c014785"/>
-    <p:sldId xmlns:r="http://schemas.openxmlformats.org/officeDocument/2006/relationships" id="257" r:id="Rbd7f003110084bba"/>
-    <p:sldId xmlns:r="http://schemas.openxmlformats.org/officeDocument/2006/relationships" id="258" r:id="R145c82726d144410"/>
-    <p:sldId xmlns:r="http://schemas.openxmlformats.org/officeDocument/2006/relationships" id="259" r:id="Rc56b982d2f704932"/>
-    <p:sldId xmlns:r="http://schemas.openxmlformats.org/officeDocument/2006/relationships" id="260" r:id="R63d7360fd3a44737"/>
-    <p:sldId xmlns:r="http://schemas.openxmlformats.org/officeDocument/2006/relationships" id="261" r:id="Raf600e77034d4fb9"/>
-    <p:sldId xmlns:r="http://schemas.openxmlformats.org/officeDocument/2006/relationships" id="262" r:id="R715054c253aa4cd1"/>
-    <p:sldId xmlns:r="http://schemas.openxmlformats.org/officeDocument/2006/relationships" id="263" r:id="R828668ef39734412"/>
+    <p:sldId xmlns:r="http://schemas.openxmlformats.org/officeDocument/2006/relationships" id="256" r:id="R9c3046b5a4ee43e9"/>
+    <p:sldId xmlns:r="http://schemas.openxmlformats.org/officeDocument/2006/relationships" id="257" r:id="Rce51e3941d16445d"/>
+    <p:sldId xmlns:r="http://schemas.openxmlformats.org/officeDocument/2006/relationships" id="258" r:id="Ree13931e152048a2"/>
+    <p:sldId xmlns:r="http://schemas.openxmlformats.org/officeDocument/2006/relationships" id="259" r:id="R8ccd7c510cee471c"/>
+    <p:sldId xmlns:r="http://schemas.openxmlformats.org/officeDocument/2006/relationships" id="260" r:id="R006b94acc36b40e7"/>
+    <p:sldId xmlns:r="http://schemas.openxmlformats.org/officeDocument/2006/relationships" id="261" r:id="Rc0fcb59cb5e34c94"/>
+    <p:sldId xmlns:r="http://schemas.openxmlformats.org/officeDocument/2006/relationships" id="262" r:id="R6e65f49b29594846"/>
+    <p:sldId xmlns:r="http://schemas.openxmlformats.org/officeDocument/2006/relationships" id="263" r:id="Rc43da0ef31b44aa6"/>
   </p:sldIdLst>
   <p:sldSz cx="12192000" cy="6858000"/>
   <p:notesSz cx="6858000" cy="9144000"/>
@@ -1070,7 +1070,7 @@
   </p:cSld>
   <p:clrMap bg1="lt1" tx1="dk1" bg2="lt2" tx2="dk2" accent1="accent1" accent2="accent2" accent3="accent3" accent4="accent4" accent5="accent5" accent6="accent6" hlink="hlink" folHlink="folHlink"/>
   <p:sldLayoutIdLst>
-    <p:sldLayoutId xmlns:r="http://schemas.openxmlformats.org/officeDocument/2006/relationships" id="2147483649" r:id="Ra10a40145b294676"/>
+    <p:sldLayoutId xmlns:r="http://schemas.openxmlformats.org/officeDocument/2006/relationships" id="2147483649" r:id="R4e32ed99fc0a4a6d"/>
   </p:sldLayoutIdLst>
   <p:txStyles>
     <p:titleStyle>
@@ -1625,7 +1625,7 @@
           <p:nvPr/>
         </p:nvPicPr>
         <p:blipFill>
-          <a:blip xmlns:r="http://schemas.openxmlformats.org/officeDocument/2006/relationships" xmlns:a="http://schemas.openxmlformats.org/drawingml/2006/main" r:embed="R8a4d916a8fd74173"/>
+          <a:blip xmlns:r="http://schemas.openxmlformats.org/officeDocument/2006/relationships" xmlns:a="http://schemas.openxmlformats.org/drawingml/2006/main" r:embed="R80756d33f8ac49b7"/>
           <a:srcRect xmlns:a="http://schemas.openxmlformats.org/drawingml/2006/main" l="0" t="0" r="0" b="0"/>
           <a:stretch xmlns:a="http://schemas.openxmlformats.org/drawingml/2006/main">
             <a:fillRect l="0" t="0" r="0" b="0"/>
@@ -1646,7 +1646,7 @@
           <p:cNvPr id="2" name="">
             <a:extLst xmlns:a="http://schemas.openxmlformats.org/drawingml/2006/main">
               <a:ext uri="{FF2B5EF4-FFF2-40B4-BE49-F238E27FC236}">
-                <a16:creationId xmlns:a16="http://schemas.microsoft.com/office/drawing/2014/main" id="{1C94AF7B-3E29-4069-B20C-024ACBD5C0B2}"/>
+                <a16:creationId xmlns:a16="http://schemas.microsoft.com/office/drawing/2014/main" id="{ACB4973B-A197-40AF-8BDA-B3392046695E}"/>
               </a:ext>
             </a:extLst>
           </p:cNvPr>
@@ -1677,7 +1677,7 @@
           <p:cNvPr id="3" name="">
             <a:extLst xmlns:a="http://schemas.openxmlformats.org/drawingml/2006/main">
               <a:ext uri="{FF2B5EF4-FFF2-40B4-BE49-F238E27FC236}">
-                <a16:creationId xmlns:a16="http://schemas.microsoft.com/office/drawing/2014/main" id="{74AB4EBA-F05F-4BD2-8009-DCAA020D5752}"/>
+                <a16:creationId xmlns:a16="http://schemas.microsoft.com/office/drawing/2014/main" id="{6275839F-6F95-4E1E-AC83-E43DD9CDCD7A}"/>
               </a:ext>
             </a:extLst>
           </p:cNvPr>
@@ -1733,7 +1733,7 @@
           <p:cNvPr id="4" name="">
             <a:extLst xmlns:a="http://schemas.openxmlformats.org/drawingml/2006/main">
               <a:ext uri="{FF2B5EF4-FFF2-40B4-BE49-F238E27FC236}">
-                <a16:creationId xmlns:a16="http://schemas.microsoft.com/office/drawing/2014/main" id="{58A7AFD8-02CA-4057-B757-0F61C3F44979}"/>
+                <a16:creationId xmlns:a16="http://schemas.microsoft.com/office/drawing/2014/main" id="{45B3E856-F931-4276-9E64-016B607C91E9}"/>
               </a:ext>
             </a:extLst>
           </p:cNvPr>
@@ -1812,7 +1812,7 @@
           <p:cNvPr id="5" name="">
             <a:extLst xmlns:a="http://schemas.openxmlformats.org/drawingml/2006/main">
               <a:ext uri="{FF2B5EF4-FFF2-40B4-BE49-F238E27FC236}">
-                <a16:creationId xmlns:a16="http://schemas.microsoft.com/office/drawing/2014/main" id="{AD84C8AB-F114-477F-B5DD-6BAD18EE4E12}"/>
+                <a16:creationId xmlns:a16="http://schemas.microsoft.com/office/drawing/2014/main" id="{B05BECAA-7446-4F80-8883-2352F030FD24}"/>
               </a:ext>
             </a:extLst>
           </p:cNvPr>
@@ -1868,7 +1868,7 @@
           <p:cNvPr id="6" name="">
             <a:extLst xmlns:a="http://schemas.openxmlformats.org/drawingml/2006/main">
               <a:ext uri="{FF2B5EF4-FFF2-40B4-BE49-F238E27FC236}">
-                <a16:creationId xmlns:a16="http://schemas.microsoft.com/office/drawing/2014/main" id="{5465BFC9-F955-43E7-9997-62E3CD6636F2}"/>
+                <a16:creationId xmlns:a16="http://schemas.microsoft.com/office/drawing/2014/main" id="{5022FDBC-708F-4C34-B5E6-214A8C96BA56}"/>
               </a:ext>
             </a:extLst>
           </p:cNvPr>
@@ -1924,7 +1924,7 @@
           <p:cNvPr id="7" name="">
             <a:extLst xmlns:a="http://schemas.openxmlformats.org/drawingml/2006/main">
               <a:ext uri="{FF2B5EF4-FFF2-40B4-BE49-F238E27FC236}">
-                <a16:creationId xmlns:a16="http://schemas.microsoft.com/office/drawing/2014/main" id="{5018AC46-DA3B-48ED-ACA4-600708A415EE}"/>
+                <a16:creationId xmlns:a16="http://schemas.microsoft.com/office/drawing/2014/main" id="{FAABDCF0-7F10-4343-B320-B7BE89A738E4}"/>
               </a:ext>
             </a:extLst>
           </p:cNvPr>
@@ -1980,19 +1980,19 @@
           <p:cNvPr id="8" name="">
             <a:extLst xmlns:a="http://schemas.openxmlformats.org/drawingml/2006/main">
               <a:ext uri="{FF2B5EF4-FFF2-40B4-BE49-F238E27FC236}">
-                <a16:creationId xmlns:a16="http://schemas.microsoft.com/office/drawing/2014/main" id="{30C225DE-E866-477E-BE1D-721B2200E207}"/>
-              </a:ext>
-            </a:extLst>
-          </p:cNvPr>
-          <p:cNvSpPr>
-            <a:spLocks xmlns:a="http://schemas.openxmlformats.org/drawingml/2006/main" noGrp="1"/>
-          </p:cNvSpPr>
-          <p:nvPr/>
-        </p:nvSpPr>
-        <p:spPr>
-          <a:xfrm xmlns:a="http://schemas.openxmlformats.org/drawingml/2006/main">
-            <a:off x="590550" y="5867400"/>
-            <a:ext cx="2476500" cy="228600"/>
+                <a16:creationId xmlns:a16="http://schemas.microsoft.com/office/drawing/2014/main" id="{4B67CF1B-A3EB-457B-B584-B860E98DA7AF}"/>
+              </a:ext>
+            </a:extLst>
+          </p:cNvPr>
+          <p:cNvSpPr>
+            <a:spLocks xmlns:a="http://schemas.openxmlformats.org/drawingml/2006/main" noGrp="1"/>
+          </p:cNvSpPr>
+          <p:nvPr/>
+        </p:nvSpPr>
+        <p:spPr>
+          <a:xfrm xmlns:a="http://schemas.openxmlformats.org/drawingml/2006/main">
+            <a:off x="590550" y="5772150"/>
+            <a:ext cx="4000500" cy="438150"/>
           </a:xfrm>
           <a:prstGeom xmlns:a="http://schemas.openxmlformats.org/drawingml/2006/main" prst="rect">
             <a:avLst/>
@@ -2008,7 +2008,7 @@
           <a:lstStyle xmlns:a="http://schemas.openxmlformats.org/drawingml/2006/main"/>
           <a:p xmlns:a="http://schemas.openxmlformats.org/drawingml/2006/main">
             <a:pPr>
-              <a:defRPr sz="1200">
+              <a:defRPr sz="1050" b="1">
                 <a:solidFill>
                   <a:srgbClr val="FFF4E4"/>
                 </a:solidFill>
@@ -2018,7 +2018,7 @@
               </a:defRPr>
             </a:pPr>
             <a:r>
-              <a:rPr sz="1200">
+              <a:rPr sz="1050" b="1">
                 <a:solidFill>
                   <a:srgbClr val="FFF4E4"/>
                 </a:solidFill>
@@ -2026,7 +2026,30 @@
                 <a:ea typeface="Microsoft YaHei"/>
                 <a:cs typeface="Microsoft YaHei"/>
               </a:rPr>
-              <a:t>Demo Link：待回填</a:t>
+              <a:t>Playable Demo:</a:t>
+            </a:r>
+          </a:p>
+          <a:p xmlns:a="http://schemas.openxmlformats.org/drawingml/2006/main">
+            <a:pPr>
+              <a:defRPr sz="1050" b="1">
+                <a:solidFill>
+                  <a:srgbClr val="FFF4E4"/>
+                </a:solidFill>
+                <a:latin typeface="Microsoft YaHei"/>
+                <a:ea typeface="Microsoft YaHei"/>
+                <a:cs typeface="Microsoft YaHei"/>
+              </a:defRPr>
+            </a:pPr>
+            <a:r>
+              <a:rPr sz="1050" b="1">
+                <a:solidFill>
+                  <a:srgbClr val="FFF4E4"/>
+                </a:solidFill>
+                <a:latin typeface="Microsoft YaHei"/>
+                <a:ea typeface="Microsoft YaHei"/>
+                <a:cs typeface="Microsoft YaHei"/>
+              </a:rPr>
+              <a:t>craftsmen-and-homo-sapiens.onrender.com</a:t>
             </a:r>
           </a:p>
         </p:txBody>
@@ -2034,7 +2057,7 @@
     </p:spTree>
     <p:extLst>
       <p:ext uri="{BB962C8B-B14F-4D97-AF65-F5344CB8AC3E}">
-        <p14:creationId xmlns:p14="http://schemas.microsoft.com/office/powerpoint/2010/main" val="148495535"/>
+        <p14:creationId xmlns:p14="http://schemas.microsoft.com/office/powerpoint/2010/main" val="1295013269"/>
       </p:ext>
     </p:extLst>
   </p:cSld>
@@ -2065,7 +2088,7 @@
           <p:cNvPr id="1" name="">
             <a:extLst xmlns:a="http://schemas.openxmlformats.org/drawingml/2006/main">
               <a:ext uri="{FF2B5EF4-FFF2-40B4-BE49-F238E27FC236}">
-                <a16:creationId xmlns:a16="http://schemas.microsoft.com/office/drawing/2014/main" id="{B5887435-D742-4DDD-AA55-BB8BE705D399}"/>
+                <a16:creationId xmlns:a16="http://schemas.microsoft.com/office/drawing/2014/main" id="{2D00585A-6A63-4CBE-9692-C65466543452}"/>
               </a:ext>
             </a:extLst>
           </p:cNvPr>
@@ -2121,7 +2144,7 @@
           <p:cNvPr id="2" name="">
             <a:extLst xmlns:a="http://schemas.openxmlformats.org/drawingml/2006/main">
               <a:ext uri="{FF2B5EF4-FFF2-40B4-BE49-F238E27FC236}">
-                <a16:creationId xmlns:a16="http://schemas.microsoft.com/office/drawing/2014/main" id="{B8D5C7EF-F930-4DF9-9CDE-A2C10A822BC2}"/>
+                <a16:creationId xmlns:a16="http://schemas.microsoft.com/office/drawing/2014/main" id="{18463540-2DEF-48B4-B0E1-9263AC8DD40E}"/>
               </a:ext>
             </a:extLst>
           </p:cNvPr>
@@ -2181,7 +2204,7 @@
           <p:nvPr/>
         </p:nvPicPr>
         <p:blipFill>
-          <a:blip xmlns:r="http://schemas.openxmlformats.org/officeDocument/2006/relationships" xmlns:a="http://schemas.openxmlformats.org/drawingml/2006/main" r:embed="R12a7de920e474284"/>
+          <a:blip xmlns:r="http://schemas.openxmlformats.org/officeDocument/2006/relationships" xmlns:a="http://schemas.openxmlformats.org/drawingml/2006/main" r:embed="R5639d0757e494626"/>
           <a:srcRect xmlns:a="http://schemas.openxmlformats.org/drawingml/2006/main" l="7019" t="0" r="7019" b="0"/>
           <a:stretch xmlns:a="http://schemas.openxmlformats.org/drawingml/2006/main">
             <a:fillRect l="0" t="0" r="0" b="0"/>
@@ -2202,7 +2225,7 @@
           <p:cNvPr id="4" name="">
             <a:extLst xmlns:a="http://schemas.openxmlformats.org/drawingml/2006/main">
               <a:ext uri="{FF2B5EF4-FFF2-40B4-BE49-F238E27FC236}">
-                <a16:creationId xmlns:a16="http://schemas.microsoft.com/office/drawing/2014/main" id="{4F0E298D-DF42-4DFB-88EC-89534B8E9903}"/>
+                <a16:creationId xmlns:a16="http://schemas.microsoft.com/office/drawing/2014/main" id="{158DAB1E-ED97-48AA-B416-2440E11F4CB8}"/>
               </a:ext>
             </a:extLst>
           </p:cNvPr>
@@ -2237,7 +2260,7 @@
           <p:cNvPr id="5" name="">
             <a:extLst xmlns:a="http://schemas.openxmlformats.org/drawingml/2006/main">
               <a:ext uri="{FF2B5EF4-FFF2-40B4-BE49-F238E27FC236}">
-                <a16:creationId xmlns:a16="http://schemas.microsoft.com/office/drawing/2014/main" id="{D35911E7-BF6E-4367-B559-9B94A8ED4067}"/>
+                <a16:creationId xmlns:a16="http://schemas.microsoft.com/office/drawing/2014/main" id="{8391AD53-662B-4075-8561-DC0A2B121350}"/>
               </a:ext>
             </a:extLst>
           </p:cNvPr>
@@ -2272,7 +2295,7 @@
           <p:cNvPr id="6" name="">
             <a:extLst xmlns:a="http://schemas.openxmlformats.org/drawingml/2006/main">
               <a:ext uri="{FF2B5EF4-FFF2-40B4-BE49-F238E27FC236}">
-                <a16:creationId xmlns:a16="http://schemas.microsoft.com/office/drawing/2014/main" id="{540DDFCB-2B49-436A-8110-0D3FAB2E6A40}"/>
+                <a16:creationId xmlns:a16="http://schemas.microsoft.com/office/drawing/2014/main" id="{F8B561F5-627D-4680-9A6B-6A8483E0B83A}"/>
               </a:ext>
             </a:extLst>
           </p:cNvPr>
@@ -2303,7 +2326,7 @@
           <p:cNvPr id="7" name="">
             <a:extLst xmlns:a="http://schemas.openxmlformats.org/drawingml/2006/main">
               <a:ext uri="{FF2B5EF4-FFF2-40B4-BE49-F238E27FC236}">
-                <a16:creationId xmlns:a16="http://schemas.microsoft.com/office/drawing/2014/main" id="{14D84A08-8398-499A-A0D1-030247EC5DD6}"/>
+                <a16:creationId xmlns:a16="http://schemas.microsoft.com/office/drawing/2014/main" id="{2C65242F-911F-4347-9CDA-3DB721B7F72E}"/>
               </a:ext>
             </a:extLst>
           </p:cNvPr>
@@ -2359,7 +2382,7 @@
           <p:cNvPr id="8" name="">
             <a:extLst xmlns:a="http://schemas.openxmlformats.org/drawingml/2006/main">
               <a:ext uri="{FF2B5EF4-FFF2-40B4-BE49-F238E27FC236}">
-                <a16:creationId xmlns:a16="http://schemas.microsoft.com/office/drawing/2014/main" id="{5ABB1C58-7AC9-4189-88C2-7DCEC5EB18FD}"/>
+                <a16:creationId xmlns:a16="http://schemas.microsoft.com/office/drawing/2014/main" id="{DEDEA3BB-0FA3-4783-9FDC-0BDC6407F979}"/>
               </a:ext>
             </a:extLst>
           </p:cNvPr>
@@ -2415,7 +2438,7 @@
           <p:cNvPr id="9" name="">
             <a:extLst xmlns:a="http://schemas.openxmlformats.org/drawingml/2006/main">
               <a:ext uri="{FF2B5EF4-FFF2-40B4-BE49-F238E27FC236}">
-                <a16:creationId xmlns:a16="http://schemas.microsoft.com/office/drawing/2014/main" id="{E0DDDD5A-0E0D-464C-8DC9-6124173B2A4D}"/>
+                <a16:creationId xmlns:a16="http://schemas.microsoft.com/office/drawing/2014/main" id="{232D9847-E4B0-470A-A204-666F471EF88D}"/>
               </a:ext>
             </a:extLst>
           </p:cNvPr>
@@ -2450,7 +2473,7 @@
           <p:cNvPr id="10" name="">
             <a:extLst xmlns:a="http://schemas.openxmlformats.org/drawingml/2006/main">
               <a:ext uri="{FF2B5EF4-FFF2-40B4-BE49-F238E27FC236}">
-                <a16:creationId xmlns:a16="http://schemas.microsoft.com/office/drawing/2014/main" id="{463FACF9-D031-4AA4-909E-31AD2EE2D9B4}"/>
+                <a16:creationId xmlns:a16="http://schemas.microsoft.com/office/drawing/2014/main" id="{9F88DC8C-C8BC-4797-B81B-7E6223CC710D}"/>
               </a:ext>
             </a:extLst>
           </p:cNvPr>
@@ -2481,7 +2504,7 @@
           <p:cNvPr id="11" name="">
             <a:extLst xmlns:a="http://schemas.openxmlformats.org/drawingml/2006/main">
               <a:ext uri="{FF2B5EF4-FFF2-40B4-BE49-F238E27FC236}">
-                <a16:creationId xmlns:a16="http://schemas.microsoft.com/office/drawing/2014/main" id="{E10A74EF-02B5-4E7A-97E4-638B4127027E}"/>
+                <a16:creationId xmlns:a16="http://schemas.microsoft.com/office/drawing/2014/main" id="{3ACFBF1A-AE00-498C-895F-5A6BD52DB44F}"/>
               </a:ext>
             </a:extLst>
           </p:cNvPr>
@@ -2537,7 +2560,7 @@
           <p:cNvPr id="12" name="">
             <a:extLst xmlns:a="http://schemas.openxmlformats.org/drawingml/2006/main">
               <a:ext uri="{FF2B5EF4-FFF2-40B4-BE49-F238E27FC236}">
-                <a16:creationId xmlns:a16="http://schemas.microsoft.com/office/drawing/2014/main" id="{2A9D2863-62CE-4660-A641-8ECC5C37262C}"/>
+                <a16:creationId xmlns:a16="http://schemas.microsoft.com/office/drawing/2014/main" id="{E9F0C83D-A4EC-4E5B-ADFC-42F8974DEA8B}"/>
               </a:ext>
             </a:extLst>
           </p:cNvPr>
@@ -2593,7 +2616,7 @@
           <p:cNvPr id="13" name="">
             <a:extLst xmlns:a="http://schemas.openxmlformats.org/drawingml/2006/main">
               <a:ext uri="{FF2B5EF4-FFF2-40B4-BE49-F238E27FC236}">
-                <a16:creationId xmlns:a16="http://schemas.microsoft.com/office/drawing/2014/main" id="{8BE4BBB1-E87A-400D-B3D0-64F6FB0CE679}"/>
+                <a16:creationId xmlns:a16="http://schemas.microsoft.com/office/drawing/2014/main" id="{9CEE196A-7B34-4E94-87F9-89746D00B553}"/>
               </a:ext>
             </a:extLst>
           </p:cNvPr>
@@ -2628,7 +2651,7 @@
           <p:cNvPr id="14" name="">
             <a:extLst xmlns:a="http://schemas.openxmlformats.org/drawingml/2006/main">
               <a:ext uri="{FF2B5EF4-FFF2-40B4-BE49-F238E27FC236}">
-                <a16:creationId xmlns:a16="http://schemas.microsoft.com/office/drawing/2014/main" id="{6BBAB347-915A-4F50-9834-0EF68A80E4E0}"/>
+                <a16:creationId xmlns:a16="http://schemas.microsoft.com/office/drawing/2014/main" id="{E869D404-D81A-465A-B35C-200EAF5FEF80}"/>
               </a:ext>
             </a:extLst>
           </p:cNvPr>
@@ -2659,7 +2682,7 @@
           <p:cNvPr id="15" name="">
             <a:extLst xmlns:a="http://schemas.openxmlformats.org/drawingml/2006/main">
               <a:ext uri="{FF2B5EF4-FFF2-40B4-BE49-F238E27FC236}">
-                <a16:creationId xmlns:a16="http://schemas.microsoft.com/office/drawing/2014/main" id="{2BFAD90F-7B47-46A2-8FB0-9AC7BBAB328C}"/>
+                <a16:creationId xmlns:a16="http://schemas.microsoft.com/office/drawing/2014/main" id="{4E98F46D-B540-469C-B67C-0459899695D3}"/>
               </a:ext>
             </a:extLst>
           </p:cNvPr>
@@ -2715,7 +2738,7 @@
           <p:cNvPr id="16" name="">
             <a:extLst xmlns:a="http://schemas.openxmlformats.org/drawingml/2006/main">
               <a:ext uri="{FF2B5EF4-FFF2-40B4-BE49-F238E27FC236}">
-                <a16:creationId xmlns:a16="http://schemas.microsoft.com/office/drawing/2014/main" id="{D4CA68C8-245B-4705-8D45-7572F611DF85}"/>
+                <a16:creationId xmlns:a16="http://schemas.microsoft.com/office/drawing/2014/main" id="{EECFC578-9563-4AEC-BCB5-218615C913C1}"/>
               </a:ext>
             </a:extLst>
           </p:cNvPr>
@@ -2771,7 +2794,7 @@
           <p:cNvPr id="17" name="">
             <a:extLst xmlns:a="http://schemas.openxmlformats.org/drawingml/2006/main">
               <a:ext uri="{FF2B5EF4-FFF2-40B4-BE49-F238E27FC236}">
-                <a16:creationId xmlns:a16="http://schemas.microsoft.com/office/drawing/2014/main" id="{91F681BF-F984-44F2-B2E5-CF5F319F6175}"/>
+                <a16:creationId xmlns:a16="http://schemas.microsoft.com/office/drawing/2014/main" id="{D69DDAFD-4EA0-4774-B66F-A7F33B6B4B3C}"/>
               </a:ext>
             </a:extLst>
           </p:cNvPr>
@@ -2827,7 +2850,7 @@
           <p:cNvPr id="18" name="">
             <a:extLst xmlns:a="http://schemas.openxmlformats.org/drawingml/2006/main">
               <a:ext uri="{FF2B5EF4-FFF2-40B4-BE49-F238E27FC236}">
-                <a16:creationId xmlns:a16="http://schemas.microsoft.com/office/drawing/2014/main" id="{140BD1CA-AC9F-46F1-8096-BCB08FCFD8B8}"/>
+                <a16:creationId xmlns:a16="http://schemas.microsoft.com/office/drawing/2014/main" id="{25FEC3B4-8A04-4663-9D3B-1CDCC7638B7E}"/>
               </a:ext>
             </a:extLst>
           </p:cNvPr>
@@ -2881,7 +2904,7 @@
     </p:spTree>
     <p:extLst>
       <p:ext uri="{BB962C8B-B14F-4D97-AF65-F5344CB8AC3E}">
-        <p14:creationId xmlns:p14="http://schemas.microsoft.com/office/powerpoint/2010/main" val="1727576200"/>
+        <p14:creationId xmlns:p14="http://schemas.microsoft.com/office/powerpoint/2010/main" val="121540185"/>
       </p:ext>
     </p:extLst>
   </p:cSld>
@@ -2916,7 +2939,7 @@
           <p:nvPr/>
         </p:nvPicPr>
         <p:blipFill>
-          <a:blip xmlns:r="http://schemas.openxmlformats.org/officeDocument/2006/relationships" xmlns:a="http://schemas.openxmlformats.org/drawingml/2006/main" r:embed="Rcbc5782dc74a43db"/>
+          <a:blip xmlns:r="http://schemas.openxmlformats.org/officeDocument/2006/relationships" xmlns:a="http://schemas.openxmlformats.org/drawingml/2006/main" r:embed="Rf86658e2834b40b7"/>
           <a:srcRect xmlns:a="http://schemas.openxmlformats.org/drawingml/2006/main" l="8984" t="0" r="8984" b="0"/>
           <a:stretch xmlns:a="http://schemas.openxmlformats.org/drawingml/2006/main">
             <a:fillRect l="0" t="0" r="0" b="0"/>
@@ -2937,7 +2960,7 @@
           <p:cNvPr id="2" name="">
             <a:extLst xmlns:a="http://schemas.openxmlformats.org/drawingml/2006/main">
               <a:ext uri="{FF2B5EF4-FFF2-40B4-BE49-F238E27FC236}">
-                <a16:creationId xmlns:a16="http://schemas.microsoft.com/office/drawing/2014/main" id="{9CAB9FE8-7600-4328-BDA1-D4128B354D37}"/>
+                <a16:creationId xmlns:a16="http://schemas.microsoft.com/office/drawing/2014/main" id="{A548245B-2377-46C1-8159-4F15504FBAAE}"/>
               </a:ext>
             </a:extLst>
           </p:cNvPr>
@@ -2993,7 +3016,7 @@
           <p:cNvPr id="3" name="">
             <a:extLst xmlns:a="http://schemas.openxmlformats.org/drawingml/2006/main">
               <a:ext uri="{FF2B5EF4-FFF2-40B4-BE49-F238E27FC236}">
-                <a16:creationId xmlns:a16="http://schemas.microsoft.com/office/drawing/2014/main" id="{09BA7243-ACE9-489C-88BA-2910686AFC80}"/>
+                <a16:creationId xmlns:a16="http://schemas.microsoft.com/office/drawing/2014/main" id="{774A762C-EBB3-4793-8C87-02E7A6AF40A5}"/>
               </a:ext>
             </a:extLst>
           </p:cNvPr>
@@ -3049,7 +3072,7 @@
           <p:cNvPr id="4" name="">
             <a:extLst xmlns:a="http://schemas.openxmlformats.org/drawingml/2006/main">
               <a:ext uri="{FF2B5EF4-FFF2-40B4-BE49-F238E27FC236}">
-                <a16:creationId xmlns:a16="http://schemas.microsoft.com/office/drawing/2014/main" id="{38126B00-6BE9-4AE4-AA67-7149099935AB}"/>
+                <a16:creationId xmlns:a16="http://schemas.microsoft.com/office/drawing/2014/main" id="{185F32FA-BFB6-4276-9A45-512C67210E1E}"/>
               </a:ext>
             </a:extLst>
           </p:cNvPr>
@@ -3080,7 +3103,7 @@
           <p:cNvPr id="5" name="">
             <a:extLst xmlns:a="http://schemas.openxmlformats.org/drawingml/2006/main">
               <a:ext uri="{FF2B5EF4-FFF2-40B4-BE49-F238E27FC236}">
-                <a16:creationId xmlns:a16="http://schemas.microsoft.com/office/drawing/2014/main" id="{C50A7E87-E0ED-48CD-9178-785D12D1BF46}"/>
+                <a16:creationId xmlns:a16="http://schemas.microsoft.com/office/drawing/2014/main" id="{DDC8EB84-572C-4A36-A91C-6C0C79B2671D}"/>
               </a:ext>
             </a:extLst>
           </p:cNvPr>
@@ -3136,7 +3159,7 @@
           <p:cNvPr id="6" name="">
             <a:extLst xmlns:a="http://schemas.openxmlformats.org/drawingml/2006/main">
               <a:ext uri="{FF2B5EF4-FFF2-40B4-BE49-F238E27FC236}">
-                <a16:creationId xmlns:a16="http://schemas.microsoft.com/office/drawing/2014/main" id="{9B6CFB19-CC80-4604-B2E0-F8F27F55497A}"/>
+                <a16:creationId xmlns:a16="http://schemas.microsoft.com/office/drawing/2014/main" id="{4E10A7C2-9584-4E5D-A989-2FDF4975936D}"/>
               </a:ext>
             </a:extLst>
           </p:cNvPr>
@@ -3167,7 +3190,7 @@
           <p:cNvPr id="7" name="">
             <a:extLst xmlns:a="http://schemas.openxmlformats.org/drawingml/2006/main">
               <a:ext uri="{FF2B5EF4-FFF2-40B4-BE49-F238E27FC236}">
-                <a16:creationId xmlns:a16="http://schemas.microsoft.com/office/drawing/2014/main" id="{D45FB60F-5595-4108-A27A-16C2E6626811}"/>
+                <a16:creationId xmlns:a16="http://schemas.microsoft.com/office/drawing/2014/main" id="{55BADF2D-0FFD-4D50-AC87-408EC3D5ADDD}"/>
               </a:ext>
             </a:extLst>
           </p:cNvPr>
@@ -3223,7 +3246,7 @@
           <p:cNvPr id="8" name="">
             <a:extLst xmlns:a="http://schemas.openxmlformats.org/drawingml/2006/main">
               <a:ext uri="{FF2B5EF4-FFF2-40B4-BE49-F238E27FC236}">
-                <a16:creationId xmlns:a16="http://schemas.microsoft.com/office/drawing/2014/main" id="{73C5B8B9-BD55-48DD-A894-D780780863BA}"/>
+                <a16:creationId xmlns:a16="http://schemas.microsoft.com/office/drawing/2014/main" id="{BCE43F45-3151-4D7A-9E0B-4CC5F9DD271C}"/>
               </a:ext>
             </a:extLst>
           </p:cNvPr>
@@ -3254,7 +3277,7 @@
           <p:cNvPr id="9" name="">
             <a:extLst xmlns:a="http://schemas.openxmlformats.org/drawingml/2006/main">
               <a:ext uri="{FF2B5EF4-FFF2-40B4-BE49-F238E27FC236}">
-                <a16:creationId xmlns:a16="http://schemas.microsoft.com/office/drawing/2014/main" id="{BB3D71E2-C758-44EC-8111-9047C6358983}"/>
+                <a16:creationId xmlns:a16="http://schemas.microsoft.com/office/drawing/2014/main" id="{E6A80A2F-22B4-4E93-A476-45F49B1D629C}"/>
               </a:ext>
             </a:extLst>
           </p:cNvPr>
@@ -3310,7 +3333,7 @@
           <p:cNvPr id="10" name="">
             <a:extLst xmlns:a="http://schemas.openxmlformats.org/drawingml/2006/main">
               <a:ext uri="{FF2B5EF4-FFF2-40B4-BE49-F238E27FC236}">
-                <a16:creationId xmlns:a16="http://schemas.microsoft.com/office/drawing/2014/main" id="{A261C820-FAA5-4148-A2D1-E8513D66C445}"/>
+                <a16:creationId xmlns:a16="http://schemas.microsoft.com/office/drawing/2014/main" id="{7BAA901D-ED59-4604-B35F-A7E004A28436}"/>
               </a:ext>
             </a:extLst>
           </p:cNvPr>
@@ -3366,7 +3389,7 @@
           <p:cNvPr id="11" name="">
             <a:extLst xmlns:a="http://schemas.openxmlformats.org/drawingml/2006/main">
               <a:ext uri="{FF2B5EF4-FFF2-40B4-BE49-F238E27FC236}">
-                <a16:creationId xmlns:a16="http://schemas.microsoft.com/office/drawing/2014/main" id="{EC89D22D-F04B-48F8-BE50-56FEAB2B691C}"/>
+                <a16:creationId xmlns:a16="http://schemas.microsoft.com/office/drawing/2014/main" id="{4249248B-AAC0-4674-8284-6E2EE171E477}"/>
               </a:ext>
             </a:extLst>
           </p:cNvPr>
@@ -3420,7 +3443,7 @@
     </p:spTree>
     <p:extLst>
       <p:ext uri="{BB962C8B-B14F-4D97-AF65-F5344CB8AC3E}">
-        <p14:creationId xmlns:p14="http://schemas.microsoft.com/office/powerpoint/2010/main" val="1170270807"/>
+        <p14:creationId xmlns:p14="http://schemas.microsoft.com/office/powerpoint/2010/main" val="552404181"/>
       </p:ext>
     </p:extLst>
   </p:cSld>
@@ -3451,7 +3474,7 @@
           <p:cNvPr id="1" name="">
             <a:extLst xmlns:a="http://schemas.openxmlformats.org/drawingml/2006/main">
               <a:ext uri="{FF2B5EF4-FFF2-40B4-BE49-F238E27FC236}">
-                <a16:creationId xmlns:a16="http://schemas.microsoft.com/office/drawing/2014/main" id="{AE424BD5-1054-41B5-8882-17A193623AE9}"/>
+                <a16:creationId xmlns:a16="http://schemas.microsoft.com/office/drawing/2014/main" id="{D06BB697-9AC8-49D3-B33E-346EB9C1140E}"/>
               </a:ext>
             </a:extLst>
           </p:cNvPr>
@@ -3507,7 +3530,7 @@
           <p:cNvPr id="2" name="">
             <a:extLst xmlns:a="http://schemas.openxmlformats.org/drawingml/2006/main">
               <a:ext uri="{FF2B5EF4-FFF2-40B4-BE49-F238E27FC236}">
-                <a16:creationId xmlns:a16="http://schemas.microsoft.com/office/drawing/2014/main" id="{720C2D26-CF52-4AAA-A547-DF359E8AB695}"/>
+                <a16:creationId xmlns:a16="http://schemas.microsoft.com/office/drawing/2014/main" id="{D736178E-AA02-4A15-AE2B-606D4CEE15DF}"/>
               </a:ext>
             </a:extLst>
           </p:cNvPr>
@@ -3567,7 +3590,7 @@
           <p:nvPr/>
         </p:nvPicPr>
         <p:blipFill>
-          <a:blip xmlns:r="http://schemas.openxmlformats.org/officeDocument/2006/relationships" xmlns:a="http://schemas.openxmlformats.org/drawingml/2006/main" r:embed="R5185ec0c12134531"/>
+          <a:blip xmlns:r="http://schemas.openxmlformats.org/officeDocument/2006/relationships" xmlns:a="http://schemas.openxmlformats.org/drawingml/2006/main" r:embed="Rfe76f11e790440c2"/>
           <a:srcRect xmlns:a="http://schemas.openxmlformats.org/drawingml/2006/main" l="291" t="0" r="291" b="0"/>
           <a:stretch xmlns:a="http://schemas.openxmlformats.org/drawingml/2006/main">
             <a:fillRect l="0" t="0" r="0" b="0"/>
@@ -3588,7 +3611,7 @@
           <p:cNvPr id="4" name="">
             <a:extLst xmlns:a="http://schemas.openxmlformats.org/drawingml/2006/main">
               <a:ext uri="{FF2B5EF4-FFF2-40B4-BE49-F238E27FC236}">
-                <a16:creationId xmlns:a16="http://schemas.microsoft.com/office/drawing/2014/main" id="{9C9F0665-8FA3-4DEA-A7BB-01D4F559A26C}"/>
+                <a16:creationId xmlns:a16="http://schemas.microsoft.com/office/drawing/2014/main" id="{697D454A-41DA-415A-AE94-362E5F3B6C0A}"/>
               </a:ext>
             </a:extLst>
           </p:cNvPr>
@@ -3623,7 +3646,7 @@
           <p:cNvPr id="5" name="">
             <a:extLst xmlns:a="http://schemas.openxmlformats.org/drawingml/2006/main">
               <a:ext uri="{FF2B5EF4-FFF2-40B4-BE49-F238E27FC236}">
-                <a16:creationId xmlns:a16="http://schemas.microsoft.com/office/drawing/2014/main" id="{0014219B-AB2A-44F1-A766-EC0899733AE3}"/>
+                <a16:creationId xmlns:a16="http://schemas.microsoft.com/office/drawing/2014/main" id="{BB8E3941-28FA-4436-94C0-3AEC4B90E42E}"/>
               </a:ext>
             </a:extLst>
           </p:cNvPr>
@@ -3679,7 +3702,7 @@
           <p:cNvPr id="6" name="">
             <a:extLst xmlns:a="http://schemas.openxmlformats.org/drawingml/2006/main">
               <a:ext uri="{FF2B5EF4-FFF2-40B4-BE49-F238E27FC236}">
-                <a16:creationId xmlns:a16="http://schemas.microsoft.com/office/drawing/2014/main" id="{FB091545-1F6E-43EE-95AF-98CD2634B9AE}"/>
+                <a16:creationId xmlns:a16="http://schemas.microsoft.com/office/drawing/2014/main" id="{F0931545-D8E5-4BDF-BE2A-270BC077B190}"/>
               </a:ext>
             </a:extLst>
           </p:cNvPr>
@@ -3710,7 +3733,7 @@
           <p:cNvPr id="7" name="">
             <a:extLst xmlns:a="http://schemas.openxmlformats.org/drawingml/2006/main">
               <a:ext uri="{FF2B5EF4-FFF2-40B4-BE49-F238E27FC236}">
-                <a16:creationId xmlns:a16="http://schemas.microsoft.com/office/drawing/2014/main" id="{1D35CEAA-101F-4044-954D-C653FA6D1C07}"/>
+                <a16:creationId xmlns:a16="http://schemas.microsoft.com/office/drawing/2014/main" id="{088D6C2D-7EBB-43AB-9DB1-367F36913F75}"/>
               </a:ext>
             </a:extLst>
           </p:cNvPr>
@@ -3766,7 +3789,7 @@
           <p:cNvPr id="8" name="">
             <a:extLst xmlns:a="http://schemas.openxmlformats.org/drawingml/2006/main">
               <a:ext uri="{FF2B5EF4-FFF2-40B4-BE49-F238E27FC236}">
-                <a16:creationId xmlns:a16="http://schemas.microsoft.com/office/drawing/2014/main" id="{8F474D2E-69A4-408E-BC74-D6B98E7AAE9A}"/>
+                <a16:creationId xmlns:a16="http://schemas.microsoft.com/office/drawing/2014/main" id="{8D55F739-108B-4312-83B6-5698810B4F12}"/>
               </a:ext>
             </a:extLst>
           </p:cNvPr>
@@ -3797,7 +3820,7 @@
           <p:cNvPr id="9" name="">
             <a:extLst xmlns:a="http://schemas.openxmlformats.org/drawingml/2006/main">
               <a:ext uri="{FF2B5EF4-FFF2-40B4-BE49-F238E27FC236}">
-                <a16:creationId xmlns:a16="http://schemas.microsoft.com/office/drawing/2014/main" id="{732B8EEE-FADB-4A51-AE7D-FB86418C0EFC}"/>
+                <a16:creationId xmlns:a16="http://schemas.microsoft.com/office/drawing/2014/main" id="{233BA7D3-574E-49D0-A8FE-28FEAD9A1B3C}"/>
               </a:ext>
             </a:extLst>
           </p:cNvPr>
@@ -3853,7 +3876,7 @@
           <p:cNvPr id="10" name="">
             <a:extLst xmlns:a="http://schemas.openxmlformats.org/drawingml/2006/main">
               <a:ext uri="{FF2B5EF4-FFF2-40B4-BE49-F238E27FC236}">
-                <a16:creationId xmlns:a16="http://schemas.microsoft.com/office/drawing/2014/main" id="{EDE18C21-D341-48A0-8B67-AD0AC0F54340}"/>
+                <a16:creationId xmlns:a16="http://schemas.microsoft.com/office/drawing/2014/main" id="{B329CCC7-E7C3-4453-8562-8E2FA26C6736}"/>
               </a:ext>
             </a:extLst>
           </p:cNvPr>
@@ -3884,7 +3907,7 @@
           <p:cNvPr id="11" name="">
             <a:extLst xmlns:a="http://schemas.openxmlformats.org/drawingml/2006/main">
               <a:ext uri="{FF2B5EF4-FFF2-40B4-BE49-F238E27FC236}">
-                <a16:creationId xmlns:a16="http://schemas.microsoft.com/office/drawing/2014/main" id="{939D9929-B2F5-4648-B159-1B1F489DF44C}"/>
+                <a16:creationId xmlns:a16="http://schemas.microsoft.com/office/drawing/2014/main" id="{5557D86C-E70F-47FC-86E2-D7C30AF3EDEA}"/>
               </a:ext>
             </a:extLst>
           </p:cNvPr>
@@ -3940,7 +3963,7 @@
           <p:cNvPr id="12" name="">
             <a:extLst xmlns:a="http://schemas.openxmlformats.org/drawingml/2006/main">
               <a:ext uri="{FF2B5EF4-FFF2-40B4-BE49-F238E27FC236}">
-                <a16:creationId xmlns:a16="http://schemas.microsoft.com/office/drawing/2014/main" id="{42E8599B-FA7F-4834-81FA-EE450B8F430E}"/>
+                <a16:creationId xmlns:a16="http://schemas.microsoft.com/office/drawing/2014/main" id="{8B4AB1B7-AD2D-4B12-BB09-58E6CB490B61}"/>
               </a:ext>
             </a:extLst>
           </p:cNvPr>
@@ -3971,7 +3994,7 @@
           <p:cNvPr id="13" name="">
             <a:extLst xmlns:a="http://schemas.openxmlformats.org/drawingml/2006/main">
               <a:ext uri="{FF2B5EF4-FFF2-40B4-BE49-F238E27FC236}">
-                <a16:creationId xmlns:a16="http://schemas.microsoft.com/office/drawing/2014/main" id="{D5EFAF3F-1FB3-405F-813D-F610D3FCBBA1}"/>
+                <a16:creationId xmlns:a16="http://schemas.microsoft.com/office/drawing/2014/main" id="{B0C6907E-E8FD-44F0-95A8-85A7A5D65B0B}"/>
               </a:ext>
             </a:extLst>
           </p:cNvPr>
@@ -4027,7 +4050,7 @@
           <p:cNvPr id="14" name="">
             <a:extLst xmlns:a="http://schemas.openxmlformats.org/drawingml/2006/main">
               <a:ext uri="{FF2B5EF4-FFF2-40B4-BE49-F238E27FC236}">
-                <a16:creationId xmlns:a16="http://schemas.microsoft.com/office/drawing/2014/main" id="{571051B1-A7CE-46F8-87A8-7E47F3534EC9}"/>
+                <a16:creationId xmlns:a16="http://schemas.microsoft.com/office/drawing/2014/main" id="{E2027AB4-6327-4C64-8972-28D0ECFFCFAB}"/>
               </a:ext>
             </a:extLst>
           </p:cNvPr>
@@ -4083,7 +4106,7 @@
           <p:cNvPr id="15" name="">
             <a:extLst xmlns:a="http://schemas.openxmlformats.org/drawingml/2006/main">
               <a:ext uri="{FF2B5EF4-FFF2-40B4-BE49-F238E27FC236}">
-                <a16:creationId xmlns:a16="http://schemas.microsoft.com/office/drawing/2014/main" id="{0FE3E49D-6D18-4EE0-A585-73AD789E7870}"/>
+                <a16:creationId xmlns:a16="http://schemas.microsoft.com/office/drawing/2014/main" id="{19057A7A-7281-4602-B271-33E303890039}"/>
               </a:ext>
             </a:extLst>
           </p:cNvPr>
@@ -4137,7 +4160,7 @@
     </p:spTree>
     <p:extLst>
       <p:ext uri="{BB962C8B-B14F-4D97-AF65-F5344CB8AC3E}">
-        <p14:creationId xmlns:p14="http://schemas.microsoft.com/office/powerpoint/2010/main" val="1738772104"/>
+        <p14:creationId xmlns:p14="http://schemas.microsoft.com/office/powerpoint/2010/main" val="526538865"/>
       </p:ext>
     </p:extLst>
   </p:cSld>
@@ -4168,7 +4191,7 @@
           <p:cNvPr id="1" name="">
             <a:extLst xmlns:a="http://schemas.openxmlformats.org/drawingml/2006/main">
               <a:ext uri="{FF2B5EF4-FFF2-40B4-BE49-F238E27FC236}">
-                <a16:creationId xmlns:a16="http://schemas.microsoft.com/office/drawing/2014/main" id="{12FEF7C3-D3CE-4AB9-B5AC-CF2C9FDDF522}"/>
+                <a16:creationId xmlns:a16="http://schemas.microsoft.com/office/drawing/2014/main" id="{AF89964F-5C19-4638-AA14-BF3A0EE98CC0}"/>
               </a:ext>
             </a:extLst>
           </p:cNvPr>
@@ -4228,7 +4251,7 @@
           <p:nvPr/>
         </p:nvPicPr>
         <p:blipFill>
-          <a:blip xmlns:r="http://schemas.openxmlformats.org/officeDocument/2006/relationships" xmlns:a="http://schemas.openxmlformats.org/drawingml/2006/main" r:embed="R92fca445d07d4be2"/>
+          <a:blip xmlns:r="http://schemas.openxmlformats.org/officeDocument/2006/relationships" xmlns:a="http://schemas.openxmlformats.org/drawingml/2006/main" r:embed="R84c0b6991e6c4666"/>
           <a:srcRect xmlns:a="http://schemas.openxmlformats.org/drawingml/2006/main" l="2907" t="0" r="2907" b="0"/>
           <a:stretch xmlns:a="http://schemas.openxmlformats.org/drawingml/2006/main">
             <a:fillRect l="0" t="0" r="0" b="0"/>
@@ -4249,7 +4272,7 @@
           <p:cNvPr id="3" name="">
             <a:extLst xmlns:a="http://schemas.openxmlformats.org/drawingml/2006/main">
               <a:ext uri="{FF2B5EF4-FFF2-40B4-BE49-F238E27FC236}">
-                <a16:creationId xmlns:a16="http://schemas.microsoft.com/office/drawing/2014/main" id="{ABE8C6F1-77C6-433C-AE92-512F58174229}"/>
+                <a16:creationId xmlns:a16="http://schemas.microsoft.com/office/drawing/2014/main" id="{A7D1A367-89B5-4655-8C02-60910F1A9BEE}"/>
               </a:ext>
             </a:extLst>
           </p:cNvPr>
@@ -4305,7 +4328,7 @@
           <p:cNvPr id="4" name="">
             <a:extLst xmlns:a="http://schemas.openxmlformats.org/drawingml/2006/main">
               <a:ext uri="{FF2B5EF4-FFF2-40B4-BE49-F238E27FC236}">
-                <a16:creationId xmlns:a16="http://schemas.microsoft.com/office/drawing/2014/main" id="{DF77FA60-5D21-434A-95F4-9C200B2D69D9}"/>
+                <a16:creationId xmlns:a16="http://schemas.microsoft.com/office/drawing/2014/main" id="{1EA390EA-C212-4303-AD61-60D6308C957E}"/>
               </a:ext>
             </a:extLst>
           </p:cNvPr>
@@ -4336,7 +4359,7 @@
           <p:cNvPr id="5" name="">
             <a:extLst xmlns:a="http://schemas.openxmlformats.org/drawingml/2006/main">
               <a:ext uri="{FF2B5EF4-FFF2-40B4-BE49-F238E27FC236}">
-                <a16:creationId xmlns:a16="http://schemas.microsoft.com/office/drawing/2014/main" id="{B1D7C9D3-E312-473D-AADE-D05685ACF813}"/>
+                <a16:creationId xmlns:a16="http://schemas.microsoft.com/office/drawing/2014/main" id="{ADC67EEA-7151-4259-9DF1-0E9FE4F87902}"/>
               </a:ext>
             </a:extLst>
           </p:cNvPr>
@@ -4392,7 +4415,7 @@
           <p:cNvPr id="6" name="">
             <a:extLst xmlns:a="http://schemas.openxmlformats.org/drawingml/2006/main">
               <a:ext uri="{FF2B5EF4-FFF2-40B4-BE49-F238E27FC236}">
-                <a16:creationId xmlns:a16="http://schemas.microsoft.com/office/drawing/2014/main" id="{231DED7A-C884-40CC-BEF7-32160CD967A1}"/>
+                <a16:creationId xmlns:a16="http://schemas.microsoft.com/office/drawing/2014/main" id="{4D0C8988-1A81-4761-8161-37537F5F52DF}"/>
               </a:ext>
             </a:extLst>
           </p:cNvPr>
@@ -4423,7 +4446,7 @@
           <p:cNvPr id="7" name="">
             <a:extLst xmlns:a="http://schemas.openxmlformats.org/drawingml/2006/main">
               <a:ext uri="{FF2B5EF4-FFF2-40B4-BE49-F238E27FC236}">
-                <a16:creationId xmlns:a16="http://schemas.microsoft.com/office/drawing/2014/main" id="{4C368694-DB7A-4D3E-9E0D-17163552E50F}"/>
+                <a16:creationId xmlns:a16="http://schemas.microsoft.com/office/drawing/2014/main" id="{418C1958-5281-47D1-9E71-CED7F4813450}"/>
               </a:ext>
             </a:extLst>
           </p:cNvPr>
@@ -4479,7 +4502,7 @@
           <p:cNvPr id="8" name="">
             <a:extLst xmlns:a="http://schemas.openxmlformats.org/drawingml/2006/main">
               <a:ext uri="{FF2B5EF4-FFF2-40B4-BE49-F238E27FC236}">
-                <a16:creationId xmlns:a16="http://schemas.microsoft.com/office/drawing/2014/main" id="{14A31D02-4A0E-411B-8351-F10D4DF877FE}"/>
+                <a16:creationId xmlns:a16="http://schemas.microsoft.com/office/drawing/2014/main" id="{C46C2B1E-6F7B-4986-8558-A0D6438E2971}"/>
               </a:ext>
             </a:extLst>
           </p:cNvPr>
@@ -4510,7 +4533,7 @@
           <p:cNvPr id="9" name="">
             <a:extLst xmlns:a="http://schemas.openxmlformats.org/drawingml/2006/main">
               <a:ext uri="{FF2B5EF4-FFF2-40B4-BE49-F238E27FC236}">
-                <a16:creationId xmlns:a16="http://schemas.microsoft.com/office/drawing/2014/main" id="{12DF93E1-CACA-43B3-B4D2-8723EFFBDD4C}"/>
+                <a16:creationId xmlns:a16="http://schemas.microsoft.com/office/drawing/2014/main" id="{2E100738-E480-4C7E-B0D4-D312552FF0DA}"/>
               </a:ext>
             </a:extLst>
           </p:cNvPr>
@@ -4566,7 +4589,7 @@
           <p:cNvPr id="10" name="">
             <a:extLst xmlns:a="http://schemas.openxmlformats.org/drawingml/2006/main">
               <a:ext uri="{FF2B5EF4-FFF2-40B4-BE49-F238E27FC236}">
-                <a16:creationId xmlns:a16="http://schemas.microsoft.com/office/drawing/2014/main" id="{1C88BC43-2B8B-4948-85EA-12110F3CF604}"/>
+                <a16:creationId xmlns:a16="http://schemas.microsoft.com/office/drawing/2014/main" id="{112B66B1-8E3D-4E46-A3C4-3C66995DF12B}"/>
               </a:ext>
             </a:extLst>
           </p:cNvPr>
@@ -4597,7 +4620,7 @@
           <p:cNvPr id="11" name="">
             <a:extLst xmlns:a="http://schemas.openxmlformats.org/drawingml/2006/main">
               <a:ext uri="{FF2B5EF4-FFF2-40B4-BE49-F238E27FC236}">
-                <a16:creationId xmlns:a16="http://schemas.microsoft.com/office/drawing/2014/main" id="{9742AFD7-6616-4106-94FC-37E526B28FD2}"/>
+                <a16:creationId xmlns:a16="http://schemas.microsoft.com/office/drawing/2014/main" id="{7FF7FA86-A608-434F-A05A-D55A801DC034}"/>
               </a:ext>
             </a:extLst>
           </p:cNvPr>
@@ -4653,7 +4676,7 @@
           <p:cNvPr id="12" name="">
             <a:extLst xmlns:a="http://schemas.openxmlformats.org/drawingml/2006/main">
               <a:ext uri="{FF2B5EF4-FFF2-40B4-BE49-F238E27FC236}">
-                <a16:creationId xmlns:a16="http://schemas.microsoft.com/office/drawing/2014/main" id="{F4614325-37F6-47C1-9A1A-A9675FF99D2A}"/>
+                <a16:creationId xmlns:a16="http://schemas.microsoft.com/office/drawing/2014/main" id="{A7DA59C7-1E70-4472-AEF8-3ACB6FC16783}"/>
               </a:ext>
             </a:extLst>
           </p:cNvPr>
@@ -4709,7 +4732,7 @@
           <p:cNvPr id="13" name="">
             <a:extLst xmlns:a="http://schemas.openxmlformats.org/drawingml/2006/main">
               <a:ext uri="{FF2B5EF4-FFF2-40B4-BE49-F238E27FC236}">
-                <a16:creationId xmlns:a16="http://schemas.microsoft.com/office/drawing/2014/main" id="{7E24DCD7-F822-4DAA-8D27-2DA10DDAE420}"/>
+                <a16:creationId xmlns:a16="http://schemas.microsoft.com/office/drawing/2014/main" id="{235AE7CA-F4F6-47F1-BA9E-D7F24A800F82}"/>
               </a:ext>
             </a:extLst>
           </p:cNvPr>
@@ -4763,7 +4786,7 @@
     </p:spTree>
     <p:extLst>
       <p:ext uri="{BB962C8B-B14F-4D97-AF65-F5344CB8AC3E}">
-        <p14:creationId xmlns:p14="http://schemas.microsoft.com/office/powerpoint/2010/main" val="1002704178"/>
+        <p14:creationId xmlns:p14="http://schemas.microsoft.com/office/powerpoint/2010/main" val="290081373"/>
       </p:ext>
     </p:extLst>
   </p:cSld>
@@ -4794,7 +4817,7 @@
           <p:cNvPr id="1" name="">
             <a:extLst xmlns:a="http://schemas.openxmlformats.org/drawingml/2006/main">
               <a:ext uri="{FF2B5EF4-FFF2-40B4-BE49-F238E27FC236}">
-                <a16:creationId xmlns:a16="http://schemas.microsoft.com/office/drawing/2014/main" id="{D5948B50-6934-4022-9DEE-6C8D9873817F}"/>
+                <a16:creationId xmlns:a16="http://schemas.microsoft.com/office/drawing/2014/main" id="{33289DEF-E550-4436-9E51-AA0F8CDB2B8C}"/>
               </a:ext>
             </a:extLst>
           </p:cNvPr>
@@ -4850,7 +4873,7 @@
           <p:cNvPr id="2" name="">
             <a:extLst xmlns:a="http://schemas.openxmlformats.org/drawingml/2006/main">
               <a:ext uri="{FF2B5EF4-FFF2-40B4-BE49-F238E27FC236}">
-                <a16:creationId xmlns:a16="http://schemas.microsoft.com/office/drawing/2014/main" id="{E8737EFA-E9D3-4FF6-8307-5B2C98A7296B}"/>
+                <a16:creationId xmlns:a16="http://schemas.microsoft.com/office/drawing/2014/main" id="{B2068FBB-25AD-427E-9BF7-E0C45A113D4F}"/>
               </a:ext>
             </a:extLst>
           </p:cNvPr>
@@ -4910,7 +4933,7 @@
           <p:nvPr/>
         </p:nvPicPr>
         <p:blipFill>
-          <a:blip xmlns:r="http://schemas.openxmlformats.org/officeDocument/2006/relationships" xmlns:a="http://schemas.openxmlformats.org/drawingml/2006/main" r:embed="Rc3de4d8828614e7f"/>
+          <a:blip xmlns:r="http://schemas.openxmlformats.org/officeDocument/2006/relationships" xmlns:a="http://schemas.openxmlformats.org/drawingml/2006/main" r:embed="R83fe1d2dd520496e"/>
           <a:srcRect xmlns:a="http://schemas.openxmlformats.org/drawingml/2006/main" l="10473" t="0" r="10473" b="0"/>
           <a:stretch xmlns:a="http://schemas.openxmlformats.org/drawingml/2006/main">
             <a:fillRect l="0" t="0" r="0" b="0"/>
@@ -4931,7 +4954,7 @@
           <p:cNvPr id="4" name="">
             <a:extLst xmlns:a="http://schemas.openxmlformats.org/drawingml/2006/main">
               <a:ext uri="{FF2B5EF4-FFF2-40B4-BE49-F238E27FC236}">
-                <a16:creationId xmlns:a16="http://schemas.microsoft.com/office/drawing/2014/main" id="{A1A7C501-ED63-48B9-B5F7-B84A51013189}"/>
+                <a16:creationId xmlns:a16="http://schemas.microsoft.com/office/drawing/2014/main" id="{C37DF66B-BD70-4CCD-A431-B35DA892A0F5}"/>
               </a:ext>
             </a:extLst>
           </p:cNvPr>
@@ -4987,7 +5010,7 @@
           <p:cNvPr id="5" name="">
             <a:extLst xmlns:a="http://schemas.openxmlformats.org/drawingml/2006/main">
               <a:ext uri="{FF2B5EF4-FFF2-40B4-BE49-F238E27FC236}">
-                <a16:creationId xmlns:a16="http://schemas.microsoft.com/office/drawing/2014/main" id="{7A93B766-0EC3-4DED-A347-2B0823DF602C}"/>
+                <a16:creationId xmlns:a16="http://schemas.microsoft.com/office/drawing/2014/main" id="{1838309C-F48D-4929-990B-3A2B07C40183}"/>
               </a:ext>
             </a:extLst>
           </p:cNvPr>
@@ -5047,7 +5070,7 @@
           <p:nvPr/>
         </p:nvPicPr>
         <p:blipFill>
-          <a:blip xmlns:r="http://schemas.openxmlformats.org/officeDocument/2006/relationships" xmlns:a="http://schemas.openxmlformats.org/drawingml/2006/main" r:embed="R7d9ab4f0466d4693"/>
+          <a:blip xmlns:r="http://schemas.openxmlformats.org/officeDocument/2006/relationships" xmlns:a="http://schemas.openxmlformats.org/drawingml/2006/main" r:embed="R0b27c0e6db03413c"/>
           <a:srcRect xmlns:a="http://schemas.openxmlformats.org/drawingml/2006/main" l="10473" t="0" r="10473" b="0"/>
           <a:stretch xmlns:a="http://schemas.openxmlformats.org/drawingml/2006/main">
             <a:fillRect l="0" t="0" r="0" b="0"/>
@@ -5068,7 +5091,7 @@
           <p:cNvPr id="7" name="">
             <a:extLst xmlns:a="http://schemas.openxmlformats.org/drawingml/2006/main">
               <a:ext uri="{FF2B5EF4-FFF2-40B4-BE49-F238E27FC236}">
-                <a16:creationId xmlns:a16="http://schemas.microsoft.com/office/drawing/2014/main" id="{4C8EF185-87F9-432F-B87F-3FA0AD5334A5}"/>
+                <a16:creationId xmlns:a16="http://schemas.microsoft.com/office/drawing/2014/main" id="{DCBFB4F1-1F15-4026-B342-A9190A9C46FD}"/>
               </a:ext>
             </a:extLst>
           </p:cNvPr>
@@ -5124,7 +5147,7 @@
           <p:cNvPr id="8" name="">
             <a:extLst xmlns:a="http://schemas.openxmlformats.org/drawingml/2006/main">
               <a:ext uri="{FF2B5EF4-FFF2-40B4-BE49-F238E27FC236}">
-                <a16:creationId xmlns:a16="http://schemas.microsoft.com/office/drawing/2014/main" id="{D4C84336-BD44-4403-B541-51D0AFDEDF33}"/>
+                <a16:creationId xmlns:a16="http://schemas.microsoft.com/office/drawing/2014/main" id="{98E5C303-F972-4D72-9BDA-88996F42FE6C}"/>
               </a:ext>
             </a:extLst>
           </p:cNvPr>
@@ -5180,7 +5203,7 @@
           <p:cNvPr id="9" name="">
             <a:extLst xmlns:a="http://schemas.openxmlformats.org/drawingml/2006/main">
               <a:ext uri="{FF2B5EF4-FFF2-40B4-BE49-F238E27FC236}">
-                <a16:creationId xmlns:a16="http://schemas.microsoft.com/office/drawing/2014/main" id="{D2C9DCB6-EDCA-4B52-8317-7CE67E64EF47}"/>
+                <a16:creationId xmlns:a16="http://schemas.microsoft.com/office/drawing/2014/main" id="{8657FF7A-9758-45F0-A782-96355684B584}"/>
               </a:ext>
             </a:extLst>
           </p:cNvPr>
@@ -5234,7 +5257,7 @@
     </p:spTree>
     <p:extLst>
       <p:ext uri="{BB962C8B-B14F-4D97-AF65-F5344CB8AC3E}">
-        <p14:creationId xmlns:p14="http://schemas.microsoft.com/office/powerpoint/2010/main" val="678779111"/>
+        <p14:creationId xmlns:p14="http://schemas.microsoft.com/office/powerpoint/2010/main" val="823098237"/>
       </p:ext>
     </p:extLst>
   </p:cSld>
@@ -5265,7 +5288,7 @@
           <p:cNvPr id="1" name="">
             <a:extLst xmlns:a="http://schemas.openxmlformats.org/drawingml/2006/main">
               <a:ext uri="{FF2B5EF4-FFF2-40B4-BE49-F238E27FC236}">
-                <a16:creationId xmlns:a16="http://schemas.microsoft.com/office/drawing/2014/main" id="{C59E8022-51F5-49FB-839E-08AF3BC1B031}"/>
+                <a16:creationId xmlns:a16="http://schemas.microsoft.com/office/drawing/2014/main" id="{6A978E51-CC57-4A77-B112-9393A2DFFB84}"/>
               </a:ext>
             </a:extLst>
           </p:cNvPr>
@@ -5321,7 +5344,7 @@
           <p:cNvPr id="2" name="">
             <a:extLst xmlns:a="http://schemas.openxmlformats.org/drawingml/2006/main">
               <a:ext uri="{FF2B5EF4-FFF2-40B4-BE49-F238E27FC236}">
-                <a16:creationId xmlns:a16="http://schemas.microsoft.com/office/drawing/2014/main" id="{CE9E35D3-94DD-4EC8-9F2A-78FA908FBDD4}"/>
+                <a16:creationId xmlns:a16="http://schemas.microsoft.com/office/drawing/2014/main" id="{BA372318-68C4-4A7F-B456-6B9E1AE1AC29}"/>
               </a:ext>
             </a:extLst>
           </p:cNvPr>
@@ -5381,7 +5404,7 @@
           <p:nvPr/>
         </p:nvPicPr>
         <p:blipFill>
-          <a:blip xmlns:r="http://schemas.openxmlformats.org/officeDocument/2006/relationships" xmlns:a="http://schemas.openxmlformats.org/drawingml/2006/main" r:embed="R9766f76f3cb24acf"/>
+          <a:blip xmlns:r="http://schemas.openxmlformats.org/officeDocument/2006/relationships" xmlns:a="http://schemas.openxmlformats.org/drawingml/2006/main" r:embed="Rc4ab7285d7b246c7"/>
           <a:srcRect xmlns:a="http://schemas.openxmlformats.org/drawingml/2006/main" l="0" t="5556" r="0" b="5556"/>
           <a:stretch xmlns:a="http://schemas.openxmlformats.org/drawingml/2006/main">
             <a:fillRect l="0" t="0" r="0" b="0"/>
@@ -5402,7 +5425,7 @@
           <p:cNvPr id="4" name="">
             <a:extLst xmlns:a="http://schemas.openxmlformats.org/drawingml/2006/main">
               <a:ext uri="{FF2B5EF4-FFF2-40B4-BE49-F238E27FC236}">
-                <a16:creationId xmlns:a16="http://schemas.microsoft.com/office/drawing/2014/main" id="{8AB61532-723E-4014-95C6-643F76EC6BF3}"/>
+                <a16:creationId xmlns:a16="http://schemas.microsoft.com/office/drawing/2014/main" id="{1C24D621-79A5-406B-A47E-60100FA71118}"/>
               </a:ext>
             </a:extLst>
           </p:cNvPr>
@@ -5462,7 +5485,7 @@
           <p:nvPr/>
         </p:nvPicPr>
         <p:blipFill>
-          <a:blip xmlns:r="http://schemas.openxmlformats.org/officeDocument/2006/relationships" xmlns:a="http://schemas.openxmlformats.org/drawingml/2006/main" r:embed="R84f2115217844fb9"/>
+          <a:blip xmlns:r="http://schemas.openxmlformats.org/officeDocument/2006/relationships" xmlns:a="http://schemas.openxmlformats.org/drawingml/2006/main" r:embed="R52e2d0c4a37a461a"/>
           <a:srcRect xmlns:a="http://schemas.openxmlformats.org/drawingml/2006/main" l="0" t="5556" r="0" b="5556"/>
           <a:stretch xmlns:a="http://schemas.openxmlformats.org/drawingml/2006/main">
             <a:fillRect l="0" t="0" r="0" b="0"/>
@@ -5483,7 +5506,7 @@
           <p:cNvPr id="6" name="">
             <a:extLst xmlns:a="http://schemas.openxmlformats.org/drawingml/2006/main">
               <a:ext uri="{FF2B5EF4-FFF2-40B4-BE49-F238E27FC236}">
-                <a16:creationId xmlns:a16="http://schemas.microsoft.com/office/drawing/2014/main" id="{102D2F57-4B40-4C1E-AE8B-5DDB8D571195}"/>
+                <a16:creationId xmlns:a16="http://schemas.microsoft.com/office/drawing/2014/main" id="{DD498DC2-27C1-4560-8E14-AE158798230E}"/>
               </a:ext>
             </a:extLst>
           </p:cNvPr>
@@ -5543,7 +5566,7 @@
           <p:nvPr/>
         </p:nvPicPr>
         <p:blipFill>
-          <a:blip xmlns:r="http://schemas.openxmlformats.org/officeDocument/2006/relationships" xmlns:a="http://schemas.openxmlformats.org/drawingml/2006/main" r:embed="R35638a015f074aa0"/>
+          <a:blip xmlns:r="http://schemas.openxmlformats.org/officeDocument/2006/relationships" xmlns:a="http://schemas.openxmlformats.org/drawingml/2006/main" r:embed="Ra9ba135aa1894ed2"/>
           <a:srcRect xmlns:a="http://schemas.openxmlformats.org/drawingml/2006/main" l="0" t="5556" r="0" b="5556"/>
           <a:stretch xmlns:a="http://schemas.openxmlformats.org/drawingml/2006/main">
             <a:fillRect l="0" t="0" r="0" b="0"/>
@@ -5564,7 +5587,7 @@
           <p:cNvPr id="8" name="">
             <a:extLst xmlns:a="http://schemas.openxmlformats.org/drawingml/2006/main">
               <a:ext uri="{FF2B5EF4-FFF2-40B4-BE49-F238E27FC236}">
-                <a16:creationId xmlns:a16="http://schemas.microsoft.com/office/drawing/2014/main" id="{15A5DF67-16E7-4E12-B0EC-7E8263DE20B7}"/>
+                <a16:creationId xmlns:a16="http://schemas.microsoft.com/office/drawing/2014/main" id="{F891A313-C2B4-4742-830D-5C35FBA931BC}"/>
               </a:ext>
             </a:extLst>
           </p:cNvPr>
@@ -5624,7 +5647,7 @@
           <p:nvPr/>
         </p:nvPicPr>
         <p:blipFill>
-          <a:blip xmlns:r="http://schemas.openxmlformats.org/officeDocument/2006/relationships" xmlns:a="http://schemas.openxmlformats.org/drawingml/2006/main" r:embed="R7daaa4819735451f"/>
+          <a:blip xmlns:r="http://schemas.openxmlformats.org/officeDocument/2006/relationships" xmlns:a="http://schemas.openxmlformats.org/drawingml/2006/main" r:embed="R9d2b017d74be450b"/>
           <a:srcRect xmlns:a="http://schemas.openxmlformats.org/drawingml/2006/main" l="0" t="5556" r="0" b="5556"/>
           <a:stretch xmlns:a="http://schemas.openxmlformats.org/drawingml/2006/main">
             <a:fillRect l="0" t="0" r="0" b="0"/>
@@ -5645,7 +5668,7 @@
           <p:cNvPr id="10" name="">
             <a:extLst xmlns:a="http://schemas.openxmlformats.org/drawingml/2006/main">
               <a:ext uri="{FF2B5EF4-FFF2-40B4-BE49-F238E27FC236}">
-                <a16:creationId xmlns:a16="http://schemas.microsoft.com/office/drawing/2014/main" id="{9BD274E7-86D9-44BC-A5D5-B92A6FF25623}"/>
+                <a16:creationId xmlns:a16="http://schemas.microsoft.com/office/drawing/2014/main" id="{75590D89-1AFB-428B-AD02-936064BBD291}"/>
               </a:ext>
             </a:extLst>
           </p:cNvPr>
@@ -5705,7 +5728,7 @@
           <p:nvPr/>
         </p:nvPicPr>
         <p:blipFill>
-          <a:blip xmlns:r="http://schemas.openxmlformats.org/officeDocument/2006/relationships" xmlns:a="http://schemas.openxmlformats.org/drawingml/2006/main" r:embed="R547001f54d2c46b1"/>
+          <a:blip xmlns:r="http://schemas.openxmlformats.org/officeDocument/2006/relationships" xmlns:a="http://schemas.openxmlformats.org/drawingml/2006/main" r:embed="R29f340322bc64e3f"/>
           <a:srcRect xmlns:a="http://schemas.openxmlformats.org/drawingml/2006/main" l="0" t="5556" r="0" b="5556"/>
           <a:stretch xmlns:a="http://schemas.openxmlformats.org/drawingml/2006/main">
             <a:fillRect l="0" t="0" r="0" b="0"/>
@@ -5726,7 +5749,7 @@
           <p:cNvPr id="12" name="">
             <a:extLst xmlns:a="http://schemas.openxmlformats.org/drawingml/2006/main">
               <a:ext uri="{FF2B5EF4-FFF2-40B4-BE49-F238E27FC236}">
-                <a16:creationId xmlns:a16="http://schemas.microsoft.com/office/drawing/2014/main" id="{CD3465BD-1C3E-46D7-AFF2-D7EAE5052CA9}"/>
+                <a16:creationId xmlns:a16="http://schemas.microsoft.com/office/drawing/2014/main" id="{E4141CDF-86C4-42B0-9F53-8CC7F0E2A8F2}"/>
               </a:ext>
             </a:extLst>
           </p:cNvPr>
@@ -5786,7 +5809,7 @@
           <p:nvPr/>
         </p:nvPicPr>
         <p:blipFill>
-          <a:blip xmlns:r="http://schemas.openxmlformats.org/officeDocument/2006/relationships" xmlns:a="http://schemas.openxmlformats.org/drawingml/2006/main" r:embed="R7cffd0437a454d75"/>
+          <a:blip xmlns:r="http://schemas.openxmlformats.org/officeDocument/2006/relationships" xmlns:a="http://schemas.openxmlformats.org/drawingml/2006/main" r:embed="R9988eada69934d79"/>
           <a:srcRect xmlns:a="http://schemas.openxmlformats.org/drawingml/2006/main" l="0" t="5556" r="0" b="5556"/>
           <a:stretch xmlns:a="http://schemas.openxmlformats.org/drawingml/2006/main">
             <a:fillRect l="0" t="0" r="0" b="0"/>
@@ -5807,7 +5830,7 @@
           <p:cNvPr id="14" name="">
             <a:extLst xmlns:a="http://schemas.openxmlformats.org/drawingml/2006/main">
               <a:ext uri="{FF2B5EF4-FFF2-40B4-BE49-F238E27FC236}">
-                <a16:creationId xmlns:a16="http://schemas.microsoft.com/office/drawing/2014/main" id="{30ECDEDD-D6CD-40B8-AE50-54C1722CB987}"/>
+                <a16:creationId xmlns:a16="http://schemas.microsoft.com/office/drawing/2014/main" id="{4BFF8B28-A4D6-469B-9741-68F4A47D046A}"/>
               </a:ext>
             </a:extLst>
           </p:cNvPr>
@@ -5863,7 +5886,7 @@
           <p:cNvPr id="15" name="">
             <a:extLst xmlns:a="http://schemas.openxmlformats.org/drawingml/2006/main">
               <a:ext uri="{FF2B5EF4-FFF2-40B4-BE49-F238E27FC236}">
-                <a16:creationId xmlns:a16="http://schemas.microsoft.com/office/drawing/2014/main" id="{3E0694FC-5282-47A6-9866-D3CB0825377A}"/>
+                <a16:creationId xmlns:a16="http://schemas.microsoft.com/office/drawing/2014/main" id="{02ED2302-6CA5-4C19-84EF-61E21A80D74E}"/>
               </a:ext>
             </a:extLst>
           </p:cNvPr>
@@ -5919,7 +5942,7 @@
           <p:cNvPr id="16" name="">
             <a:extLst xmlns:a="http://schemas.openxmlformats.org/drawingml/2006/main">
               <a:ext uri="{FF2B5EF4-FFF2-40B4-BE49-F238E27FC236}">
-                <a16:creationId xmlns:a16="http://schemas.microsoft.com/office/drawing/2014/main" id="{8D944E4B-FE9C-432F-B60D-A517B0569837}"/>
+                <a16:creationId xmlns:a16="http://schemas.microsoft.com/office/drawing/2014/main" id="{02AE6145-1F3B-49F6-9D12-5E6C4AE94922}"/>
               </a:ext>
             </a:extLst>
           </p:cNvPr>
@@ -5973,7 +5996,7 @@
     </p:spTree>
     <p:extLst>
       <p:ext uri="{BB962C8B-B14F-4D97-AF65-F5344CB8AC3E}">
-        <p14:creationId xmlns:p14="http://schemas.microsoft.com/office/powerpoint/2010/main" val="2006956231"/>
+        <p14:creationId xmlns:p14="http://schemas.microsoft.com/office/powerpoint/2010/main" val="235719260"/>
       </p:ext>
     </p:extLst>
   </p:cSld>
@@ -6004,7 +6027,7 @@
           <p:cNvPr id="1" name="">
             <a:extLst xmlns:a="http://schemas.openxmlformats.org/drawingml/2006/main">
               <a:ext uri="{FF2B5EF4-FFF2-40B4-BE49-F238E27FC236}">
-                <a16:creationId xmlns:a16="http://schemas.microsoft.com/office/drawing/2014/main" id="{E6B8F686-BD8F-4482-94A1-E9C603B1FE5D}"/>
+                <a16:creationId xmlns:a16="http://schemas.microsoft.com/office/drawing/2014/main" id="{CB712E08-85FA-43E4-A4CC-DBD7A35D9FCB}"/>
               </a:ext>
             </a:extLst>
           </p:cNvPr>
@@ -6060,7 +6083,7 @@
           <p:cNvPr id="2" name="">
             <a:extLst xmlns:a="http://schemas.openxmlformats.org/drawingml/2006/main">
               <a:ext uri="{FF2B5EF4-FFF2-40B4-BE49-F238E27FC236}">
-                <a16:creationId xmlns:a16="http://schemas.microsoft.com/office/drawing/2014/main" id="{FD470D94-053B-4160-B551-DA469CF16F86}"/>
+                <a16:creationId xmlns:a16="http://schemas.microsoft.com/office/drawing/2014/main" id="{35771C49-F0CA-49B5-AF0F-A07E39C5EDFF}"/>
               </a:ext>
             </a:extLst>
           </p:cNvPr>
@@ -6099,7 +6122,7 @@
           <p:nvPr/>
         </p:nvPicPr>
         <p:blipFill>
-          <a:blip xmlns:r="http://schemas.openxmlformats.org/officeDocument/2006/relationships" xmlns:a="http://schemas.openxmlformats.org/drawingml/2006/main" r:embed="R4bfd0ad94dfb4a14"/>
+          <a:blip xmlns:r="http://schemas.openxmlformats.org/officeDocument/2006/relationships" xmlns:a="http://schemas.openxmlformats.org/drawingml/2006/main" r:embed="R7124fe585e7442d8"/>
           <a:stretch xmlns:a="http://schemas.openxmlformats.org/drawingml/2006/main"/>
         </p:blipFill>
         <p:spPr>
@@ -6117,7 +6140,7 @@
           <p:cNvPr id="4" name="">
             <a:extLst xmlns:a="http://schemas.openxmlformats.org/drawingml/2006/main">
               <a:ext uri="{FF2B5EF4-FFF2-40B4-BE49-F238E27FC236}">
-                <a16:creationId xmlns:a16="http://schemas.microsoft.com/office/drawing/2014/main" id="{6D79E6D8-DF50-4D38-9D85-31439EC9BDA8}"/>
+                <a16:creationId xmlns:a16="http://schemas.microsoft.com/office/drawing/2014/main" id="{1601B06D-89AC-4949-A4B2-C320EB669DEC}"/>
               </a:ext>
             </a:extLst>
           </p:cNvPr>
@@ -6156,7 +6179,7 @@
           <p:nvPr/>
         </p:nvPicPr>
         <p:blipFill>
-          <a:blip xmlns:r="http://schemas.openxmlformats.org/officeDocument/2006/relationships" xmlns:a="http://schemas.openxmlformats.org/drawingml/2006/main" r:embed="R527efd4a0e594280"/>
+          <a:blip xmlns:r="http://schemas.openxmlformats.org/officeDocument/2006/relationships" xmlns:a="http://schemas.openxmlformats.org/drawingml/2006/main" r:embed="Rf294af5d94304aa6"/>
           <a:srcRect xmlns:a="http://schemas.openxmlformats.org/drawingml/2006/main" l="727" t="0" r="727" b="0"/>
           <a:stretch xmlns:a="http://schemas.openxmlformats.org/drawingml/2006/main">
             <a:fillRect l="0" t="0" r="0" b="0"/>
@@ -6177,7 +6200,7 @@
           <p:cNvPr id="6" name="">
             <a:extLst xmlns:a="http://schemas.openxmlformats.org/drawingml/2006/main">
               <a:ext uri="{FF2B5EF4-FFF2-40B4-BE49-F238E27FC236}">
-                <a16:creationId xmlns:a16="http://schemas.microsoft.com/office/drawing/2014/main" id="{FA8D604A-331C-4C06-A41A-46795FECF2DA}"/>
+                <a16:creationId xmlns:a16="http://schemas.microsoft.com/office/drawing/2014/main" id="{686E9BAC-7B56-4185-AC3D-1E3A443969A8}"/>
               </a:ext>
             </a:extLst>
           </p:cNvPr>
@@ -6233,7 +6256,7 @@
           <p:cNvPr id="7" name="">
             <a:extLst xmlns:a="http://schemas.openxmlformats.org/drawingml/2006/main">
               <a:ext uri="{FF2B5EF4-FFF2-40B4-BE49-F238E27FC236}">
-                <a16:creationId xmlns:a16="http://schemas.microsoft.com/office/drawing/2014/main" id="{5B3A689D-E590-4155-A648-B711172D0BC5}"/>
+                <a16:creationId xmlns:a16="http://schemas.microsoft.com/office/drawing/2014/main" id="{C12F500D-3414-44CE-84B6-206564027002}"/>
               </a:ext>
             </a:extLst>
           </p:cNvPr>
@@ -6289,7 +6312,7 @@
           <p:cNvPr id="8" name="">
             <a:extLst xmlns:a="http://schemas.openxmlformats.org/drawingml/2006/main">
               <a:ext uri="{FF2B5EF4-FFF2-40B4-BE49-F238E27FC236}">
-                <a16:creationId xmlns:a16="http://schemas.microsoft.com/office/drawing/2014/main" id="{9B7919CA-7158-4267-94D5-C066465462A2}"/>
+                <a16:creationId xmlns:a16="http://schemas.microsoft.com/office/drawing/2014/main" id="{CEC2390C-18AA-4184-B720-9149747ADCF3}"/>
               </a:ext>
             </a:extLst>
           </p:cNvPr>
@@ -6322,7 +6345,7 @@
           <p:cNvPr id="9" name="">
             <a:extLst xmlns:a="http://schemas.openxmlformats.org/drawingml/2006/main">
               <a:ext uri="{FF2B5EF4-FFF2-40B4-BE49-F238E27FC236}">
-                <a16:creationId xmlns:a16="http://schemas.microsoft.com/office/drawing/2014/main" id="{FAA3C5C0-EE85-4F94-8952-A80A63E40151}"/>
+                <a16:creationId xmlns:a16="http://schemas.microsoft.com/office/drawing/2014/main" id="{AB0817CC-3075-4B76-BD89-9A61434DBABE}"/>
               </a:ext>
             </a:extLst>
           </p:cNvPr>
@@ -6368,7 +6391,7 @@
                 <a:ea typeface="Microsoft YaHei"/>
                 <a:cs typeface="Microsoft YaHei"/>
               </a:rPr>
-              <a:t>WebGL Build</a:t>
+              <a:t>Playable Demo</a:t>
             </a:r>
           </a:p>
           <a:p xmlns:a="http://schemas.openxmlformats.org/drawingml/2006/main">
@@ -6391,7 +6414,7 @@
                 <a:ea typeface="Microsoft YaHei"/>
                 <a:cs typeface="Microsoft YaHei"/>
               </a:rPr>
-              <a:t>Render / Cloudflare Pages / GitHub Pages</a:t>
+              <a:t>craftsmen-and-homo-sapiens.onrender.com</a:t>
             </a:r>
           </a:p>
         </p:txBody>
@@ -6401,7 +6424,7 @@
           <p:cNvPr id="10" name="">
             <a:extLst xmlns:a="http://schemas.openxmlformats.org/drawingml/2006/main">
               <a:ext uri="{FF2B5EF4-FFF2-40B4-BE49-F238E27FC236}">
-                <a16:creationId xmlns:a16="http://schemas.microsoft.com/office/drawing/2014/main" id="{6EEFDB7C-D1A1-4E64-9925-9D7E5D584F28}"/>
+                <a16:creationId xmlns:a16="http://schemas.microsoft.com/office/drawing/2014/main" id="{0C1E3932-8631-4A75-BF72-8A85C0A448B9}"/>
               </a:ext>
             </a:extLst>
           </p:cNvPr>
@@ -6457,7 +6480,7 @@
           <p:cNvPr id="11" name="">
             <a:extLst xmlns:a="http://schemas.openxmlformats.org/drawingml/2006/main">
               <a:ext uri="{FF2B5EF4-FFF2-40B4-BE49-F238E27FC236}">
-                <a16:creationId xmlns:a16="http://schemas.microsoft.com/office/drawing/2014/main" id="{C78AA382-C46F-4C9D-9410-6C91973A4B90}"/>
+                <a16:creationId xmlns:a16="http://schemas.microsoft.com/office/drawing/2014/main" id="{CBB79E88-FCC1-4287-B905-985B72711729}"/>
               </a:ext>
             </a:extLst>
           </p:cNvPr>
@@ -6511,7 +6534,7 @@
     </p:spTree>
     <p:extLst>
       <p:ext uri="{BB962C8B-B14F-4D97-AF65-F5344CB8AC3E}">
-        <p14:creationId xmlns:p14="http://schemas.microsoft.com/office/powerpoint/2010/main" val="2137611072"/>
+        <p14:creationId xmlns:p14="http://schemas.microsoft.com/office/powerpoint/2010/main" val="1377745625"/>
       </p:ext>
     </p:extLst>
   </p:cSld>

</xml_diff>